<commit_message>
Remove cover description per presentation comment
</commit_message>
<xml_diff>
--- a/teaching/final_presentation/台灣房屋銷售價格預測挑戰賽_上台簡報.pptx
+++ b/teaching/final_presentation/台灣房屋銷售價格預測挑戰賽_上台簡報.pptx
@@ -6613,74 +6613,6 @@
                 <a:cs typeface="Microsoft JhengHei"/>
               </a:rPr>
               <a:t>預測挑戰賽</a:t>
-            </a:r>
-          </a:p>
-        </p:txBody>
-      </p:sp>
-      <p:sp>
-        <p:nvSpPr>
-          <p:cNvPr id="4" name="body">
-            <a:extLst xmlns:a="http://schemas.openxmlformats.org/drawingml/2006/main">
-              <a:ext uri="{FF2B5EF4-FFF2-40B4-BE49-F238E27FC236}">
-                <a16:creationId xmlns:a16="http://schemas.microsoft.com/office/drawing/2014/main" id="{6C2EE17B-B6EF-4AB5-8D2E-1E2089B5DC68}"/>
-              </a:ext>
-            </a:extLst>
-          </p:cNvPr>
-          <p:cNvSpPr>
-            <a:spLocks xmlns:a="http://schemas.openxmlformats.org/drawingml/2006/main" noGrp="1"/>
-          </p:cNvSpPr>
-          <p:nvPr/>
-        </p:nvSpPr>
-        <p:spPr>
-          <a:xfrm xmlns:a="http://schemas.openxmlformats.org/drawingml/2006/main">
-            <a:off x="876300" y="4029075"/>
-            <a:ext cx="9906000" cy="571500"/>
-          </a:xfrm>
-          <a:prstGeom xmlns:a="http://schemas.openxmlformats.org/drawingml/2006/main" prst="rect">
-            <a:avLst/>
-          </a:prstGeom>
-          <a:noFill xmlns:a="http://schemas.openxmlformats.org/drawingml/2006/main"/>
-          <a:ln xmlns:a="http://schemas.openxmlformats.org/drawingml/2006/main" w="0">
-            <a:noFill/>
-          </a:ln>
-        </p:spPr>
-        <p:txBody>
-          <a:bodyPr xmlns:a="http://schemas.openxmlformats.org/drawingml/2006/main" wrap="square" lIns="0" tIns="0" rIns="0" bIns="0" anchor="t">
-            <a:noAutofit/>
-          </a:bodyPr>
-          <a:lstStyle xmlns:a="http://schemas.openxmlformats.org/drawingml/2006/main">
-            <a:defPPr algn="l">
-              <a:defRPr sz="2250" b="0">
-                <a:solidFill>
-                  <a:srgbClr val="C7DAD4"/>
-                </a:solidFill>
-                <a:latin typeface="Microsoft JhengHei"/>
-                <a:ea typeface="Microsoft JhengHei"/>
-                <a:cs typeface="Microsoft JhengHei"/>
-              </a:defRPr>
-            </a:defPPr>
-          </a:lstStyle>
-          <a:p xmlns:a="http://schemas.openxmlformats.org/drawingml/2006/main">
-            <a:pPr algn="l">
-              <a:defRPr sz="2250" b="0">
-                <a:solidFill>
-                  <a:srgbClr val="C7DAD4"/>
-                </a:solidFill>
-                <a:latin typeface="Microsoft JhengHei"/>
-                <a:ea typeface="Microsoft JhengHei"/>
-                <a:cs typeface="Microsoft JhengHei"/>
-              </a:defRPr>
-            </a:pPr>
-            <a:r>
-              <a:rPr sz="2250" b="0">
-                <a:solidFill>
-                  <a:srgbClr val="C7DAD4"/>
-                </a:solidFill>
-                <a:latin typeface="Microsoft JhengHei"/>
-                <a:ea typeface="Microsoft JhengHei"/>
-                <a:cs typeface="Microsoft JhengHei"/>
-              </a:rPr>
-              <a:t>利用歷史成交資料，估計新交易總價</a:t>
             </a:r>
           </a:p>
         </p:txBody>

</xml_diff>

<commit_message>
Add house illustration to presentation slide two
</commit_message>
<xml_diff>
--- a/teaching/final_presentation/台灣房屋銷售價格預測挑戰賽_上台簡報.pptx
+++ b/teaching/final_presentation/台灣房屋銷售價格預測挑戰賽_上台簡報.pptx
@@ -14982,6 +14982,34 @@
           </a:p>
         </p:txBody>
       </p:sp>
+      <p:pic>
+        <p:nvPicPr>
+          <p:cNvPr id="10" name="房屋示意插圖" descr="AI生成青綠色房屋示意插圖，非實際交易物件。">
+            <a:extLst xmlns:a="http://schemas.openxmlformats.org/drawingml/2006/main">
+              <a:ext uri="{FF2B5EF4-FFF2-40B4-BE49-F238E27FC236}">
+                <a16:creationId xmlns:a16="http://schemas.microsoft.com/office/drawing/2014/main" id="{51BB0392-3582-4886-AAE1-81156571DE3E}"/>
+              </a:ext>
+            </a:extLst>
+          </p:cNvPr>
+          <p:cNvPicPr>
+            <a:picLocks xmlns:a="http://schemas.openxmlformats.org/drawingml/2006/main" noChangeAspect="1"/>
+          </p:cNvPicPr>
+          <p:nvPr/>
+        </p:nvPicPr>
+        <p:blipFill>
+          <a:blip xmlns:r="http://schemas.openxmlformats.org/officeDocument/2006/relationships" xmlns:a="http://schemas.openxmlformats.org/drawingml/2006/main" r:embed="rId1"/>
+          <a:stretch xmlns:a="http://schemas.openxmlformats.org/drawingml/2006/main"/>
+        </p:blipFill>
+        <p:spPr>
+          <a:xfrm xmlns:a="http://schemas.openxmlformats.org/drawingml/2006/main">
+            <a:off x="7736661" y="3143250"/>
+            <a:ext cx="2909928" cy="2619375"/>
+          </a:xfrm>
+          <a:prstGeom xmlns:a="http://schemas.openxmlformats.org/drawingml/2006/main" prst="rect">
+            <a:avLst/>
+          </a:prstGeom>
+        </p:spPr>
+      </p:pic>
     </p:spTree>
     <p:extLst>
       <p:ext uri="{BB962C8B-B14F-4D97-AF65-F5344CB8AC3E}">

</xml_diff>

<commit_message>
Remove two presentation slides and renumber narration
</commit_message>
<xml_diff>
--- a/teaching/final_presentation/台灣房屋銷售價格預測挑戰賽_上台簡報.pptx
+++ b/teaching/final_presentation/台灣房屋銷售價格預測挑戰賽_上台簡報.pptx
@@ -11,8 +11,6 @@
     <p:sldId xmlns:r="http://schemas.openxmlformats.org/officeDocument/2006/relationships" id="256" r:id="R932776737e564dca"/>
     <p:sldId xmlns:r="http://schemas.openxmlformats.org/officeDocument/2006/relationships" id="257" r:id="R3b1b25ff07d34f44"/>
     <p:sldId xmlns:r="http://schemas.openxmlformats.org/officeDocument/2006/relationships" id="258" r:id="R416a9c064a1d4ebf"/>
-    <p:sldId xmlns:r="http://schemas.openxmlformats.org/officeDocument/2006/relationships" id="259" r:id="R3a6d4b644aec4d7c"/>
-    <p:sldId xmlns:r="http://schemas.openxmlformats.org/officeDocument/2006/relationships" id="260" r:id="Rc494890e518e4908"/>
     <p:sldId xmlns:r="http://schemas.openxmlformats.org/officeDocument/2006/relationships" id="261" r:id="Rdb3b9819f9c44b2e"/>
     <p:sldId xmlns:r="http://schemas.openxmlformats.org/officeDocument/2006/relationships" id="262" r:id="R01cff1bf1a5849cc"/>
     <p:sldId xmlns:r="http://schemas.openxmlformats.org/officeDocument/2006/relationships" id="263" r:id="R0ca587361aff4fd6"/>
@@ -2471,246 +2469,6 @@
           <a:p xmlns:a="http://schemas.openxmlformats.org/drawingml/2006/main">
             <a:r>
               <a:t>完整算一次比只展示公式容易理解，也能預防把MAE當成百分比或有正負號的平均誤差。</a:t>
-            </a:r>
-          </a:p>
-          <a:p xmlns:a="http://schemas.openxmlformats.org/drawingml/2006/main">
-            <a:r>
-              <a:t/>
-            </a:r>
-          </a:p>
-          <a:p xmlns:a="http://schemas.openxmlformats.org/drawingml/2006/main">
-            <a:r>
-              <a:t>資料依據</a:t>
-            </a:r>
-          </a:p>
-          <a:p xmlns:a="http://schemas.openxmlformats.org/drawingml/2006/main">
-            <a:r>
-              <a:t>課程交易資料、保存的程式與發行證據、方法與程式導覽。</a:t>
-            </a:r>
-          </a:p>
-        </p:txBody>
-      </p:sp>
-      <p:sp>
-        <p:nvSpPr>
-          <p:cNvPr id="4" name="Slide Number Placeholder 3"/>
-          <p:cNvSpPr>
-            <a:spLocks xmlns:a="http://schemas.openxmlformats.org/drawingml/2006/main" noGrp="1"/>
-          </p:cNvSpPr>
-          <p:nvPr>
-            <p:ph type="sldNum" idx="5"/>
-          </p:nvPr>
-        </p:nvSpPr>
-        <p:spPr/>
-        <p:txBody>
-          <a:bodyPr xmlns:a="http://schemas.openxmlformats.org/drawingml/2006/main"/>
-          <a:lstStyle xmlns:a="http://schemas.openxmlformats.org/drawingml/2006/main"/>
-          <a:p xmlns:a="http://schemas.openxmlformats.org/drawingml/2006/main"/>
-        </p:txBody>
-      </p:sp>
-    </p:spTree>
-  </p:cSld>
-  <p:clrMapOvr>
-    <a:masterClrMapping xmlns:a="http://schemas.openxmlformats.org/drawingml/2006/main"/>
-  </p:clrMapOvr>
-</p:notes>
-</file>
-
-<file path=ppt/notesSlides/notesSlide4.xml><?xml version="1.0" encoding="utf-8"?>
-<p:notes xmlns:p="http://schemas.openxmlformats.org/presentationml/2006/main">
-  <p:cSld>
-    <p:spTree>
-      <p:nvGrpSpPr>
-        <p:cNvPr id="1" name=""/>
-        <p:cNvGrpSpPr/>
-        <p:nvPr/>
-      </p:nvGrpSpPr>
-      <p:grpSpPr>
-        <a:xfrm xmlns:a="http://schemas.openxmlformats.org/drawingml/2006/main"/>
-      </p:grpSpPr>
-      <p:sp>
-        <p:nvSpPr>
-          <p:cNvPr id="2" name="Slide Image Placeholder 1"/>
-          <p:cNvSpPr>
-            <a:spLocks xmlns:a="http://schemas.openxmlformats.org/drawingml/2006/main" noGrp="1"/>
-          </p:cNvSpPr>
-          <p:nvPr>
-            <p:ph type="sldImg" idx="0"/>
-          </p:nvPr>
-        </p:nvSpPr>
-        <p:spPr/>
-      </p:sp>
-      <p:sp>
-        <p:nvSpPr>
-          <p:cNvPr id="3" name="Notes Placeholder 2"/>
-          <p:cNvSpPr>
-            <a:spLocks xmlns:a="http://schemas.openxmlformats.org/drawingml/2006/main" noGrp="1"/>
-          </p:cNvSpPr>
-          <p:nvPr>
-            <p:ph type="body" idx="1"/>
-          </p:nvPr>
-        </p:nvSpPr>
-        <p:spPr/>
-        <p:txBody>
-          <a:bodyPr xmlns:a="http://schemas.openxmlformats.org/drawingml/2006/main"/>
-          <a:lstStyle xmlns:a="http://schemas.openxmlformats.org/drawingml/2006/main"/>
-          <a:p xmlns:a="http://schemas.openxmlformats.org/drawingml/2006/main">
-            <a:r>
-              <a:t>四份資料用途不同。訓練檔約四十五萬六千列，有房屋條件與價格答案。驗證檔約一萬二千列，也有答案，最後完整訓練時才加入。</a:t>
-            </a:r>
-          </a:p>
-          <a:p xmlns:a="http://schemas.openxmlformats.org/drawingml/2006/main">
-            <a:r>
-              <a:t/>
-            </a:r>
-          </a:p>
-          <a:p xmlns:a="http://schemas.openxmlformats.org/drawingml/2006/main">
-            <a:r>
-              <a:t>測試檔四萬七千零七十三筆，沒有價格答案，要全部估出來。提交範本只規定欄位與編號順序，示範價格不能拿來學。</a:t>
-            </a:r>
-          </a:p>
-          <a:p xmlns:a="http://schemas.openxmlformats.org/drawingml/2006/main">
-            <a:r>
-              <a:t/>
-            </a:r>
-          </a:p>
-          <a:p xmlns:a="http://schemas.openxmlformats.org/drawingml/2006/main">
-            <a:r>
-              <a:t>平台把測試檔約三成用於公開分數，叫Public，其餘約七成算隱藏分數，叫Private。三比七分的是測試檔，和有答案的驗證檔用途不同。隱藏部分的答案仍不知道。</a:t>
-            </a:r>
-          </a:p>
-          <a:p xmlns:a="http://schemas.openxmlformats.org/drawingml/2006/main">
-            <a:r>
-              <a:t/>
-            </a:r>
-          </a:p>
-          <a:p xmlns:a="http://schemas.openxmlformats.org/drawingml/2006/main">
-            <a:r>
-              <a:t>補充理由</a:t>
-            </a:r>
-          </a:p>
-          <a:p xmlns:a="http://schemas.openxmlformats.org/drawingml/2006/main">
-            <a:r>
-              <a:t>以資料用途取代只念檔名，明確區分課程valid與平台test分割。</a:t>
-            </a:r>
-          </a:p>
-          <a:p xmlns:a="http://schemas.openxmlformats.org/drawingml/2006/main">
-            <a:r>
-              <a:t/>
-            </a:r>
-          </a:p>
-          <a:p xmlns:a="http://schemas.openxmlformats.org/drawingml/2006/main">
-            <a:r>
-              <a:t>資料依據</a:t>
-            </a:r>
-          </a:p>
-          <a:p xmlns:a="http://schemas.openxmlformats.org/drawingml/2006/main">
-            <a:r>
-              <a:t>課程交易資料、保存的程式與發行證據、方法與程式導覽。</a:t>
-            </a:r>
-          </a:p>
-        </p:txBody>
-      </p:sp>
-      <p:sp>
-        <p:nvSpPr>
-          <p:cNvPr id="4" name="Slide Number Placeholder 3"/>
-          <p:cNvSpPr>
-            <a:spLocks xmlns:a="http://schemas.openxmlformats.org/drawingml/2006/main" noGrp="1"/>
-          </p:cNvSpPr>
-          <p:nvPr>
-            <p:ph type="sldNum" idx="5"/>
-          </p:nvPr>
-        </p:nvSpPr>
-        <p:spPr/>
-        <p:txBody>
-          <a:bodyPr xmlns:a="http://schemas.openxmlformats.org/drawingml/2006/main"/>
-          <a:lstStyle xmlns:a="http://schemas.openxmlformats.org/drawingml/2006/main"/>
-          <a:p xmlns:a="http://schemas.openxmlformats.org/drawingml/2006/main"/>
-        </p:txBody>
-      </p:sp>
-    </p:spTree>
-  </p:cSld>
-  <p:clrMapOvr>
-    <a:masterClrMapping xmlns:a="http://schemas.openxmlformats.org/drawingml/2006/main"/>
-  </p:clrMapOvr>
-</p:notes>
-</file>
-
-<file path=ppt/notesSlides/notesSlide5.xml><?xml version="1.0" encoding="utf-8"?>
-<p:notes xmlns:p="http://schemas.openxmlformats.org/presentationml/2006/main">
-  <p:cSld>
-    <p:spTree>
-      <p:nvGrpSpPr>
-        <p:cNvPr id="1" name=""/>
-        <p:cNvGrpSpPr/>
-        <p:nvPr/>
-      </p:nvGrpSpPr>
-      <p:grpSpPr>
-        <a:xfrm xmlns:a="http://schemas.openxmlformats.org/drawingml/2006/main"/>
-      </p:grpSpPr>
-      <p:sp>
-        <p:nvSpPr>
-          <p:cNvPr id="2" name="Slide Image Placeholder 1"/>
-          <p:cNvSpPr>
-            <a:spLocks xmlns:a="http://schemas.openxmlformats.org/drawingml/2006/main" noGrp="1"/>
-          </p:cNvSpPr>
-          <p:nvPr>
-            <p:ph type="sldImg" idx="0"/>
-          </p:nvPr>
-        </p:nvSpPr>
-        <p:spPr/>
-      </p:sp>
-      <p:sp>
-        <p:nvSpPr>
-          <p:cNvPr id="3" name="Notes Placeholder 2"/>
-          <p:cNvSpPr>
-            <a:spLocks xmlns:a="http://schemas.openxmlformats.org/drawingml/2006/main" noGrp="1"/>
-          </p:cNvSpPr>
-          <p:nvPr>
-            <p:ph type="body" idx="1"/>
-          </p:nvPr>
-        </p:nvSpPr>
-        <p:spPr/>
-        <p:txBody>
-          <a:bodyPr xmlns:a="http://schemas.openxmlformats.org/drawingml/2006/main"/>
-          <a:lstStyle xmlns:a="http://schemas.openxmlformats.org/drawingml/2006/main"/>
-          <a:p xmlns:a="http://schemas.openxmlformats.org/drawingml/2006/main">
-            <a:r>
-              <a:t>資料整理先處理兩個明確問題。原始訓練檔混入三列英文欄名，程式同時確認編號欄是英文的序號，總價欄是英文的總價名稱，才把它辨識為表頭。不是看到英文就刪。</a:t>
-            </a:r>
-          </a:p>
-          <a:p xmlns:a="http://schemas.openxmlformats.org/drawingml/2006/main">
-            <a:r>
-              <a:t/>
-            </a:r>
-          </a:p>
-          <a:p xmlns:a="http://schemas.openxmlformats.org/drawingml/2006/main">
-            <a:r>
-              <a:t>再比較除了編號以外的全部原始欄位，成交總價也要一起比較。全部相同才算完全重複，只留第一次，共移除五百二十九列。相同建案或面積並不夠，日期或價格不同仍可能是另一筆交易。</a:t>
-            </a:r>
-          </a:p>
-          <a:p xmlns:a="http://schemas.openxmlformats.org/drawingml/2006/main">
-            <a:r>
-              <a:t/>
-            </a:r>
-          </a:p>
-          <a:p xmlns:a="http://schemas.openxmlformats.org/drawingml/2006/main">
-            <a:r>
-              <a:t>最後合併有答案的驗證檔，再移除二十八筆跨檔重複，得到四十六萬七千二百二十一筆。這樣避免同一紀錄反覆影響模型。測試檔則完整保留。</a:t>
-            </a:r>
-          </a:p>
-          <a:p xmlns:a="http://schemas.openxmlformats.org/drawingml/2006/main">
-            <a:r>
-              <a:t/>
-            </a:r>
-          </a:p>
-          <a:p xmlns:a="http://schemas.openxmlformats.org/drawingml/2006/main">
-            <a:r>
-              <a:t>補充理由</a:t>
-            </a:r>
-          </a:p>
-          <a:p xmlns:a="http://schemas.openxmlformats.org/drawingml/2006/main">
-            <a:r>
-              <a:t>先呈現整體順序，讓後面的技術各自有位置，並說明資料正確、評分和交付檢查的不同用途。</a:t>
             </a:r>
           </a:p>
           <a:p xmlns:a="http://schemas.openxmlformats.org/drawingml/2006/main">
@@ -6868,7 +6626,7 @@
                 <a:ea typeface="Microsoft JhengHei"/>
                 <a:cs typeface="Microsoft JhengHei"/>
               </a:rPr>
-              <a:t>10</a:t>
+              <a:t>08</a:t>
             </a:r>
           </a:p>
         </p:txBody>
@@ -7418,7 +7176,7 @@
                 <a:ea typeface="Microsoft JhengHei"/>
                 <a:cs typeface="Microsoft JhengHei"/>
               </a:rPr>
-              <a:t>11</a:t>
+              <a:t>09</a:t>
             </a:r>
           </a:p>
         </p:txBody>
@@ -7968,7 +7726,7 @@
                 <a:ea typeface="Microsoft JhengHei"/>
                 <a:cs typeface="Microsoft JhengHei"/>
               </a:rPr>
-              <a:t>12</a:t>
+              <a:t>10</a:t>
             </a:r>
           </a:p>
         </p:txBody>
@@ -8587,7 +8345,7 @@
                 <a:ea typeface="Microsoft JhengHei"/>
                 <a:cs typeface="Microsoft JhengHei"/>
               </a:rPr>
-              <a:t>13</a:t>
+              <a:t>11</a:t>
             </a:r>
           </a:p>
         </p:txBody>
@@ -9435,7 +9193,7 @@
                 <a:ea typeface="Microsoft JhengHei"/>
                 <a:cs typeface="Microsoft JhengHei"/>
               </a:rPr>
-              <a:t>14</a:t>
+              <a:t>12</a:t>
             </a:r>
           </a:p>
         </p:txBody>
@@ -10122,7 +9880,7 @@
                 <a:ea typeface="Microsoft JhengHei"/>
                 <a:cs typeface="Microsoft JhengHei"/>
               </a:rPr>
-              <a:t>15</a:t>
+              <a:t>13</a:t>
             </a:r>
           </a:p>
         </p:txBody>
@@ -11035,7 +10793,7 @@
                 <a:ea typeface="Microsoft JhengHei"/>
                 <a:cs typeface="Microsoft JhengHei"/>
               </a:rPr>
-              <a:t>16</a:t>
+              <a:t>14</a:t>
             </a:r>
           </a:p>
         </p:txBody>
@@ -12210,7 +11968,7 @@
                 <a:ea typeface="Microsoft JhengHei"/>
                 <a:cs typeface="Microsoft JhengHei"/>
               </a:rPr>
-              <a:t>17</a:t>
+              <a:t>15</a:t>
             </a:r>
           </a:p>
         </p:txBody>
@@ -13149,7 +12907,7 @@
                 <a:ea typeface="Microsoft JhengHei"/>
                 <a:cs typeface="Microsoft JhengHei"/>
               </a:rPr>
-              <a:t>18</a:t>
+              <a:t>16</a:t>
             </a:r>
           </a:p>
         </p:txBody>
@@ -13881,7 +13639,7 @@
                 <a:ea typeface="Microsoft JhengHei"/>
                 <a:cs typeface="Microsoft JhengHei"/>
               </a:rPr>
-              <a:t>19</a:t>
+              <a:t>17</a:t>
             </a:r>
           </a:p>
         </p:txBody>
@@ -15170,7 +14928,7 @@
                 <a:ea typeface="Microsoft JhengHei"/>
                 <a:cs typeface="Microsoft JhengHei"/>
               </a:rPr>
-              <a:t>20</a:t>
+              <a:t>18</a:t>
             </a:r>
           </a:p>
         </p:txBody>
@@ -15879,7 +15637,7 @@
                 <a:ea typeface="Microsoft JhengHei"/>
                 <a:cs typeface="Microsoft JhengHei"/>
               </a:rPr>
-              <a:t>21</a:t>
+              <a:t>19</a:t>
             </a:r>
           </a:p>
         </p:txBody>
@@ -16317,7 +16075,7 @@
                 <a:ea typeface="Microsoft JhengHei"/>
                 <a:cs typeface="Microsoft JhengHei"/>
               </a:rPr>
-              <a:t>22</a:t>
+              <a:t>20</a:t>
             </a:r>
           </a:p>
         </p:txBody>
@@ -16970,7 +16728,7 @@
                 <a:ea typeface="Microsoft JhengHei"/>
                 <a:cs typeface="Microsoft JhengHei"/>
               </a:rPr>
-              <a:t>23</a:t>
+              <a:t>21</a:t>
             </a:r>
           </a:p>
         </p:txBody>
@@ -17759,7 +17517,7 @@
                 <a:ea typeface="Microsoft JhengHei"/>
                 <a:cs typeface="Microsoft JhengHei"/>
               </a:rPr>
-              <a:t>24</a:t>
+              <a:t>22</a:t>
             </a:r>
           </a:p>
         </p:txBody>
@@ -19709,2004 +19467,6 @@
 </p:sld>
 </file>
 
-<file path=ppt/slides/slide4.xml><?xml version="1.0" encoding="utf-8"?>
-<p:sld xmlns:p="http://schemas.openxmlformats.org/presentationml/2006/main">
-  <p:cSld>
-    <p:bg>
-      <p:bgPr>
-        <a:solidFill xmlns:a="http://schemas.openxmlformats.org/drawingml/2006/main">
-          <a:srgbClr val="FCFCFA"/>
-        </a:solidFill>
-      </p:bgPr>
-    </p:bg>
-    <p:spTree>
-      <p:nvGrpSpPr>
-        <p:cNvPr id="1" name=""/>
-        <p:cNvGrpSpPr/>
-        <p:nvPr/>
-      </p:nvGrpSpPr>
-      <p:grpSpPr>
-        <a:xfrm xmlns:a="http://schemas.openxmlformats.org/drawingml/2006/main"/>
-      </p:grpSpPr>
-      <p:sp>
-        <p:nvSpPr>
-          <p:cNvPr id="5" name="slide-title">
-            <a:extLst xmlns:a="http://schemas.openxmlformats.org/drawingml/2006/main">
-              <a:ext uri="{FF2B5EF4-FFF2-40B4-BE49-F238E27FC236}">
-                <a16:creationId xmlns:a16="http://schemas.microsoft.com/office/drawing/2014/main" id="{3751357B-5674-429C-882E-EB374560D4F5}"/>
-              </a:ext>
-            </a:extLst>
-          </p:cNvPr>
-          <p:cNvSpPr>
-            <a:spLocks xmlns:a="http://schemas.openxmlformats.org/drawingml/2006/main" noGrp="1"/>
-          </p:cNvSpPr>
-          <p:nvPr/>
-        </p:nvSpPr>
-        <p:spPr>
-          <a:xfrm xmlns:a="http://schemas.openxmlformats.org/drawingml/2006/main">
-            <a:off x="762000" y="457200"/>
-            <a:ext cx="10668000" cy="723900"/>
-          </a:xfrm>
-          <a:prstGeom xmlns:a="http://schemas.openxmlformats.org/drawingml/2006/main" prst="rect">
-            <a:avLst/>
-          </a:prstGeom>
-          <a:noFill xmlns:a="http://schemas.openxmlformats.org/drawingml/2006/main"/>
-          <a:ln xmlns:a="http://schemas.openxmlformats.org/drawingml/2006/main" w="0">
-            <a:noFill/>
-          </a:ln>
-        </p:spPr>
-        <p:txBody>
-          <a:bodyPr xmlns:a="http://schemas.openxmlformats.org/drawingml/2006/main" wrap="square" lIns="0" tIns="0" rIns="0" bIns="0" anchor="t">
-            <a:noAutofit/>
-          </a:bodyPr>
-          <a:lstStyle xmlns:a="http://schemas.openxmlformats.org/drawingml/2006/main">
-            <a:defPPr algn="l">
-              <a:defRPr sz="3300" b="1">
-                <a:solidFill>
-                  <a:srgbClr val="23343A"/>
-                </a:solidFill>
-                <a:latin typeface="Microsoft JhengHei"/>
-                <a:ea typeface="Microsoft JhengHei"/>
-                <a:cs typeface="Microsoft JhengHei"/>
-              </a:defRPr>
-            </a:defPPr>
-          </a:lstStyle>
-          <a:p xmlns:a="http://schemas.openxmlformats.org/drawingml/2006/main">
-            <a:pPr algn="l">
-              <a:defRPr sz="3300" b="1">
-                <a:solidFill>
-                  <a:srgbClr val="23343A"/>
-                </a:solidFill>
-                <a:latin typeface="Microsoft JhengHei"/>
-                <a:ea typeface="Microsoft JhengHei"/>
-                <a:cs typeface="Microsoft JhengHei"/>
-              </a:defRPr>
-            </a:pPr>
-            <a:r>
-              <a:rPr sz="3300" b="1">
-                <a:solidFill>
-                  <a:srgbClr val="23343A"/>
-                </a:solidFill>
-                <a:latin typeface="Microsoft JhengHei"/>
-                <a:ea typeface="Microsoft JhengHei"/>
-                <a:cs typeface="Microsoft JhengHei"/>
-              </a:rPr>
-              <a:t>四份資料的用途</a:t>
-            </a:r>
-          </a:p>
-        </p:txBody>
-      </p:sp>
-      <p:sp>
-        <p:nvSpPr>
-          <p:cNvPr id="2" name="body">
-            <a:extLst xmlns:a="http://schemas.openxmlformats.org/drawingml/2006/main">
-              <a:ext uri="{FF2B5EF4-FFF2-40B4-BE49-F238E27FC236}">
-                <a16:creationId xmlns:a16="http://schemas.microsoft.com/office/drawing/2014/main" id="{4579E70A-868D-4EC5-A925-486D505BB298}"/>
-              </a:ext>
-            </a:extLst>
-          </p:cNvPr>
-          <p:cNvSpPr>
-            <a:spLocks xmlns:a="http://schemas.openxmlformats.org/drawingml/2006/main" noGrp="1"/>
-          </p:cNvSpPr>
-          <p:nvPr/>
-        </p:nvSpPr>
-        <p:spPr>
-          <a:xfrm xmlns:a="http://schemas.openxmlformats.org/drawingml/2006/main">
-            <a:off x="10953750" y="6419850"/>
-            <a:ext cx="476250" cy="238125"/>
-          </a:xfrm>
-          <a:prstGeom xmlns:a="http://schemas.openxmlformats.org/drawingml/2006/main" prst="rect">
-            <a:avLst/>
-          </a:prstGeom>
-          <a:noFill xmlns:a="http://schemas.openxmlformats.org/drawingml/2006/main"/>
-          <a:ln xmlns:a="http://schemas.openxmlformats.org/drawingml/2006/main" w="0">
-            <a:noFill/>
-          </a:ln>
-        </p:spPr>
-        <p:txBody>
-          <a:bodyPr xmlns:a="http://schemas.openxmlformats.org/drawingml/2006/main" wrap="square" lIns="0" tIns="0" rIns="0" bIns="0" anchor="t">
-            <a:noAutofit/>
-          </a:bodyPr>
-          <a:lstStyle xmlns:a="http://schemas.openxmlformats.org/drawingml/2006/main">
-            <a:defPPr algn="r">
-              <a:defRPr sz="1275" b="0">
-                <a:solidFill>
-                  <a:srgbClr val="718082"/>
-                </a:solidFill>
-                <a:latin typeface="Microsoft JhengHei"/>
-                <a:ea typeface="Microsoft JhengHei"/>
-                <a:cs typeface="Microsoft JhengHei"/>
-              </a:defRPr>
-            </a:defPPr>
-          </a:lstStyle>
-          <a:p xmlns:a="http://schemas.openxmlformats.org/drawingml/2006/main">
-            <a:pPr algn="r">
-              <a:defRPr sz="1275" b="0">
-                <a:solidFill>
-                  <a:srgbClr val="718082"/>
-                </a:solidFill>
-                <a:latin typeface="Microsoft JhengHei"/>
-                <a:ea typeface="Microsoft JhengHei"/>
-                <a:cs typeface="Microsoft JhengHei"/>
-              </a:defRPr>
-            </a:pPr>
-            <a:r>
-              <a:rPr sz="1275" b="0">
-                <a:solidFill>
-                  <a:srgbClr val="718082"/>
-                </a:solidFill>
-                <a:latin typeface="Microsoft JhengHei"/>
-                <a:ea typeface="Microsoft JhengHei"/>
-                <a:cs typeface="Microsoft JhengHei"/>
-              </a:rPr>
-              <a:t>04</a:t>
-            </a:r>
-          </a:p>
-        </p:txBody>
-      </p:sp>
-      <p:graphicFrame>
-        <p:nvGraphicFramePr>
-          <p:cNvPr id="3" name="">
-            <a:extLst xmlns:a="http://schemas.openxmlformats.org/drawingml/2006/main">
-              <a:ext uri="{FF2B5EF4-FFF2-40B4-BE49-F238E27FC236}">
-                <a16:creationId xmlns:a16="http://schemas.microsoft.com/office/drawing/2014/main" id="{E7D059DB-3537-43BD-A795-813B815E50AE}"/>
-              </a:ext>
-            </a:extLst>
-          </p:cNvPr>
-          <p:cNvGraphicFramePr/>
-          <p:nvPr/>
-        </p:nvGraphicFramePr>
-        <p:xfrm>
-          <a:off xmlns:a="http://schemas.openxmlformats.org/drawingml/2006/main" x="762000" y="1781175"/>
-          <a:ext xmlns:a="http://schemas.openxmlformats.org/drawingml/2006/main" cx="10668000" cy="3333750"/>
-        </p:xfrm>
-        <a:graphic xmlns:a="http://schemas.openxmlformats.org/drawingml/2006/main">
-          <a:graphicData uri="http://schemas.openxmlformats.org/drawingml/2006/table">
-            <a:tbl>
-              <a:tblPr/>
-              <a:tblGrid>
-                <a:gridCol w="1619250"/>
-                <a:gridCol w="2095500"/>
-                <a:gridCol w="2190750"/>
-                <a:gridCol w="4762500"/>
-              </a:tblGrid>
-              <a:tr h="666750">
-                <a:tc>
-                  <a:txBody>
-                    <a:bodyPr lIns="133350" tIns="114300" rIns="152400" bIns="95250">
-                      <a:noAutofit/>
-                    </a:bodyPr>
-                    <a:lstStyle/>
-                    <a:p>
-                      <a:pPr algn="l"/>
-                      <a:r>
-                        <a:rPr sz="2025" b="1">
-                          <a:solidFill>
-                            <a:srgbClr val="23343A"/>
-                          </a:solidFill>
-                          <a:latin typeface="Microsoft JhengHei"/>
-                          <a:ea typeface="Microsoft JhengHei"/>
-                          <a:cs typeface="Microsoft JhengHei"/>
-                        </a:rPr>
-                        <a:t>資料</a:t>
-                      </a:r>
-                    </a:p>
-                  </a:txBody>
-                  <a:tcPr marL="91440" marR="91440" marT="45720" marB="45720" anchor="ctr">
-                    <a:lnL w="9525">
-                      <a:solidFill>
-                        <a:srgbClr val="FCFCFA"/>
-                      </a:solidFill>
-                      <a:prstDash val="solid"/>
-                    </a:lnL>
-                    <a:lnR w="9525">
-                      <a:solidFill>
-                        <a:srgbClr val="FCFCFA"/>
-                      </a:solidFill>
-                      <a:prstDash val="solid"/>
-                    </a:lnR>
-                    <a:lnT w="9525">
-                      <a:solidFill>
-                        <a:srgbClr val="FCFCFA"/>
-                      </a:solidFill>
-                      <a:prstDash val="solid"/>
-                    </a:lnT>
-                    <a:lnB w="7620">
-                      <a:solidFill>
-                        <a:srgbClr val="E1E7E4"/>
-                      </a:solidFill>
-                      <a:prstDash val="solid"/>
-                    </a:lnB>
-                    <a:solidFill>
-                      <a:srgbClr val="EEF3F0"/>
-                    </a:solidFill>
-                  </a:tcPr>
-                </a:tc>
-                <a:tc>
-                  <a:txBody>
-                    <a:bodyPr lIns="133350" tIns="114300" rIns="152400" bIns="95250">
-                      <a:noAutofit/>
-                    </a:bodyPr>
-                    <a:lstStyle/>
-                    <a:p>
-                      <a:pPr algn="r"/>
-                      <a:r>
-                        <a:rPr sz="2025" b="1">
-                          <a:solidFill>
-                            <a:srgbClr val="23343A"/>
-                          </a:solidFill>
-                          <a:latin typeface="Microsoft JhengHei"/>
-                          <a:ea typeface="Microsoft JhengHei"/>
-                          <a:cs typeface="Microsoft JhengHei"/>
-                        </a:rPr>
-                        <a:t>原始列數</a:t>
-                      </a:r>
-                    </a:p>
-                  </a:txBody>
-                  <a:tcPr marL="91440" marR="91440" marT="45720" marB="45720" anchor="ctr">
-                    <a:lnR w="9525">
-                      <a:solidFill>
-                        <a:srgbClr val="FCFCFA"/>
-                      </a:solidFill>
-                      <a:prstDash val="solid"/>
-                    </a:lnR>
-                    <a:lnT w="9525">
-                      <a:solidFill>
-                        <a:srgbClr val="FCFCFA"/>
-                      </a:solidFill>
-                      <a:prstDash val="solid"/>
-                    </a:lnT>
-                    <a:lnB w="7620">
-                      <a:solidFill>
-                        <a:srgbClr val="E1E7E4"/>
-                      </a:solidFill>
-                      <a:prstDash val="solid"/>
-                    </a:lnB>
-                    <a:solidFill>
-                      <a:srgbClr val="EEF3F0"/>
-                    </a:solidFill>
-                  </a:tcPr>
-                </a:tc>
-                <a:tc>
-                  <a:txBody>
-                    <a:bodyPr lIns="133350" tIns="114300" rIns="152400" bIns="95250">
-                      <a:noAutofit/>
-                    </a:bodyPr>
-                    <a:lstStyle/>
-                    <a:p>
-                      <a:pPr algn="l"/>
-                      <a:r>
-                        <a:rPr sz="2025" b="1">
-                          <a:solidFill>
-                            <a:srgbClr val="23343A"/>
-                          </a:solidFill>
-                          <a:latin typeface="Microsoft JhengHei"/>
-                          <a:ea typeface="Microsoft JhengHei"/>
-                          <a:cs typeface="Microsoft JhengHei"/>
-                        </a:rPr>
-                        <a:t>價格答案</a:t>
-                      </a:r>
-                    </a:p>
-                  </a:txBody>
-                  <a:tcPr marL="91440" marR="91440" marT="45720" marB="45720" anchor="ctr">
-                    <a:lnR w="9525">
-                      <a:solidFill>
-                        <a:srgbClr val="FCFCFA"/>
-                      </a:solidFill>
-                      <a:prstDash val="solid"/>
-                    </a:lnR>
-                    <a:lnT w="9525">
-                      <a:solidFill>
-                        <a:srgbClr val="FCFCFA"/>
-                      </a:solidFill>
-                      <a:prstDash val="solid"/>
-                    </a:lnT>
-                    <a:lnB w="7620">
-                      <a:solidFill>
-                        <a:srgbClr val="E1E7E4"/>
-                      </a:solidFill>
-                      <a:prstDash val="solid"/>
-                    </a:lnB>
-                    <a:solidFill>
-                      <a:srgbClr val="EEF3F0"/>
-                    </a:solidFill>
-                  </a:tcPr>
-                </a:tc>
-                <a:tc>
-                  <a:txBody>
-                    <a:bodyPr lIns="133350" tIns="114300" rIns="152400" bIns="95250">
-                      <a:noAutofit/>
-                    </a:bodyPr>
-                    <a:lstStyle/>
-                    <a:p>
-                      <a:pPr algn="l"/>
-                      <a:r>
-                        <a:rPr sz="2025" b="1">
-                          <a:solidFill>
-                            <a:srgbClr val="23343A"/>
-                          </a:solidFill>
-                          <a:latin typeface="Microsoft JhengHei"/>
-                          <a:ea typeface="Microsoft JhengHei"/>
-                          <a:cs typeface="Microsoft JhengHei"/>
-                        </a:rPr>
-                        <a:t>用途</a:t>
-                      </a:r>
-                    </a:p>
-                  </a:txBody>
-                  <a:tcPr marL="91440" marR="91440" marT="45720" marB="45720" anchor="ctr">
-                    <a:lnR w="9525">
-                      <a:solidFill>
-                        <a:srgbClr val="FCFCFA"/>
-                      </a:solidFill>
-                      <a:prstDash val="solid"/>
-                    </a:lnR>
-                    <a:lnT w="9525">
-                      <a:solidFill>
-                        <a:srgbClr val="FCFCFA"/>
-                      </a:solidFill>
-                      <a:prstDash val="solid"/>
-                    </a:lnT>
-                    <a:lnB w="7620">
-                      <a:solidFill>
-                        <a:srgbClr val="E1E7E4"/>
-                      </a:solidFill>
-                      <a:prstDash val="solid"/>
-                    </a:lnB>
-                    <a:solidFill>
-                      <a:srgbClr val="EEF3F0"/>
-                    </a:solidFill>
-                  </a:tcPr>
-                </a:tc>
-              </a:tr>
-              <a:tr h="666750">
-                <a:tc>
-                  <a:txBody>
-                    <a:bodyPr lIns="133350" tIns="114300" rIns="152400" bIns="95250">
-                      <a:noAutofit/>
-                    </a:bodyPr>
-                    <a:lstStyle/>
-                    <a:p>
-                      <a:pPr algn="l"/>
-                      <a:r>
-                        <a:rPr sz="2025" b="0">
-                          <a:solidFill>
-                            <a:srgbClr val="3A4A4E"/>
-                          </a:solidFill>
-                          <a:latin typeface="Microsoft JhengHei"/>
-                          <a:ea typeface="Microsoft JhengHei"/>
-                          <a:cs typeface="Microsoft JhengHei"/>
-                        </a:rPr>
-                        <a:t>train</a:t>
-                      </a:r>
-                    </a:p>
-                  </a:txBody>
-                  <a:tcPr marL="91440" marR="91440" marT="45720" marB="45720" anchor="ctr">
-                    <a:lnL w="9525">
-                      <a:solidFill>
-                        <a:srgbClr val="FCFCFA"/>
-                      </a:solidFill>
-                      <a:prstDash val="solid"/>
-                    </a:lnL>
-                    <a:lnR w="9525">
-                      <a:solidFill>
-                        <a:srgbClr val="FCFCFA"/>
-                      </a:solidFill>
-                      <a:prstDash val="solid"/>
-                    </a:lnR>
-                    <a:lnB w="7620">
-                      <a:solidFill>
-                        <a:srgbClr val="E1E7E4"/>
-                      </a:solidFill>
-                      <a:prstDash val="solid"/>
-                    </a:lnB>
-                    <a:solidFill>
-                      <a:srgbClr val="FCFCFA"/>
-                    </a:solidFill>
-                  </a:tcPr>
-                </a:tc>
-                <a:tc>
-                  <a:txBody>
-                    <a:bodyPr lIns="133350" tIns="114300" rIns="152400" bIns="95250">
-                      <a:noAutofit/>
-                    </a:bodyPr>
-                    <a:lstStyle/>
-                    <a:p>
-                      <a:pPr algn="r"/>
-                      <a:r>
-                        <a:rPr sz="2025" b="0">
-                          <a:solidFill>
-                            <a:srgbClr val="3A4A4E"/>
-                          </a:solidFill>
-                          <a:latin typeface="Microsoft JhengHei"/>
-                          <a:ea typeface="Microsoft JhengHei"/>
-                          <a:cs typeface="Microsoft JhengHei"/>
-                        </a:rPr>
-                        <a:t>455,787</a:t>
-                      </a:r>
-                    </a:p>
-                  </a:txBody>
-                  <a:tcPr marL="91440" marR="91440" marT="45720" marB="45720" anchor="ctr">
-                    <a:lnR w="9525">
-                      <a:solidFill>
-                        <a:srgbClr val="FCFCFA"/>
-                      </a:solidFill>
-                      <a:prstDash val="solid"/>
-                    </a:lnR>
-                    <a:lnB w="7620">
-                      <a:solidFill>
-                        <a:srgbClr val="E1E7E4"/>
-                      </a:solidFill>
-                      <a:prstDash val="solid"/>
-                    </a:lnB>
-                    <a:solidFill>
-                      <a:srgbClr val="FCFCFA"/>
-                    </a:solidFill>
-                  </a:tcPr>
-                </a:tc>
-                <a:tc>
-                  <a:txBody>
-                    <a:bodyPr lIns="133350" tIns="114300" rIns="152400" bIns="95250">
-                      <a:noAutofit/>
-                    </a:bodyPr>
-                    <a:lstStyle/>
-                    <a:p>
-                      <a:pPr algn="l"/>
-                      <a:r>
-                        <a:rPr sz="2025" b="0">
-                          <a:solidFill>
-                            <a:srgbClr val="3A4A4E"/>
-                          </a:solidFill>
-                          <a:latin typeface="Microsoft JhengHei"/>
-                          <a:ea typeface="Microsoft JhengHei"/>
-                          <a:cs typeface="Microsoft JhengHei"/>
-                        </a:rPr>
-                        <a:t>有</a:t>
-                      </a:r>
-                    </a:p>
-                  </a:txBody>
-                  <a:tcPr marL="91440" marR="91440" marT="45720" marB="45720" anchor="ctr">
-                    <a:lnR w="9525">
-                      <a:solidFill>
-                        <a:srgbClr val="FCFCFA"/>
-                      </a:solidFill>
-                      <a:prstDash val="solid"/>
-                    </a:lnR>
-                    <a:lnB w="7620">
-                      <a:solidFill>
-                        <a:srgbClr val="E1E7E4"/>
-                      </a:solidFill>
-                      <a:prstDash val="solid"/>
-                    </a:lnB>
-                    <a:solidFill>
-                      <a:srgbClr val="FCFCFA"/>
-                    </a:solidFill>
-                  </a:tcPr>
-                </a:tc>
-                <a:tc>
-                  <a:txBody>
-                    <a:bodyPr lIns="133350" tIns="114300" rIns="152400" bIns="95250">
-                      <a:noAutofit/>
-                    </a:bodyPr>
-                    <a:lstStyle/>
-                    <a:p>
-                      <a:pPr algn="l"/>
-                      <a:r>
-                        <a:rPr sz="2025" b="0">
-                          <a:solidFill>
-                            <a:srgbClr val="3A4A4E"/>
-                          </a:solidFill>
-                          <a:latin typeface="Microsoft JhengHei"/>
-                          <a:ea typeface="Microsoft JhengHei"/>
-                          <a:cs typeface="Microsoft JhengHei"/>
-                        </a:rPr>
-                        <a:t>學習與歷史回測</a:t>
-                      </a:r>
-                    </a:p>
-                  </a:txBody>
-                  <a:tcPr marL="91440" marR="91440" marT="45720" marB="45720" anchor="ctr">
-                    <a:lnR w="9525">
-                      <a:solidFill>
-                        <a:srgbClr val="FCFCFA"/>
-                      </a:solidFill>
-                      <a:prstDash val="solid"/>
-                    </a:lnR>
-                    <a:lnB w="7620">
-                      <a:solidFill>
-                        <a:srgbClr val="E1E7E4"/>
-                      </a:solidFill>
-                      <a:prstDash val="solid"/>
-                    </a:lnB>
-                    <a:solidFill>
-                      <a:srgbClr val="FCFCFA"/>
-                    </a:solidFill>
-                  </a:tcPr>
-                </a:tc>
-              </a:tr>
-              <a:tr h="666750">
-                <a:tc>
-                  <a:txBody>
-                    <a:bodyPr lIns="133350" tIns="114300" rIns="152400" bIns="95250">
-                      <a:noAutofit/>
-                    </a:bodyPr>
-                    <a:lstStyle/>
-                    <a:p>
-                      <a:pPr algn="l"/>
-                      <a:r>
-                        <a:rPr sz="2025" b="0">
-                          <a:solidFill>
-                            <a:srgbClr val="3A4A4E"/>
-                          </a:solidFill>
-                          <a:latin typeface="Microsoft JhengHei"/>
-                          <a:ea typeface="Microsoft JhengHei"/>
-                          <a:cs typeface="Microsoft JhengHei"/>
-                        </a:rPr>
-                        <a:t>valid</a:t>
-                      </a:r>
-                    </a:p>
-                  </a:txBody>
-                  <a:tcPr marL="91440" marR="91440" marT="45720" marB="45720" anchor="ctr">
-                    <a:lnL w="9525">
-                      <a:solidFill>
-                        <a:srgbClr val="FCFCFA"/>
-                      </a:solidFill>
-                      <a:prstDash val="solid"/>
-                    </a:lnL>
-                    <a:lnR w="9525">
-                      <a:solidFill>
-                        <a:srgbClr val="FCFCFA"/>
-                      </a:solidFill>
-                      <a:prstDash val="solid"/>
-                    </a:lnR>
-                    <a:lnB w="7620">
-                      <a:solidFill>
-                        <a:srgbClr val="E1E7E4"/>
-                      </a:solidFill>
-                      <a:prstDash val="solid"/>
-                    </a:lnB>
-                    <a:solidFill>
-                      <a:srgbClr val="FCFCFA"/>
-                    </a:solidFill>
-                  </a:tcPr>
-                </a:tc>
-                <a:tc>
-                  <a:txBody>
-                    <a:bodyPr lIns="133350" tIns="114300" rIns="152400" bIns="95250">
-                      <a:noAutofit/>
-                    </a:bodyPr>
-                    <a:lstStyle/>
-                    <a:p>
-                      <a:pPr algn="r"/>
-                      <a:r>
-                        <a:rPr sz="2025" b="0">
-                          <a:solidFill>
-                            <a:srgbClr val="3A4A4E"/>
-                          </a:solidFill>
-                          <a:latin typeface="Microsoft JhengHei"/>
-                          <a:ea typeface="Microsoft JhengHei"/>
-                          <a:cs typeface="Microsoft JhengHei"/>
-                        </a:rPr>
-                        <a:t>11,994</a:t>
-                      </a:r>
-                    </a:p>
-                  </a:txBody>
-                  <a:tcPr marL="91440" marR="91440" marT="45720" marB="45720" anchor="ctr">
-                    <a:lnR w="9525">
-                      <a:solidFill>
-                        <a:srgbClr val="FCFCFA"/>
-                      </a:solidFill>
-                      <a:prstDash val="solid"/>
-                    </a:lnR>
-                    <a:lnB w="7620">
-                      <a:solidFill>
-                        <a:srgbClr val="E1E7E4"/>
-                      </a:solidFill>
-                      <a:prstDash val="solid"/>
-                    </a:lnB>
-                    <a:solidFill>
-                      <a:srgbClr val="FCFCFA"/>
-                    </a:solidFill>
-                  </a:tcPr>
-                </a:tc>
-                <a:tc>
-                  <a:txBody>
-                    <a:bodyPr lIns="133350" tIns="114300" rIns="152400" bIns="95250">
-                      <a:noAutofit/>
-                    </a:bodyPr>
-                    <a:lstStyle/>
-                    <a:p>
-                      <a:pPr algn="l"/>
-                      <a:r>
-                        <a:rPr sz="2025" b="0">
-                          <a:solidFill>
-                            <a:srgbClr val="3A4A4E"/>
-                          </a:solidFill>
-                          <a:latin typeface="Microsoft JhengHei"/>
-                          <a:ea typeface="Microsoft JhengHei"/>
-                          <a:cs typeface="Microsoft JhengHei"/>
-                        </a:rPr>
-                        <a:t>有</a:t>
-                      </a:r>
-                    </a:p>
-                  </a:txBody>
-                  <a:tcPr marL="91440" marR="91440" marT="45720" marB="45720" anchor="ctr">
-                    <a:lnR w="9525">
-                      <a:solidFill>
-                        <a:srgbClr val="FCFCFA"/>
-                      </a:solidFill>
-                      <a:prstDash val="solid"/>
-                    </a:lnR>
-                    <a:lnB w="7620">
-                      <a:solidFill>
-                        <a:srgbClr val="E1E7E4"/>
-                      </a:solidFill>
-                      <a:prstDash val="solid"/>
-                    </a:lnB>
-                    <a:solidFill>
-                      <a:srgbClr val="FCFCFA"/>
-                    </a:solidFill>
-                  </a:tcPr>
-                </a:tc>
-                <a:tc>
-                  <a:txBody>
-                    <a:bodyPr lIns="133350" tIns="114300" rIns="152400" bIns="95250">
-                      <a:noAutofit/>
-                    </a:bodyPr>
-                    <a:lstStyle/>
-                    <a:p>
-                      <a:pPr algn="l"/>
-                      <a:r>
-                        <a:rPr sz="2025" b="0">
-                          <a:solidFill>
-                            <a:srgbClr val="3A4A4E"/>
-                          </a:solidFill>
-                          <a:latin typeface="Microsoft JhengHei"/>
-                          <a:ea typeface="Microsoft JhengHei"/>
-                          <a:cs typeface="Microsoft JhengHei"/>
-                        </a:rPr>
-                        <a:t>最終訓練才合併</a:t>
-                      </a:r>
-                    </a:p>
-                  </a:txBody>
-                  <a:tcPr marL="91440" marR="91440" marT="45720" marB="45720" anchor="ctr">
-                    <a:lnR w="9525">
-                      <a:solidFill>
-                        <a:srgbClr val="FCFCFA"/>
-                      </a:solidFill>
-                      <a:prstDash val="solid"/>
-                    </a:lnR>
-                    <a:lnB w="7620">
-                      <a:solidFill>
-                        <a:srgbClr val="E1E7E4"/>
-                      </a:solidFill>
-                      <a:prstDash val="solid"/>
-                    </a:lnB>
-                    <a:solidFill>
-                      <a:srgbClr val="FCFCFA"/>
-                    </a:solidFill>
-                  </a:tcPr>
-                </a:tc>
-              </a:tr>
-              <a:tr h="666750">
-                <a:tc>
-                  <a:txBody>
-                    <a:bodyPr lIns="133350" tIns="114300" rIns="152400" bIns="95250">
-                      <a:noAutofit/>
-                    </a:bodyPr>
-                    <a:lstStyle/>
-                    <a:p>
-                      <a:pPr algn="l"/>
-                      <a:r>
-                        <a:rPr sz="2025" b="0">
-                          <a:solidFill>
-                            <a:srgbClr val="3A4A4E"/>
-                          </a:solidFill>
-                          <a:latin typeface="Microsoft JhengHei"/>
-                          <a:ea typeface="Microsoft JhengHei"/>
-                          <a:cs typeface="Microsoft JhengHei"/>
-                        </a:rPr>
-                        <a:t>test</a:t>
-                      </a:r>
-                    </a:p>
-                  </a:txBody>
-                  <a:tcPr marL="91440" marR="91440" marT="45720" marB="45720" anchor="ctr">
-                    <a:lnL w="9525">
-                      <a:solidFill>
-                        <a:srgbClr val="FCFCFA"/>
-                      </a:solidFill>
-                      <a:prstDash val="solid"/>
-                    </a:lnL>
-                    <a:lnR w="9525">
-                      <a:solidFill>
-                        <a:srgbClr val="FCFCFA"/>
-                      </a:solidFill>
-                      <a:prstDash val="solid"/>
-                    </a:lnR>
-                    <a:lnB w="7620">
-                      <a:solidFill>
-                        <a:srgbClr val="E1E7E4"/>
-                      </a:solidFill>
-                      <a:prstDash val="solid"/>
-                    </a:lnB>
-                    <a:solidFill>
-                      <a:srgbClr val="FCFCFA"/>
-                    </a:solidFill>
-                  </a:tcPr>
-                </a:tc>
-                <a:tc>
-                  <a:txBody>
-                    <a:bodyPr lIns="133350" tIns="114300" rIns="152400" bIns="95250">
-                      <a:noAutofit/>
-                    </a:bodyPr>
-                    <a:lstStyle/>
-                    <a:p>
-                      <a:pPr algn="r"/>
-                      <a:r>
-                        <a:rPr sz="2025" b="0">
-                          <a:solidFill>
-                            <a:srgbClr val="3A4A4E"/>
-                          </a:solidFill>
-                          <a:latin typeface="Microsoft JhengHei"/>
-                          <a:ea typeface="Microsoft JhengHei"/>
-                          <a:cs typeface="Microsoft JhengHei"/>
-                        </a:rPr>
-                        <a:t>47,073</a:t>
-                      </a:r>
-                    </a:p>
-                  </a:txBody>
-                  <a:tcPr marL="91440" marR="91440" marT="45720" marB="45720" anchor="ctr">
-                    <a:lnR w="9525">
-                      <a:solidFill>
-                        <a:srgbClr val="FCFCFA"/>
-                      </a:solidFill>
-                      <a:prstDash val="solid"/>
-                    </a:lnR>
-                    <a:lnB w="7620">
-                      <a:solidFill>
-                        <a:srgbClr val="E1E7E4"/>
-                      </a:solidFill>
-                      <a:prstDash val="solid"/>
-                    </a:lnB>
-                    <a:solidFill>
-                      <a:srgbClr val="FCFCFA"/>
-                    </a:solidFill>
-                  </a:tcPr>
-                </a:tc>
-                <a:tc>
-                  <a:txBody>
-                    <a:bodyPr lIns="133350" tIns="114300" rIns="152400" bIns="95250">
-                      <a:noAutofit/>
-                    </a:bodyPr>
-                    <a:lstStyle/>
-                    <a:p>
-                      <a:pPr algn="l"/>
-                      <a:r>
-                        <a:rPr sz="2025" b="0">
-                          <a:solidFill>
-                            <a:srgbClr val="3A4A4E"/>
-                          </a:solidFill>
-                          <a:latin typeface="Microsoft JhengHei"/>
-                          <a:ea typeface="Microsoft JhengHei"/>
-                          <a:cs typeface="Microsoft JhengHei"/>
-                        </a:rPr>
-                        <a:t>無</a:t>
-                      </a:r>
-                    </a:p>
-                  </a:txBody>
-                  <a:tcPr marL="91440" marR="91440" marT="45720" marB="45720" anchor="ctr">
-                    <a:lnR w="9525">
-                      <a:solidFill>
-                        <a:srgbClr val="FCFCFA"/>
-                      </a:solidFill>
-                      <a:prstDash val="solid"/>
-                    </a:lnR>
-                    <a:lnB w="7620">
-                      <a:solidFill>
-                        <a:srgbClr val="E1E7E4"/>
-                      </a:solidFill>
-                      <a:prstDash val="solid"/>
-                    </a:lnB>
-                    <a:solidFill>
-                      <a:srgbClr val="FCFCFA"/>
-                    </a:solidFill>
-                  </a:tcPr>
-                </a:tc>
-                <a:tc>
-                  <a:txBody>
-                    <a:bodyPr lIns="133350" tIns="114300" rIns="152400" bIns="95250">
-                      <a:noAutofit/>
-                    </a:bodyPr>
-                    <a:lstStyle/>
-                    <a:p>
-                      <a:pPr algn="l"/>
-                      <a:r>
-                        <a:rPr sz="2025" b="0">
-                          <a:solidFill>
-                            <a:srgbClr val="3A4A4E"/>
-                          </a:solidFill>
-                          <a:latin typeface="Microsoft JhengHei"/>
-                          <a:ea typeface="Microsoft JhengHei"/>
-                          <a:cs typeface="Microsoft JhengHei"/>
-                        </a:rPr>
-                        <a:t>每筆均須估價</a:t>
-                      </a:r>
-                    </a:p>
-                  </a:txBody>
-                  <a:tcPr marL="91440" marR="91440" marT="45720" marB="45720" anchor="ctr">
-                    <a:lnR w="9525">
-                      <a:solidFill>
-                        <a:srgbClr val="FCFCFA"/>
-                      </a:solidFill>
-                      <a:prstDash val="solid"/>
-                    </a:lnR>
-                    <a:lnB w="7620">
-                      <a:solidFill>
-                        <a:srgbClr val="E1E7E4"/>
-                      </a:solidFill>
-                      <a:prstDash val="solid"/>
-                    </a:lnB>
-                    <a:solidFill>
-                      <a:srgbClr val="FCFCFA"/>
-                    </a:solidFill>
-                  </a:tcPr>
-                </a:tc>
-              </a:tr>
-              <a:tr h="666750">
-                <a:tc>
-                  <a:txBody>
-                    <a:bodyPr lIns="133350" tIns="114300" rIns="152400" bIns="95250">
-                      <a:noAutofit/>
-                    </a:bodyPr>
-                    <a:lstStyle/>
-                    <a:p>
-                      <a:pPr algn="l"/>
-                      <a:r>
-                        <a:rPr sz="2025" b="0">
-                          <a:solidFill>
-                            <a:srgbClr val="3A4A4E"/>
-                          </a:solidFill>
-                          <a:latin typeface="Microsoft JhengHei"/>
-                          <a:ea typeface="Microsoft JhengHei"/>
-                          <a:cs typeface="Microsoft JhengHei"/>
-                        </a:rPr>
-                        <a:t>sample</a:t>
-                      </a:r>
-                    </a:p>
-                  </a:txBody>
-                  <a:tcPr marL="91440" marR="91440" marT="45720" marB="45720" anchor="ctr">
-                    <a:lnL w="9525">
-                      <a:solidFill>
-                        <a:srgbClr val="FCFCFA"/>
-                      </a:solidFill>
-                      <a:prstDash val="solid"/>
-                    </a:lnL>
-                    <a:lnR w="9525">
-                      <a:solidFill>
-                        <a:srgbClr val="FCFCFA"/>
-                      </a:solidFill>
-                      <a:prstDash val="solid"/>
-                    </a:lnR>
-                    <a:lnB w="9525">
-                      <a:solidFill>
-                        <a:srgbClr val="FCFCFA"/>
-                      </a:solidFill>
-                      <a:prstDash val="solid"/>
-                    </a:lnB>
-                    <a:solidFill>
-                      <a:srgbClr val="FCFCFA"/>
-                    </a:solidFill>
-                  </a:tcPr>
-                </a:tc>
-                <a:tc>
-                  <a:txBody>
-                    <a:bodyPr lIns="133350" tIns="114300" rIns="152400" bIns="95250">
-                      <a:noAutofit/>
-                    </a:bodyPr>
-                    <a:lstStyle/>
-                    <a:p>
-                      <a:pPr algn="r"/>
-                      <a:r>
-                        <a:rPr sz="2025" b="0">
-                          <a:solidFill>
-                            <a:srgbClr val="3A4A4E"/>
-                          </a:solidFill>
-                          <a:latin typeface="Microsoft JhengHei"/>
-                          <a:ea typeface="Microsoft JhengHei"/>
-                          <a:cs typeface="Microsoft JhengHei"/>
-                        </a:rPr>
-                        <a:t>47,073</a:t>
-                      </a:r>
-                    </a:p>
-                  </a:txBody>
-                  <a:tcPr marL="91440" marR="91440" marT="45720" marB="45720" anchor="ctr">
-                    <a:lnR w="9525">
-                      <a:solidFill>
-                        <a:srgbClr val="FCFCFA"/>
-                      </a:solidFill>
-                      <a:prstDash val="solid"/>
-                    </a:lnR>
-                    <a:lnB w="9525">
-                      <a:solidFill>
-                        <a:srgbClr val="FCFCFA"/>
-                      </a:solidFill>
-                      <a:prstDash val="solid"/>
-                    </a:lnB>
-                    <a:solidFill>
-                      <a:srgbClr val="FCFCFA"/>
-                    </a:solidFill>
-                  </a:tcPr>
-                </a:tc>
-                <a:tc>
-                  <a:txBody>
-                    <a:bodyPr lIns="133350" tIns="114300" rIns="152400" bIns="95250">
-                      <a:noAutofit/>
-                    </a:bodyPr>
-                    <a:lstStyle/>
-                    <a:p>
-                      <a:pPr algn="l"/>
-                      <a:r>
-                        <a:rPr sz="2025" b="0">
-                          <a:solidFill>
-                            <a:srgbClr val="3A4A4E"/>
-                          </a:solidFill>
-                          <a:latin typeface="Microsoft JhengHei"/>
-                          <a:ea typeface="Microsoft JhengHei"/>
-                          <a:cs typeface="Microsoft JhengHei"/>
-                        </a:rPr>
-                        <a:t>格式示例</a:t>
-                      </a:r>
-                    </a:p>
-                  </a:txBody>
-                  <a:tcPr marL="91440" marR="91440" marT="45720" marB="45720" anchor="ctr">
-                    <a:lnR w="9525">
-                      <a:solidFill>
-                        <a:srgbClr val="FCFCFA"/>
-                      </a:solidFill>
-                      <a:prstDash val="solid"/>
-                    </a:lnR>
-                    <a:lnB w="9525">
-                      <a:solidFill>
-                        <a:srgbClr val="FCFCFA"/>
-                      </a:solidFill>
-                      <a:prstDash val="solid"/>
-                    </a:lnB>
-                    <a:solidFill>
-                      <a:srgbClr val="FCFCFA"/>
-                    </a:solidFill>
-                  </a:tcPr>
-                </a:tc>
-                <a:tc>
-                  <a:txBody>
-                    <a:bodyPr lIns="133350" tIns="114300" rIns="152400" bIns="95250">
-                      <a:noAutofit/>
-                    </a:bodyPr>
-                    <a:lstStyle/>
-                    <a:p>
-                      <a:pPr algn="l"/>
-                      <a:r>
-                        <a:rPr sz="2025" b="0">
-                          <a:solidFill>
-                            <a:srgbClr val="3A4A4E"/>
-                          </a:solidFill>
-                          <a:latin typeface="Microsoft JhengHei"/>
-                          <a:ea typeface="Microsoft JhengHei"/>
-                          <a:cs typeface="Microsoft JhengHei"/>
-                        </a:rPr>
-                        <a:t>指定編號與欄位</a:t>
-                      </a:r>
-                    </a:p>
-                  </a:txBody>
-                  <a:tcPr marL="91440" marR="91440" marT="45720" marB="45720" anchor="ctr">
-                    <a:lnR w="9525">
-                      <a:solidFill>
-                        <a:srgbClr val="FCFCFA"/>
-                      </a:solidFill>
-                      <a:prstDash val="solid"/>
-                    </a:lnR>
-                    <a:lnB w="9525">
-                      <a:solidFill>
-                        <a:srgbClr val="FCFCFA"/>
-                      </a:solidFill>
-                      <a:prstDash val="solid"/>
-                    </a:lnB>
-                    <a:solidFill>
-                      <a:srgbClr val="FCFCFA"/>
-                    </a:solidFill>
-                  </a:tcPr>
-                </a:tc>
-              </a:tr>
-            </a:tbl>
-          </a:graphicData>
-        </a:graphic>
-      </p:graphicFrame>
-      <p:sp>
-        <p:nvSpPr>
-          <p:cNvPr id="4" name="body">
-            <a:extLst xmlns:a="http://schemas.openxmlformats.org/drawingml/2006/main">
-              <a:ext uri="{FF2B5EF4-FFF2-40B4-BE49-F238E27FC236}">
-                <a16:creationId xmlns:a16="http://schemas.microsoft.com/office/drawing/2014/main" id="{245FF78D-D04C-4A32-AAB6-8E3D1B63206E}"/>
-              </a:ext>
-            </a:extLst>
-          </p:cNvPr>
-          <p:cNvSpPr>
-            <a:spLocks xmlns:a="http://schemas.openxmlformats.org/drawingml/2006/main" noGrp="1"/>
-          </p:cNvSpPr>
-          <p:nvPr/>
-        </p:nvSpPr>
-        <p:spPr>
-          <a:xfrm xmlns:a="http://schemas.openxmlformats.org/drawingml/2006/main">
-            <a:off x="762000" y="5972175"/>
-            <a:ext cx="10572750" cy="571500"/>
-          </a:xfrm>
-          <a:prstGeom xmlns:a="http://schemas.openxmlformats.org/drawingml/2006/main" prst="rect">
-            <a:avLst/>
-          </a:prstGeom>
-          <a:noFill xmlns:a="http://schemas.openxmlformats.org/drawingml/2006/main"/>
-          <a:ln xmlns:a="http://schemas.openxmlformats.org/drawingml/2006/main" w="0">
-            <a:noFill/>
-          </a:ln>
-        </p:spPr>
-        <p:txBody>
-          <a:bodyPr xmlns:a="http://schemas.openxmlformats.org/drawingml/2006/main" wrap="square" lIns="0" tIns="0" rIns="0" bIns="0" anchor="t">
-            <a:noAutofit/>
-          </a:bodyPr>
-          <a:lstStyle xmlns:a="http://schemas.openxmlformats.org/drawingml/2006/main">
-            <a:defPPr algn="l">
-              <a:defRPr sz="1725" b="0">
-                <a:solidFill>
-                  <a:srgbClr val="718082"/>
-                </a:solidFill>
-                <a:latin typeface="Microsoft JhengHei"/>
-                <a:ea typeface="Microsoft JhengHei"/>
-                <a:cs typeface="Microsoft JhengHei"/>
-              </a:defRPr>
-            </a:defPPr>
-          </a:lstStyle>
-          <a:p xmlns:a="http://schemas.openxmlformats.org/drawingml/2006/main">
-            <a:pPr algn="l">
-              <a:defRPr sz="1725" b="0">
-                <a:solidFill>
-                  <a:srgbClr val="718082"/>
-                </a:solidFill>
-                <a:latin typeface="Microsoft JhengHei"/>
-                <a:ea typeface="Microsoft JhengHei"/>
-                <a:cs typeface="Microsoft JhengHei"/>
-              </a:defRPr>
-            </a:pPr>
-            <a:r>
-              <a:rPr sz="1725" b="0">
-                <a:solidFill>
-                  <a:srgbClr val="718082"/>
-                </a:solidFill>
-                <a:latin typeface="Microsoft JhengHei"/>
-                <a:ea typeface="Microsoft JhengHei"/>
-                <a:cs typeface="Microsoft JhengHei"/>
-              </a:rPr>
-              <a:t>Public／Private 約以 test 的30%／70%評分，與課程 valid 的用途不同。</a:t>
-            </a:r>
-          </a:p>
-        </p:txBody>
-      </p:sp>
-    </p:spTree>
-    <p:extLst>
-      <p:ext uri="{BB962C8B-B14F-4D97-AF65-F5344CB8AC3E}">
-        <p14:creationId xmlns:p14="http://schemas.microsoft.com/office/powerpoint/2010/main" val="538737192"/>
-      </p:ext>
-    </p:extLst>
-  </p:cSld>
-</p:sld>
-</file>
-
-<file path=ppt/slides/slide5.xml><?xml version="1.0" encoding="utf-8"?>
-<p:sld xmlns:p="http://schemas.openxmlformats.org/presentationml/2006/main">
-  <p:cSld>
-    <p:bg>
-      <p:bgPr>
-        <a:solidFill xmlns:a="http://schemas.openxmlformats.org/drawingml/2006/main">
-          <a:srgbClr val="FCFCFA"/>
-        </a:solidFill>
-      </p:bgPr>
-    </p:bg>
-    <p:spTree>
-      <p:nvGrpSpPr>
-        <p:cNvPr id="1" name=""/>
-        <p:cNvGrpSpPr/>
-        <p:nvPr/>
-      </p:nvGrpSpPr>
-      <p:grpSpPr>
-        <a:xfrm xmlns:a="http://schemas.openxmlformats.org/drawingml/2006/main"/>
-      </p:grpSpPr>
-      <p:sp>
-        <p:nvSpPr>
-          <p:cNvPr id="13" name="slide-title">
-            <a:extLst xmlns:a="http://schemas.openxmlformats.org/drawingml/2006/main">
-              <a:ext uri="{FF2B5EF4-FFF2-40B4-BE49-F238E27FC236}">
-                <a16:creationId xmlns:a16="http://schemas.microsoft.com/office/drawing/2014/main" id="{01572E6F-BFCD-46AC-9460-A0E223B821AD}"/>
-              </a:ext>
-            </a:extLst>
-          </p:cNvPr>
-          <p:cNvSpPr>
-            <a:spLocks xmlns:a="http://schemas.openxmlformats.org/drawingml/2006/main" noGrp="1"/>
-          </p:cNvSpPr>
-          <p:nvPr/>
-        </p:nvSpPr>
-        <p:spPr>
-          <a:xfrm xmlns:a="http://schemas.openxmlformats.org/drawingml/2006/main">
-            <a:off x="762000" y="457200"/>
-            <a:ext cx="10668000" cy="723900"/>
-          </a:xfrm>
-          <a:prstGeom xmlns:a="http://schemas.openxmlformats.org/drawingml/2006/main" prst="rect">
-            <a:avLst/>
-          </a:prstGeom>
-          <a:noFill xmlns:a="http://schemas.openxmlformats.org/drawingml/2006/main"/>
-          <a:ln xmlns:a="http://schemas.openxmlformats.org/drawingml/2006/main" w="0">
-            <a:noFill/>
-          </a:ln>
-        </p:spPr>
-        <p:txBody>
-          <a:bodyPr xmlns:a="http://schemas.openxmlformats.org/drawingml/2006/main" wrap="square" lIns="0" tIns="0" rIns="0" bIns="0" anchor="t">
-            <a:noAutofit/>
-          </a:bodyPr>
-          <a:lstStyle xmlns:a="http://schemas.openxmlformats.org/drawingml/2006/main">
-            <a:defPPr algn="l">
-              <a:defRPr sz="3300" b="1">
-                <a:solidFill>
-                  <a:srgbClr val="23343A"/>
-                </a:solidFill>
-                <a:latin typeface="Microsoft JhengHei"/>
-                <a:ea typeface="Microsoft JhengHei"/>
-                <a:cs typeface="Microsoft JhengHei"/>
-              </a:defRPr>
-            </a:defPPr>
-          </a:lstStyle>
-          <a:p xmlns:a="http://schemas.openxmlformats.org/drawingml/2006/main">
-            <a:pPr algn="l">
-              <a:defRPr sz="3300" b="1">
-                <a:solidFill>
-                  <a:srgbClr val="23343A"/>
-                </a:solidFill>
-                <a:latin typeface="Microsoft JhengHei"/>
-                <a:ea typeface="Microsoft JhengHei"/>
-                <a:cs typeface="Microsoft JhengHei"/>
-              </a:defRPr>
-            </a:pPr>
-            <a:r>
-              <a:rPr sz="3300" b="1">
-                <a:solidFill>
-                  <a:srgbClr val="23343A"/>
-                </a:solidFill>
-                <a:latin typeface="Microsoft JhengHei"/>
-                <a:ea typeface="Microsoft JhengHei"/>
-                <a:cs typeface="Microsoft JhengHei"/>
-              </a:rPr>
-              <a:t>表頭排除與完全去重</a:t>
-            </a:r>
-          </a:p>
-        </p:txBody>
-      </p:sp>
-      <p:sp>
-        <p:nvSpPr>
-          <p:cNvPr id="2" name="body">
-            <a:extLst xmlns:a="http://schemas.openxmlformats.org/drawingml/2006/main">
-              <a:ext uri="{FF2B5EF4-FFF2-40B4-BE49-F238E27FC236}">
-                <a16:creationId xmlns:a16="http://schemas.microsoft.com/office/drawing/2014/main" id="{9A61123A-E2AB-4D71-94AF-55911E828170}"/>
-              </a:ext>
-            </a:extLst>
-          </p:cNvPr>
-          <p:cNvSpPr>
-            <a:spLocks xmlns:a="http://schemas.openxmlformats.org/drawingml/2006/main" noGrp="1"/>
-          </p:cNvSpPr>
-          <p:nvPr/>
-        </p:nvSpPr>
-        <p:spPr>
-          <a:xfrm xmlns:a="http://schemas.openxmlformats.org/drawingml/2006/main">
-            <a:off x="10953750" y="6419850"/>
-            <a:ext cx="476250" cy="238125"/>
-          </a:xfrm>
-          <a:prstGeom xmlns:a="http://schemas.openxmlformats.org/drawingml/2006/main" prst="rect">
-            <a:avLst/>
-          </a:prstGeom>
-          <a:noFill xmlns:a="http://schemas.openxmlformats.org/drawingml/2006/main"/>
-          <a:ln xmlns:a="http://schemas.openxmlformats.org/drawingml/2006/main" w="0">
-            <a:noFill/>
-          </a:ln>
-        </p:spPr>
-        <p:txBody>
-          <a:bodyPr xmlns:a="http://schemas.openxmlformats.org/drawingml/2006/main" wrap="square" lIns="0" tIns="0" rIns="0" bIns="0" anchor="t">
-            <a:noAutofit/>
-          </a:bodyPr>
-          <a:lstStyle xmlns:a="http://schemas.openxmlformats.org/drawingml/2006/main">
-            <a:defPPr algn="r">
-              <a:defRPr sz="1275" b="0">
-                <a:solidFill>
-                  <a:srgbClr val="718082"/>
-                </a:solidFill>
-                <a:latin typeface="Microsoft JhengHei"/>
-                <a:ea typeface="Microsoft JhengHei"/>
-                <a:cs typeface="Microsoft JhengHei"/>
-              </a:defRPr>
-            </a:defPPr>
-          </a:lstStyle>
-          <a:p xmlns:a="http://schemas.openxmlformats.org/drawingml/2006/main">
-            <a:pPr algn="r">
-              <a:defRPr sz="1275" b="0">
-                <a:solidFill>
-                  <a:srgbClr val="718082"/>
-                </a:solidFill>
-                <a:latin typeface="Microsoft JhengHei"/>
-                <a:ea typeface="Microsoft JhengHei"/>
-                <a:cs typeface="Microsoft JhengHei"/>
-              </a:defRPr>
-            </a:pPr>
-            <a:r>
-              <a:rPr sz="1275" b="0">
-                <a:solidFill>
-                  <a:srgbClr val="718082"/>
-                </a:solidFill>
-                <a:latin typeface="Microsoft JhengHei"/>
-                <a:ea typeface="Microsoft JhengHei"/>
-                <a:cs typeface="Microsoft JhengHei"/>
-              </a:rPr>
-              <a:t>05</a:t>
-            </a:r>
-          </a:p>
-        </p:txBody>
-      </p:sp>
-      <p:sp>
-        <p:nvSpPr>
-          <p:cNvPr id="3" name="body">
-            <a:extLst xmlns:a="http://schemas.openxmlformats.org/drawingml/2006/main">
-              <a:ext uri="{FF2B5EF4-FFF2-40B4-BE49-F238E27FC236}">
-                <a16:creationId xmlns:a16="http://schemas.microsoft.com/office/drawing/2014/main" id="{747C4E08-CE43-4265-8AA2-E4A483EC5998}"/>
-              </a:ext>
-            </a:extLst>
-          </p:cNvPr>
-          <p:cNvSpPr>
-            <a:spLocks xmlns:a="http://schemas.openxmlformats.org/drawingml/2006/main" noGrp="1"/>
-          </p:cNvSpPr>
-          <p:nvPr/>
-        </p:nvSpPr>
-        <p:spPr>
-          <a:xfrm xmlns:a="http://schemas.openxmlformats.org/drawingml/2006/main">
-            <a:off x="762000" y="1752600"/>
-            <a:ext cx="3048000" cy="714375"/>
-          </a:xfrm>
-          <a:prstGeom xmlns:a="http://schemas.openxmlformats.org/drawingml/2006/main" prst="rect">
-            <a:avLst/>
-          </a:prstGeom>
-          <a:noFill xmlns:a="http://schemas.openxmlformats.org/drawingml/2006/main"/>
-          <a:ln xmlns:a="http://schemas.openxmlformats.org/drawingml/2006/main" w="0">
-            <a:noFill/>
-          </a:ln>
-        </p:spPr>
-        <p:txBody>
-          <a:bodyPr xmlns:a="http://schemas.openxmlformats.org/drawingml/2006/main" wrap="square" lIns="0" tIns="0" rIns="0" bIns="0" anchor="t">
-            <a:noAutofit/>
-          </a:bodyPr>
-          <a:lstStyle xmlns:a="http://schemas.openxmlformats.org/drawingml/2006/main">
-            <a:defPPr algn="l">
-              <a:defRPr sz="3225" b="0">
-                <a:solidFill>
-                  <a:srgbClr val="23343A"/>
-                </a:solidFill>
-                <a:latin typeface="Microsoft JhengHei"/>
-                <a:ea typeface="Microsoft JhengHei"/>
-                <a:cs typeface="Microsoft JhengHei"/>
-              </a:defRPr>
-            </a:defPPr>
-          </a:lstStyle>
-          <a:p xmlns:a="http://schemas.openxmlformats.org/drawingml/2006/main">
-            <a:pPr algn="l">
-              <a:defRPr sz="3225" b="0">
-                <a:solidFill>
-                  <a:srgbClr val="23343A"/>
-                </a:solidFill>
-                <a:latin typeface="Microsoft JhengHei"/>
-                <a:ea typeface="Microsoft JhengHei"/>
-                <a:cs typeface="Microsoft JhengHei"/>
-              </a:defRPr>
-            </a:pPr>
-            <a:r>
-              <a:rPr sz="3225" b="0">
-                <a:solidFill>
-                  <a:srgbClr val="23343A"/>
-                </a:solidFill>
-                <a:latin typeface="Microsoft JhengHei"/>
-                <a:ea typeface="Microsoft JhengHei"/>
-                <a:cs typeface="Microsoft JhengHei"/>
-              </a:rPr>
-              <a:t>455,787</a:t>
-            </a:r>
-          </a:p>
-        </p:txBody>
-      </p:sp>
-      <p:sp>
-        <p:nvSpPr>
-          <p:cNvPr id="4" name="body">
-            <a:extLst xmlns:a="http://schemas.openxmlformats.org/drawingml/2006/main">
-              <a:ext uri="{FF2B5EF4-FFF2-40B4-BE49-F238E27FC236}">
-                <a16:creationId xmlns:a16="http://schemas.microsoft.com/office/drawing/2014/main" id="{FB0DEB68-A631-49EB-8EA0-FF3555601E2F}"/>
-              </a:ext>
-            </a:extLst>
-          </p:cNvPr>
-          <p:cNvSpPr>
-            <a:spLocks xmlns:a="http://schemas.openxmlformats.org/drawingml/2006/main" noGrp="1"/>
-          </p:cNvSpPr>
-          <p:nvPr/>
-        </p:nvSpPr>
-        <p:spPr>
-          <a:xfrm xmlns:a="http://schemas.openxmlformats.org/drawingml/2006/main">
-            <a:off x="3952875" y="1876425"/>
-            <a:ext cx="3714750" cy="523875"/>
-          </a:xfrm>
-          <a:prstGeom xmlns:a="http://schemas.openxmlformats.org/drawingml/2006/main" prst="rect">
-            <a:avLst/>
-          </a:prstGeom>
-          <a:noFill xmlns:a="http://schemas.openxmlformats.org/drawingml/2006/main"/>
-          <a:ln xmlns:a="http://schemas.openxmlformats.org/drawingml/2006/main" w="0">
-            <a:noFill/>
-          </a:ln>
-        </p:spPr>
-        <p:txBody>
-          <a:bodyPr xmlns:a="http://schemas.openxmlformats.org/drawingml/2006/main" wrap="square" lIns="0" tIns="0" rIns="0" bIns="0" anchor="t">
-            <a:noAutofit/>
-          </a:bodyPr>
-          <a:lstStyle xmlns:a="http://schemas.openxmlformats.org/drawingml/2006/main">
-            <a:defPPr algn="l">
-              <a:defRPr sz="2025" b="0">
-                <a:solidFill>
-                  <a:srgbClr val="3A4A4E"/>
-                </a:solidFill>
-                <a:latin typeface="Microsoft JhengHei"/>
-                <a:ea typeface="Microsoft JhengHei"/>
-                <a:cs typeface="Microsoft JhengHei"/>
-              </a:defRPr>
-            </a:defPPr>
-          </a:lstStyle>
-          <a:p xmlns:a="http://schemas.openxmlformats.org/drawingml/2006/main">
-            <a:pPr algn="l">
-              <a:defRPr sz="2025" b="0">
-                <a:solidFill>
-                  <a:srgbClr val="3A4A4E"/>
-                </a:solidFill>
-                <a:latin typeface="Microsoft JhengHei"/>
-                <a:ea typeface="Microsoft JhengHei"/>
-                <a:cs typeface="Microsoft JhengHei"/>
-              </a:defRPr>
-            </a:pPr>
-            <a:r>
-              <a:rPr sz="2025" b="0">
-                <a:solidFill>
-                  <a:srgbClr val="3A4A4E"/>
-                </a:solidFill>
-                <a:latin typeface="Microsoft JhengHei"/>
-                <a:ea typeface="Microsoft JhengHei"/>
-                <a:cs typeface="Microsoft JhengHei"/>
-              </a:rPr>
-              <a:t>原始訓練資料</a:t>
-            </a:r>
-          </a:p>
-        </p:txBody>
-      </p:sp>
-      <p:sp>
-        <p:nvSpPr>
-          <p:cNvPr id="5" name="body">
-            <a:extLst xmlns:a="http://schemas.openxmlformats.org/drawingml/2006/main">
-              <a:ext uri="{FF2B5EF4-FFF2-40B4-BE49-F238E27FC236}">
-                <a16:creationId xmlns:a16="http://schemas.microsoft.com/office/drawing/2014/main" id="{7004519E-6605-48F2-9DE9-4F4BD54447FA}"/>
-              </a:ext>
-            </a:extLst>
-          </p:cNvPr>
-          <p:cNvSpPr>
-            <a:spLocks xmlns:a="http://schemas.openxmlformats.org/drawingml/2006/main" noGrp="1"/>
-          </p:cNvSpPr>
-          <p:nvPr/>
-        </p:nvSpPr>
-        <p:spPr>
-          <a:xfrm xmlns:a="http://schemas.openxmlformats.org/drawingml/2006/main">
-            <a:off x="762000" y="2781300"/>
-            <a:ext cx="3048000" cy="714375"/>
-          </a:xfrm>
-          <a:prstGeom xmlns:a="http://schemas.openxmlformats.org/drawingml/2006/main" prst="rect">
-            <a:avLst/>
-          </a:prstGeom>
-          <a:noFill xmlns:a="http://schemas.openxmlformats.org/drawingml/2006/main"/>
-          <a:ln xmlns:a="http://schemas.openxmlformats.org/drawingml/2006/main" w="0">
-            <a:noFill/>
-          </a:ln>
-        </p:spPr>
-        <p:txBody>
-          <a:bodyPr xmlns:a="http://schemas.openxmlformats.org/drawingml/2006/main" wrap="square" lIns="0" tIns="0" rIns="0" bIns="0" anchor="t">
-            <a:noAutofit/>
-          </a:bodyPr>
-          <a:lstStyle xmlns:a="http://schemas.openxmlformats.org/drawingml/2006/main">
-            <a:defPPr algn="l">
-              <a:defRPr sz="3225" b="0">
-                <a:solidFill>
-                  <a:srgbClr val="23343A"/>
-                </a:solidFill>
-                <a:latin typeface="Microsoft JhengHei"/>
-                <a:ea typeface="Microsoft JhengHei"/>
-                <a:cs typeface="Microsoft JhengHei"/>
-              </a:defRPr>
-            </a:defPPr>
-          </a:lstStyle>
-          <a:p xmlns:a="http://schemas.openxmlformats.org/drawingml/2006/main">
-            <a:pPr algn="l">
-              <a:defRPr sz="3225" b="0">
-                <a:solidFill>
-                  <a:srgbClr val="23343A"/>
-                </a:solidFill>
-                <a:latin typeface="Microsoft JhengHei"/>
-                <a:ea typeface="Microsoft JhengHei"/>
-                <a:cs typeface="Microsoft JhengHei"/>
-              </a:defRPr>
-            </a:pPr>
-            <a:r>
-              <a:rPr sz="3225" b="0">
-                <a:solidFill>
-                  <a:srgbClr val="23343A"/>
-                </a:solidFill>
-                <a:latin typeface="Microsoft JhengHei"/>
-                <a:ea typeface="Microsoft JhengHei"/>
-                <a:cs typeface="Microsoft JhengHei"/>
-              </a:rPr>
-              <a:t>455,784</a:t>
-            </a:r>
-          </a:p>
-        </p:txBody>
-      </p:sp>
-      <p:sp>
-        <p:nvSpPr>
-          <p:cNvPr id="6" name="body">
-            <a:extLst xmlns:a="http://schemas.openxmlformats.org/drawingml/2006/main">
-              <a:ext uri="{FF2B5EF4-FFF2-40B4-BE49-F238E27FC236}">
-                <a16:creationId xmlns:a16="http://schemas.microsoft.com/office/drawing/2014/main" id="{7A7EB74F-3E96-4475-9FF3-206B02C83303}"/>
-              </a:ext>
-            </a:extLst>
-          </p:cNvPr>
-          <p:cNvSpPr>
-            <a:spLocks xmlns:a="http://schemas.openxmlformats.org/drawingml/2006/main" noGrp="1"/>
-          </p:cNvSpPr>
-          <p:nvPr/>
-        </p:nvSpPr>
-        <p:spPr>
-          <a:xfrm xmlns:a="http://schemas.openxmlformats.org/drawingml/2006/main">
-            <a:off x="3952875" y="2905125"/>
-            <a:ext cx="3714750" cy="523875"/>
-          </a:xfrm>
-          <a:prstGeom xmlns:a="http://schemas.openxmlformats.org/drawingml/2006/main" prst="rect">
-            <a:avLst/>
-          </a:prstGeom>
-          <a:noFill xmlns:a="http://schemas.openxmlformats.org/drawingml/2006/main"/>
-          <a:ln xmlns:a="http://schemas.openxmlformats.org/drawingml/2006/main" w="0">
-            <a:noFill/>
-          </a:ln>
-        </p:spPr>
-        <p:txBody>
-          <a:bodyPr xmlns:a="http://schemas.openxmlformats.org/drawingml/2006/main" wrap="square" lIns="0" tIns="0" rIns="0" bIns="0" anchor="t">
-            <a:noAutofit/>
-          </a:bodyPr>
-          <a:lstStyle xmlns:a="http://schemas.openxmlformats.org/drawingml/2006/main">
-            <a:defPPr algn="l">
-              <a:defRPr sz="2025" b="0">
-                <a:solidFill>
-                  <a:srgbClr val="3A4A4E"/>
-                </a:solidFill>
-                <a:latin typeface="Microsoft JhengHei"/>
-                <a:ea typeface="Microsoft JhengHei"/>
-                <a:cs typeface="Microsoft JhengHei"/>
-              </a:defRPr>
-            </a:defPPr>
-          </a:lstStyle>
-          <a:p xmlns:a="http://schemas.openxmlformats.org/drawingml/2006/main">
-            <a:pPr algn="l">
-              <a:defRPr sz="2025" b="0">
-                <a:solidFill>
-                  <a:srgbClr val="3A4A4E"/>
-                </a:solidFill>
-                <a:latin typeface="Microsoft JhengHei"/>
-                <a:ea typeface="Microsoft JhengHei"/>
-                <a:cs typeface="Microsoft JhengHei"/>
-              </a:defRPr>
-            </a:pPr>
-            <a:r>
-              <a:rPr sz="2025" b="0">
-                <a:solidFill>
-                  <a:srgbClr val="3A4A4E"/>
-                </a:solidFill>
-                <a:latin typeface="Microsoft JhengHei"/>
-                <a:ea typeface="Microsoft JhengHei"/>
-                <a:cs typeface="Microsoft JhengHei"/>
-              </a:rPr>
-              <a:t>排除3列表頭</a:t>
-            </a:r>
-          </a:p>
-        </p:txBody>
-      </p:sp>
-      <p:sp>
-        <p:nvSpPr>
-          <p:cNvPr id="7" name="body">
-            <a:extLst xmlns:a="http://schemas.openxmlformats.org/drawingml/2006/main">
-              <a:ext uri="{FF2B5EF4-FFF2-40B4-BE49-F238E27FC236}">
-                <a16:creationId xmlns:a16="http://schemas.microsoft.com/office/drawing/2014/main" id="{09854758-51E6-4B91-9EC7-DA8C34AB1F12}"/>
-              </a:ext>
-            </a:extLst>
-          </p:cNvPr>
-          <p:cNvSpPr>
-            <a:spLocks xmlns:a="http://schemas.openxmlformats.org/drawingml/2006/main" noGrp="1"/>
-          </p:cNvSpPr>
-          <p:nvPr/>
-        </p:nvSpPr>
-        <p:spPr>
-          <a:xfrm xmlns:a="http://schemas.openxmlformats.org/drawingml/2006/main">
-            <a:off x="762000" y="3810000"/>
-            <a:ext cx="3048000" cy="714375"/>
-          </a:xfrm>
-          <a:prstGeom xmlns:a="http://schemas.openxmlformats.org/drawingml/2006/main" prst="rect">
-            <a:avLst/>
-          </a:prstGeom>
-          <a:noFill xmlns:a="http://schemas.openxmlformats.org/drawingml/2006/main"/>
-          <a:ln xmlns:a="http://schemas.openxmlformats.org/drawingml/2006/main" w="0">
-            <a:noFill/>
-          </a:ln>
-        </p:spPr>
-        <p:txBody>
-          <a:bodyPr xmlns:a="http://schemas.openxmlformats.org/drawingml/2006/main" wrap="square" lIns="0" tIns="0" rIns="0" bIns="0" anchor="t">
-            <a:noAutofit/>
-          </a:bodyPr>
-          <a:lstStyle xmlns:a="http://schemas.openxmlformats.org/drawingml/2006/main">
-            <a:defPPr algn="l">
-              <a:defRPr sz="3225" b="1">
-                <a:solidFill>
-                  <a:srgbClr val="276E68"/>
-                </a:solidFill>
-                <a:latin typeface="Microsoft JhengHei"/>
-                <a:ea typeface="Microsoft JhengHei"/>
-                <a:cs typeface="Microsoft JhengHei"/>
-              </a:defRPr>
-            </a:defPPr>
-          </a:lstStyle>
-          <a:p xmlns:a="http://schemas.openxmlformats.org/drawingml/2006/main">
-            <a:pPr algn="l">
-              <a:defRPr sz="3225" b="1">
-                <a:solidFill>
-                  <a:srgbClr val="276E68"/>
-                </a:solidFill>
-                <a:latin typeface="Microsoft JhengHei"/>
-                <a:ea typeface="Microsoft JhengHei"/>
-                <a:cs typeface="Microsoft JhengHei"/>
-              </a:defRPr>
-            </a:pPr>
-            <a:r>
-              <a:rPr sz="3225" b="1">
-                <a:solidFill>
-                  <a:srgbClr val="276E68"/>
-                </a:solidFill>
-                <a:latin typeface="Microsoft JhengHei"/>
-                <a:ea typeface="Microsoft JhengHei"/>
-                <a:cs typeface="Microsoft JhengHei"/>
-              </a:rPr>
-              <a:t>455,255</a:t>
-            </a:r>
-          </a:p>
-        </p:txBody>
-      </p:sp>
-      <p:sp>
-        <p:nvSpPr>
-          <p:cNvPr id="8" name="body">
-            <a:extLst xmlns:a="http://schemas.openxmlformats.org/drawingml/2006/main">
-              <a:ext uri="{FF2B5EF4-FFF2-40B4-BE49-F238E27FC236}">
-                <a16:creationId xmlns:a16="http://schemas.microsoft.com/office/drawing/2014/main" id="{7F7AE002-D2A4-4711-A488-FCAEFCE80CC5}"/>
-              </a:ext>
-            </a:extLst>
-          </p:cNvPr>
-          <p:cNvSpPr>
-            <a:spLocks xmlns:a="http://schemas.openxmlformats.org/drawingml/2006/main" noGrp="1"/>
-          </p:cNvSpPr>
-          <p:nvPr/>
-        </p:nvSpPr>
-        <p:spPr>
-          <a:xfrm xmlns:a="http://schemas.openxmlformats.org/drawingml/2006/main">
-            <a:off x="3952875" y="3933825"/>
-            <a:ext cx="3714750" cy="523875"/>
-          </a:xfrm>
-          <a:prstGeom xmlns:a="http://schemas.openxmlformats.org/drawingml/2006/main" prst="rect">
-            <a:avLst/>
-          </a:prstGeom>
-          <a:noFill xmlns:a="http://schemas.openxmlformats.org/drawingml/2006/main"/>
-          <a:ln xmlns:a="http://schemas.openxmlformats.org/drawingml/2006/main" w="0">
-            <a:noFill/>
-          </a:ln>
-        </p:spPr>
-        <p:txBody>
-          <a:bodyPr xmlns:a="http://schemas.openxmlformats.org/drawingml/2006/main" wrap="square" lIns="0" tIns="0" rIns="0" bIns="0" anchor="t">
-            <a:noAutofit/>
-          </a:bodyPr>
-          <a:lstStyle xmlns:a="http://schemas.openxmlformats.org/drawingml/2006/main">
-            <a:defPPr algn="l">
-              <a:defRPr sz="2025" b="0">
-                <a:solidFill>
-                  <a:srgbClr val="3A4A4E"/>
-                </a:solidFill>
-                <a:latin typeface="Microsoft JhengHei"/>
-                <a:ea typeface="Microsoft JhengHei"/>
-                <a:cs typeface="Microsoft JhengHei"/>
-              </a:defRPr>
-            </a:defPPr>
-          </a:lstStyle>
-          <a:p xmlns:a="http://schemas.openxmlformats.org/drawingml/2006/main">
-            <a:pPr algn="l">
-              <a:defRPr sz="2025" b="0">
-                <a:solidFill>
-                  <a:srgbClr val="3A4A4E"/>
-                </a:solidFill>
-                <a:latin typeface="Microsoft JhengHei"/>
-                <a:ea typeface="Microsoft JhengHei"/>
-                <a:cs typeface="Microsoft JhengHei"/>
-              </a:defRPr>
-            </a:pPr>
-            <a:r>
-              <a:rPr sz="2025" b="0">
-                <a:solidFill>
-                  <a:srgbClr val="3A4A4E"/>
-                </a:solidFill>
-                <a:latin typeface="Microsoft JhengHei"/>
-                <a:ea typeface="Microsoft JhengHei"/>
-                <a:cs typeface="Microsoft JhengHei"/>
-              </a:rPr>
-              <a:t>移除529筆完全重複</a:t>
-            </a:r>
-          </a:p>
-        </p:txBody>
-      </p:sp>
-      <p:sp>
-        <p:nvSpPr>
-          <p:cNvPr id="9" name="body">
-            <a:extLst xmlns:a="http://schemas.openxmlformats.org/drawingml/2006/main">
-              <a:ext uri="{FF2B5EF4-FFF2-40B4-BE49-F238E27FC236}">
-                <a16:creationId xmlns:a16="http://schemas.microsoft.com/office/drawing/2014/main" id="{35C658EA-E268-41B1-9705-0A33CF90F2A4}"/>
-              </a:ext>
-            </a:extLst>
-          </p:cNvPr>
-          <p:cNvSpPr>
-            <a:spLocks xmlns:a="http://schemas.openxmlformats.org/drawingml/2006/main" noGrp="1"/>
-          </p:cNvSpPr>
-          <p:nvPr/>
-        </p:nvSpPr>
-        <p:spPr>
-          <a:xfrm xmlns:a="http://schemas.openxmlformats.org/drawingml/2006/main">
-            <a:off x="8315325" y="1838325"/>
-            <a:ext cx="3143250" cy="428625"/>
-          </a:xfrm>
-          <a:prstGeom xmlns:a="http://schemas.openxmlformats.org/drawingml/2006/main" prst="rect">
-            <a:avLst/>
-          </a:prstGeom>
-          <a:noFill xmlns:a="http://schemas.openxmlformats.org/drawingml/2006/main"/>
-          <a:ln xmlns:a="http://schemas.openxmlformats.org/drawingml/2006/main" w="0">
-            <a:noFill/>
-          </a:ln>
-        </p:spPr>
-        <p:txBody>
-          <a:bodyPr xmlns:a="http://schemas.openxmlformats.org/drawingml/2006/main" wrap="square" lIns="0" tIns="0" rIns="0" bIns="0" anchor="t">
-            <a:noAutofit/>
-          </a:bodyPr>
-          <a:lstStyle xmlns:a="http://schemas.openxmlformats.org/drawingml/2006/main">
-            <a:defPPr algn="l">
-              <a:defRPr sz="2100" b="1">
-                <a:solidFill>
-                  <a:srgbClr val="276E68"/>
-                </a:solidFill>
-                <a:latin typeface="Microsoft JhengHei"/>
-                <a:ea typeface="Microsoft JhengHei"/>
-                <a:cs typeface="Microsoft JhengHei"/>
-              </a:defRPr>
-            </a:defPPr>
-          </a:lstStyle>
-          <a:p xmlns:a="http://schemas.openxmlformats.org/drawingml/2006/main">
-            <a:pPr algn="l">
-              <a:defRPr sz="2100" b="1">
-                <a:solidFill>
-                  <a:srgbClr val="276E68"/>
-                </a:solidFill>
-                <a:latin typeface="Microsoft JhengHei"/>
-                <a:ea typeface="Microsoft JhengHei"/>
-                <a:cs typeface="Microsoft JhengHei"/>
-              </a:defRPr>
-            </a:pPr>
-            <a:r>
-              <a:rPr sz="2100" b="1">
-                <a:solidFill>
-                  <a:srgbClr val="276E68"/>
-                </a:solidFill>
-                <a:latin typeface="Microsoft JhengHei"/>
-                <a:ea typeface="Microsoft JhengHei"/>
-                <a:cs typeface="Microsoft JhengHei"/>
-              </a:rPr>
-              <a:t>最終有標籤資料</a:t>
-            </a:r>
-          </a:p>
-        </p:txBody>
-      </p:sp>
-      <p:sp>
-        <p:nvSpPr>
-          <p:cNvPr id="10" name="body">
-            <a:extLst xmlns:a="http://schemas.openxmlformats.org/drawingml/2006/main">
-              <a:ext uri="{FF2B5EF4-FFF2-40B4-BE49-F238E27FC236}">
-                <a16:creationId xmlns:a16="http://schemas.microsoft.com/office/drawing/2014/main" id="{DBF3D7EB-DA66-497C-8E54-2154EBE963D6}"/>
-              </a:ext>
-            </a:extLst>
-          </p:cNvPr>
-          <p:cNvSpPr>
-            <a:spLocks xmlns:a="http://schemas.openxmlformats.org/drawingml/2006/main" noGrp="1"/>
-          </p:cNvSpPr>
-          <p:nvPr/>
-        </p:nvSpPr>
-        <p:spPr>
-          <a:xfrm xmlns:a="http://schemas.openxmlformats.org/drawingml/2006/main">
-            <a:off x="8267700" y="2533650"/>
-            <a:ext cx="3190875" cy="952500"/>
-          </a:xfrm>
-          <a:prstGeom xmlns:a="http://schemas.openxmlformats.org/drawingml/2006/main" prst="rect">
-            <a:avLst/>
-          </a:prstGeom>
-          <a:noFill xmlns:a="http://schemas.openxmlformats.org/drawingml/2006/main"/>
-          <a:ln xmlns:a="http://schemas.openxmlformats.org/drawingml/2006/main" w="0">
-            <a:noFill/>
-          </a:ln>
-        </p:spPr>
-        <p:txBody>
-          <a:bodyPr xmlns:a="http://schemas.openxmlformats.org/drawingml/2006/main" wrap="square" lIns="0" tIns="0" rIns="0" bIns="0" anchor="t">
-            <a:noAutofit/>
-          </a:bodyPr>
-          <a:lstStyle xmlns:a="http://schemas.openxmlformats.org/drawingml/2006/main">
-            <a:defPPr algn="l">
-              <a:defRPr sz="4800" b="1">
-                <a:solidFill>
-                  <a:srgbClr val="276E68"/>
-                </a:solidFill>
-                <a:latin typeface="Microsoft JhengHei"/>
-                <a:ea typeface="Microsoft JhengHei"/>
-                <a:cs typeface="Microsoft JhengHei"/>
-              </a:defRPr>
-            </a:defPPr>
-          </a:lstStyle>
-          <a:p xmlns:a="http://schemas.openxmlformats.org/drawingml/2006/main">
-            <a:pPr algn="l">
-              <a:defRPr sz="4800" b="1">
-                <a:solidFill>
-                  <a:srgbClr val="276E68"/>
-                </a:solidFill>
-                <a:latin typeface="Microsoft JhengHei"/>
-                <a:ea typeface="Microsoft JhengHei"/>
-                <a:cs typeface="Microsoft JhengHei"/>
-              </a:defRPr>
-            </a:pPr>
-            <a:r>
-              <a:rPr sz="4800" b="1">
-                <a:solidFill>
-                  <a:srgbClr val="276E68"/>
-                </a:solidFill>
-                <a:latin typeface="Microsoft JhengHei"/>
-                <a:ea typeface="Microsoft JhengHei"/>
-                <a:cs typeface="Microsoft JhengHei"/>
-              </a:rPr>
-              <a:t>467,221</a:t>
-            </a:r>
-          </a:p>
-        </p:txBody>
-      </p:sp>
-      <p:sp>
-        <p:nvSpPr>
-          <p:cNvPr id="11" name="body">
-            <a:extLst xmlns:a="http://schemas.openxmlformats.org/drawingml/2006/main">
-              <a:ext uri="{FF2B5EF4-FFF2-40B4-BE49-F238E27FC236}">
-                <a16:creationId xmlns:a16="http://schemas.microsoft.com/office/drawing/2014/main" id="{58A12235-DFD0-47B0-8592-10A3B3008078}"/>
-              </a:ext>
-            </a:extLst>
-          </p:cNvPr>
-          <p:cNvSpPr>
-            <a:spLocks xmlns:a="http://schemas.openxmlformats.org/drawingml/2006/main" noGrp="1"/>
-          </p:cNvSpPr>
-          <p:nvPr/>
-        </p:nvSpPr>
-        <p:spPr>
-          <a:xfrm xmlns:a="http://schemas.openxmlformats.org/drawingml/2006/main">
-            <a:off x="8343900" y="3676650"/>
-            <a:ext cx="3143250" cy="1047750"/>
-          </a:xfrm>
-          <a:prstGeom xmlns:a="http://schemas.openxmlformats.org/drawingml/2006/main" prst="rect">
-            <a:avLst/>
-          </a:prstGeom>
-          <a:noFill xmlns:a="http://schemas.openxmlformats.org/drawingml/2006/main"/>
-          <a:ln xmlns:a="http://schemas.openxmlformats.org/drawingml/2006/main" w="0">
-            <a:noFill/>
-          </a:ln>
-        </p:spPr>
-        <p:txBody>
-          <a:bodyPr xmlns:a="http://schemas.openxmlformats.org/drawingml/2006/main" wrap="square" lIns="0" tIns="0" rIns="0" bIns="0" anchor="t">
-            <a:noAutofit/>
-          </a:bodyPr>
-          <a:lstStyle xmlns:a="http://schemas.openxmlformats.org/drawingml/2006/main">
-            <a:defPPr algn="l">
-              <a:defRPr sz="2025" b="0">
-                <a:solidFill>
-                  <a:srgbClr val="3A4A4E"/>
-                </a:solidFill>
-                <a:latin typeface="Microsoft JhengHei"/>
-                <a:ea typeface="Microsoft JhengHei"/>
-                <a:cs typeface="Microsoft JhengHei"/>
-              </a:defRPr>
-            </a:defPPr>
-          </a:lstStyle>
-          <a:p xmlns:a="http://schemas.openxmlformats.org/drawingml/2006/main">
-            <a:pPr algn="l">
-              <a:defRPr sz="2025" b="0">
-                <a:solidFill>
-                  <a:srgbClr val="3A4A4E"/>
-                </a:solidFill>
-                <a:latin typeface="Microsoft JhengHei"/>
-                <a:ea typeface="Microsoft JhengHei"/>
-                <a:cs typeface="Microsoft JhengHei"/>
-              </a:defRPr>
-            </a:pPr>
-            <a:r>
-              <a:rPr sz="2025" b="0">
-                <a:solidFill>
-                  <a:srgbClr val="3A4A4E"/>
-                </a:solidFill>
-                <a:latin typeface="Microsoft JhengHei"/>
-                <a:ea typeface="Microsoft JhengHei"/>
-                <a:cs typeface="Microsoft JhengHei"/>
-              </a:rPr>
-              <a:t>加入 valid 11,994筆</a:t>
-            </a:r>
-          </a:p>
-          <a:p xmlns:a="http://schemas.openxmlformats.org/drawingml/2006/main">
-            <a:pPr algn="l">
-              <a:defRPr sz="2025" b="0">
-                <a:solidFill>
-                  <a:srgbClr val="3A4A4E"/>
-                </a:solidFill>
-                <a:latin typeface="Microsoft JhengHei"/>
-                <a:ea typeface="Microsoft JhengHei"/>
-                <a:cs typeface="Microsoft JhengHei"/>
-              </a:defRPr>
-            </a:pPr>
-            <a:r>
-              <a:rPr sz="2025" b="0">
-                <a:solidFill>
-                  <a:srgbClr val="3A4A4E"/>
-                </a:solidFill>
-                <a:latin typeface="Microsoft JhengHei"/>
-                <a:ea typeface="Microsoft JhengHei"/>
-                <a:cs typeface="Microsoft JhengHei"/>
-              </a:rPr>
-              <a:t>再排除28筆跨檔重複</a:t>
-            </a:r>
-          </a:p>
-        </p:txBody>
-      </p:sp>
-      <p:sp>
-        <p:nvSpPr>
-          <p:cNvPr id="12" name="body">
-            <a:extLst xmlns:a="http://schemas.openxmlformats.org/drawingml/2006/main">
-              <a:ext uri="{FF2B5EF4-FFF2-40B4-BE49-F238E27FC236}">
-                <a16:creationId xmlns:a16="http://schemas.microsoft.com/office/drawing/2014/main" id="{AB7CA643-46F4-4C52-93FD-8B5279E66B57}"/>
-              </a:ext>
-            </a:extLst>
-          </p:cNvPr>
-          <p:cNvSpPr>
-            <a:spLocks xmlns:a="http://schemas.openxmlformats.org/drawingml/2006/main" noGrp="1"/>
-          </p:cNvSpPr>
-          <p:nvPr/>
-        </p:nvSpPr>
-        <p:spPr>
-          <a:xfrm xmlns:a="http://schemas.openxmlformats.org/drawingml/2006/main">
-            <a:off x="762000" y="5181600"/>
-            <a:ext cx="10668000" cy="876300"/>
-          </a:xfrm>
-          <a:prstGeom xmlns:a="http://schemas.openxmlformats.org/drawingml/2006/main" prst="rect">
-            <a:avLst/>
-          </a:prstGeom>
-          <a:noFill xmlns:a="http://schemas.openxmlformats.org/drawingml/2006/main"/>
-          <a:ln xmlns:a="http://schemas.openxmlformats.org/drawingml/2006/main" w="0">
-            <a:noFill/>
-          </a:ln>
-        </p:spPr>
-        <p:txBody>
-          <a:bodyPr xmlns:a="http://schemas.openxmlformats.org/drawingml/2006/main" wrap="square" lIns="0" tIns="0" rIns="0" bIns="0" anchor="t">
-            <a:noAutofit/>
-          </a:bodyPr>
-          <a:lstStyle xmlns:a="http://schemas.openxmlformats.org/drawingml/2006/main">
-            <a:defPPr algn="l">
-              <a:defRPr sz="1875" b="0">
-                <a:solidFill>
-                  <a:srgbClr val="718082"/>
-                </a:solidFill>
-                <a:latin typeface="Microsoft JhengHei"/>
-                <a:ea typeface="Microsoft JhengHei"/>
-                <a:cs typeface="Microsoft JhengHei"/>
-              </a:defRPr>
-            </a:defPPr>
-          </a:lstStyle>
-          <a:p xmlns:a="http://schemas.openxmlformats.org/drawingml/2006/main">
-            <a:pPr algn="l">
-              <a:defRPr sz="1875" b="0">
-                <a:solidFill>
-                  <a:srgbClr val="718082"/>
-                </a:solidFill>
-                <a:latin typeface="Microsoft JhengHei"/>
-                <a:ea typeface="Microsoft JhengHei"/>
-                <a:cs typeface="Microsoft JhengHei"/>
-              </a:defRPr>
-            </a:pPr>
-            <a:r>
-              <a:rPr sz="1875" b="0">
-                <a:solidFill>
-                  <a:srgbClr val="718082"/>
-                </a:solidFill>
-                <a:latin typeface="Microsoft JhengHei"/>
-                <a:ea typeface="Microsoft JhengHei"/>
-                <a:cs typeface="Microsoft JhengHei"/>
-              </a:rPr>
-              <a:t>表頭：serial number 與 total price NTD 同時符合</a:t>
-            </a:r>
-          </a:p>
-          <a:p xmlns:a="http://schemas.openxmlformats.org/drawingml/2006/main">
-            <a:pPr algn="l">
-              <a:defRPr sz="1875" b="0">
-                <a:solidFill>
-                  <a:srgbClr val="718082"/>
-                </a:solidFill>
-                <a:latin typeface="Microsoft JhengHei"/>
-                <a:ea typeface="Microsoft JhengHei"/>
-                <a:cs typeface="Microsoft JhengHei"/>
-              </a:defRPr>
-            </a:pPr>
-            <a:r>
-              <a:rPr sz="1875" b="0">
-                <a:solidFill>
-                  <a:srgbClr val="718082"/>
-                </a:solidFill>
-                <a:latin typeface="Microsoft JhengHei"/>
-                <a:ea typeface="Microsoft JhengHei"/>
-                <a:cs typeface="Microsoft JhengHei"/>
-              </a:rPr>
-              <a:t>完全去重：比較全部原始欄位，包含總價、排除編號</a:t>
-            </a:r>
-          </a:p>
-        </p:txBody>
-      </p:sp>
-    </p:spTree>
-    <p:extLst>
-      <p:ext uri="{BB962C8B-B14F-4D97-AF65-F5344CB8AC3E}">
-        <p14:creationId xmlns:p14="http://schemas.microsoft.com/office/powerpoint/2010/main" val="1660671705"/>
-      </p:ext>
-    </p:extLst>
-  </p:cSld>
-</p:sld>
-</file>
-
 <file path=ppt/slides/slide6.xml><?xml version="1.0" encoding="utf-8"?>
 <p:sld xmlns:p="http://schemas.openxmlformats.org/presentationml/2006/main">
   <p:cSld>
@@ -21857,7 +19617,7 @@
                 <a:ea typeface="Microsoft JhengHei"/>
                 <a:cs typeface="Microsoft JhengHei"/>
               </a:rPr>
-              <a:t>06</a:t>
+              <a:t>04</a:t>
             </a:r>
           </a:p>
         </p:txBody>
@@ -22906,7 +20666,7 @@
                 <a:ea typeface="Microsoft JhengHei"/>
                 <a:cs typeface="Microsoft JhengHei"/>
               </a:rPr>
-              <a:t>07</a:t>
+              <a:t>05</a:t>
             </a:r>
           </a:p>
         </p:txBody>
@@ -23571,7 +21331,7 @@
                 <a:ea typeface="Microsoft JhengHei"/>
                 <a:cs typeface="Microsoft JhengHei"/>
               </a:rPr>
-              <a:t>08</a:t>
+              <a:t>06</a:t>
             </a:r>
           </a:p>
         </p:txBody>
@@ -24274,7 +22034,7 @@
                 <a:ea typeface="Microsoft JhengHei"/>
                 <a:cs typeface="Microsoft JhengHei"/>
               </a:rPr>
-              <a:t>09</a:t>
+              <a:t>07</a:t>
             </a:r>
           </a:p>
         </p:txBody>

</xml_diff>

<commit_message>
Clarify model price targets and total-price conversion on slide 7
</commit_message>
<xml_diff>
--- a/teaching/final_presentation/台灣房屋銷售價格預測挑戰賽_上台簡報.pptx
+++ b/teaching/final_presentation/台灣房屋銷售價格預測挑戰賽_上台簡報.pptx
@@ -2097,7 +2097,7 @@
           <a:lstStyle xmlns:a="http://schemas.openxmlformats.org/drawingml/2006/main"/>
           <a:p xmlns:a="http://schemas.openxmlformats.org/drawingml/2006/main">
             <a:r>
-              <a:t>訓練時，我把條件、價格目標和必要權重交給模型。共同流程是輸入條件、產生估價、和答案計算誤差，再由演算法調整模型。</a:t>
+              <a:t>這頁先說清楚：有些模型先估單價，再乘回面積；也有模型直接估總價，不能把所有預測都再乘一次面積。樹模型和神經網路是學習方法，單價或總價則是要學的答案，這是兩個不同的選擇。</a:t>
             </a:r>
           </a:p>
           <a:p xmlns:a="http://schemas.openxmlformats.org/drawingml/2006/main">
@@ -2107,7 +2107,7 @@
           </a:p>
           <a:p xmlns:a="http://schemas.openxmlformats.org/drawingml/2006/main">
             <a:r>
-              <a:t>樹模型使用ＣａｔＢｏｏｓｔ和ＬｉｇｈｔＧＢＭ。演算法從資料找出條件與門檻，逐步增加小樹，修正預測誤差。門檻不是我人工指定房價。類別處理也不同：前者使用原生類別處理，後者使用從訓練資料建立的代碼。</a:t>
+              <a:t>單價樹模型訓練時，我把已知成交總價除以有效面積，得到每平方公尺單價，作為學習答案。預測新交易時，只輸入房屋條件，由模型估出單價，再乘已知面積。例如估每平方公尺二十萬元、面積五十平方公尺，總價就是一千萬元。未知交易的總價沒有拿來計算輸入。</a:t>
             </a:r>
           </a:p>
           <a:p xmlns:a="http://schemas.openxmlformats.org/drawingml/2006/main">
@@ -2117,7 +2117,7 @@
           </a:p>
           <a:p xmlns:a="http://schemas.openxmlformats.org/drawingml/2006/main">
             <a:r>
-              <a:t>神經網路把數值和類別表示送入多層計算，利用誤差反向調整權重。以參考單價網路為例，每輪先打亂資料，每批取兩千零四十八筆，先估價，再計算日期加權平滑損失，用最佳化器更新參數，固定重複三十輪。類別的數字表示也一起學習。一批更新一次參數，一輪包含多批。網路參數也叫權重，但和每筆交易的訓練權重用途不同。</a:t>
+              <a:t>直接總價模型學成交總價。對數模型先把總價取對數，壓縮金額尺度，預測後再做反向轉換。參考單價網路則先用訓練交易建立參考價，再預測調整倍率。參考單價乘面積、再乘倍率，才得到總價。倍率是一點一，就代表在參考總價上乘一點一。倍率是調整參考總價的方法，不是另外一份價格答案。</a:t>
             </a:r>
           </a:p>
           <a:p xmlns:a="http://schemas.openxmlformats.org/drawingml/2006/main">
@@ -2127,7 +2127,7 @@
           </a:p>
           <a:p xmlns:a="http://schemas.openxmlformats.org/drawingml/2006/main">
             <a:r>
-              <a:t>驗證時固定模型，只預測與計算誤差，不更新參數。兩類學法不同，後面組合使用，但是否有幫助仍要檢查。</a:t>
+              <a:t>共同訓練流程是輸入條件、產生預測、依學習目標計算損失，再更新模型。單價樹模型比較單價誤差，搭配面積等權重；面積網路與參考單價網路則換回總價計算損失。對數模型比較的是對數尺度誤差，不能說每個模型都直接用總價ＭＡＥ訓練。</a:t>
             </a:r>
           </a:p>
           <a:p xmlns:a="http://schemas.openxmlformats.org/drawingml/2006/main">
@@ -2137,12 +2137,22 @@
           </a:p>
           <a:p xmlns:a="http://schemas.openxmlformats.org/drawingml/2006/main">
             <a:r>
+              <a:t>樹模型逐步增加小樹修正誤差；神經網路依損失反向更新參數。參考單價網路每批兩千零四十八筆，固定三十輪，一批更新一次，一輪包含多批。驗證時固定參數，不繼續學習。所有輸出都先換回總價元，才進行融合、修正與總價ＭＡＥ評分。</a:t>
+            </a:r>
+          </a:p>
+          <a:p xmlns:a="http://schemas.openxmlformats.org/drawingml/2006/main">
+            <a:r>
+              <a:t/>
+            </a:r>
+          </a:p>
+          <a:p xmlns:a="http://schemas.openxmlformats.org/drawingml/2006/main">
+            <a:r>
               <a:t>補充理由</a:t>
             </a:r>
           </a:p>
           <a:p xmlns:a="http://schemas.openxmlformats.org/drawingml/2006/main">
             <a:r>
-              <a:t>把模型名稱連到可講述的訓練動作，區分樹的逐步修正與網路的參數更新。</a:t>
+              <a:t>區分學習演算法與價格表示，明示單價答案的建立及預測後乘回面積；補上參考網路預測正倍率、對數反向轉換。各模型原生訓練損失不同，融合與最終評分才統一為總價元，避免重複乘面積或誤稱所有模型直接最小化總價MAE。</a:t>
             </a:r>
           </a:p>
           <a:p xmlns:a="http://schemas.openxmlformats.org/drawingml/2006/main">
@@ -16064,10 +16074,10 @@
       </p:grpSpPr>
       <p:sp>
         <p:nvSpPr>
-          <p:cNvPr id="17" name="slide-title">
+          <p:cNvPr id="8" name="slide-title">
             <a:extLst xmlns:a="http://schemas.openxmlformats.org/drawingml/2006/main">
               <a:ext uri="{FF2B5EF4-FFF2-40B4-BE49-F238E27FC236}">
-                <a16:creationId xmlns:a16="http://schemas.microsoft.com/office/drawing/2014/main" id="{8FEBDB21-92DD-4443-ACB0-F1780884093D}"/>
+                <a16:creationId xmlns:a16="http://schemas.microsoft.com/office/drawing/2014/main" id="{E9779D5E-BFDD-4E62-80E0-C72DD2FDD015}"/>
               </a:ext>
             </a:extLst>
           </p:cNvPr>
@@ -16125,7 +16135,7 @@
                 <a:ea typeface="Microsoft JhengHei"/>
                 <a:cs typeface="Microsoft JhengHei"/>
               </a:rPr>
-              <a:t>模型的訓練步驟</a:t>
+              <a:t>模型的價格目標與訓練步驟</a:t>
             </a:r>
           </a:p>
         </p:txBody>
@@ -16135,7 +16145,7 @@
           <p:cNvPr id="2" name="body">
             <a:extLst xmlns:a="http://schemas.openxmlformats.org/drawingml/2006/main">
               <a:ext uri="{FF2B5EF4-FFF2-40B4-BE49-F238E27FC236}">
-                <a16:creationId xmlns:a16="http://schemas.microsoft.com/office/drawing/2014/main" id="{94F05B51-8CF1-4F07-AE4B-29CFBF804982}"/>
+                <a16:creationId xmlns:a16="http://schemas.microsoft.com/office/drawing/2014/main" id="{80E6FACE-0E79-4845-A998-825D1EAB8AB2}"/>
               </a:ext>
             </a:extLst>
           </p:cNvPr>
@@ -16203,7 +16213,7 @@
           <p:cNvPr id="3" name="body">
             <a:extLst xmlns:a="http://schemas.openxmlformats.org/drawingml/2006/main">
               <a:ext uri="{FF2B5EF4-FFF2-40B4-BE49-F238E27FC236}">
-                <a16:creationId xmlns:a16="http://schemas.microsoft.com/office/drawing/2014/main" id="{F5F71283-DF3E-4B6E-9C23-22184FAE9FBA}"/>
+                <a16:creationId xmlns:a16="http://schemas.microsoft.com/office/drawing/2014/main" id="{0071D72A-A4CE-46DC-B6F4-BD6DAFECF505}"/>
               </a:ext>
             </a:extLst>
           </p:cNvPr>
@@ -16214,8 +16224,8 @@
         </p:nvSpPr>
         <p:spPr>
           <a:xfrm xmlns:a="http://schemas.openxmlformats.org/drawingml/2006/main">
-            <a:off x="762000" y="1371600"/>
-            <a:ext cx="10668000" cy="476250"/>
+            <a:off x="762000" y="1362075"/>
+            <a:ext cx="10668000" cy="381000"/>
           </a:xfrm>
           <a:prstGeom xmlns:a="http://schemas.openxmlformats.org/drawingml/2006/main" prst="rect">
             <a:avLst/>
@@ -16231,9 +16241,9 @@
           </a:bodyPr>
           <a:lstStyle xmlns:a="http://schemas.openxmlformats.org/drawingml/2006/main">
             <a:defPPr algn="l">
-              <a:defRPr sz="2175" b="0">
-                <a:solidFill>
-                  <a:srgbClr val="718082"/>
+              <a:defRPr sz="1875" b="0">
+                <a:solidFill>
+                  <a:srgbClr val="276E68"/>
                 </a:solidFill>
                 <a:latin typeface="Microsoft JhengHei"/>
                 <a:ea typeface="Microsoft JhengHei"/>
@@ -16243,9 +16253,9 @@
           </a:lstStyle>
           <a:p xmlns:a="http://schemas.openxmlformats.org/drawingml/2006/main">
             <a:pPr algn="l">
-              <a:defRPr sz="2175" b="0">
-                <a:solidFill>
-                  <a:srgbClr val="718082"/>
+              <a:defRPr sz="1875" b="0">
+                <a:solidFill>
+                  <a:srgbClr val="276E68"/>
                 </a:solidFill>
                 <a:latin typeface="Microsoft JhengHei"/>
                 <a:ea typeface="Microsoft JhengHei"/>
@@ -16253,25 +16263,697 @@
               </a:defRPr>
             </a:pPr>
             <a:r>
-              <a:rPr sz="2175" b="0">
-                <a:solidFill>
-                  <a:srgbClr val="718082"/>
+              <a:rPr sz="1875" b="0">
+                <a:solidFill>
+                  <a:srgbClr val="276E68"/>
                 </a:solidFill>
                 <a:latin typeface="Microsoft JhengHei"/>
                 <a:ea typeface="Microsoft JhengHei"/>
                 <a:cs typeface="Microsoft JhengHei"/>
               </a:rPr>
-              <a:t>用已知答案計算誤差，讓模型逐步調整</a:t>
+              <a:t>單價樹模型：訓練答案＝已知總價 ÷ 有效面積</a:t>
             </a:r>
           </a:p>
         </p:txBody>
       </p:sp>
+      <p:graphicFrame>
+        <p:nvGraphicFramePr>
+          <p:cNvPr id="4" name="">
+            <a:extLst xmlns:a="http://schemas.openxmlformats.org/drawingml/2006/main">
+              <a:ext uri="{FF2B5EF4-FFF2-40B4-BE49-F238E27FC236}">
+                <a16:creationId xmlns:a16="http://schemas.microsoft.com/office/drawing/2014/main" id="{FA0E60E7-6764-490E-8ED8-5335D58840FA}"/>
+              </a:ext>
+            </a:extLst>
+          </p:cNvPr>
+          <p:cNvGraphicFramePr/>
+          <p:nvPr/>
+        </p:nvGraphicFramePr>
+        <p:xfrm>
+          <a:off xmlns:a="http://schemas.openxmlformats.org/drawingml/2006/main" x="762000" y="1885950"/>
+          <a:ext xmlns:a="http://schemas.openxmlformats.org/drawingml/2006/main" cx="10668000" cy="3095625"/>
+        </p:xfrm>
+        <a:graphic xmlns:a="http://schemas.openxmlformats.org/drawingml/2006/main">
+          <a:graphicData uri="http://schemas.openxmlformats.org/drawingml/2006/table">
+            <a:tbl>
+              <a:tblPr/>
+              <a:tblGrid>
+                <a:gridCol w="3905250"/>
+                <a:gridCol w="2857500"/>
+                <a:gridCol w="3905250"/>
+              </a:tblGrid>
+              <a:tr h="619125">
+                <a:tc>
+                  <a:txBody>
+                    <a:bodyPr lIns="133350" tIns="114300" rIns="152400" bIns="95250">
+                      <a:noAutofit/>
+                    </a:bodyPr>
+                    <a:lstStyle/>
+                    <a:p>
+                      <a:pPr algn="l"/>
+                      <a:r>
+                        <a:rPr sz="1800" b="1">
+                          <a:solidFill>
+                            <a:srgbClr val="23343A"/>
+                          </a:solidFill>
+                          <a:latin typeface="Microsoft JhengHei"/>
+                          <a:ea typeface="Microsoft JhengHei"/>
+                          <a:cs typeface="Microsoft JhengHei"/>
+                        </a:rPr>
+                        <a:t>模型路線</a:t>
+                      </a:r>
+                    </a:p>
+                  </a:txBody>
+                  <a:tcPr marL="91440" marR="91440" marT="45720" marB="45720" anchor="ctr">
+                    <a:lnL w="9525">
+                      <a:solidFill>
+                        <a:srgbClr val="FCFCFA"/>
+                      </a:solidFill>
+                      <a:prstDash val="solid"/>
+                    </a:lnL>
+                    <a:lnR w="9525">
+                      <a:solidFill>
+                        <a:srgbClr val="FCFCFA"/>
+                      </a:solidFill>
+                      <a:prstDash val="solid"/>
+                    </a:lnR>
+                    <a:lnT w="9525">
+                      <a:solidFill>
+                        <a:srgbClr val="FCFCFA"/>
+                      </a:solidFill>
+                      <a:prstDash val="solid"/>
+                    </a:lnT>
+                    <a:lnB w="7620">
+                      <a:solidFill>
+                        <a:srgbClr val="E1E7E4"/>
+                      </a:solidFill>
+                      <a:prstDash val="solid"/>
+                    </a:lnB>
+                    <a:solidFill>
+                      <a:srgbClr val="EEF3F0"/>
+                    </a:solidFill>
+                  </a:tcPr>
+                </a:tc>
+                <a:tc>
+                  <a:txBody>
+                    <a:bodyPr lIns="133350" tIns="114300" rIns="152400" bIns="95250">
+                      <a:noAutofit/>
+                    </a:bodyPr>
+                    <a:lstStyle/>
+                    <a:p>
+                      <a:pPr algn="l"/>
+                      <a:r>
+                        <a:rPr sz="1800" b="1">
+                          <a:solidFill>
+                            <a:srgbClr val="23343A"/>
+                          </a:solidFill>
+                          <a:latin typeface="Microsoft JhengHei"/>
+                          <a:ea typeface="Microsoft JhengHei"/>
+                          <a:cs typeface="Microsoft JhengHei"/>
+                        </a:rPr>
+                        <a:t>先預測什麼</a:t>
+                      </a:r>
+                    </a:p>
+                  </a:txBody>
+                  <a:tcPr marL="91440" marR="91440" marT="45720" marB="45720" anchor="ctr">
+                    <a:lnR w="9525">
+                      <a:solidFill>
+                        <a:srgbClr val="FCFCFA"/>
+                      </a:solidFill>
+                      <a:prstDash val="solid"/>
+                    </a:lnR>
+                    <a:lnT w="9525">
+                      <a:solidFill>
+                        <a:srgbClr val="FCFCFA"/>
+                      </a:solidFill>
+                      <a:prstDash val="solid"/>
+                    </a:lnT>
+                    <a:lnB w="7620">
+                      <a:solidFill>
+                        <a:srgbClr val="E1E7E4"/>
+                      </a:solidFill>
+                      <a:prstDash val="solid"/>
+                    </a:lnB>
+                    <a:solidFill>
+                      <a:srgbClr val="EEF3F0"/>
+                    </a:solidFill>
+                  </a:tcPr>
+                </a:tc>
+                <a:tc>
+                  <a:txBody>
+                    <a:bodyPr lIns="133350" tIns="114300" rIns="152400" bIns="95250">
+                      <a:noAutofit/>
+                    </a:bodyPr>
+                    <a:lstStyle/>
+                    <a:p>
+                      <a:pPr algn="l"/>
+                      <a:r>
+                        <a:rPr sz="1800" b="1">
+                          <a:solidFill>
+                            <a:srgbClr val="23343A"/>
+                          </a:solidFill>
+                          <a:latin typeface="Microsoft JhengHei"/>
+                          <a:ea typeface="Microsoft JhengHei"/>
+                          <a:cs typeface="Microsoft JhengHei"/>
+                        </a:rPr>
+                        <a:t>總價如何產生</a:t>
+                      </a:r>
+                    </a:p>
+                  </a:txBody>
+                  <a:tcPr marL="91440" marR="91440" marT="45720" marB="45720" anchor="ctr">
+                    <a:lnR w="9525">
+                      <a:solidFill>
+                        <a:srgbClr val="FCFCFA"/>
+                      </a:solidFill>
+                      <a:prstDash val="solid"/>
+                    </a:lnR>
+                    <a:lnT w="9525">
+                      <a:solidFill>
+                        <a:srgbClr val="FCFCFA"/>
+                      </a:solidFill>
+                      <a:prstDash val="solid"/>
+                    </a:lnT>
+                    <a:lnB w="7620">
+                      <a:solidFill>
+                        <a:srgbClr val="E1E7E4"/>
+                      </a:solidFill>
+                      <a:prstDash val="solid"/>
+                    </a:lnB>
+                    <a:solidFill>
+                      <a:srgbClr val="EEF3F0"/>
+                    </a:solidFill>
+                  </a:tcPr>
+                </a:tc>
+              </a:tr>
+              <a:tr h="619125">
+                <a:tc>
+                  <a:txBody>
+                    <a:bodyPr lIns="133350" tIns="114300" rIns="152400" bIns="95250">
+                      <a:noAutofit/>
+                    </a:bodyPr>
+                    <a:lstStyle/>
+                    <a:p>
+                      <a:pPr algn="l"/>
+                      <a:r>
+                        <a:rPr sz="1800" b="0">
+                          <a:solidFill>
+                            <a:srgbClr val="3A4A4E"/>
+                          </a:solidFill>
+                          <a:latin typeface="Microsoft JhengHei"/>
+                          <a:ea typeface="Microsoft JhengHei"/>
+                          <a:cs typeface="Microsoft JhengHei"/>
+                        </a:rPr>
+                        <a:t>單價樹模型、面積網路</a:t>
+                      </a:r>
+                    </a:p>
+                  </a:txBody>
+                  <a:tcPr marL="91440" marR="91440" marT="45720" marB="45720" anchor="ctr">
+                    <a:lnL w="9525">
+                      <a:solidFill>
+                        <a:srgbClr val="FCFCFA"/>
+                      </a:solidFill>
+                      <a:prstDash val="solid"/>
+                    </a:lnL>
+                    <a:lnR w="9525">
+                      <a:solidFill>
+                        <a:srgbClr val="FCFCFA"/>
+                      </a:solidFill>
+                      <a:prstDash val="solid"/>
+                    </a:lnR>
+                    <a:lnB w="7620">
+                      <a:solidFill>
+                        <a:srgbClr val="E1E7E4"/>
+                      </a:solidFill>
+                      <a:prstDash val="solid"/>
+                    </a:lnB>
+                    <a:solidFill>
+                      <a:srgbClr val="FCFCFA"/>
+                    </a:solidFill>
+                  </a:tcPr>
+                </a:tc>
+                <a:tc>
+                  <a:txBody>
+                    <a:bodyPr lIns="133350" tIns="114300" rIns="152400" bIns="95250">
+                      <a:noAutofit/>
+                    </a:bodyPr>
+                    <a:lstStyle/>
+                    <a:p>
+                      <a:pPr algn="l"/>
+                      <a:r>
+                        <a:rPr sz="1800" b="0">
+                          <a:solidFill>
+                            <a:srgbClr val="3A4A4E"/>
+                          </a:solidFill>
+                          <a:latin typeface="Microsoft JhengHei"/>
+                          <a:ea typeface="Microsoft JhengHei"/>
+                          <a:cs typeface="Microsoft JhengHei"/>
+                        </a:rPr>
+                        <a:t>每平方公尺單價</a:t>
+                      </a:r>
+                    </a:p>
+                  </a:txBody>
+                  <a:tcPr marL="91440" marR="91440" marT="45720" marB="45720" anchor="ctr">
+                    <a:lnR w="9525">
+                      <a:solidFill>
+                        <a:srgbClr val="FCFCFA"/>
+                      </a:solidFill>
+                      <a:prstDash val="solid"/>
+                    </a:lnR>
+                    <a:lnB w="7620">
+                      <a:solidFill>
+                        <a:srgbClr val="E1E7E4"/>
+                      </a:solidFill>
+                      <a:prstDash val="solid"/>
+                    </a:lnB>
+                    <a:solidFill>
+                      <a:srgbClr val="FCFCFA"/>
+                    </a:solidFill>
+                  </a:tcPr>
+                </a:tc>
+                <a:tc>
+                  <a:txBody>
+                    <a:bodyPr lIns="133350" tIns="114300" rIns="152400" bIns="95250">
+                      <a:noAutofit/>
+                    </a:bodyPr>
+                    <a:lstStyle/>
+                    <a:p>
+                      <a:pPr algn="l"/>
+                      <a:r>
+                        <a:rPr sz="1800" b="0">
+                          <a:solidFill>
+                            <a:srgbClr val="3A4A4E"/>
+                          </a:solidFill>
+                          <a:latin typeface="Microsoft JhengHei"/>
+                          <a:ea typeface="Microsoft JhengHei"/>
+                          <a:cs typeface="Microsoft JhengHei"/>
+                        </a:rPr>
+                        <a:t>預測單價 × 有效面積</a:t>
+                      </a:r>
+                    </a:p>
+                  </a:txBody>
+                  <a:tcPr marL="91440" marR="91440" marT="45720" marB="45720" anchor="ctr">
+                    <a:lnR w="9525">
+                      <a:solidFill>
+                        <a:srgbClr val="FCFCFA"/>
+                      </a:solidFill>
+                      <a:prstDash val="solid"/>
+                    </a:lnR>
+                    <a:lnB w="7620">
+                      <a:solidFill>
+                        <a:srgbClr val="E1E7E4"/>
+                      </a:solidFill>
+                      <a:prstDash val="solid"/>
+                    </a:lnB>
+                    <a:solidFill>
+                      <a:srgbClr val="FCFCFA"/>
+                    </a:solidFill>
+                  </a:tcPr>
+                </a:tc>
+              </a:tr>
+              <a:tr h="619125">
+                <a:tc>
+                  <a:txBody>
+                    <a:bodyPr lIns="133350" tIns="114300" rIns="152400" bIns="95250">
+                      <a:noAutofit/>
+                    </a:bodyPr>
+                    <a:lstStyle/>
+                    <a:p>
+                      <a:pPr algn="l"/>
+                      <a:r>
+                        <a:rPr sz="1800" b="0">
+                          <a:solidFill>
+                            <a:srgbClr val="3A4A4E"/>
+                          </a:solidFill>
+                          <a:latin typeface="Microsoft JhengHei"/>
+                          <a:ea typeface="Microsoft JhengHei"/>
+                          <a:cs typeface="Microsoft JhengHei"/>
+                        </a:rPr>
+                        <a:t>直接總價樹模型</a:t>
+                      </a:r>
+                    </a:p>
+                  </a:txBody>
+                  <a:tcPr marL="91440" marR="91440" marT="45720" marB="45720" anchor="ctr">
+                    <a:lnL w="9525">
+                      <a:solidFill>
+                        <a:srgbClr val="FCFCFA"/>
+                      </a:solidFill>
+                      <a:prstDash val="solid"/>
+                    </a:lnL>
+                    <a:lnR w="9525">
+                      <a:solidFill>
+                        <a:srgbClr val="FCFCFA"/>
+                      </a:solidFill>
+                      <a:prstDash val="solid"/>
+                    </a:lnR>
+                    <a:lnB w="7620">
+                      <a:solidFill>
+                        <a:srgbClr val="E1E7E4"/>
+                      </a:solidFill>
+                      <a:prstDash val="solid"/>
+                    </a:lnB>
+                    <a:solidFill>
+                      <a:srgbClr val="FCFCFA"/>
+                    </a:solidFill>
+                  </a:tcPr>
+                </a:tc>
+                <a:tc>
+                  <a:txBody>
+                    <a:bodyPr lIns="133350" tIns="114300" rIns="152400" bIns="95250">
+                      <a:noAutofit/>
+                    </a:bodyPr>
+                    <a:lstStyle/>
+                    <a:p>
+                      <a:pPr algn="l"/>
+                      <a:r>
+                        <a:rPr sz="1800" b="0">
+                          <a:solidFill>
+                            <a:srgbClr val="3A4A4E"/>
+                          </a:solidFill>
+                          <a:latin typeface="Microsoft JhengHei"/>
+                          <a:ea typeface="Microsoft JhengHei"/>
+                          <a:cs typeface="Microsoft JhengHei"/>
+                        </a:rPr>
+                        <a:t>總價</a:t>
+                      </a:r>
+                    </a:p>
+                  </a:txBody>
+                  <a:tcPr marL="91440" marR="91440" marT="45720" marB="45720" anchor="ctr">
+                    <a:lnR w="9525">
+                      <a:solidFill>
+                        <a:srgbClr val="FCFCFA"/>
+                      </a:solidFill>
+                      <a:prstDash val="solid"/>
+                    </a:lnR>
+                    <a:lnB w="7620">
+                      <a:solidFill>
+                        <a:srgbClr val="E1E7E4"/>
+                      </a:solidFill>
+                      <a:prstDash val="solid"/>
+                    </a:lnB>
+                    <a:solidFill>
+                      <a:srgbClr val="FCFCFA"/>
+                    </a:solidFill>
+                  </a:tcPr>
+                </a:tc>
+                <a:tc>
+                  <a:txBody>
+                    <a:bodyPr lIns="133350" tIns="114300" rIns="152400" bIns="95250">
+                      <a:noAutofit/>
+                    </a:bodyPr>
+                    <a:lstStyle/>
+                    <a:p>
+                      <a:pPr algn="l"/>
+                      <a:r>
+                        <a:rPr sz="1800" b="0">
+                          <a:solidFill>
+                            <a:srgbClr val="3A4A4E"/>
+                          </a:solidFill>
+                          <a:latin typeface="Microsoft JhengHei"/>
+                          <a:ea typeface="Microsoft JhengHei"/>
+                          <a:cs typeface="Microsoft JhengHei"/>
+                        </a:rPr>
+                        <a:t>直接換回總價元</a:t>
+                      </a:r>
+                    </a:p>
+                  </a:txBody>
+                  <a:tcPr marL="91440" marR="91440" marT="45720" marB="45720" anchor="ctr">
+                    <a:lnR w="9525">
+                      <a:solidFill>
+                        <a:srgbClr val="FCFCFA"/>
+                      </a:solidFill>
+                      <a:prstDash val="solid"/>
+                    </a:lnR>
+                    <a:lnB w="7620">
+                      <a:solidFill>
+                        <a:srgbClr val="E1E7E4"/>
+                      </a:solidFill>
+                      <a:prstDash val="solid"/>
+                    </a:lnB>
+                    <a:solidFill>
+                      <a:srgbClr val="FCFCFA"/>
+                    </a:solidFill>
+                  </a:tcPr>
+                </a:tc>
+              </a:tr>
+              <a:tr h="619125">
+                <a:tc>
+                  <a:txBody>
+                    <a:bodyPr lIns="133350" tIns="114300" rIns="152400" bIns="95250">
+                      <a:noAutofit/>
+                    </a:bodyPr>
+                    <a:lstStyle/>
+                    <a:p>
+                      <a:pPr algn="l"/>
+                      <a:r>
+                        <a:rPr sz="1800" b="0">
+                          <a:solidFill>
+                            <a:srgbClr val="3A4A4E"/>
+                          </a:solidFill>
+                          <a:latin typeface="Microsoft JhengHei"/>
+                          <a:ea typeface="Microsoft JhengHei"/>
+                          <a:cs typeface="Microsoft JhengHei"/>
+                        </a:rPr>
+                        <a:t>對數總價樹模型</a:t>
+                      </a:r>
+                    </a:p>
+                  </a:txBody>
+                  <a:tcPr marL="91440" marR="91440" marT="45720" marB="45720" anchor="ctr">
+                    <a:lnL w="9525">
+                      <a:solidFill>
+                        <a:srgbClr val="FCFCFA"/>
+                      </a:solidFill>
+                      <a:prstDash val="solid"/>
+                    </a:lnL>
+                    <a:lnR w="9525">
+                      <a:solidFill>
+                        <a:srgbClr val="FCFCFA"/>
+                      </a:solidFill>
+                      <a:prstDash val="solid"/>
+                    </a:lnR>
+                    <a:lnB w="7620">
+                      <a:solidFill>
+                        <a:srgbClr val="E1E7E4"/>
+                      </a:solidFill>
+                      <a:prstDash val="solid"/>
+                    </a:lnB>
+                    <a:solidFill>
+                      <a:srgbClr val="FCFCFA"/>
+                    </a:solidFill>
+                  </a:tcPr>
+                </a:tc>
+                <a:tc>
+                  <a:txBody>
+                    <a:bodyPr lIns="133350" tIns="114300" rIns="152400" bIns="95250">
+                      <a:noAutofit/>
+                    </a:bodyPr>
+                    <a:lstStyle/>
+                    <a:p>
+                      <a:pPr algn="l"/>
+                      <a:r>
+                        <a:rPr sz="1800" b="0">
+                          <a:solidFill>
+                            <a:srgbClr val="3A4A4E"/>
+                          </a:solidFill>
+                          <a:latin typeface="Microsoft JhengHei"/>
+                          <a:ea typeface="Microsoft JhengHei"/>
+                          <a:cs typeface="Microsoft JhengHei"/>
+                        </a:rPr>
+                        <a:t>取對數後的總價</a:t>
+                      </a:r>
+                    </a:p>
+                  </a:txBody>
+                  <a:tcPr marL="91440" marR="91440" marT="45720" marB="45720" anchor="ctr">
+                    <a:lnR w="9525">
+                      <a:solidFill>
+                        <a:srgbClr val="FCFCFA"/>
+                      </a:solidFill>
+                      <a:prstDash val="solid"/>
+                    </a:lnR>
+                    <a:lnB w="7620">
+                      <a:solidFill>
+                        <a:srgbClr val="E1E7E4"/>
+                      </a:solidFill>
+                      <a:prstDash val="solid"/>
+                    </a:lnB>
+                    <a:solidFill>
+                      <a:srgbClr val="FCFCFA"/>
+                    </a:solidFill>
+                  </a:tcPr>
+                </a:tc>
+                <a:tc>
+                  <a:txBody>
+                    <a:bodyPr lIns="133350" tIns="114300" rIns="152400" bIns="95250">
+                      <a:noAutofit/>
+                    </a:bodyPr>
+                    <a:lstStyle/>
+                    <a:p>
+                      <a:pPr algn="l"/>
+                      <a:r>
+                        <a:rPr sz="1800" b="0">
+                          <a:solidFill>
+                            <a:srgbClr val="3A4A4E"/>
+                          </a:solidFill>
+                          <a:latin typeface="Microsoft JhengHei"/>
+                          <a:ea typeface="Microsoft JhengHei"/>
+                          <a:cs typeface="Microsoft JhengHei"/>
+                        </a:rPr>
+                        <a:t>將預測值還原為總價</a:t>
+                      </a:r>
+                    </a:p>
+                  </a:txBody>
+                  <a:tcPr marL="91440" marR="91440" marT="45720" marB="45720" anchor="ctr">
+                    <a:lnR w="9525">
+                      <a:solidFill>
+                        <a:srgbClr val="FCFCFA"/>
+                      </a:solidFill>
+                      <a:prstDash val="solid"/>
+                    </a:lnR>
+                    <a:lnB w="7620">
+                      <a:solidFill>
+                        <a:srgbClr val="E1E7E4"/>
+                      </a:solidFill>
+                      <a:prstDash val="solid"/>
+                    </a:lnB>
+                    <a:solidFill>
+                      <a:srgbClr val="FCFCFA"/>
+                    </a:solidFill>
+                  </a:tcPr>
+                </a:tc>
+              </a:tr>
+              <a:tr h="619125">
+                <a:tc>
+                  <a:txBody>
+                    <a:bodyPr lIns="133350" tIns="114300" rIns="152400" bIns="95250">
+                      <a:noAutofit/>
+                    </a:bodyPr>
+                    <a:lstStyle/>
+                    <a:p>
+                      <a:pPr algn="l"/>
+                      <a:r>
+                        <a:rPr sz="1800" b="0">
+                          <a:solidFill>
+                            <a:srgbClr val="3A4A4E"/>
+                          </a:solidFill>
+                          <a:latin typeface="Microsoft JhengHei"/>
+                          <a:ea typeface="Microsoft JhengHei"/>
+                          <a:cs typeface="Microsoft JhengHei"/>
+                        </a:rPr>
+                        <a:t>參考單價網路</a:t>
+                      </a:r>
+                    </a:p>
+                  </a:txBody>
+                  <a:tcPr marL="91440" marR="91440" marT="45720" marB="45720" anchor="ctr">
+                    <a:lnL w="9525">
+                      <a:solidFill>
+                        <a:srgbClr val="FCFCFA"/>
+                      </a:solidFill>
+                      <a:prstDash val="solid"/>
+                    </a:lnL>
+                    <a:lnR w="9525">
+                      <a:solidFill>
+                        <a:srgbClr val="FCFCFA"/>
+                      </a:solidFill>
+                      <a:prstDash val="solid"/>
+                    </a:lnR>
+                    <a:lnB w="9525">
+                      <a:solidFill>
+                        <a:srgbClr val="FCFCFA"/>
+                      </a:solidFill>
+                      <a:prstDash val="solid"/>
+                    </a:lnB>
+                    <a:solidFill>
+                      <a:srgbClr val="FCFCFA"/>
+                    </a:solidFill>
+                  </a:tcPr>
+                </a:tc>
+                <a:tc>
+                  <a:txBody>
+                    <a:bodyPr lIns="133350" tIns="114300" rIns="152400" bIns="95250">
+                      <a:noAutofit/>
+                    </a:bodyPr>
+                    <a:lstStyle/>
+                    <a:p>
+                      <a:pPr algn="l"/>
+                      <a:r>
+                        <a:rPr sz="1800" b="0">
+                          <a:solidFill>
+                            <a:srgbClr val="3A4A4E"/>
+                          </a:solidFill>
+                          <a:latin typeface="Microsoft JhengHei"/>
+                          <a:ea typeface="Microsoft JhengHei"/>
+                          <a:cs typeface="Microsoft JhengHei"/>
+                        </a:rPr>
+                        <a:t>相對參考價的倍率</a:t>
+                      </a:r>
+                    </a:p>
+                  </a:txBody>
+                  <a:tcPr marL="91440" marR="91440" marT="45720" marB="45720" anchor="ctr">
+                    <a:lnR w="9525">
+                      <a:solidFill>
+                        <a:srgbClr val="FCFCFA"/>
+                      </a:solidFill>
+                      <a:prstDash val="solid"/>
+                    </a:lnR>
+                    <a:lnB w="9525">
+                      <a:solidFill>
+                        <a:srgbClr val="FCFCFA"/>
+                      </a:solidFill>
+                      <a:prstDash val="solid"/>
+                    </a:lnB>
+                    <a:solidFill>
+                      <a:srgbClr val="FCFCFA"/>
+                    </a:solidFill>
+                  </a:tcPr>
+                </a:tc>
+                <a:tc>
+                  <a:txBody>
+                    <a:bodyPr lIns="133350" tIns="114300" rIns="152400" bIns="95250">
+                      <a:noAutofit/>
+                    </a:bodyPr>
+                    <a:lstStyle/>
+                    <a:p>
+                      <a:pPr algn="l"/>
+                      <a:r>
+                        <a:rPr sz="1800" b="0">
+                          <a:solidFill>
+                            <a:srgbClr val="3A4A4E"/>
+                          </a:solidFill>
+                          <a:latin typeface="Microsoft JhengHei"/>
+                          <a:ea typeface="Microsoft JhengHei"/>
+                          <a:cs typeface="Microsoft JhengHei"/>
+                        </a:rPr>
+                        <a:t>參考單價 × 有效面積 × 倍率</a:t>
+                      </a:r>
+                    </a:p>
+                  </a:txBody>
+                  <a:tcPr marL="91440" marR="91440" marT="45720" marB="45720" anchor="ctr">
+                    <a:lnR w="9525">
+                      <a:solidFill>
+                        <a:srgbClr val="FCFCFA"/>
+                      </a:solidFill>
+                      <a:prstDash val="solid"/>
+                    </a:lnR>
+                    <a:lnB w="9525">
+                      <a:solidFill>
+                        <a:srgbClr val="FCFCFA"/>
+                      </a:solidFill>
+                      <a:prstDash val="solid"/>
+                    </a:lnB>
+                    <a:solidFill>
+                      <a:srgbClr val="FCFCFA"/>
+                    </a:solidFill>
+                  </a:tcPr>
+                </a:tc>
+              </a:tr>
+            </a:tbl>
+          </a:graphicData>
+        </a:graphic>
+      </p:graphicFrame>
       <p:sp>
         <p:nvSpPr>
-          <p:cNvPr id="4" name="body">
+          <p:cNvPr id="5" name="body">
             <a:extLst xmlns:a="http://schemas.openxmlformats.org/drawingml/2006/main">
               <a:ext uri="{FF2B5EF4-FFF2-40B4-BE49-F238E27FC236}">
-                <a16:creationId xmlns:a16="http://schemas.microsoft.com/office/drawing/2014/main" id="{4D0400E6-FCF9-4597-A944-69E940E33240}"/>
+                <a16:creationId xmlns:a16="http://schemas.microsoft.com/office/drawing/2014/main" id="{3BB79B8B-1E4E-4E2E-8A84-AF0C5C05240B}"/>
               </a:ext>
             </a:extLst>
           </p:cNvPr>
@@ -16282,76 +16964,8 @@
         </p:nvSpPr>
         <p:spPr>
           <a:xfrm xmlns:a="http://schemas.openxmlformats.org/drawingml/2006/main">
-            <a:off x="762000" y="2228850"/>
-            <a:ext cx="2381250" cy="428625"/>
-          </a:xfrm>
-          <a:prstGeom xmlns:a="http://schemas.openxmlformats.org/drawingml/2006/main" prst="rect">
-            <a:avLst/>
-          </a:prstGeom>
-          <a:noFill xmlns:a="http://schemas.openxmlformats.org/drawingml/2006/main"/>
-          <a:ln xmlns:a="http://schemas.openxmlformats.org/drawingml/2006/main" w="0">
-            <a:noFill/>
-          </a:ln>
-        </p:spPr>
-        <p:txBody>
-          <a:bodyPr xmlns:a="http://schemas.openxmlformats.org/drawingml/2006/main" wrap="square" lIns="0" tIns="0" rIns="0" bIns="0" anchor="t">
-            <a:noAutofit/>
-          </a:bodyPr>
-          <a:lstStyle xmlns:a="http://schemas.openxmlformats.org/drawingml/2006/main">
-            <a:defPPr algn="l">
-              <a:defRPr sz="2100" b="1">
-                <a:solidFill>
-                  <a:srgbClr val="276E68"/>
-                </a:solidFill>
-                <a:latin typeface="Microsoft JhengHei"/>
-                <a:ea typeface="Microsoft JhengHei"/>
-                <a:cs typeface="Microsoft JhengHei"/>
-              </a:defRPr>
-            </a:defPPr>
-          </a:lstStyle>
-          <a:p xmlns:a="http://schemas.openxmlformats.org/drawingml/2006/main">
-            <a:pPr algn="l">
-              <a:defRPr sz="2100" b="1">
-                <a:solidFill>
-                  <a:srgbClr val="276E68"/>
-                </a:solidFill>
-                <a:latin typeface="Microsoft JhengHei"/>
-                <a:ea typeface="Microsoft JhengHei"/>
-                <a:cs typeface="Microsoft JhengHei"/>
-              </a:defRPr>
-            </a:pPr>
-            <a:r>
-              <a:rPr sz="2100" b="1">
-                <a:solidFill>
-                  <a:srgbClr val="276E68"/>
-                </a:solidFill>
-                <a:latin typeface="Microsoft JhengHei"/>
-                <a:ea typeface="Microsoft JhengHei"/>
-                <a:cs typeface="Microsoft JhengHei"/>
-              </a:rPr>
-              <a:t>01　輸入條件</a:t>
-            </a:r>
-          </a:p>
-        </p:txBody>
-      </p:sp>
-      <p:sp>
-        <p:nvSpPr>
-          <p:cNvPr id="5" name="body">
-            <a:extLst xmlns:a="http://schemas.openxmlformats.org/drawingml/2006/main">
-              <a:ext uri="{FF2B5EF4-FFF2-40B4-BE49-F238E27FC236}">
-                <a16:creationId xmlns:a16="http://schemas.microsoft.com/office/drawing/2014/main" id="{A4FF8C01-F439-4AA7-A8F7-CCB1FC7ACB37}"/>
-              </a:ext>
-            </a:extLst>
-          </p:cNvPr>
-          <p:cNvSpPr>
-            <a:spLocks xmlns:a="http://schemas.openxmlformats.org/drawingml/2006/main" noGrp="1"/>
-          </p:cNvSpPr>
-          <p:nvPr/>
-        </p:nvSpPr>
-        <p:spPr>
-          <a:xfrm xmlns:a="http://schemas.openxmlformats.org/drawingml/2006/main">
-            <a:off x="762000" y="2819400"/>
-            <a:ext cx="2381250" cy="904875"/>
+            <a:off x="762000" y="5238750"/>
+            <a:ext cx="10668000" cy="400050"/>
           </a:xfrm>
           <a:prstGeom xmlns:a="http://schemas.openxmlformats.org/drawingml/2006/main" prst="rect">
             <a:avLst/>
@@ -16369,7 +16983,7 @@
             <a:defPPr algn="l">
               <a:defRPr sz="2025" b="0">
                 <a:solidFill>
-                  <a:srgbClr val="3A4A4E"/>
+                  <a:srgbClr val="23343A"/>
                 </a:solidFill>
                 <a:latin typeface="Microsoft JhengHei"/>
                 <a:ea typeface="Microsoft JhengHei"/>
@@ -16381,7 +16995,7 @@
             <a:pPr algn="l">
               <a:defRPr sz="2025" b="0">
                 <a:solidFill>
-                  <a:srgbClr val="3A4A4E"/>
+                  <a:srgbClr val="23343A"/>
                 </a:solidFill>
                 <a:latin typeface="Microsoft JhengHei"/>
                 <a:ea typeface="Microsoft JhengHei"/>
@@ -16391,36 +17005,13 @@
             <a:r>
               <a:rPr sz="2025" b="0">
                 <a:solidFill>
-                  <a:srgbClr val="3A4A4E"/>
+                  <a:srgbClr val="23343A"/>
                 </a:solidFill>
                 <a:latin typeface="Microsoft JhengHei"/>
                 <a:ea typeface="Microsoft JhengHei"/>
                 <a:cs typeface="Microsoft JhengHei"/>
               </a:rPr>
-              <a:t>面積、地區等</a:t>
-            </a:r>
-          </a:p>
-          <a:p xmlns:a="http://schemas.openxmlformats.org/drawingml/2006/main">
-            <a:pPr algn="l">
-              <a:defRPr sz="2025" b="0">
-                <a:solidFill>
-                  <a:srgbClr val="3A4A4E"/>
-                </a:solidFill>
-                <a:latin typeface="Microsoft JhengHei"/>
-                <a:ea typeface="Microsoft JhengHei"/>
-                <a:cs typeface="Microsoft JhengHei"/>
-              </a:defRPr>
-            </a:pPr>
-            <a:r>
-              <a:rPr sz="2025" b="0">
-                <a:solidFill>
-                  <a:srgbClr val="3A4A4E"/>
-                </a:solidFill>
-                <a:latin typeface="Microsoft JhengHei"/>
-                <a:ea typeface="Microsoft JhengHei"/>
-                <a:cs typeface="Microsoft JhengHei"/>
-              </a:rPr>
-              <a:t>整理好的特徵</a:t>
+              <a:t>共同訓練：輸入條件、產生預測、依目標計算損失、更新模型</a:t>
             </a:r>
           </a:p>
         </p:txBody>
@@ -16430,7 +17021,7 @@
           <p:cNvPr id="6" name="body">
             <a:extLst xmlns:a="http://schemas.openxmlformats.org/drawingml/2006/main">
               <a:ext uri="{FF2B5EF4-FFF2-40B4-BE49-F238E27FC236}">
-                <a16:creationId xmlns:a16="http://schemas.microsoft.com/office/drawing/2014/main" id="{848A3451-96E8-42AE-8757-395E875B7478}"/>
+                <a16:creationId xmlns:a16="http://schemas.microsoft.com/office/drawing/2014/main" id="{B0C60E0E-CA38-4D08-9746-5E2263487FC3}"/>
               </a:ext>
             </a:extLst>
           </p:cNvPr>
@@ -16441,8 +17032,8 @@
         </p:nvSpPr>
         <p:spPr>
           <a:xfrm xmlns:a="http://schemas.openxmlformats.org/drawingml/2006/main">
-            <a:off x="3524250" y="2228850"/>
-            <a:ext cx="2381250" cy="428625"/>
+            <a:off x="762000" y="5676900"/>
+            <a:ext cx="10668000" cy="333375"/>
           </a:xfrm>
           <a:prstGeom xmlns:a="http://schemas.openxmlformats.org/drawingml/2006/main" prst="rect">
             <a:avLst/>
@@ -16458,9 +17049,9 @@
           </a:bodyPr>
           <a:lstStyle xmlns:a="http://schemas.openxmlformats.org/drawingml/2006/main">
             <a:defPPr algn="l">
-              <a:defRPr sz="2100" b="1">
-                <a:solidFill>
-                  <a:srgbClr val="276E68"/>
+              <a:defRPr sz="1875" b="0">
+                <a:solidFill>
+                  <a:srgbClr val="3A4A4E"/>
                 </a:solidFill>
                 <a:latin typeface="Microsoft JhengHei"/>
                 <a:ea typeface="Microsoft JhengHei"/>
@@ -16470,9 +17061,9 @@
           </a:lstStyle>
           <a:p xmlns:a="http://schemas.openxmlformats.org/drawingml/2006/main">
             <a:pPr algn="l">
-              <a:defRPr sz="2100" b="1">
-                <a:solidFill>
-                  <a:srgbClr val="276E68"/>
+              <a:defRPr sz="1875" b="0">
+                <a:solidFill>
+                  <a:srgbClr val="3A4A4E"/>
                 </a:solidFill>
                 <a:latin typeface="Microsoft JhengHei"/>
                 <a:ea typeface="Microsoft JhengHei"/>
@@ -16480,15 +17071,15 @@
               </a:defRPr>
             </a:pPr>
             <a:r>
-              <a:rPr sz="2100" b="1">
-                <a:solidFill>
-                  <a:srgbClr val="276E68"/>
+              <a:rPr sz="1875" b="0">
+                <a:solidFill>
+                  <a:srgbClr val="3A4A4E"/>
                 </a:solidFill>
                 <a:latin typeface="Microsoft JhengHei"/>
                 <a:ea typeface="Microsoft JhengHei"/>
                 <a:cs typeface="Microsoft JhengHei"/>
               </a:rPr>
-              <a:t>02　產生估價</a:t>
+              <a:t>樹模型：增加小樹修正誤差　神經網路：反向更新參數</a:t>
             </a:r>
           </a:p>
         </p:txBody>
@@ -16498,7 +17089,7 @@
           <p:cNvPr id="7" name="body">
             <a:extLst xmlns:a="http://schemas.openxmlformats.org/drawingml/2006/main">
               <a:ext uri="{FF2B5EF4-FFF2-40B4-BE49-F238E27FC236}">
-                <a16:creationId xmlns:a16="http://schemas.microsoft.com/office/drawing/2014/main" id="{FEC0E3FE-44D9-4A28-91C1-F40973E9CC2D}"/>
+                <a16:creationId xmlns:a16="http://schemas.microsoft.com/office/drawing/2014/main" id="{DF62C97F-2F34-4F6D-A437-69E2E850E71B}"/>
               </a:ext>
             </a:extLst>
           </p:cNvPr>
@@ -16509,8 +17100,8 @@
         </p:nvSpPr>
         <p:spPr>
           <a:xfrm xmlns:a="http://schemas.openxmlformats.org/drawingml/2006/main">
-            <a:off x="3524250" y="2819400"/>
-            <a:ext cx="2381250" cy="904875"/>
+            <a:off x="762000" y="6143625"/>
+            <a:ext cx="9953625" cy="342900"/>
           </a:xfrm>
           <a:prstGeom xmlns:a="http://schemas.openxmlformats.org/drawingml/2006/main" prst="rect">
             <a:avLst/>
@@ -16526,9 +17117,9 @@
           </a:bodyPr>
           <a:lstStyle xmlns:a="http://schemas.openxmlformats.org/drawingml/2006/main">
             <a:defPPr algn="l">
-              <a:defRPr sz="2025" b="0">
-                <a:solidFill>
-                  <a:srgbClr val="3A4A4E"/>
+              <a:defRPr sz="1650" b="0">
+                <a:solidFill>
+                  <a:srgbClr val="718082"/>
                 </a:solidFill>
                 <a:latin typeface="Microsoft JhengHei"/>
                 <a:ea typeface="Microsoft JhengHei"/>
@@ -16538,9 +17129,9 @@
           </a:lstStyle>
           <a:p xmlns:a="http://schemas.openxmlformats.org/drawingml/2006/main">
             <a:pPr algn="l">
-              <a:defRPr sz="2025" b="0">
-                <a:solidFill>
-                  <a:srgbClr val="3A4A4E"/>
+              <a:defRPr sz="1650" b="0">
+                <a:solidFill>
+                  <a:srgbClr val="718082"/>
                 </a:solidFill>
                 <a:latin typeface="Microsoft JhengHei"/>
                 <a:ea typeface="Microsoft JhengHei"/>
@@ -16548,742 +17139,15 @@
               </a:defRPr>
             </a:pPr>
             <a:r>
-              <a:rPr sz="2025" b="0">
-                <a:solidFill>
-                  <a:srgbClr val="3A4A4E"/>
+              <a:rPr sz="1650" b="0">
+                <a:solidFill>
+                  <a:srgbClr val="718082"/>
                 </a:solidFill>
                 <a:latin typeface="Microsoft JhengHei"/>
                 <a:ea typeface="Microsoft JhengHei"/>
                 <a:cs typeface="Microsoft JhengHei"/>
               </a:rPr>
-              <a:t>依目前模型</a:t>
-            </a:r>
-          </a:p>
-          <a:p xmlns:a="http://schemas.openxmlformats.org/drawingml/2006/main">
-            <a:pPr algn="l">
-              <a:defRPr sz="2025" b="0">
-                <a:solidFill>
-                  <a:srgbClr val="3A4A4E"/>
-                </a:solidFill>
-                <a:latin typeface="Microsoft JhengHei"/>
-                <a:ea typeface="Microsoft JhengHei"/>
-                <a:cs typeface="Microsoft JhengHei"/>
-              </a:defRPr>
-            </a:pPr>
-            <a:r>
-              <a:rPr sz="2025" b="0">
-                <a:solidFill>
-                  <a:srgbClr val="3A4A4E"/>
-                </a:solidFill>
-                <a:latin typeface="Microsoft JhengHei"/>
-                <a:ea typeface="Microsoft JhengHei"/>
-                <a:cs typeface="Microsoft JhengHei"/>
-              </a:rPr>
-              <a:t>計算預測</a:t>
-            </a:r>
-          </a:p>
-        </p:txBody>
-      </p:sp>
-      <p:sp>
-        <p:nvSpPr>
-          <p:cNvPr id="8" name="body">
-            <a:extLst xmlns:a="http://schemas.openxmlformats.org/drawingml/2006/main">
-              <a:ext uri="{FF2B5EF4-FFF2-40B4-BE49-F238E27FC236}">
-                <a16:creationId xmlns:a16="http://schemas.microsoft.com/office/drawing/2014/main" id="{EE287122-FC2D-4099-96DA-AC4A2B65EE23}"/>
-              </a:ext>
-            </a:extLst>
-          </p:cNvPr>
-          <p:cNvSpPr>
-            <a:spLocks xmlns:a="http://schemas.openxmlformats.org/drawingml/2006/main" noGrp="1"/>
-          </p:cNvSpPr>
-          <p:nvPr/>
-        </p:nvSpPr>
-        <p:spPr>
-          <a:xfrm xmlns:a="http://schemas.openxmlformats.org/drawingml/2006/main">
-            <a:off x="6286500" y="2228850"/>
-            <a:ext cx="2381250" cy="428625"/>
-          </a:xfrm>
-          <a:prstGeom xmlns:a="http://schemas.openxmlformats.org/drawingml/2006/main" prst="rect">
-            <a:avLst/>
-          </a:prstGeom>
-          <a:noFill xmlns:a="http://schemas.openxmlformats.org/drawingml/2006/main"/>
-          <a:ln xmlns:a="http://schemas.openxmlformats.org/drawingml/2006/main" w="0">
-            <a:noFill/>
-          </a:ln>
-        </p:spPr>
-        <p:txBody>
-          <a:bodyPr xmlns:a="http://schemas.openxmlformats.org/drawingml/2006/main" wrap="square" lIns="0" tIns="0" rIns="0" bIns="0" anchor="t">
-            <a:noAutofit/>
-          </a:bodyPr>
-          <a:lstStyle xmlns:a="http://schemas.openxmlformats.org/drawingml/2006/main">
-            <a:defPPr algn="l">
-              <a:defRPr sz="2100" b="1">
-                <a:solidFill>
-                  <a:srgbClr val="276E68"/>
-                </a:solidFill>
-                <a:latin typeface="Microsoft JhengHei"/>
-                <a:ea typeface="Microsoft JhengHei"/>
-                <a:cs typeface="Microsoft JhengHei"/>
-              </a:defRPr>
-            </a:defPPr>
-          </a:lstStyle>
-          <a:p xmlns:a="http://schemas.openxmlformats.org/drawingml/2006/main">
-            <a:pPr algn="l">
-              <a:defRPr sz="2100" b="1">
-                <a:solidFill>
-                  <a:srgbClr val="276E68"/>
-                </a:solidFill>
-                <a:latin typeface="Microsoft JhengHei"/>
-                <a:ea typeface="Microsoft JhengHei"/>
-                <a:cs typeface="Microsoft JhengHei"/>
-              </a:defRPr>
-            </a:pPr>
-            <a:r>
-              <a:rPr sz="2100" b="1">
-                <a:solidFill>
-                  <a:srgbClr val="276E68"/>
-                </a:solidFill>
-                <a:latin typeface="Microsoft JhengHei"/>
-                <a:ea typeface="Microsoft JhengHei"/>
-                <a:cs typeface="Microsoft JhengHei"/>
-              </a:rPr>
-              <a:t>03　計算誤差</a:t>
-            </a:r>
-          </a:p>
-        </p:txBody>
-      </p:sp>
-      <p:sp>
-        <p:nvSpPr>
-          <p:cNvPr id="9" name="body">
-            <a:extLst xmlns:a="http://schemas.openxmlformats.org/drawingml/2006/main">
-              <a:ext uri="{FF2B5EF4-FFF2-40B4-BE49-F238E27FC236}">
-                <a16:creationId xmlns:a16="http://schemas.microsoft.com/office/drawing/2014/main" id="{3390B570-7D88-42DB-A1B8-E9D0B71ACFC9}"/>
-              </a:ext>
-            </a:extLst>
-          </p:cNvPr>
-          <p:cNvSpPr>
-            <a:spLocks xmlns:a="http://schemas.openxmlformats.org/drawingml/2006/main" noGrp="1"/>
-          </p:cNvSpPr>
-          <p:nvPr/>
-        </p:nvSpPr>
-        <p:spPr>
-          <a:xfrm xmlns:a="http://schemas.openxmlformats.org/drawingml/2006/main">
-            <a:off x="6286500" y="2819400"/>
-            <a:ext cx="2381250" cy="904875"/>
-          </a:xfrm>
-          <a:prstGeom xmlns:a="http://schemas.openxmlformats.org/drawingml/2006/main" prst="rect">
-            <a:avLst/>
-          </a:prstGeom>
-          <a:noFill xmlns:a="http://schemas.openxmlformats.org/drawingml/2006/main"/>
-          <a:ln xmlns:a="http://schemas.openxmlformats.org/drawingml/2006/main" w="0">
-            <a:noFill/>
-          </a:ln>
-        </p:spPr>
-        <p:txBody>
-          <a:bodyPr xmlns:a="http://schemas.openxmlformats.org/drawingml/2006/main" wrap="square" lIns="0" tIns="0" rIns="0" bIns="0" anchor="t">
-            <a:noAutofit/>
-          </a:bodyPr>
-          <a:lstStyle xmlns:a="http://schemas.openxmlformats.org/drawingml/2006/main">
-            <a:defPPr algn="l">
-              <a:defRPr sz="2025" b="0">
-                <a:solidFill>
-                  <a:srgbClr val="3A4A4E"/>
-                </a:solidFill>
-                <a:latin typeface="Microsoft JhengHei"/>
-                <a:ea typeface="Microsoft JhengHei"/>
-                <a:cs typeface="Microsoft JhengHei"/>
-              </a:defRPr>
-            </a:defPPr>
-          </a:lstStyle>
-          <a:p xmlns:a="http://schemas.openxmlformats.org/drawingml/2006/main">
-            <a:pPr algn="l">
-              <a:defRPr sz="2025" b="0">
-                <a:solidFill>
-                  <a:srgbClr val="3A4A4E"/>
-                </a:solidFill>
-                <a:latin typeface="Microsoft JhengHei"/>
-                <a:ea typeface="Microsoft JhengHei"/>
-                <a:cs typeface="Microsoft JhengHei"/>
-              </a:defRPr>
-            </a:pPr>
-            <a:r>
-              <a:rPr sz="2025" b="0">
-                <a:solidFill>
-                  <a:srgbClr val="3A4A4E"/>
-                </a:solidFill>
-                <a:latin typeface="Microsoft JhengHei"/>
-                <a:ea typeface="Microsoft JhengHei"/>
-                <a:cs typeface="Microsoft JhengHei"/>
-              </a:rPr>
-              <a:t>估價與已知</a:t>
-            </a:r>
-          </a:p>
-          <a:p xmlns:a="http://schemas.openxmlformats.org/drawingml/2006/main">
-            <a:pPr algn="l">
-              <a:defRPr sz="2025" b="0">
-                <a:solidFill>
-                  <a:srgbClr val="3A4A4E"/>
-                </a:solidFill>
-                <a:latin typeface="Microsoft JhengHei"/>
-                <a:ea typeface="Microsoft JhengHei"/>
-                <a:cs typeface="Microsoft JhengHei"/>
-              </a:defRPr>
-            </a:pPr>
-            <a:r>
-              <a:rPr sz="2025" b="0">
-                <a:solidFill>
-                  <a:srgbClr val="3A4A4E"/>
-                </a:solidFill>
-                <a:latin typeface="Microsoft JhengHei"/>
-                <a:ea typeface="Microsoft JhengHei"/>
-                <a:cs typeface="Microsoft JhengHei"/>
-              </a:rPr>
-              <a:t>答案比較</a:t>
-            </a:r>
-          </a:p>
-        </p:txBody>
-      </p:sp>
-      <p:sp>
-        <p:nvSpPr>
-          <p:cNvPr id="10" name="body">
-            <a:extLst xmlns:a="http://schemas.openxmlformats.org/drawingml/2006/main">
-              <a:ext uri="{FF2B5EF4-FFF2-40B4-BE49-F238E27FC236}">
-                <a16:creationId xmlns:a16="http://schemas.microsoft.com/office/drawing/2014/main" id="{576CAC0B-82B5-42D4-8346-FB6D904880C7}"/>
-              </a:ext>
-            </a:extLst>
-          </p:cNvPr>
-          <p:cNvSpPr>
-            <a:spLocks xmlns:a="http://schemas.openxmlformats.org/drawingml/2006/main" noGrp="1"/>
-          </p:cNvSpPr>
-          <p:nvPr/>
-        </p:nvSpPr>
-        <p:spPr>
-          <a:xfrm xmlns:a="http://schemas.openxmlformats.org/drawingml/2006/main">
-            <a:off x="9048750" y="2228850"/>
-            <a:ext cx="2381250" cy="428625"/>
-          </a:xfrm>
-          <a:prstGeom xmlns:a="http://schemas.openxmlformats.org/drawingml/2006/main" prst="rect">
-            <a:avLst/>
-          </a:prstGeom>
-          <a:noFill xmlns:a="http://schemas.openxmlformats.org/drawingml/2006/main"/>
-          <a:ln xmlns:a="http://schemas.openxmlformats.org/drawingml/2006/main" w="0">
-            <a:noFill/>
-          </a:ln>
-        </p:spPr>
-        <p:txBody>
-          <a:bodyPr xmlns:a="http://schemas.openxmlformats.org/drawingml/2006/main" wrap="square" lIns="0" tIns="0" rIns="0" bIns="0" anchor="t">
-            <a:noAutofit/>
-          </a:bodyPr>
-          <a:lstStyle xmlns:a="http://schemas.openxmlformats.org/drawingml/2006/main">
-            <a:defPPr algn="l">
-              <a:defRPr sz="2100" b="1">
-                <a:solidFill>
-                  <a:srgbClr val="276E68"/>
-                </a:solidFill>
-                <a:latin typeface="Microsoft JhengHei"/>
-                <a:ea typeface="Microsoft JhengHei"/>
-                <a:cs typeface="Microsoft JhengHei"/>
-              </a:defRPr>
-            </a:defPPr>
-          </a:lstStyle>
-          <a:p xmlns:a="http://schemas.openxmlformats.org/drawingml/2006/main">
-            <a:pPr algn="l">
-              <a:defRPr sz="2100" b="1">
-                <a:solidFill>
-                  <a:srgbClr val="276E68"/>
-                </a:solidFill>
-                <a:latin typeface="Microsoft JhengHei"/>
-                <a:ea typeface="Microsoft JhengHei"/>
-                <a:cs typeface="Microsoft JhengHei"/>
-              </a:defRPr>
-            </a:pPr>
-            <a:r>
-              <a:rPr sz="2100" b="1">
-                <a:solidFill>
-                  <a:srgbClr val="276E68"/>
-                </a:solidFill>
-                <a:latin typeface="Microsoft JhengHei"/>
-                <a:ea typeface="Microsoft JhengHei"/>
-                <a:cs typeface="Microsoft JhengHei"/>
-              </a:rPr>
-              <a:t>04　更新模型</a:t>
-            </a:r>
-          </a:p>
-        </p:txBody>
-      </p:sp>
-      <p:sp>
-        <p:nvSpPr>
-          <p:cNvPr id="11" name="body">
-            <a:extLst xmlns:a="http://schemas.openxmlformats.org/drawingml/2006/main">
-              <a:ext uri="{FF2B5EF4-FFF2-40B4-BE49-F238E27FC236}">
-                <a16:creationId xmlns:a16="http://schemas.microsoft.com/office/drawing/2014/main" id="{71BD9749-3504-48EE-BBC2-7918C9C48364}"/>
-              </a:ext>
-            </a:extLst>
-          </p:cNvPr>
-          <p:cNvSpPr>
-            <a:spLocks xmlns:a="http://schemas.openxmlformats.org/drawingml/2006/main" noGrp="1"/>
-          </p:cNvSpPr>
-          <p:nvPr/>
-        </p:nvSpPr>
-        <p:spPr>
-          <a:xfrm xmlns:a="http://schemas.openxmlformats.org/drawingml/2006/main">
-            <a:off x="9048750" y="2819400"/>
-            <a:ext cx="2381250" cy="904875"/>
-          </a:xfrm>
-          <a:prstGeom xmlns:a="http://schemas.openxmlformats.org/drawingml/2006/main" prst="rect">
-            <a:avLst/>
-          </a:prstGeom>
-          <a:noFill xmlns:a="http://schemas.openxmlformats.org/drawingml/2006/main"/>
-          <a:ln xmlns:a="http://schemas.openxmlformats.org/drawingml/2006/main" w="0">
-            <a:noFill/>
-          </a:ln>
-        </p:spPr>
-        <p:txBody>
-          <a:bodyPr xmlns:a="http://schemas.openxmlformats.org/drawingml/2006/main" wrap="square" lIns="0" tIns="0" rIns="0" bIns="0" anchor="t">
-            <a:noAutofit/>
-          </a:bodyPr>
-          <a:lstStyle xmlns:a="http://schemas.openxmlformats.org/drawingml/2006/main">
-            <a:defPPr algn="l">
-              <a:defRPr sz="2025" b="0">
-                <a:solidFill>
-                  <a:srgbClr val="3A4A4E"/>
-                </a:solidFill>
-                <a:latin typeface="Microsoft JhengHei"/>
-                <a:ea typeface="Microsoft JhengHei"/>
-                <a:cs typeface="Microsoft JhengHei"/>
-              </a:defRPr>
-            </a:defPPr>
-          </a:lstStyle>
-          <a:p xmlns:a="http://schemas.openxmlformats.org/drawingml/2006/main">
-            <a:pPr algn="l">
-              <a:defRPr sz="2025" b="0">
-                <a:solidFill>
-                  <a:srgbClr val="3A4A4E"/>
-                </a:solidFill>
-                <a:latin typeface="Microsoft JhengHei"/>
-                <a:ea typeface="Microsoft JhengHei"/>
-                <a:cs typeface="Microsoft JhengHei"/>
-              </a:defRPr>
-            </a:pPr>
-            <a:r>
-              <a:rPr sz="2025" b="0">
-                <a:solidFill>
-                  <a:srgbClr val="3A4A4E"/>
-                </a:solidFill>
-                <a:latin typeface="Microsoft JhengHei"/>
-                <a:ea typeface="Microsoft JhengHei"/>
-                <a:cs typeface="Microsoft JhengHei"/>
-              </a:rPr>
-              <a:t>新增小樹或</a:t>
-            </a:r>
-          </a:p>
-          <a:p xmlns:a="http://schemas.openxmlformats.org/drawingml/2006/main">
-            <a:pPr algn="l">
-              <a:defRPr sz="2025" b="0">
-                <a:solidFill>
-                  <a:srgbClr val="3A4A4E"/>
-                </a:solidFill>
-                <a:latin typeface="Microsoft JhengHei"/>
-                <a:ea typeface="Microsoft JhengHei"/>
-                <a:cs typeface="Microsoft JhengHei"/>
-              </a:defRPr>
-            </a:pPr>
-            <a:r>
-              <a:rPr sz="2025" b="0">
-                <a:solidFill>
-                  <a:srgbClr val="3A4A4E"/>
-                </a:solidFill>
-                <a:latin typeface="Microsoft JhengHei"/>
-                <a:ea typeface="Microsoft JhengHei"/>
-                <a:cs typeface="Microsoft JhengHei"/>
-              </a:rPr>
-              <a:t>更新網路權重</a:t>
-            </a:r>
-          </a:p>
-        </p:txBody>
-      </p:sp>
-      <p:sp>
-        <p:nvSpPr>
-          <p:cNvPr id="12" name="body">
-            <a:extLst xmlns:a="http://schemas.openxmlformats.org/drawingml/2006/main">
-              <a:ext uri="{FF2B5EF4-FFF2-40B4-BE49-F238E27FC236}">
-                <a16:creationId xmlns:a16="http://schemas.microsoft.com/office/drawing/2014/main" id="{314F27BD-D742-4235-8751-96A07E174AF2}"/>
-              </a:ext>
-            </a:extLst>
-          </p:cNvPr>
-          <p:cNvSpPr>
-            <a:spLocks xmlns:a="http://schemas.openxmlformats.org/drawingml/2006/main" noGrp="1"/>
-          </p:cNvSpPr>
-          <p:nvPr/>
-        </p:nvSpPr>
-        <p:spPr>
-          <a:xfrm xmlns:a="http://schemas.openxmlformats.org/drawingml/2006/main">
-            <a:off x="762000" y="4124325"/>
-            <a:ext cx="4953000" cy="428625"/>
-          </a:xfrm>
-          <a:prstGeom xmlns:a="http://schemas.openxmlformats.org/drawingml/2006/main" prst="rect">
-            <a:avLst/>
-          </a:prstGeom>
-          <a:noFill xmlns:a="http://schemas.openxmlformats.org/drawingml/2006/main"/>
-          <a:ln xmlns:a="http://schemas.openxmlformats.org/drawingml/2006/main" w="0">
-            <a:noFill/>
-          </a:ln>
-        </p:spPr>
-        <p:txBody>
-          <a:bodyPr xmlns:a="http://schemas.openxmlformats.org/drawingml/2006/main" wrap="square" lIns="0" tIns="0" rIns="0" bIns="0" anchor="t">
-            <a:noAutofit/>
-          </a:bodyPr>
-          <a:lstStyle xmlns:a="http://schemas.openxmlformats.org/drawingml/2006/main">
-            <a:defPPr algn="l">
-              <a:defRPr sz="2100" b="1">
-                <a:solidFill>
-                  <a:srgbClr val="276E68"/>
-                </a:solidFill>
-                <a:latin typeface="Microsoft JhengHei"/>
-                <a:ea typeface="Microsoft JhengHei"/>
-                <a:cs typeface="Microsoft JhengHei"/>
-              </a:defRPr>
-            </a:defPPr>
-          </a:lstStyle>
-          <a:p xmlns:a="http://schemas.openxmlformats.org/drawingml/2006/main">
-            <a:pPr algn="l">
-              <a:defRPr sz="2100" b="1">
-                <a:solidFill>
-                  <a:srgbClr val="276E68"/>
-                </a:solidFill>
-                <a:latin typeface="Microsoft JhengHei"/>
-                <a:ea typeface="Microsoft JhengHei"/>
-                <a:cs typeface="Microsoft JhengHei"/>
-              </a:defRPr>
-            </a:pPr>
-            <a:r>
-              <a:rPr sz="2100" b="1">
-                <a:solidFill>
-                  <a:srgbClr val="276E68"/>
-                </a:solidFill>
-                <a:latin typeface="Microsoft JhengHei"/>
-                <a:ea typeface="Microsoft JhengHei"/>
-                <a:cs typeface="Microsoft JhengHei"/>
-              </a:rPr>
-              <a:t>樹模型</a:t>
-            </a:r>
-          </a:p>
-        </p:txBody>
-      </p:sp>
-      <p:sp>
-        <p:nvSpPr>
-          <p:cNvPr id="13" name="body">
-            <a:extLst xmlns:a="http://schemas.openxmlformats.org/drawingml/2006/main">
-              <a:ext uri="{FF2B5EF4-FFF2-40B4-BE49-F238E27FC236}">
-                <a16:creationId xmlns:a16="http://schemas.microsoft.com/office/drawing/2014/main" id="{3CA986EE-7AC7-4A4D-BE6C-9E75DFBE5353}"/>
-              </a:ext>
-            </a:extLst>
-          </p:cNvPr>
-          <p:cNvSpPr>
-            <a:spLocks xmlns:a="http://schemas.openxmlformats.org/drawingml/2006/main" noGrp="1"/>
-          </p:cNvSpPr>
-          <p:nvPr/>
-        </p:nvSpPr>
-        <p:spPr>
-          <a:xfrm xmlns:a="http://schemas.openxmlformats.org/drawingml/2006/main">
-            <a:off x="762000" y="4657725"/>
-            <a:ext cx="5095875" cy="904875"/>
-          </a:xfrm>
-          <a:prstGeom xmlns:a="http://schemas.openxmlformats.org/drawingml/2006/main" prst="rect">
-            <a:avLst/>
-          </a:prstGeom>
-          <a:noFill xmlns:a="http://schemas.openxmlformats.org/drawingml/2006/main"/>
-          <a:ln xmlns:a="http://schemas.openxmlformats.org/drawingml/2006/main" w="0">
-            <a:noFill/>
-          </a:ln>
-        </p:spPr>
-        <p:txBody>
-          <a:bodyPr xmlns:a="http://schemas.openxmlformats.org/drawingml/2006/main" wrap="square" lIns="0" tIns="0" rIns="0" bIns="0" anchor="t">
-            <a:noAutofit/>
-          </a:bodyPr>
-          <a:lstStyle xmlns:a="http://schemas.openxmlformats.org/drawingml/2006/main">
-            <a:defPPr algn="l">
-              <a:defRPr sz="2175" b="0">
-                <a:solidFill>
-                  <a:srgbClr val="3A4A4E"/>
-                </a:solidFill>
-                <a:latin typeface="Microsoft JhengHei"/>
-                <a:ea typeface="Microsoft JhengHei"/>
-                <a:cs typeface="Microsoft JhengHei"/>
-              </a:defRPr>
-            </a:defPPr>
-          </a:lstStyle>
-          <a:p xmlns:a="http://schemas.openxmlformats.org/drawingml/2006/main">
-            <a:pPr algn="l">
-              <a:defRPr sz="2175" b="0">
-                <a:solidFill>
-                  <a:srgbClr val="3A4A4E"/>
-                </a:solidFill>
-                <a:latin typeface="Microsoft JhengHei"/>
-                <a:ea typeface="Microsoft JhengHei"/>
-                <a:cs typeface="Microsoft JhengHei"/>
-              </a:defRPr>
-            </a:pPr>
-            <a:r>
-              <a:rPr sz="2175" b="0">
-                <a:solidFill>
-                  <a:srgbClr val="3A4A4E"/>
-                </a:solidFill>
-                <a:latin typeface="Microsoft JhengHei"/>
-                <a:ea typeface="Microsoft JhengHei"/>
-                <a:cs typeface="Microsoft JhengHei"/>
-              </a:rPr>
-              <a:t>逐步增加小樹，修正誤差</a:t>
-            </a:r>
-          </a:p>
-          <a:p xmlns:a="http://schemas.openxmlformats.org/drawingml/2006/main">
-            <a:pPr algn="l">
-              <a:defRPr sz="2175" b="0">
-                <a:solidFill>
-                  <a:srgbClr val="3A4A4E"/>
-                </a:solidFill>
-                <a:latin typeface="Microsoft JhengHei"/>
-                <a:ea typeface="Microsoft JhengHei"/>
-                <a:cs typeface="Microsoft JhengHei"/>
-              </a:defRPr>
-            </a:pPr>
-            <a:r>
-              <a:rPr sz="2175" b="0">
-                <a:solidFill>
-                  <a:srgbClr val="3A4A4E"/>
-                </a:solidFill>
-                <a:latin typeface="Microsoft JhengHei"/>
-                <a:ea typeface="Microsoft JhengHei"/>
-                <a:cs typeface="Microsoft JhengHei"/>
-              </a:rPr>
-              <a:t>CatBoost、LightGBM</a:t>
-            </a:r>
-          </a:p>
-        </p:txBody>
-      </p:sp>
-      <p:sp>
-        <p:nvSpPr>
-          <p:cNvPr id="14" name="body">
-            <a:extLst xmlns:a="http://schemas.openxmlformats.org/drawingml/2006/main">
-              <a:ext uri="{FF2B5EF4-FFF2-40B4-BE49-F238E27FC236}">
-                <a16:creationId xmlns:a16="http://schemas.microsoft.com/office/drawing/2014/main" id="{76C97CF7-E726-43D6-856A-99134E305D8A}"/>
-              </a:ext>
-            </a:extLst>
-          </p:cNvPr>
-          <p:cNvSpPr>
-            <a:spLocks xmlns:a="http://schemas.openxmlformats.org/drawingml/2006/main" noGrp="1"/>
-          </p:cNvSpPr>
-          <p:nvPr/>
-        </p:nvSpPr>
-        <p:spPr>
-          <a:xfrm xmlns:a="http://schemas.openxmlformats.org/drawingml/2006/main">
-            <a:off x="6667500" y="4124325"/>
-            <a:ext cx="4762500" cy="428625"/>
-          </a:xfrm>
-          <a:prstGeom xmlns:a="http://schemas.openxmlformats.org/drawingml/2006/main" prst="rect">
-            <a:avLst/>
-          </a:prstGeom>
-          <a:noFill xmlns:a="http://schemas.openxmlformats.org/drawingml/2006/main"/>
-          <a:ln xmlns:a="http://schemas.openxmlformats.org/drawingml/2006/main" w="0">
-            <a:noFill/>
-          </a:ln>
-        </p:spPr>
-        <p:txBody>
-          <a:bodyPr xmlns:a="http://schemas.openxmlformats.org/drawingml/2006/main" wrap="square" lIns="0" tIns="0" rIns="0" bIns="0" anchor="t">
-            <a:noAutofit/>
-          </a:bodyPr>
-          <a:lstStyle xmlns:a="http://schemas.openxmlformats.org/drawingml/2006/main">
-            <a:defPPr algn="l">
-              <a:defRPr sz="2100" b="1">
-                <a:solidFill>
-                  <a:srgbClr val="276E68"/>
-                </a:solidFill>
-                <a:latin typeface="Microsoft JhengHei"/>
-                <a:ea typeface="Microsoft JhengHei"/>
-                <a:cs typeface="Microsoft JhengHei"/>
-              </a:defRPr>
-            </a:defPPr>
-          </a:lstStyle>
-          <a:p xmlns:a="http://schemas.openxmlformats.org/drawingml/2006/main">
-            <a:pPr algn="l">
-              <a:defRPr sz="2100" b="1">
-                <a:solidFill>
-                  <a:srgbClr val="276E68"/>
-                </a:solidFill>
-                <a:latin typeface="Microsoft JhengHei"/>
-                <a:ea typeface="Microsoft JhengHei"/>
-                <a:cs typeface="Microsoft JhengHei"/>
-              </a:defRPr>
-            </a:pPr>
-            <a:r>
-              <a:rPr sz="2100" b="1">
-                <a:solidFill>
-                  <a:srgbClr val="276E68"/>
-                </a:solidFill>
-                <a:latin typeface="Microsoft JhengHei"/>
-                <a:ea typeface="Microsoft JhengHei"/>
-                <a:cs typeface="Microsoft JhengHei"/>
-              </a:rPr>
-              <a:t>神經網路（以參考單價為例）</a:t>
-            </a:r>
-          </a:p>
-        </p:txBody>
-      </p:sp>
-      <p:sp>
-        <p:nvSpPr>
-          <p:cNvPr id="15" name="body">
-            <a:extLst xmlns:a="http://schemas.openxmlformats.org/drawingml/2006/main">
-              <a:ext uri="{FF2B5EF4-FFF2-40B4-BE49-F238E27FC236}">
-                <a16:creationId xmlns:a16="http://schemas.microsoft.com/office/drawing/2014/main" id="{8B34C4FA-467F-40F2-ADB1-17711DB55239}"/>
-              </a:ext>
-            </a:extLst>
-          </p:cNvPr>
-          <p:cNvSpPr>
-            <a:spLocks xmlns:a="http://schemas.openxmlformats.org/drawingml/2006/main" noGrp="1"/>
-          </p:cNvSpPr>
-          <p:nvPr/>
-        </p:nvSpPr>
-        <p:spPr>
-          <a:xfrm xmlns:a="http://schemas.openxmlformats.org/drawingml/2006/main">
-            <a:off x="6667500" y="4657725"/>
-            <a:ext cx="4762500" cy="904875"/>
-          </a:xfrm>
-          <a:prstGeom xmlns:a="http://schemas.openxmlformats.org/drawingml/2006/main" prst="rect">
-            <a:avLst/>
-          </a:prstGeom>
-          <a:noFill xmlns:a="http://schemas.openxmlformats.org/drawingml/2006/main"/>
-          <a:ln xmlns:a="http://schemas.openxmlformats.org/drawingml/2006/main" w="0">
-            <a:noFill/>
-          </a:ln>
-        </p:spPr>
-        <p:txBody>
-          <a:bodyPr xmlns:a="http://schemas.openxmlformats.org/drawingml/2006/main" wrap="square" lIns="0" tIns="0" rIns="0" bIns="0" anchor="t">
-            <a:noAutofit/>
-          </a:bodyPr>
-          <a:lstStyle xmlns:a="http://schemas.openxmlformats.org/drawingml/2006/main">
-            <a:defPPr algn="l">
-              <a:defRPr sz="2175" b="0">
-                <a:solidFill>
-                  <a:srgbClr val="3A4A4E"/>
-                </a:solidFill>
-                <a:latin typeface="Microsoft JhengHei"/>
-                <a:ea typeface="Microsoft JhengHei"/>
-                <a:cs typeface="Microsoft JhengHei"/>
-              </a:defRPr>
-            </a:defPPr>
-          </a:lstStyle>
-          <a:p xmlns:a="http://schemas.openxmlformats.org/drawingml/2006/main">
-            <a:pPr algn="l">
-              <a:defRPr sz="2175" b="0">
-                <a:solidFill>
-                  <a:srgbClr val="3A4A4E"/>
-                </a:solidFill>
-                <a:latin typeface="Microsoft JhengHei"/>
-                <a:ea typeface="Microsoft JhengHei"/>
-                <a:cs typeface="Microsoft JhengHei"/>
-              </a:defRPr>
-            </a:pPr>
-            <a:r>
-              <a:rPr sz="2175" b="0">
-                <a:solidFill>
-                  <a:srgbClr val="3A4A4E"/>
-                </a:solidFill>
-                <a:latin typeface="Microsoft JhengHei"/>
-                <a:ea typeface="Microsoft JhengHei"/>
-                <a:cs typeface="Microsoft JhengHei"/>
-              </a:rPr>
-              <a:t>反向調整計算權重</a:t>
-            </a:r>
-          </a:p>
-          <a:p xmlns:a="http://schemas.openxmlformats.org/drawingml/2006/main">
-            <a:pPr algn="l">
-              <a:defRPr sz="2175" b="0">
-                <a:solidFill>
-                  <a:srgbClr val="3A4A4E"/>
-                </a:solidFill>
-                <a:latin typeface="Microsoft JhengHei"/>
-                <a:ea typeface="Microsoft JhengHei"/>
-                <a:cs typeface="Microsoft JhengHei"/>
-              </a:defRPr>
-            </a:pPr>
-            <a:r>
-              <a:rPr sz="2175" b="0">
-                <a:solidFill>
-                  <a:srgbClr val="3A4A4E"/>
-                </a:solidFill>
-                <a:latin typeface="Microsoft JhengHei"/>
-                <a:ea typeface="Microsoft JhengHei"/>
-                <a:cs typeface="Microsoft JhengHei"/>
-              </a:rPr>
-              <a:t>每批2,048筆，固定30輪</a:t>
-            </a:r>
-          </a:p>
-        </p:txBody>
-      </p:sp>
-      <p:sp>
-        <p:nvSpPr>
-          <p:cNvPr id="16" name="body">
-            <a:extLst xmlns:a="http://schemas.openxmlformats.org/drawingml/2006/main">
-              <a:ext uri="{FF2B5EF4-FFF2-40B4-BE49-F238E27FC236}">
-                <a16:creationId xmlns:a16="http://schemas.microsoft.com/office/drawing/2014/main" id="{06FACB9C-4D24-4747-A078-E3DE86EAD669}"/>
-              </a:ext>
-            </a:extLst>
-          </p:cNvPr>
-          <p:cNvSpPr>
-            <a:spLocks xmlns:a="http://schemas.openxmlformats.org/drawingml/2006/main" noGrp="1"/>
-          </p:cNvSpPr>
-          <p:nvPr/>
-        </p:nvSpPr>
-        <p:spPr>
-          <a:xfrm xmlns:a="http://schemas.openxmlformats.org/drawingml/2006/main">
-            <a:off x="762000" y="5972175"/>
-            <a:ext cx="10572750" cy="571500"/>
-          </a:xfrm>
-          <a:prstGeom xmlns:a="http://schemas.openxmlformats.org/drawingml/2006/main" prst="rect">
-            <a:avLst/>
-          </a:prstGeom>
-          <a:noFill xmlns:a="http://schemas.openxmlformats.org/drawingml/2006/main"/>
-          <a:ln xmlns:a="http://schemas.openxmlformats.org/drawingml/2006/main" w="0">
-            <a:noFill/>
-          </a:ln>
-        </p:spPr>
-        <p:txBody>
-          <a:bodyPr xmlns:a="http://schemas.openxmlformats.org/drawingml/2006/main" wrap="square" lIns="0" tIns="0" rIns="0" bIns="0" anchor="t">
-            <a:noAutofit/>
-          </a:bodyPr>
-          <a:lstStyle xmlns:a="http://schemas.openxmlformats.org/drawingml/2006/main">
-            <a:defPPr algn="l">
-              <a:defRPr sz="1725" b="0">
-                <a:solidFill>
-                  <a:srgbClr val="718082"/>
-                </a:solidFill>
-                <a:latin typeface="Microsoft JhengHei"/>
-                <a:ea typeface="Microsoft JhengHei"/>
-                <a:cs typeface="Microsoft JhengHei"/>
-              </a:defRPr>
-            </a:defPPr>
-          </a:lstStyle>
-          <a:p xmlns:a="http://schemas.openxmlformats.org/drawingml/2006/main">
-            <a:pPr algn="l">
-              <a:defRPr sz="1725" b="0">
-                <a:solidFill>
-                  <a:srgbClr val="718082"/>
-                </a:solidFill>
-                <a:latin typeface="Microsoft JhengHei"/>
-                <a:ea typeface="Microsoft JhengHei"/>
-                <a:cs typeface="Microsoft JhengHei"/>
-              </a:defRPr>
-            </a:pPr>
-            <a:r>
-              <a:rPr sz="1725" b="0">
-                <a:solidFill>
-                  <a:srgbClr val="718082"/>
-                </a:solidFill>
-                <a:latin typeface="Microsoft JhengHei"/>
-                <a:ea typeface="Microsoft JhengHei"/>
-                <a:cs typeface="Microsoft JhengHei"/>
-              </a:rPr>
-              <a:t>訓練時更新參數。驗證時固定模型，只產生預測與計算誤差。</a:t>
+              <a:t>各模型先換回總價元，再進行分支融合與修正。驗證時固定參數。</a:t>
             </a:r>
           </a:p>
         </p:txBody>

</xml_diff>

<commit_message>
Explain date weights and reference prices with a concrete example
</commit_message>
<xml_diff>
--- a/teaching/final_presentation/台灣房屋銷售價格預測挑戰賽_上台簡報.pptx
+++ b/teaching/final_presentation/台灣房屋銷售價格預測挑戰賽_上台簡報.pptx
@@ -567,7 +567,7 @@
           <a:lstStyle xmlns:a="http://schemas.openxmlformats.org/drawingml/2006/main"/>
           <a:p xmlns:a="http://schemas.openxmlformats.org/drawingml/2006/main">
             <a:r>
-              <a:t>參考單價網路先建立一張參考表。從當期訓練成交依地區、交易類型和建物類型整理單價，資料不足就逐層放寬分組，最後回到整體參考。網路再從房屋條件學習調整倍率，用參考單價乘面積和倍率，產生總價。</a:t>
+              <a:t>接著，我替房子找一個估價起點。用當期訓練交易，依城市、行政區、交易類型和建物類型分類，整理參考單價，稱為分組先驗。採用中位單價，近期交易的影響較大；同類不足三十筆就逐層放寬條件。</a:t>
             </a:r>
           </a:p>
           <a:p xmlns:a="http://schemas.openxmlformats.org/drawingml/2006/main">
@@ -577,7 +577,7 @@
           </a:p>
           <a:p xmlns:a="http://schemas.openxmlformats.org/drawingml/2006/main">
             <a:r>
-              <a:t>為避免自己的答案帶回輸入，我按建案分成五組，每組只使用其他四組的價格建立參考。建案用來分組，不是參考表的查詢鍵。這叫分組折外處理，隔開同建案的答案。當某組作為被預測的交易時，該組答案不參與建立自己的參考。</a:t>
+              <a:t>畫面是假設例子。參考單價每平方公尺二十萬元，面積五十平方公尺，參考總價是一千萬元。神經網路再依房屋條件學調整倍率。假設倍率是一點一，預測總價就是一千一百萬元。倍率由模型學習，不是我逐筆指定。</a:t>
             </a:r>
           </a:p>
           <a:p xmlns:a="http://schemas.openxmlformats.org/drawingml/2006/main">
@@ -587,7 +587,7 @@
           </a:p>
           <a:p xmlns:a="http://schemas.openxmlformats.org/drawingml/2006/main">
             <a:r>
-              <a:t>新交易使用當期全部訓練資料建立參考。建案分組不等於時間切分，仍要遵守時間邊界。</a:t>
+              <a:t>右下方是防止答案回流的另一個動作。建立訓練用參考價時，依建案分成五組，同建案留在同組。每組只用其他四組建立參考價，排除自己所在整組的答案。這是按建案隔開，沒有按年份切成五段。</a:t>
             </a:r>
           </a:p>
           <a:p xmlns:a="http://schemas.openxmlformats.org/drawingml/2006/main">
@@ -597,7 +597,7 @@
           </a:p>
           <a:p xmlns:a="http://schemas.openxmlformats.org/drawingml/2006/main">
             <a:r>
-              <a:t>這支網路使用日期加權平滑絕對損失，十萬元是轉折，讓小誤差附近的更新較平順。固定訓練三十輪，保存最後一輪，不用驗證最低點挑輪數。接著看另行保存的訓練診斷。</a:t>
+              <a:t>預測新的交易時，沿用當期完整訓練資料建立的參考表，不使用新交易的真價。模型先有參考價，再學如何調整，最後換成總價。</a:t>
             </a:r>
           </a:p>
           <a:p xmlns:a="http://schemas.openxmlformats.org/drawingml/2006/main">
@@ -612,7 +612,7 @@
           </a:p>
           <a:p xmlns:a="http://schemas.openxmlformats.org/drawingml/2006/main">
             <a:r>
-              <a:t>用答案混入參考基準的具體風險解釋OOF，明確保留按建案而非時間分組的限制。</a:t>
+              <a:t>畫面先展示參考單價及具體金額，再分開說明查表分類與訓練時隔開答案，避免把兩種分組混為一談。先驗精確查詢依序為城市＋行政區＋交易類型＋建物類型，城市＋交易類型＋建物類型，交易類型＋建物類型，交易類型，最後全域。前四層至少30筆原始reference交易；採365天日期加權中位單價，全域不受30筆門檻限制。建案不是先驗查表key，是OOF隔離分組；同組與同折的全部標籤均排除，訓練每列先驗可用同一fit範圍內較晚交易，故不是時間OOF。各時間切點的query標籤不參與先驗；query查完整當期fit。正倍率由Softplus直接輸出，並非log倍率再exp；總價＝參考單價×有效面積×倍率。NN固定30輪，日期加權SmoothL1轉折為10萬元，參考價加權中位數與NN損失加權是不同步驟。例子20萬元/m²、50m²、1.1及1100萬元皆為教學假設，未當成實際評分或真價。</a:t>
             </a:r>
           </a:p>
           <a:p xmlns:a="http://schemas.openxmlformats.org/drawingml/2006/main">
@@ -627,7 +627,27 @@
           </a:p>
           <a:p xmlns:a="http://schemas.openxmlformats.org/drawingml/2006/main">
             <a:r>
-              <a:t>課程交易資料、保存的程式與發行證據、方法與程式導覽。</a:t>
+              <a:t>src/round52_price_prior.py</a:t>
+            </a:r>
+          </a:p>
+          <a:p xmlns:a="http://schemas.openxmlformats.org/drawingml/2006/main">
+            <a:r>
+              <a:t>src/round60_recency_price_prior.py</a:t>
+            </a:r>
+          </a:p>
+          <a:p xmlns:a="http://schemas.openxmlformats.org/drawingml/2006/main">
+            <a:r>
+              <a:t>src/round47_nn_train.py</a:t>
+            </a:r>
+          </a:p>
+          <a:p xmlns:a="http://schemas.openxmlformats.org/drawingml/2006/main">
+            <a:r>
+              <a:t>src/round107_weighted_smooth_train.py</a:t>
+            </a:r>
+          </a:p>
+          <a:p xmlns:a="http://schemas.openxmlformats.org/drawingml/2006/main">
+            <a:r>
+              <a:t>reports/v25_method_and_code_20261010.md</a:t>
             </a:r>
           </a:p>
         </p:txBody>
@@ -2357,7 +2377,7 @@
           <a:lstStyle xmlns:a="http://schemas.openxmlformats.org/drawingml/2006/main"/>
           <a:p xmlns:a="http://schemas.openxmlformats.org/drawingml/2006/main">
             <a:r>
-              <a:t>特定模型也加入日期權重。距離當期最新日期越遠，相對權重越小，因為近期成交可能更接近待預測期間的市場。</a:t>
+              <a:t>上一頁說明面積如何影響總價誤差，接著我處理交易日期。房價會隨時間改變，所以我讓較近期成交對學習有較大影響。這個影響程度叫權重，會乘在每筆交易的訓練損失上。</a:t>
             </a:r>
           </a:p>
           <a:p xmlns:a="http://schemas.openxmlformats.org/drawingml/2006/main">
@@ -2367,7 +2387,7 @@
           </a:p>
           <a:p xmlns:a="http://schemas.openxmlformats.org/drawingml/2006/main">
             <a:r>
-              <a:t>這裡使用三百六十五天半衰期。圖中最新日期的相對權重是一，早一年是零點五，早兩年是零點二五。這是正規化前的比例，實際將有效日期權重除以它們的平均值，無效日期給一。</a:t>
+              <a:t>圖中是正規化前的相對比例。當期最新的有效日期設為一，早三百六十五天是零點五，早七百三十天是零點二五。每早一年，原始影響降為一半，這個設定叫三百六十五天半衰期。</a:t>
             </a:r>
           </a:p>
           <a:p xmlns:a="http://schemas.openxmlformats.org/drawingml/2006/main">
@@ -2377,7 +2397,7 @@
           </a:p>
           <a:p xmlns:a="http://schemas.openxmlformats.org/drawingml/2006/main">
             <a:r>
-              <a:t>權重乘在每筆訓練誤差上，改變它對參數更新的影響，不會把一千萬元的真實價格乘成五百萬元。單價樹模型還搭配面積權重，參考單價網路也用日期權重，其他模型保留各自設定。舊資料仍參與學習，只是影響程度不同。</a:t>
+              <a:t>權重調整的是學習影響，成交價仍維持原值，舊交易也繼續參與。單價樹模型還搭配面積權重，參考單價網路使用日期加權損失，其他模型保留各自設定。下一頁建立參考單價時，也會讓近期成交有較大的影響。</a:t>
             </a:r>
           </a:p>
           <a:p xmlns:a="http://schemas.openxmlformats.org/drawingml/2006/main">
@@ -2392,7 +2412,7 @@
           </a:p>
           <a:p xmlns:a="http://schemas.openxmlformats.org/drawingml/2006/main">
             <a:r>
-              <a:t>說清楚權重作用於訓練誤差，不是修改房價，並呈現半衰期示意與實際正規化差別。</a:t>
+              <a:t>先接續上一頁的面積誤差，再交代日期加權的動機，定義權重後才讀圖。一年是365天，1、0.5、0.25是正規化前原始相對比例。實際有效日期權重除以有效參考列權重平均值，無效日期給1；相對於每次reference資料中的最新有效日期計算，OOF補集各自建立anchor。日期權重在NN訓練時乘loss，在下一頁先驗建立時用於加權中位數，屬兩個不同作用。單價樹另有面積權重，不宣稱六模型都共用同一權重，也不保證加權一定改善。</a:t>
             </a:r>
           </a:p>
           <a:p xmlns:a="http://schemas.openxmlformats.org/drawingml/2006/main">
@@ -2407,7 +2427,27 @@
           </a:p>
           <a:p xmlns:a="http://schemas.openxmlformats.org/drawingml/2006/main">
             <a:r>
-              <a:t>課程交易資料、保存的程式與發行證據、方法與程式導覽。</a:t>
+              <a:t>src/round79_recency_unit.py</a:t>
+            </a:r>
+          </a:p>
+          <a:p xmlns:a="http://schemas.openxmlformats.org/drawingml/2006/main">
+            <a:r>
+              <a:t>src/round60_recency_price_prior.py</a:t>
+            </a:r>
+          </a:p>
+          <a:p xmlns:a="http://schemas.openxmlformats.org/drawingml/2006/main">
+            <a:r>
+              <a:t>src/round63_recency_weighted_prior_train.py</a:t>
+            </a:r>
+          </a:p>
+          <a:p xmlns:a="http://schemas.openxmlformats.org/drawingml/2006/main">
+            <a:r>
+              <a:t>src/round107_weighted_smooth_train.py</a:t>
+            </a:r>
+          </a:p>
+          <a:p xmlns:a="http://schemas.openxmlformats.org/drawingml/2006/main">
+            <a:r>
+              <a:t>reports/v25_method_and_code_20261010.md</a:t>
             </a:r>
           </a:p>
         </p:txBody>
@@ -5941,10 +5981,10 @@
       </p:grpSpPr>
       <p:sp>
         <p:nvSpPr>
-          <p:cNvPr id="9" name="slide-title">
+          <p:cNvPr id="18" name="slide-title">
             <a:extLst xmlns:a="http://schemas.openxmlformats.org/drawingml/2006/main">
               <a:ext uri="{FF2B5EF4-FFF2-40B4-BE49-F238E27FC236}">
-                <a16:creationId xmlns:a16="http://schemas.microsoft.com/office/drawing/2014/main" id="{7B295D6F-10EC-49E0-9AFD-000B87708F62}"/>
+                <a16:creationId xmlns:a16="http://schemas.microsoft.com/office/drawing/2014/main" id="{0547BFED-AB20-4DBC-A2AD-D149D77FEDCF}"/>
               </a:ext>
             </a:extLst>
           </p:cNvPr>
@@ -6002,7 +6042,7 @@
                 <a:ea typeface="Microsoft JhengHei"/>
                 <a:cs typeface="Microsoft JhengHei"/>
               </a:rPr>
-              <a:t>參考單價與分組先驗</a:t>
+              <a:t>相似交易提供參考單價</a:t>
             </a:r>
           </a:p>
         </p:txBody>
@@ -6012,7 +6052,7 @@
           <p:cNvPr id="2" name="body">
             <a:extLst xmlns:a="http://schemas.openxmlformats.org/drawingml/2006/main">
               <a:ext uri="{FF2B5EF4-FFF2-40B4-BE49-F238E27FC236}">
-                <a16:creationId xmlns:a16="http://schemas.microsoft.com/office/drawing/2014/main" id="{6028D9C9-3C11-42BA-9D21-DF5803000F03}"/>
+                <a16:creationId xmlns:a16="http://schemas.microsoft.com/office/drawing/2014/main" id="{E2D4827E-8BEE-4D64-A342-324F4BF39E69}"/>
               </a:ext>
             </a:extLst>
           </p:cNvPr>
@@ -6080,7 +6120,7 @@
           <p:cNvPr id="3" name="body">
             <a:extLst xmlns:a="http://schemas.openxmlformats.org/drawingml/2006/main">
               <a:ext uri="{FF2B5EF4-FFF2-40B4-BE49-F238E27FC236}">
-                <a16:creationId xmlns:a16="http://schemas.microsoft.com/office/drawing/2014/main" id="{376D7E41-00E5-4F74-A3FE-CF85D774CB71}"/>
+                <a16:creationId xmlns:a16="http://schemas.microsoft.com/office/drawing/2014/main" id="{1C15B2B4-E88C-49C1-89E8-814E0D21601B}"/>
               </a:ext>
             </a:extLst>
           </p:cNvPr>
@@ -6091,8 +6131,8 @@
         </p:nvSpPr>
         <p:spPr>
           <a:xfrm xmlns:a="http://schemas.openxmlformats.org/drawingml/2006/main">
-            <a:off x="762000" y="1714500"/>
-            <a:ext cx="10668000" cy="762000"/>
+            <a:off x="762000" y="1457325"/>
+            <a:ext cx="10668000" cy="438150"/>
           </a:xfrm>
           <a:prstGeom xmlns:a="http://schemas.openxmlformats.org/drawingml/2006/main" prst="rect">
             <a:avLst/>
@@ -6108,9 +6148,9 @@
           </a:bodyPr>
           <a:lstStyle xmlns:a="http://schemas.openxmlformats.org/drawingml/2006/main">
             <a:defPPr algn="l">
-              <a:defRPr sz="2700" b="1">
-                <a:solidFill>
-                  <a:srgbClr val="23343A"/>
+              <a:defRPr sz="2175" b="0">
+                <a:solidFill>
+                  <a:srgbClr val="718082"/>
                 </a:solidFill>
                 <a:latin typeface="Microsoft JhengHei"/>
                 <a:ea typeface="Microsoft JhengHei"/>
@@ -6120,9 +6160,9 @@
           </a:lstStyle>
           <a:p xmlns:a="http://schemas.openxmlformats.org/drawingml/2006/main">
             <a:pPr algn="l">
-              <a:defRPr sz="2700" b="1">
-                <a:solidFill>
-                  <a:srgbClr val="23343A"/>
+              <a:defRPr sz="2175" b="0">
+                <a:solidFill>
+                  <a:srgbClr val="718082"/>
                 </a:solidFill>
                 <a:latin typeface="Microsoft JhengHei"/>
                 <a:ea typeface="Microsoft JhengHei"/>
@@ -6130,15 +6170,15 @@
               </a:defRPr>
             </a:pPr>
             <a:r>
-              <a:rPr sz="2700" b="1">
-                <a:solidFill>
-                  <a:srgbClr val="23343A"/>
+              <a:rPr sz="2175" b="0">
+                <a:solidFill>
+                  <a:srgbClr val="718082"/>
                 </a:solidFill>
                 <a:latin typeface="Microsoft JhengHei"/>
                 <a:ea typeface="Microsoft JhengHei"/>
                 <a:cs typeface="Microsoft JhengHei"/>
               </a:rPr>
-              <a:t>參考單價 × 有效面積 × 預測倍率</a:t>
+              <a:t>用同類交易的中位單價作參考，近期交易影響較大</a:t>
             </a:r>
           </a:p>
         </p:txBody>
@@ -6148,7 +6188,7 @@
           <p:cNvPr id="4" name="body">
             <a:extLst xmlns:a="http://schemas.openxmlformats.org/drawingml/2006/main">
               <a:ext uri="{FF2B5EF4-FFF2-40B4-BE49-F238E27FC236}">
-                <a16:creationId xmlns:a16="http://schemas.microsoft.com/office/drawing/2014/main" id="{75A359F4-256C-43C6-AC41-3CE01B565532}"/>
+                <a16:creationId xmlns:a16="http://schemas.microsoft.com/office/drawing/2014/main" id="{78A3FF46-0B9E-4B3D-8E7A-74E5EF85FBF0}"/>
               </a:ext>
             </a:extLst>
           </p:cNvPr>
@@ -6159,7 +6199,778 @@
         </p:nvSpPr>
         <p:spPr>
           <a:xfrm xmlns:a="http://schemas.openxmlformats.org/drawingml/2006/main">
-            <a:off x="762000" y="3048000"/>
+            <a:off x="762000" y="2238375"/>
+            <a:ext cx="10668000" cy="333375"/>
+          </a:xfrm>
+          <a:prstGeom xmlns:a="http://schemas.openxmlformats.org/drawingml/2006/main" prst="rect">
+            <a:avLst/>
+          </a:prstGeom>
+          <a:noFill xmlns:a="http://schemas.openxmlformats.org/drawingml/2006/main"/>
+          <a:ln xmlns:a="http://schemas.openxmlformats.org/drawingml/2006/main" w="0">
+            <a:noFill/>
+          </a:ln>
+        </p:spPr>
+        <p:txBody>
+          <a:bodyPr xmlns:a="http://schemas.openxmlformats.org/drawingml/2006/main" wrap="square" lIns="0" tIns="0" rIns="0" bIns="0" anchor="t">
+            <a:noAutofit/>
+          </a:bodyPr>
+          <a:lstStyle xmlns:a="http://schemas.openxmlformats.org/drawingml/2006/main">
+            <a:defPPr algn="l">
+              <a:defRPr sz="1725" b="0">
+                <a:solidFill>
+                  <a:srgbClr val="718082"/>
+                </a:solidFill>
+                <a:latin typeface="Microsoft JhengHei"/>
+                <a:ea typeface="Microsoft JhengHei"/>
+                <a:cs typeface="Microsoft JhengHei"/>
+              </a:defRPr>
+            </a:defPPr>
+          </a:lstStyle>
+          <a:p xmlns:a="http://schemas.openxmlformats.org/drawingml/2006/main">
+            <a:pPr algn="l">
+              <a:defRPr sz="1725" b="0">
+                <a:solidFill>
+                  <a:srgbClr val="718082"/>
+                </a:solidFill>
+                <a:latin typeface="Microsoft JhengHei"/>
+                <a:ea typeface="Microsoft JhengHei"/>
+                <a:cs typeface="Microsoft JhengHei"/>
+              </a:defRPr>
+            </a:pPr>
+            <a:r>
+              <a:rPr sz="1725" b="0">
+                <a:solidFill>
+                  <a:srgbClr val="718082"/>
+                </a:solidFill>
+                <a:latin typeface="Microsoft JhengHei"/>
+                <a:ea typeface="Microsoft JhengHei"/>
+                <a:cs typeface="Microsoft JhengHei"/>
+              </a:rPr>
+              <a:t>教學假例</a:t>
+            </a:r>
+          </a:p>
+        </p:txBody>
+      </p:sp>
+      <p:sp>
+        <p:nvSpPr>
+          <p:cNvPr id="5" name="body">
+            <a:extLst xmlns:a="http://schemas.openxmlformats.org/drawingml/2006/main">
+              <a:ext uri="{FF2B5EF4-FFF2-40B4-BE49-F238E27FC236}">
+                <a16:creationId xmlns:a16="http://schemas.microsoft.com/office/drawing/2014/main" id="{E84E899A-5C1D-4D9F-99D0-E0FE0627F7DA}"/>
+              </a:ext>
+            </a:extLst>
+          </p:cNvPr>
+          <p:cNvSpPr>
+            <a:spLocks xmlns:a="http://schemas.openxmlformats.org/drawingml/2006/main" noGrp="1"/>
+          </p:cNvSpPr>
+          <p:nvPr/>
+        </p:nvSpPr>
+        <p:spPr>
+          <a:xfrm xmlns:a="http://schemas.openxmlformats.org/drawingml/2006/main">
+            <a:off x="762000" y="2714625"/>
+            <a:ext cx="2619375" cy="666750"/>
+          </a:xfrm>
+          <a:prstGeom xmlns:a="http://schemas.openxmlformats.org/drawingml/2006/main" prst="rect">
+            <a:avLst/>
+          </a:prstGeom>
+          <a:noFill xmlns:a="http://schemas.openxmlformats.org/drawingml/2006/main"/>
+          <a:ln xmlns:a="http://schemas.openxmlformats.org/drawingml/2006/main" w="0">
+            <a:noFill/>
+          </a:ln>
+        </p:spPr>
+        <p:txBody>
+          <a:bodyPr xmlns:a="http://schemas.openxmlformats.org/drawingml/2006/main" wrap="square" lIns="0" tIns="0" rIns="0" bIns="0" anchor="t">
+            <a:noAutofit/>
+          </a:bodyPr>
+          <a:lstStyle xmlns:a="http://schemas.openxmlformats.org/drawingml/2006/main">
+            <a:defPPr algn="l">
+              <a:defRPr sz="3450" b="1">
+                <a:solidFill>
+                  <a:srgbClr val="23343A"/>
+                </a:solidFill>
+                <a:latin typeface="Microsoft JhengHei"/>
+                <a:ea typeface="Microsoft JhengHei"/>
+                <a:cs typeface="Microsoft JhengHei"/>
+              </a:defRPr>
+            </a:defPPr>
+          </a:lstStyle>
+          <a:p xmlns:a="http://schemas.openxmlformats.org/drawingml/2006/main">
+            <a:pPr algn="l">
+              <a:defRPr sz="3450" b="1">
+                <a:solidFill>
+                  <a:srgbClr val="23343A"/>
+                </a:solidFill>
+                <a:latin typeface="Microsoft JhengHei"/>
+                <a:ea typeface="Microsoft JhengHei"/>
+                <a:cs typeface="Microsoft JhengHei"/>
+              </a:defRPr>
+            </a:pPr>
+            <a:r>
+              <a:rPr sz="3450" b="1">
+                <a:solidFill>
+                  <a:srgbClr val="23343A"/>
+                </a:solidFill>
+                <a:latin typeface="Microsoft JhengHei"/>
+                <a:ea typeface="Microsoft JhengHei"/>
+                <a:cs typeface="Microsoft JhengHei"/>
+              </a:rPr>
+              <a:t>20萬/m²</a:t>
+            </a:r>
+          </a:p>
+        </p:txBody>
+      </p:sp>
+      <p:sp>
+        <p:nvSpPr>
+          <p:cNvPr id="6" name="body">
+            <a:extLst xmlns:a="http://schemas.openxmlformats.org/drawingml/2006/main">
+              <a:ext uri="{FF2B5EF4-FFF2-40B4-BE49-F238E27FC236}">
+                <a16:creationId xmlns:a16="http://schemas.microsoft.com/office/drawing/2014/main" id="{F7EDECAA-4FD8-48A5-802D-43C921EEC0F2}"/>
+              </a:ext>
+            </a:extLst>
+          </p:cNvPr>
+          <p:cNvSpPr>
+            <a:spLocks xmlns:a="http://schemas.openxmlformats.org/drawingml/2006/main" noGrp="1"/>
+          </p:cNvSpPr>
+          <p:nvPr/>
+        </p:nvSpPr>
+        <p:spPr>
+          <a:xfrm xmlns:a="http://schemas.openxmlformats.org/drawingml/2006/main">
+            <a:off x="3381375" y="2714625"/>
+            <a:ext cx="2524125" cy="666750"/>
+          </a:xfrm>
+          <a:prstGeom xmlns:a="http://schemas.openxmlformats.org/drawingml/2006/main" prst="rect">
+            <a:avLst/>
+          </a:prstGeom>
+          <a:noFill xmlns:a="http://schemas.openxmlformats.org/drawingml/2006/main"/>
+          <a:ln xmlns:a="http://schemas.openxmlformats.org/drawingml/2006/main" w="0">
+            <a:noFill/>
+          </a:ln>
+        </p:spPr>
+        <p:txBody>
+          <a:bodyPr xmlns:a="http://schemas.openxmlformats.org/drawingml/2006/main" wrap="square" lIns="0" tIns="0" rIns="0" bIns="0" anchor="t">
+            <a:noAutofit/>
+          </a:bodyPr>
+          <a:lstStyle xmlns:a="http://schemas.openxmlformats.org/drawingml/2006/main">
+            <a:defPPr algn="l">
+              <a:defRPr sz="3450" b="1">
+                <a:solidFill>
+                  <a:srgbClr val="23343A"/>
+                </a:solidFill>
+                <a:latin typeface="Microsoft JhengHei"/>
+                <a:ea typeface="Microsoft JhengHei"/>
+                <a:cs typeface="Microsoft JhengHei"/>
+              </a:defRPr>
+            </a:defPPr>
+          </a:lstStyle>
+          <a:p xmlns:a="http://schemas.openxmlformats.org/drawingml/2006/main">
+            <a:pPr algn="l">
+              <a:defRPr sz="3450" b="1">
+                <a:solidFill>
+                  <a:srgbClr val="23343A"/>
+                </a:solidFill>
+                <a:latin typeface="Microsoft JhengHei"/>
+                <a:ea typeface="Microsoft JhengHei"/>
+                <a:cs typeface="Microsoft JhengHei"/>
+              </a:defRPr>
+            </a:pPr>
+            <a:r>
+              <a:rPr sz="3450" b="1">
+                <a:solidFill>
+                  <a:srgbClr val="23343A"/>
+                </a:solidFill>
+                <a:latin typeface="Microsoft JhengHei"/>
+                <a:ea typeface="Microsoft JhengHei"/>
+                <a:cs typeface="Microsoft JhengHei"/>
+              </a:rPr>
+              <a:t>× 50m²</a:t>
+            </a:r>
+          </a:p>
+        </p:txBody>
+      </p:sp>
+      <p:sp>
+        <p:nvSpPr>
+          <p:cNvPr id="7" name="body">
+            <a:extLst xmlns:a="http://schemas.openxmlformats.org/drawingml/2006/main">
+              <a:ext uri="{FF2B5EF4-FFF2-40B4-BE49-F238E27FC236}">
+                <a16:creationId xmlns:a16="http://schemas.microsoft.com/office/drawing/2014/main" id="{0F3105CB-62A4-41F2-AF03-EBFD61F1D411}"/>
+              </a:ext>
+            </a:extLst>
+          </p:cNvPr>
+          <p:cNvSpPr>
+            <a:spLocks xmlns:a="http://schemas.openxmlformats.org/drawingml/2006/main" noGrp="1"/>
+          </p:cNvSpPr>
+          <p:nvPr/>
+        </p:nvSpPr>
+        <p:spPr>
+          <a:xfrm xmlns:a="http://schemas.openxmlformats.org/drawingml/2006/main">
+            <a:off x="5905500" y="2714625"/>
+            <a:ext cx="2667000" cy="666750"/>
+          </a:xfrm>
+          <a:prstGeom xmlns:a="http://schemas.openxmlformats.org/drawingml/2006/main" prst="rect">
+            <a:avLst/>
+          </a:prstGeom>
+          <a:noFill xmlns:a="http://schemas.openxmlformats.org/drawingml/2006/main"/>
+          <a:ln xmlns:a="http://schemas.openxmlformats.org/drawingml/2006/main" w="0">
+            <a:noFill/>
+          </a:ln>
+        </p:spPr>
+        <p:txBody>
+          <a:bodyPr xmlns:a="http://schemas.openxmlformats.org/drawingml/2006/main" wrap="square" lIns="0" tIns="0" rIns="0" bIns="0" anchor="t">
+            <a:noAutofit/>
+          </a:bodyPr>
+          <a:lstStyle xmlns:a="http://schemas.openxmlformats.org/drawingml/2006/main">
+            <a:defPPr algn="l">
+              <a:defRPr sz="3450" b="1">
+                <a:solidFill>
+                  <a:srgbClr val="276E68"/>
+                </a:solidFill>
+                <a:latin typeface="Microsoft JhengHei"/>
+                <a:ea typeface="Microsoft JhengHei"/>
+                <a:cs typeface="Microsoft JhengHei"/>
+              </a:defRPr>
+            </a:defPPr>
+          </a:lstStyle>
+          <a:p xmlns:a="http://schemas.openxmlformats.org/drawingml/2006/main">
+            <a:pPr algn="l">
+              <a:defRPr sz="3450" b="1">
+                <a:solidFill>
+                  <a:srgbClr val="276E68"/>
+                </a:solidFill>
+                <a:latin typeface="Microsoft JhengHei"/>
+                <a:ea typeface="Microsoft JhengHei"/>
+                <a:cs typeface="Microsoft JhengHei"/>
+              </a:defRPr>
+            </a:pPr>
+            <a:r>
+              <a:rPr sz="3450" b="1">
+                <a:solidFill>
+                  <a:srgbClr val="276E68"/>
+                </a:solidFill>
+                <a:latin typeface="Microsoft JhengHei"/>
+                <a:ea typeface="Microsoft JhengHei"/>
+                <a:cs typeface="Microsoft JhengHei"/>
+              </a:rPr>
+              <a:t>× 1.1</a:t>
+            </a:r>
+          </a:p>
+        </p:txBody>
+      </p:sp>
+      <p:sp>
+        <p:nvSpPr>
+          <p:cNvPr id="8" name="body">
+            <a:extLst xmlns:a="http://schemas.openxmlformats.org/drawingml/2006/main">
+              <a:ext uri="{FF2B5EF4-FFF2-40B4-BE49-F238E27FC236}">
+                <a16:creationId xmlns:a16="http://schemas.microsoft.com/office/drawing/2014/main" id="{347A99BF-C24D-4BAB-8680-B18013808897}"/>
+              </a:ext>
+            </a:extLst>
+          </p:cNvPr>
+          <p:cNvSpPr>
+            <a:spLocks xmlns:a="http://schemas.openxmlformats.org/drawingml/2006/main" noGrp="1"/>
+          </p:cNvSpPr>
+          <p:nvPr/>
+        </p:nvSpPr>
+        <p:spPr>
+          <a:xfrm xmlns:a="http://schemas.openxmlformats.org/drawingml/2006/main">
+            <a:off x="8572500" y="2714625"/>
+            <a:ext cx="2857500" cy="666750"/>
+          </a:xfrm>
+          <a:prstGeom xmlns:a="http://schemas.openxmlformats.org/drawingml/2006/main" prst="rect">
+            <a:avLst/>
+          </a:prstGeom>
+          <a:noFill xmlns:a="http://schemas.openxmlformats.org/drawingml/2006/main"/>
+          <a:ln xmlns:a="http://schemas.openxmlformats.org/drawingml/2006/main" w="0">
+            <a:noFill/>
+          </a:ln>
+        </p:spPr>
+        <p:txBody>
+          <a:bodyPr xmlns:a="http://schemas.openxmlformats.org/drawingml/2006/main" wrap="square" lIns="0" tIns="0" rIns="0" bIns="0" anchor="t">
+            <a:noAutofit/>
+          </a:bodyPr>
+          <a:lstStyle xmlns:a="http://schemas.openxmlformats.org/drawingml/2006/main">
+            <a:defPPr algn="l">
+              <a:defRPr sz="3450" b="1">
+                <a:solidFill>
+                  <a:srgbClr val="276E68"/>
+                </a:solidFill>
+                <a:latin typeface="Microsoft JhengHei"/>
+                <a:ea typeface="Microsoft JhengHei"/>
+                <a:cs typeface="Microsoft JhengHei"/>
+              </a:defRPr>
+            </a:defPPr>
+          </a:lstStyle>
+          <a:p xmlns:a="http://schemas.openxmlformats.org/drawingml/2006/main">
+            <a:pPr algn="l">
+              <a:defRPr sz="3450" b="1">
+                <a:solidFill>
+                  <a:srgbClr val="276E68"/>
+                </a:solidFill>
+                <a:latin typeface="Microsoft JhengHei"/>
+                <a:ea typeface="Microsoft JhengHei"/>
+                <a:cs typeface="Microsoft JhengHei"/>
+              </a:defRPr>
+            </a:pPr>
+            <a:r>
+              <a:rPr sz="3450" b="1">
+                <a:solidFill>
+                  <a:srgbClr val="276E68"/>
+                </a:solidFill>
+                <a:latin typeface="Microsoft JhengHei"/>
+                <a:ea typeface="Microsoft JhengHei"/>
+                <a:cs typeface="Microsoft JhengHei"/>
+              </a:rPr>
+              <a:t>＝1,100萬</a:t>
+            </a:r>
+          </a:p>
+        </p:txBody>
+      </p:sp>
+      <p:sp>
+        <p:nvSpPr>
+          <p:cNvPr id="9" name="body">
+            <a:extLst xmlns:a="http://schemas.openxmlformats.org/drawingml/2006/main">
+              <a:ext uri="{FF2B5EF4-FFF2-40B4-BE49-F238E27FC236}">
+                <a16:creationId xmlns:a16="http://schemas.microsoft.com/office/drawing/2014/main" id="{6EF9E3D2-7CE9-4EEE-BD63-50618FAE5376}"/>
+              </a:ext>
+            </a:extLst>
+          </p:cNvPr>
+          <p:cNvSpPr>
+            <a:spLocks xmlns:a="http://schemas.openxmlformats.org/drawingml/2006/main" noGrp="1"/>
+          </p:cNvSpPr>
+          <p:nvPr/>
+        </p:nvSpPr>
+        <p:spPr>
+          <a:xfrm xmlns:a="http://schemas.openxmlformats.org/drawingml/2006/main">
+            <a:off x="762000" y="3448050"/>
+            <a:ext cx="2619375" cy="419100"/>
+          </a:xfrm>
+          <a:prstGeom xmlns:a="http://schemas.openxmlformats.org/drawingml/2006/main" prst="rect">
+            <a:avLst/>
+          </a:prstGeom>
+          <a:noFill xmlns:a="http://schemas.openxmlformats.org/drawingml/2006/main"/>
+          <a:ln xmlns:a="http://schemas.openxmlformats.org/drawingml/2006/main" w="0">
+            <a:noFill/>
+          </a:ln>
+        </p:spPr>
+        <p:txBody>
+          <a:bodyPr xmlns:a="http://schemas.openxmlformats.org/drawingml/2006/main" wrap="square" lIns="0" tIns="0" rIns="0" bIns="0" anchor="t">
+            <a:noAutofit/>
+          </a:bodyPr>
+          <a:lstStyle xmlns:a="http://schemas.openxmlformats.org/drawingml/2006/main">
+            <a:defPPr algn="l">
+              <a:defRPr sz="1950" b="0">
+                <a:solidFill>
+                  <a:srgbClr val="3A4A4E"/>
+                </a:solidFill>
+                <a:latin typeface="Microsoft JhengHei"/>
+                <a:ea typeface="Microsoft JhengHei"/>
+                <a:cs typeface="Microsoft JhengHei"/>
+              </a:defRPr>
+            </a:defPPr>
+          </a:lstStyle>
+          <a:p xmlns:a="http://schemas.openxmlformats.org/drawingml/2006/main">
+            <a:pPr algn="l">
+              <a:defRPr sz="1950" b="0">
+                <a:solidFill>
+                  <a:srgbClr val="3A4A4E"/>
+                </a:solidFill>
+                <a:latin typeface="Microsoft JhengHei"/>
+                <a:ea typeface="Microsoft JhengHei"/>
+                <a:cs typeface="Microsoft JhengHei"/>
+              </a:defRPr>
+            </a:pPr>
+            <a:r>
+              <a:rPr sz="1950" b="0">
+                <a:solidFill>
+                  <a:srgbClr val="3A4A4E"/>
+                </a:solidFill>
+                <a:latin typeface="Microsoft JhengHei"/>
+                <a:ea typeface="Microsoft JhengHei"/>
+                <a:cs typeface="Microsoft JhengHei"/>
+              </a:rPr>
+              <a:t>參考單價</a:t>
+            </a:r>
+          </a:p>
+        </p:txBody>
+      </p:sp>
+      <p:sp>
+        <p:nvSpPr>
+          <p:cNvPr id="10" name="body">
+            <a:extLst xmlns:a="http://schemas.openxmlformats.org/drawingml/2006/main">
+              <a:ext uri="{FF2B5EF4-FFF2-40B4-BE49-F238E27FC236}">
+                <a16:creationId xmlns:a16="http://schemas.microsoft.com/office/drawing/2014/main" id="{0139BD2E-E742-448C-B75B-E59388BD4505}"/>
+              </a:ext>
+            </a:extLst>
+          </p:cNvPr>
+          <p:cNvSpPr>
+            <a:spLocks xmlns:a="http://schemas.openxmlformats.org/drawingml/2006/main" noGrp="1"/>
+          </p:cNvSpPr>
+          <p:nvPr/>
+        </p:nvSpPr>
+        <p:spPr>
+          <a:xfrm xmlns:a="http://schemas.openxmlformats.org/drawingml/2006/main">
+            <a:off x="3714750" y="3448050"/>
+            <a:ext cx="2190750" cy="419100"/>
+          </a:xfrm>
+          <a:prstGeom xmlns:a="http://schemas.openxmlformats.org/drawingml/2006/main" prst="rect">
+            <a:avLst/>
+          </a:prstGeom>
+          <a:noFill xmlns:a="http://schemas.openxmlformats.org/drawingml/2006/main"/>
+          <a:ln xmlns:a="http://schemas.openxmlformats.org/drawingml/2006/main" w="0">
+            <a:noFill/>
+          </a:ln>
+        </p:spPr>
+        <p:txBody>
+          <a:bodyPr xmlns:a="http://schemas.openxmlformats.org/drawingml/2006/main" wrap="square" lIns="0" tIns="0" rIns="0" bIns="0" anchor="t">
+            <a:noAutofit/>
+          </a:bodyPr>
+          <a:lstStyle xmlns:a="http://schemas.openxmlformats.org/drawingml/2006/main">
+            <a:defPPr algn="l">
+              <a:defRPr sz="1950" b="0">
+                <a:solidFill>
+                  <a:srgbClr val="3A4A4E"/>
+                </a:solidFill>
+                <a:latin typeface="Microsoft JhengHei"/>
+                <a:ea typeface="Microsoft JhengHei"/>
+                <a:cs typeface="Microsoft JhengHei"/>
+              </a:defRPr>
+            </a:defPPr>
+          </a:lstStyle>
+          <a:p xmlns:a="http://schemas.openxmlformats.org/drawingml/2006/main">
+            <a:pPr algn="l">
+              <a:defRPr sz="1950" b="0">
+                <a:solidFill>
+                  <a:srgbClr val="3A4A4E"/>
+                </a:solidFill>
+                <a:latin typeface="Microsoft JhengHei"/>
+                <a:ea typeface="Microsoft JhengHei"/>
+                <a:cs typeface="Microsoft JhengHei"/>
+              </a:defRPr>
+            </a:pPr>
+            <a:r>
+              <a:rPr sz="1950" b="0">
+                <a:solidFill>
+                  <a:srgbClr val="3A4A4E"/>
+                </a:solidFill>
+                <a:latin typeface="Microsoft JhengHei"/>
+                <a:ea typeface="Microsoft JhengHei"/>
+                <a:cs typeface="Microsoft JhengHei"/>
+              </a:rPr>
+              <a:t>有效面積</a:t>
+            </a:r>
+          </a:p>
+        </p:txBody>
+      </p:sp>
+      <p:sp>
+        <p:nvSpPr>
+          <p:cNvPr id="11" name="body">
+            <a:extLst xmlns:a="http://schemas.openxmlformats.org/drawingml/2006/main">
+              <a:ext uri="{FF2B5EF4-FFF2-40B4-BE49-F238E27FC236}">
+                <a16:creationId xmlns:a16="http://schemas.microsoft.com/office/drawing/2014/main" id="{D2818A5E-F5E2-40BF-AD2F-561FB303CCD9}"/>
+              </a:ext>
+            </a:extLst>
+          </p:cNvPr>
+          <p:cNvSpPr>
+            <a:spLocks xmlns:a="http://schemas.openxmlformats.org/drawingml/2006/main" noGrp="1"/>
+          </p:cNvSpPr>
+          <p:nvPr/>
+        </p:nvSpPr>
+        <p:spPr>
+          <a:xfrm xmlns:a="http://schemas.openxmlformats.org/drawingml/2006/main">
+            <a:off x="6191250" y="3448050"/>
+            <a:ext cx="2476500" cy="419100"/>
+          </a:xfrm>
+          <a:prstGeom xmlns:a="http://schemas.openxmlformats.org/drawingml/2006/main" prst="rect">
+            <a:avLst/>
+          </a:prstGeom>
+          <a:noFill xmlns:a="http://schemas.openxmlformats.org/drawingml/2006/main"/>
+          <a:ln xmlns:a="http://schemas.openxmlformats.org/drawingml/2006/main" w="0">
+            <a:noFill/>
+          </a:ln>
+        </p:spPr>
+        <p:txBody>
+          <a:bodyPr xmlns:a="http://schemas.openxmlformats.org/drawingml/2006/main" wrap="square" lIns="0" tIns="0" rIns="0" bIns="0" anchor="t">
+            <a:noAutofit/>
+          </a:bodyPr>
+          <a:lstStyle xmlns:a="http://schemas.openxmlformats.org/drawingml/2006/main">
+            <a:defPPr algn="l">
+              <a:defRPr sz="1950" b="0">
+                <a:solidFill>
+                  <a:srgbClr val="3A4A4E"/>
+                </a:solidFill>
+                <a:latin typeface="Microsoft JhengHei"/>
+                <a:ea typeface="Microsoft JhengHei"/>
+                <a:cs typeface="Microsoft JhengHei"/>
+              </a:defRPr>
+            </a:defPPr>
+          </a:lstStyle>
+          <a:p xmlns:a="http://schemas.openxmlformats.org/drawingml/2006/main">
+            <a:pPr algn="l">
+              <a:defRPr sz="1950" b="0">
+                <a:solidFill>
+                  <a:srgbClr val="3A4A4E"/>
+                </a:solidFill>
+                <a:latin typeface="Microsoft JhengHei"/>
+                <a:ea typeface="Microsoft JhengHei"/>
+                <a:cs typeface="Microsoft JhengHei"/>
+              </a:defRPr>
+            </a:pPr>
+            <a:r>
+              <a:rPr sz="1950" b="0">
+                <a:solidFill>
+                  <a:srgbClr val="3A4A4E"/>
+                </a:solidFill>
+                <a:latin typeface="Microsoft JhengHei"/>
+                <a:ea typeface="Microsoft JhengHei"/>
+                <a:cs typeface="Microsoft JhengHei"/>
+              </a:rPr>
+              <a:t>模型學到的倍率</a:t>
+            </a:r>
+          </a:p>
+        </p:txBody>
+      </p:sp>
+      <p:sp>
+        <p:nvSpPr>
+          <p:cNvPr id="12" name="body">
+            <a:extLst xmlns:a="http://schemas.openxmlformats.org/drawingml/2006/main">
+              <a:ext uri="{FF2B5EF4-FFF2-40B4-BE49-F238E27FC236}">
+                <a16:creationId xmlns:a16="http://schemas.microsoft.com/office/drawing/2014/main" id="{534552A6-6B13-48FF-B4D5-8C85287DE9D1}"/>
+              </a:ext>
+            </a:extLst>
+          </p:cNvPr>
+          <p:cNvSpPr>
+            <a:spLocks xmlns:a="http://schemas.openxmlformats.org/drawingml/2006/main" noGrp="1"/>
+          </p:cNvSpPr>
+          <p:nvPr/>
+        </p:nvSpPr>
+        <p:spPr>
+          <a:xfrm xmlns:a="http://schemas.openxmlformats.org/drawingml/2006/main">
+            <a:off x="8953500" y="3448050"/>
+            <a:ext cx="2476500" cy="419100"/>
+          </a:xfrm>
+          <a:prstGeom xmlns:a="http://schemas.openxmlformats.org/drawingml/2006/main" prst="rect">
+            <a:avLst/>
+          </a:prstGeom>
+          <a:noFill xmlns:a="http://schemas.openxmlformats.org/drawingml/2006/main"/>
+          <a:ln xmlns:a="http://schemas.openxmlformats.org/drawingml/2006/main" w="0">
+            <a:noFill/>
+          </a:ln>
+        </p:spPr>
+        <p:txBody>
+          <a:bodyPr xmlns:a="http://schemas.openxmlformats.org/drawingml/2006/main" wrap="square" lIns="0" tIns="0" rIns="0" bIns="0" anchor="t">
+            <a:noAutofit/>
+          </a:bodyPr>
+          <a:lstStyle xmlns:a="http://schemas.openxmlformats.org/drawingml/2006/main">
+            <a:defPPr algn="l">
+              <a:defRPr sz="1950" b="0">
+                <a:solidFill>
+                  <a:srgbClr val="3A4A4E"/>
+                </a:solidFill>
+                <a:latin typeface="Microsoft JhengHei"/>
+                <a:ea typeface="Microsoft JhengHei"/>
+                <a:cs typeface="Microsoft JhengHei"/>
+              </a:defRPr>
+            </a:defPPr>
+          </a:lstStyle>
+          <a:p xmlns:a="http://schemas.openxmlformats.org/drawingml/2006/main">
+            <a:pPr algn="l">
+              <a:defRPr sz="1950" b="0">
+                <a:solidFill>
+                  <a:srgbClr val="3A4A4E"/>
+                </a:solidFill>
+                <a:latin typeface="Microsoft JhengHei"/>
+                <a:ea typeface="Microsoft JhengHei"/>
+                <a:cs typeface="Microsoft JhengHei"/>
+              </a:defRPr>
+            </a:pPr>
+            <a:r>
+              <a:rPr sz="1950" b="0">
+                <a:solidFill>
+                  <a:srgbClr val="3A4A4E"/>
+                </a:solidFill>
+                <a:latin typeface="Microsoft JhengHei"/>
+                <a:ea typeface="Microsoft JhengHei"/>
+                <a:cs typeface="Microsoft JhengHei"/>
+              </a:rPr>
+              <a:t>預測總價</a:t>
+            </a:r>
+          </a:p>
+        </p:txBody>
+      </p:sp>
+      <p:sp>
+        <p:nvSpPr>
+          <p:cNvPr id="13" name="body">
+            <a:extLst xmlns:a="http://schemas.openxmlformats.org/drawingml/2006/main">
+              <a:ext uri="{FF2B5EF4-FFF2-40B4-BE49-F238E27FC236}">
+                <a16:creationId xmlns:a16="http://schemas.microsoft.com/office/drawing/2014/main" id="{57602815-1BEE-454F-BB2D-2A4325F1D063}"/>
+              </a:ext>
+            </a:extLst>
+          </p:cNvPr>
+          <p:cNvSpPr>
+            <a:spLocks xmlns:a="http://schemas.openxmlformats.org/drawingml/2006/main" noGrp="1"/>
+          </p:cNvSpPr>
+          <p:nvPr/>
+        </p:nvSpPr>
+        <p:spPr>
+          <a:xfrm xmlns:a="http://schemas.openxmlformats.org/drawingml/2006/main">
+            <a:off x="762000" y="4429125"/>
+            <a:ext cx="5095875" cy="428625"/>
+          </a:xfrm>
+          <a:prstGeom xmlns:a="http://schemas.openxmlformats.org/drawingml/2006/main" prst="rect">
+            <a:avLst/>
+          </a:prstGeom>
+          <a:noFill xmlns:a="http://schemas.openxmlformats.org/drawingml/2006/main"/>
+          <a:ln xmlns:a="http://schemas.openxmlformats.org/drawingml/2006/main" w="0">
+            <a:noFill/>
+          </a:ln>
+        </p:spPr>
+        <p:txBody>
+          <a:bodyPr xmlns:a="http://schemas.openxmlformats.org/drawingml/2006/main" wrap="square" lIns="0" tIns="0" rIns="0" bIns="0" anchor="t">
+            <a:noAutofit/>
+          </a:bodyPr>
+          <a:lstStyle xmlns:a="http://schemas.openxmlformats.org/drawingml/2006/main">
+            <a:defPPr algn="l">
+              <a:defRPr sz="2100" b="1">
+                <a:solidFill>
+                  <a:srgbClr val="276E68"/>
+                </a:solidFill>
+                <a:latin typeface="Microsoft JhengHei"/>
+                <a:ea typeface="Microsoft JhengHei"/>
+                <a:cs typeface="Microsoft JhengHei"/>
+              </a:defRPr>
+            </a:defPPr>
+          </a:lstStyle>
+          <a:p xmlns:a="http://schemas.openxmlformats.org/drawingml/2006/main">
+            <a:pPr algn="l">
+              <a:defRPr sz="2100" b="1">
+                <a:solidFill>
+                  <a:srgbClr val="276E68"/>
+                </a:solidFill>
+                <a:latin typeface="Microsoft JhengHei"/>
+                <a:ea typeface="Microsoft JhengHei"/>
+                <a:cs typeface="Microsoft JhengHei"/>
+              </a:defRPr>
+            </a:pPr>
+            <a:r>
+              <a:rPr sz="2100" b="1">
+                <a:solidFill>
+                  <a:srgbClr val="276E68"/>
+                </a:solidFill>
+                <a:latin typeface="Microsoft JhengHei"/>
+                <a:ea typeface="Microsoft JhengHei"/>
+                <a:cs typeface="Microsoft JhengHei"/>
+              </a:rPr>
+              <a:t>參考價的分類</a:t>
+            </a:r>
+          </a:p>
+        </p:txBody>
+      </p:sp>
+      <p:sp>
+        <p:nvSpPr>
+          <p:cNvPr id="14" name="body">
+            <a:extLst xmlns:a="http://schemas.openxmlformats.org/drawingml/2006/main">
+              <a:ext uri="{FF2B5EF4-FFF2-40B4-BE49-F238E27FC236}">
+                <a16:creationId xmlns:a16="http://schemas.microsoft.com/office/drawing/2014/main" id="{79516018-E0E2-4052-9B40-A012D25061F2}"/>
+              </a:ext>
+            </a:extLst>
+          </p:cNvPr>
+          <p:cNvSpPr>
+            <a:spLocks xmlns:a="http://schemas.openxmlformats.org/drawingml/2006/main" noGrp="1"/>
+          </p:cNvSpPr>
+          <p:nvPr/>
+        </p:nvSpPr>
+        <p:spPr>
+          <a:xfrm xmlns:a="http://schemas.openxmlformats.org/drawingml/2006/main">
+            <a:off x="762000" y="4943475"/>
+            <a:ext cx="5095875" cy="904875"/>
+          </a:xfrm>
+          <a:prstGeom xmlns:a="http://schemas.openxmlformats.org/drawingml/2006/main" prst="rect">
+            <a:avLst/>
+          </a:prstGeom>
+          <a:noFill xmlns:a="http://schemas.openxmlformats.org/drawingml/2006/main"/>
+          <a:ln xmlns:a="http://schemas.openxmlformats.org/drawingml/2006/main" w="0">
+            <a:noFill/>
+          </a:ln>
+        </p:spPr>
+        <p:txBody>
+          <a:bodyPr xmlns:a="http://schemas.openxmlformats.org/drawingml/2006/main" wrap="square" lIns="0" tIns="0" rIns="0" bIns="0" anchor="t">
+            <a:noAutofit/>
+          </a:bodyPr>
+          <a:lstStyle xmlns:a="http://schemas.openxmlformats.org/drawingml/2006/main">
+            <a:defPPr algn="l">
+              <a:defRPr sz="2025" b="0">
+                <a:solidFill>
+                  <a:srgbClr val="3A4A4E"/>
+                </a:solidFill>
+                <a:latin typeface="Microsoft JhengHei"/>
+                <a:ea typeface="Microsoft JhengHei"/>
+                <a:cs typeface="Microsoft JhengHei"/>
+              </a:defRPr>
+            </a:defPPr>
+          </a:lstStyle>
+          <a:p xmlns:a="http://schemas.openxmlformats.org/drawingml/2006/main">
+            <a:pPr algn="l">
+              <a:defRPr sz="2025" b="0">
+                <a:solidFill>
+                  <a:srgbClr val="3A4A4E"/>
+                </a:solidFill>
+                <a:latin typeface="Microsoft JhengHei"/>
+                <a:ea typeface="Microsoft JhengHei"/>
+                <a:cs typeface="Microsoft JhengHei"/>
+              </a:defRPr>
+            </a:pPr>
+            <a:r>
+              <a:rPr sz="2025" b="0">
+                <a:solidFill>
+                  <a:srgbClr val="3A4A4E"/>
+                </a:solidFill>
+                <a:latin typeface="Microsoft JhengHei"/>
+                <a:ea typeface="Microsoft JhengHei"/>
+                <a:cs typeface="Microsoft JhengHei"/>
+              </a:rPr>
+              <a:t>依地區、交易及建物類型整理</a:t>
+            </a:r>
+          </a:p>
+          <a:p xmlns:a="http://schemas.openxmlformats.org/drawingml/2006/main">
+            <a:pPr algn="l">
+              <a:defRPr sz="2025" b="0">
+                <a:solidFill>
+                  <a:srgbClr val="3A4A4E"/>
+                </a:solidFill>
+                <a:latin typeface="Microsoft JhengHei"/>
+                <a:ea typeface="Microsoft JhengHei"/>
+                <a:cs typeface="Microsoft JhengHei"/>
+              </a:defRPr>
+            </a:pPr>
+            <a:r>
+              <a:rPr sz="2025" b="0">
+                <a:solidFill>
+                  <a:srgbClr val="3A4A4E"/>
+                </a:solidFill>
+                <a:latin typeface="Microsoft JhengHei"/>
+                <a:ea typeface="Microsoft JhengHei"/>
+                <a:cs typeface="Microsoft JhengHei"/>
+              </a:rPr>
+              <a:t>同類不足30筆，就逐層放寬</a:t>
+            </a:r>
+          </a:p>
+        </p:txBody>
+      </p:sp>
+      <p:sp>
+        <p:nvSpPr>
+          <p:cNvPr id="15" name="body">
+            <a:extLst xmlns:a="http://schemas.openxmlformats.org/drawingml/2006/main">
+              <a:ext uri="{FF2B5EF4-FFF2-40B4-BE49-F238E27FC236}">
+                <a16:creationId xmlns:a16="http://schemas.microsoft.com/office/drawing/2014/main" id="{2F4135F8-10EE-4376-A3EB-79A042762733}"/>
+              </a:ext>
+            </a:extLst>
+          </p:cNvPr>
+          <p:cNvSpPr>
+            <a:spLocks xmlns:a="http://schemas.openxmlformats.org/drawingml/2006/main" noGrp="1"/>
+          </p:cNvSpPr>
+          <p:nvPr/>
+        </p:nvSpPr>
+        <p:spPr>
+          <a:xfrm xmlns:a="http://schemas.openxmlformats.org/drawingml/2006/main">
+            <a:off x="6667500" y="4429125"/>
             <a:ext cx="4762500" cy="428625"/>
           </a:xfrm>
           <a:prstGeom xmlns:a="http://schemas.openxmlformats.org/drawingml/2006/main" prst="rect">
@@ -6206,17 +7017,17 @@
                 <a:ea typeface="Microsoft JhengHei"/>
                 <a:cs typeface="Microsoft JhengHei"/>
               </a:rPr>
-              <a:t>參考單價</a:t>
+              <a:t>訓練時隔開答案</a:t>
             </a:r>
           </a:p>
         </p:txBody>
       </p:sp>
       <p:sp>
         <p:nvSpPr>
-          <p:cNvPr id="5" name="body">
+          <p:cNvPr id="16" name="body">
             <a:extLst xmlns:a="http://schemas.openxmlformats.org/drawingml/2006/main">
               <a:ext uri="{FF2B5EF4-FFF2-40B4-BE49-F238E27FC236}">
-                <a16:creationId xmlns:a16="http://schemas.microsoft.com/office/drawing/2014/main" id="{CB92DF6D-A7B3-42EF-8506-3A1687852C4A}"/>
+                <a16:creationId xmlns:a16="http://schemas.microsoft.com/office/drawing/2014/main" id="{F414F82D-64EC-4756-AE2B-2B65C8D392EA}"/>
               </a:ext>
             </a:extLst>
           </p:cNvPr>
@@ -6227,8 +7038,8 @@
         </p:nvSpPr>
         <p:spPr>
           <a:xfrm xmlns:a="http://schemas.openxmlformats.org/drawingml/2006/main">
-            <a:off x="762000" y="3667125"/>
-            <a:ext cx="5143500" cy="1104900"/>
+            <a:off x="6667500" y="4943475"/>
+            <a:ext cx="4762500" cy="904875"/>
           </a:xfrm>
           <a:prstGeom xmlns:a="http://schemas.openxmlformats.org/drawingml/2006/main" prst="rect">
             <a:avLst/>
@@ -6244,7 +7055,7 @@
           </a:bodyPr>
           <a:lstStyle xmlns:a="http://schemas.openxmlformats.org/drawingml/2006/main">
             <a:defPPr algn="l">
-              <a:defRPr sz="2175" b="0">
+              <a:defRPr sz="2025" b="0">
                 <a:solidFill>
                   <a:srgbClr val="3A4A4E"/>
                 </a:solidFill>
@@ -6256,7 +7067,7 @@
           </a:lstStyle>
           <a:p xmlns:a="http://schemas.openxmlformats.org/drawingml/2006/main">
             <a:pPr algn="l">
-              <a:defRPr sz="2175" b="0">
+              <a:defRPr sz="2025" b="0">
                 <a:solidFill>
                   <a:srgbClr val="3A4A4E"/>
                 </a:solidFill>
@@ -6266,7 +7077,7 @@
               </a:defRPr>
             </a:pPr>
             <a:r>
-              <a:rPr sz="2175" b="0">
+              <a:rPr sz="2025" b="0">
                 <a:solidFill>
                   <a:srgbClr val="3A4A4E"/>
                 </a:solidFill>
@@ -6274,12 +7085,12 @@
                 <a:ea typeface="Microsoft JhengHei"/>
                 <a:cs typeface="Microsoft JhengHei"/>
               </a:rPr>
-              <a:t>依地區、交易類型與建物類型</a:t>
+              <a:t>同建案放同組，分成5組</a:t>
             </a:r>
           </a:p>
           <a:p xmlns:a="http://schemas.openxmlformats.org/drawingml/2006/main">
             <a:pPr algn="l">
-              <a:defRPr sz="2175" b="0">
+              <a:defRPr sz="2025" b="0">
                 <a:solidFill>
                   <a:srgbClr val="3A4A4E"/>
                 </a:solidFill>
@@ -6289,7 +7100,7 @@
               </a:defRPr>
             </a:pPr>
             <a:r>
-              <a:rPr sz="2175" b="0">
+              <a:rPr sz="2025" b="0">
                 <a:solidFill>
                   <a:srgbClr val="3A4A4E"/>
                 </a:solidFill>
@@ -6297,17 +7108,17 @@
                 <a:ea typeface="Microsoft JhengHei"/>
                 <a:cs typeface="Microsoft JhengHei"/>
               </a:rPr>
-              <a:t>資料不足時逐層放寬</a:t>
+              <a:t>每組只參考其他4組的交易</a:t>
             </a:r>
           </a:p>
         </p:txBody>
       </p:sp>
       <p:sp>
         <p:nvSpPr>
-          <p:cNvPr id="6" name="body">
+          <p:cNvPr id="17" name="body">
             <a:extLst xmlns:a="http://schemas.openxmlformats.org/drawingml/2006/main">
               <a:ext uri="{FF2B5EF4-FFF2-40B4-BE49-F238E27FC236}">
-                <a16:creationId xmlns:a16="http://schemas.microsoft.com/office/drawing/2014/main" id="{643EA126-E88E-4FA8-9FE4-F6E374B6FC12}"/>
+                <a16:creationId xmlns:a16="http://schemas.microsoft.com/office/drawing/2014/main" id="{801444C5-E287-4A64-A9EA-6CEE41EF64F4}"/>
               </a:ext>
             </a:extLst>
           </p:cNvPr>
@@ -6318,166 +7129,7 @@
         </p:nvSpPr>
         <p:spPr>
           <a:xfrm xmlns:a="http://schemas.openxmlformats.org/drawingml/2006/main">
-            <a:off x="6667500" y="3048000"/>
-            <a:ext cx="4762500" cy="428625"/>
-          </a:xfrm>
-          <a:prstGeom xmlns:a="http://schemas.openxmlformats.org/drawingml/2006/main" prst="rect">
-            <a:avLst/>
-          </a:prstGeom>
-          <a:noFill xmlns:a="http://schemas.openxmlformats.org/drawingml/2006/main"/>
-          <a:ln xmlns:a="http://schemas.openxmlformats.org/drawingml/2006/main" w="0">
-            <a:noFill/>
-          </a:ln>
-        </p:spPr>
-        <p:txBody>
-          <a:bodyPr xmlns:a="http://schemas.openxmlformats.org/drawingml/2006/main" wrap="square" lIns="0" tIns="0" rIns="0" bIns="0" anchor="t">
-            <a:noAutofit/>
-          </a:bodyPr>
-          <a:lstStyle xmlns:a="http://schemas.openxmlformats.org/drawingml/2006/main">
-            <a:defPPr algn="l">
-              <a:defRPr sz="2100" b="1">
-                <a:solidFill>
-                  <a:srgbClr val="276E68"/>
-                </a:solidFill>
-                <a:latin typeface="Microsoft JhengHei"/>
-                <a:ea typeface="Microsoft JhengHei"/>
-                <a:cs typeface="Microsoft JhengHei"/>
-              </a:defRPr>
-            </a:defPPr>
-          </a:lstStyle>
-          <a:p xmlns:a="http://schemas.openxmlformats.org/drawingml/2006/main">
-            <a:pPr algn="l">
-              <a:defRPr sz="2100" b="1">
-                <a:solidFill>
-                  <a:srgbClr val="276E68"/>
-                </a:solidFill>
-                <a:latin typeface="Microsoft JhengHei"/>
-                <a:ea typeface="Microsoft JhengHei"/>
-                <a:cs typeface="Microsoft JhengHei"/>
-              </a:defRPr>
-            </a:pPr>
-            <a:r>
-              <a:rPr sz="2100" b="1">
-                <a:solidFill>
-                  <a:srgbClr val="276E68"/>
-                </a:solidFill>
-                <a:latin typeface="Microsoft JhengHei"/>
-                <a:ea typeface="Microsoft JhengHei"/>
-                <a:cs typeface="Microsoft JhengHei"/>
-              </a:rPr>
-              <a:t>建案分組 OOF</a:t>
-            </a:r>
-          </a:p>
-        </p:txBody>
-      </p:sp>
-      <p:sp>
-        <p:nvSpPr>
-          <p:cNvPr id="7" name="body">
-            <a:extLst xmlns:a="http://schemas.openxmlformats.org/drawingml/2006/main">
-              <a:ext uri="{FF2B5EF4-FFF2-40B4-BE49-F238E27FC236}">
-                <a16:creationId xmlns:a16="http://schemas.microsoft.com/office/drawing/2014/main" id="{32CEA467-EBEB-4E89-B447-A8915AEC0F3A}"/>
-              </a:ext>
-            </a:extLst>
-          </p:cNvPr>
-          <p:cNvSpPr>
-            <a:spLocks xmlns:a="http://schemas.openxmlformats.org/drawingml/2006/main" noGrp="1"/>
-          </p:cNvSpPr>
-          <p:nvPr/>
-        </p:nvSpPr>
-        <p:spPr>
-          <a:xfrm xmlns:a="http://schemas.openxmlformats.org/drawingml/2006/main">
-            <a:off x="6667500" y="3667125"/>
-            <a:ext cx="4762500" cy="1104900"/>
-          </a:xfrm>
-          <a:prstGeom xmlns:a="http://schemas.openxmlformats.org/drawingml/2006/main" prst="rect">
-            <a:avLst/>
-          </a:prstGeom>
-          <a:noFill xmlns:a="http://schemas.openxmlformats.org/drawingml/2006/main"/>
-          <a:ln xmlns:a="http://schemas.openxmlformats.org/drawingml/2006/main" w="0">
-            <a:noFill/>
-          </a:ln>
-        </p:spPr>
-        <p:txBody>
-          <a:bodyPr xmlns:a="http://schemas.openxmlformats.org/drawingml/2006/main" wrap="square" lIns="0" tIns="0" rIns="0" bIns="0" anchor="t">
-            <a:noAutofit/>
-          </a:bodyPr>
-          <a:lstStyle xmlns:a="http://schemas.openxmlformats.org/drawingml/2006/main">
-            <a:defPPr algn="l">
-              <a:defRPr sz="2175" b="0">
-                <a:solidFill>
-                  <a:srgbClr val="3A4A4E"/>
-                </a:solidFill>
-                <a:latin typeface="Microsoft JhengHei"/>
-                <a:ea typeface="Microsoft JhengHei"/>
-                <a:cs typeface="Microsoft JhengHei"/>
-              </a:defRPr>
-            </a:defPPr>
-          </a:lstStyle>
-          <a:p xmlns:a="http://schemas.openxmlformats.org/drawingml/2006/main">
-            <a:pPr algn="l">
-              <a:defRPr sz="2175" b="0">
-                <a:solidFill>
-                  <a:srgbClr val="3A4A4E"/>
-                </a:solidFill>
-                <a:latin typeface="Microsoft JhengHei"/>
-                <a:ea typeface="Microsoft JhengHei"/>
-                <a:cs typeface="Microsoft JhengHei"/>
-              </a:defRPr>
-            </a:pPr>
-            <a:r>
-              <a:rPr sz="2175" b="0">
-                <a:solidFill>
-                  <a:srgbClr val="3A4A4E"/>
-                </a:solidFill>
-                <a:latin typeface="Microsoft JhengHei"/>
-                <a:ea typeface="Microsoft JhengHei"/>
-                <a:cs typeface="Microsoft JhengHei"/>
-              </a:rPr>
-              <a:t>分成5組，每組只參考其他4組</a:t>
-            </a:r>
-          </a:p>
-          <a:p xmlns:a="http://schemas.openxmlformats.org/drawingml/2006/main">
-            <a:pPr algn="l">
-              <a:defRPr sz="2175" b="0">
-                <a:solidFill>
-                  <a:srgbClr val="3A4A4E"/>
-                </a:solidFill>
-                <a:latin typeface="Microsoft JhengHei"/>
-                <a:ea typeface="Microsoft JhengHei"/>
-                <a:cs typeface="Microsoft JhengHei"/>
-              </a:defRPr>
-            </a:pPr>
-            <a:r>
-              <a:rPr sz="2175" b="0">
-                <a:solidFill>
-                  <a:srgbClr val="3A4A4E"/>
-                </a:solidFill>
-                <a:latin typeface="Microsoft JhengHei"/>
-                <a:ea typeface="Microsoft JhengHei"/>
-                <a:cs typeface="Microsoft JhengHei"/>
-              </a:rPr>
-              <a:t>query 使用當期完整 fit</a:t>
-            </a:r>
-          </a:p>
-        </p:txBody>
-      </p:sp>
-      <p:sp>
-        <p:nvSpPr>
-          <p:cNvPr id="8" name="body">
-            <a:extLst xmlns:a="http://schemas.openxmlformats.org/drawingml/2006/main">
-              <a:ext uri="{FF2B5EF4-FFF2-40B4-BE49-F238E27FC236}">
-                <a16:creationId xmlns:a16="http://schemas.microsoft.com/office/drawing/2014/main" id="{E9D27BDC-2AD4-4A66-9CA2-5EC405EBFF63}"/>
-              </a:ext>
-            </a:extLst>
-          </p:cNvPr>
-          <p:cNvSpPr>
-            <a:spLocks xmlns:a="http://schemas.openxmlformats.org/drawingml/2006/main" noGrp="1"/>
-          </p:cNvSpPr>
-          <p:nvPr/>
-        </p:nvSpPr>
-        <p:spPr>
-          <a:xfrm xmlns:a="http://schemas.openxmlformats.org/drawingml/2006/main">
-            <a:off x="762000" y="5972175"/>
+            <a:off x="762000" y="6096000"/>
             <a:ext cx="10572750" cy="571500"/>
           </a:xfrm>
           <a:prstGeom xmlns:a="http://schemas.openxmlformats.org/drawingml/2006/main" prst="rect">
@@ -6524,7 +7176,7 @@
                 <a:ea typeface="Microsoft JhengHei"/>
                 <a:cs typeface="Microsoft JhengHei"/>
               </a:rPr>
-              <a:t>建案分組與時間隔離處理不同問題。NN固定30輪，SmoothL1轉折為10萬元。</a:t>
+              <a:t>這份參考單價稱為「分組先驗」，由當期訓練交易建立。</a:t>
             </a:r>
           </a:p>
         </p:txBody>
@@ -17731,12 +18383,34 @@
       <p:grpSpPr>
         <a:xfrm xmlns:a="http://schemas.openxmlformats.org/drawingml/2006/main"/>
       </p:grpSpPr>
+      <p:graphicFrame>
+        <p:nvGraphicFramePr>
+          <p:cNvPr id="4" name="Chart">
+            <a:extLst xmlns:a="http://schemas.openxmlformats.org/drawingml/2006/main">
+              <a:ext uri="{FF2B5EF4-FFF2-40B4-BE49-F238E27FC236}">
+                <a16:creationId xmlns:a16="http://schemas.microsoft.com/office/drawing/2014/main" id="{6EC65ACB-7AFD-43BA-B0E4-BA2677BAE9B0}"/>
+              </a:ext>
+            </a:extLst>
+          </p:cNvPr>
+          <p:cNvGraphicFramePr/>
+          <p:nvPr/>
+        </p:nvGraphicFramePr>
+        <p:xfrm>
+          <a:off xmlns:a="http://schemas.openxmlformats.org/drawingml/2006/main" x="762000" y="2381250"/>
+          <a:ext xmlns:a="http://schemas.openxmlformats.org/drawingml/2006/main" cx="7048500" cy="3048000"/>
+        </p:xfrm>
+        <a:graphic xmlns:a="http://schemas.openxmlformats.org/drawingml/2006/main">
+          <a:graphicData uri="http://schemas.openxmlformats.org/drawingml/2006/chart">
+            <c:chart xmlns:r="http://schemas.openxmlformats.org/officeDocument/2006/relationships" xmlns:c="http://schemas.openxmlformats.org/drawingml/2006/chart" r:id="Rfbf0a3a4a5224da3"/>
+          </a:graphicData>
+        </a:graphic>
+      </p:graphicFrame>
       <p:sp>
         <p:nvSpPr>
-          <p:cNvPr id="9" name="slide-title">
+          <p:cNvPr id="5" name="slide-title">
             <a:extLst xmlns:a="http://schemas.openxmlformats.org/drawingml/2006/main">
               <a:ext uri="{FF2B5EF4-FFF2-40B4-BE49-F238E27FC236}">
-                <a16:creationId xmlns:a16="http://schemas.microsoft.com/office/drawing/2014/main" id="{66C496AE-BA48-4009-AB25-E9125922760D}"/>
+                <a16:creationId xmlns:a16="http://schemas.microsoft.com/office/drawing/2014/main" id="{337D141D-149C-4B5E-923F-F2D6C5465BF5}"/>
               </a:ext>
             </a:extLst>
           </p:cNvPr>
@@ -17794,17 +18468,17 @@
                 <a:ea typeface="Microsoft JhengHei"/>
                 <a:cs typeface="Microsoft JhengHei"/>
               </a:rPr>
-              <a:t>日期權重的影響</a:t>
+              <a:t>新舊交易的學習影響</a:t>
             </a:r>
           </a:p>
         </p:txBody>
       </p:sp>
       <p:sp>
         <p:nvSpPr>
-          <p:cNvPr id="2" name="body">
+          <p:cNvPr id="6" name="body">
             <a:extLst xmlns:a="http://schemas.openxmlformats.org/drawingml/2006/main">
               <a:ext uri="{FF2B5EF4-FFF2-40B4-BE49-F238E27FC236}">
-                <a16:creationId xmlns:a16="http://schemas.microsoft.com/office/drawing/2014/main" id="{BA94C22D-C426-4ED7-AFED-39F0ABC944E9}"/>
+                <a16:creationId xmlns:a16="http://schemas.microsoft.com/office/drawing/2014/main" id="{2D9728CF-10C7-4A02-B17E-F9EA3C7E7B1F}"/>
               </a:ext>
             </a:extLst>
           </p:cNvPr>
@@ -17869,10 +18543,10 @@
       </p:sp>
       <p:sp>
         <p:nvSpPr>
-          <p:cNvPr id="3" name="body">
+          <p:cNvPr id="7" name="body">
             <a:extLst xmlns:a="http://schemas.openxmlformats.org/drawingml/2006/main">
               <a:ext uri="{FF2B5EF4-FFF2-40B4-BE49-F238E27FC236}">
-                <a16:creationId xmlns:a16="http://schemas.microsoft.com/office/drawing/2014/main" id="{F8D242F1-D942-4B1E-86EB-8AF90B8E7BD0}"/>
+                <a16:creationId xmlns:a16="http://schemas.microsoft.com/office/drawing/2014/main" id="{E669B521-4D6E-427E-AA52-8B5D87CA7858}"/>
               </a:ext>
             </a:extLst>
           </p:cNvPr>
@@ -17883,8 +18557,235 @@
         </p:nvSpPr>
         <p:spPr>
           <a:xfrm xmlns:a="http://schemas.openxmlformats.org/drawingml/2006/main">
-            <a:off x="762000" y="1743075"/>
-            <a:ext cx="8572500" cy="619125"/>
+            <a:off x="762000" y="1333500"/>
+            <a:ext cx="10668000" cy="409575"/>
+          </a:xfrm>
+          <a:prstGeom xmlns:a="http://schemas.openxmlformats.org/drawingml/2006/main" prst="rect">
+            <a:avLst/>
+          </a:prstGeom>
+          <a:noFill xmlns:a="http://schemas.openxmlformats.org/drawingml/2006/main"/>
+          <a:ln xmlns:a="http://schemas.openxmlformats.org/drawingml/2006/main" w="0">
+            <a:noFill/>
+          </a:ln>
+        </p:spPr>
+        <p:txBody>
+          <a:bodyPr xmlns:a="http://schemas.openxmlformats.org/drawingml/2006/main" wrap="square" lIns="0" tIns="0" rIns="0" bIns="0" anchor="t">
+            <a:noAutofit/>
+          </a:bodyPr>
+          <a:lstStyle xmlns:a="http://schemas.openxmlformats.org/drawingml/2006/main">
+            <a:defPPr algn="l">
+              <a:defRPr sz="2175" b="0">
+                <a:solidFill>
+                  <a:srgbClr val="718082"/>
+                </a:solidFill>
+                <a:latin typeface="Microsoft JhengHei"/>
+                <a:ea typeface="Microsoft JhengHei"/>
+                <a:cs typeface="Microsoft JhengHei"/>
+              </a:defRPr>
+            </a:defPPr>
+          </a:lstStyle>
+          <a:p xmlns:a="http://schemas.openxmlformats.org/drawingml/2006/main">
+            <a:pPr algn="l">
+              <a:defRPr sz="2175" b="0">
+                <a:solidFill>
+                  <a:srgbClr val="718082"/>
+                </a:solidFill>
+                <a:latin typeface="Microsoft JhengHei"/>
+                <a:ea typeface="Microsoft JhengHei"/>
+                <a:cs typeface="Microsoft JhengHei"/>
+              </a:defRPr>
+            </a:pPr>
+            <a:r>
+              <a:rPr sz="2175" b="0">
+                <a:solidFill>
+                  <a:srgbClr val="718082"/>
+                </a:solidFill>
+                <a:latin typeface="Microsoft JhengHei"/>
+                <a:ea typeface="Microsoft JhengHei"/>
+                <a:cs typeface="Microsoft JhengHei"/>
+              </a:rPr>
+              <a:t>房價會隨時間改變，因此讓近期成交有較大影響</a:t>
+            </a:r>
+          </a:p>
+        </p:txBody>
+      </p:sp>
+      <p:sp>
+        <p:nvSpPr>
+          <p:cNvPr id="8" name="body">
+            <a:extLst xmlns:a="http://schemas.openxmlformats.org/drawingml/2006/main">
+              <a:ext uri="{FF2B5EF4-FFF2-40B4-BE49-F238E27FC236}">
+                <a16:creationId xmlns:a16="http://schemas.microsoft.com/office/drawing/2014/main" id="{FDC57AB6-1D7A-4FFE-BA59-09625F4AB141}"/>
+              </a:ext>
+            </a:extLst>
+          </p:cNvPr>
+          <p:cNvSpPr>
+            <a:spLocks xmlns:a="http://schemas.openxmlformats.org/drawingml/2006/main" noGrp="1"/>
+          </p:cNvSpPr>
+          <p:nvPr/>
+        </p:nvSpPr>
+        <p:spPr>
+          <a:xfrm xmlns:a="http://schemas.openxmlformats.org/drawingml/2006/main">
+            <a:off x="762000" y="1809750"/>
+            <a:ext cx="10668000" cy="428625"/>
+          </a:xfrm>
+          <a:prstGeom xmlns:a="http://schemas.openxmlformats.org/drawingml/2006/main" prst="rect">
+            <a:avLst/>
+          </a:prstGeom>
+          <a:noFill xmlns:a="http://schemas.openxmlformats.org/drawingml/2006/main"/>
+          <a:ln xmlns:a="http://schemas.openxmlformats.org/drawingml/2006/main" w="0">
+            <a:noFill/>
+          </a:ln>
+        </p:spPr>
+        <p:txBody>
+          <a:bodyPr xmlns:a="http://schemas.openxmlformats.org/drawingml/2006/main" wrap="square" lIns="0" tIns="0" rIns="0" bIns="0" anchor="t">
+            <a:noAutofit/>
+          </a:bodyPr>
+          <a:lstStyle xmlns:a="http://schemas.openxmlformats.org/drawingml/2006/main">
+            <a:defPPr algn="l">
+              <a:defRPr sz="2175" b="1">
+                <a:solidFill>
+                  <a:srgbClr val="276E68"/>
+                </a:solidFill>
+                <a:latin typeface="Microsoft JhengHei"/>
+                <a:ea typeface="Microsoft JhengHei"/>
+                <a:cs typeface="Microsoft JhengHei"/>
+              </a:defRPr>
+            </a:defPPr>
+          </a:lstStyle>
+          <a:p xmlns:a="http://schemas.openxmlformats.org/drawingml/2006/main">
+            <a:pPr algn="l">
+              <a:defRPr sz="2175" b="1">
+                <a:solidFill>
+                  <a:srgbClr val="276E68"/>
+                </a:solidFill>
+                <a:latin typeface="Microsoft JhengHei"/>
+                <a:ea typeface="Microsoft JhengHei"/>
+                <a:cs typeface="Microsoft JhengHei"/>
+              </a:defRPr>
+            </a:pPr>
+            <a:r>
+              <a:rPr sz="2175" b="1">
+                <a:solidFill>
+                  <a:srgbClr val="276E68"/>
+                </a:solidFill>
+                <a:latin typeface="Microsoft JhengHei"/>
+                <a:ea typeface="Microsoft JhengHei"/>
+                <a:cs typeface="Microsoft JhengHei"/>
+              </a:rPr>
+              <a:t>權重：一筆交易對模型學習的影響程度</a:t>
+            </a:r>
+          </a:p>
+        </p:txBody>
+      </p:sp>
+      <p:sp>
+        <p:nvSpPr>
+          <p:cNvPr id="9" name="body">
+            <a:extLst xmlns:a="http://schemas.openxmlformats.org/drawingml/2006/main">
+              <a:ext uri="{FF2B5EF4-FFF2-40B4-BE49-F238E27FC236}">
+                <a16:creationId xmlns:a16="http://schemas.microsoft.com/office/drawing/2014/main" id="{F14EB66C-5800-49AF-9639-C1877CCB83B7}"/>
+              </a:ext>
+            </a:extLst>
+          </p:cNvPr>
+          <p:cNvSpPr>
+            <a:spLocks xmlns:a="http://schemas.openxmlformats.org/drawingml/2006/main" noGrp="1"/>
+          </p:cNvSpPr>
+          <p:nvPr/>
+        </p:nvSpPr>
+        <p:spPr>
+          <a:xfrm xmlns:a="http://schemas.openxmlformats.org/drawingml/2006/main">
+            <a:off x="8572500" y="2667000"/>
+            <a:ext cx="2857500" cy="857250"/>
+          </a:xfrm>
+          <a:prstGeom xmlns:a="http://schemas.openxmlformats.org/drawingml/2006/main" prst="rect">
+            <a:avLst/>
+          </a:prstGeom>
+          <a:noFill xmlns:a="http://schemas.openxmlformats.org/drawingml/2006/main"/>
+          <a:ln xmlns:a="http://schemas.openxmlformats.org/drawingml/2006/main" w="0">
+            <a:noFill/>
+          </a:ln>
+        </p:spPr>
+        <p:txBody>
+          <a:bodyPr xmlns:a="http://schemas.openxmlformats.org/drawingml/2006/main" wrap="square" lIns="0" tIns="0" rIns="0" bIns="0" anchor="t">
+            <a:noAutofit/>
+          </a:bodyPr>
+          <a:lstStyle xmlns:a="http://schemas.openxmlformats.org/drawingml/2006/main">
+            <a:defPPr algn="l">
+              <a:defRPr sz="2100" b="0">
+                <a:solidFill>
+                  <a:srgbClr val="3A4A4E"/>
+                </a:solidFill>
+                <a:latin typeface="Microsoft JhengHei"/>
+                <a:ea typeface="Microsoft JhengHei"/>
+                <a:cs typeface="Microsoft JhengHei"/>
+              </a:defRPr>
+            </a:defPPr>
+          </a:lstStyle>
+          <a:p xmlns:a="http://schemas.openxmlformats.org/drawingml/2006/main">
+            <a:pPr algn="l">
+              <a:defRPr sz="2100" b="0">
+                <a:solidFill>
+                  <a:srgbClr val="3A4A4E"/>
+                </a:solidFill>
+                <a:latin typeface="Microsoft JhengHei"/>
+                <a:ea typeface="Microsoft JhengHei"/>
+                <a:cs typeface="Microsoft JhengHei"/>
+              </a:defRPr>
+            </a:pPr>
+            <a:r>
+              <a:rPr sz="2100" b="0">
+                <a:solidFill>
+                  <a:srgbClr val="3A4A4E"/>
+                </a:solidFill>
+                <a:latin typeface="Microsoft JhengHei"/>
+                <a:ea typeface="Microsoft JhengHei"/>
+                <a:cs typeface="Microsoft JhengHei"/>
+              </a:rPr>
+              <a:t>圖中的數字代表</a:t>
+            </a:r>
+          </a:p>
+          <a:p xmlns:a="http://schemas.openxmlformats.org/drawingml/2006/main">
+            <a:pPr algn="l">
+              <a:defRPr sz="2100" b="0">
+                <a:solidFill>
+                  <a:srgbClr val="3A4A4E"/>
+                </a:solidFill>
+                <a:latin typeface="Microsoft JhengHei"/>
+                <a:ea typeface="Microsoft JhengHei"/>
+                <a:cs typeface="Microsoft JhengHei"/>
+              </a:defRPr>
+            </a:pPr>
+            <a:r>
+              <a:rPr sz="2100" b="0">
+                <a:solidFill>
+                  <a:srgbClr val="3A4A4E"/>
+                </a:solidFill>
+                <a:latin typeface="Microsoft JhengHei"/>
+                <a:ea typeface="Microsoft JhengHei"/>
+                <a:cs typeface="Microsoft JhengHei"/>
+              </a:rPr>
+              <a:t>相對學習影響</a:t>
+            </a:r>
+          </a:p>
+        </p:txBody>
+      </p:sp>
+      <p:sp>
+        <p:nvSpPr>
+          <p:cNvPr id="10" name="body">
+            <a:extLst xmlns:a="http://schemas.openxmlformats.org/drawingml/2006/main">
+              <a:ext uri="{FF2B5EF4-FFF2-40B4-BE49-F238E27FC236}">
+                <a16:creationId xmlns:a16="http://schemas.microsoft.com/office/drawing/2014/main" id="{4D66D93F-3DE4-463C-B762-F17B6E147C31}"/>
+              </a:ext>
+            </a:extLst>
+          </p:cNvPr>
+          <p:cNvSpPr>
+            <a:spLocks xmlns:a="http://schemas.openxmlformats.org/drawingml/2006/main" noGrp="1"/>
+          </p:cNvSpPr>
+          <p:nvPr/>
+        </p:nvSpPr>
+        <p:spPr>
+          <a:xfrm xmlns:a="http://schemas.openxmlformats.org/drawingml/2006/main">
+            <a:off x="8572500" y="3952875"/>
+            <a:ext cx="2857500" cy="1047750"/>
           </a:xfrm>
           <a:prstGeom xmlns:a="http://schemas.openxmlformats.org/drawingml/2006/main" prst="rect">
             <a:avLst/>
@@ -17902,7 +18803,7 @@
             <a:defPPr algn="l">
               <a:defRPr sz="2700" b="1">
                 <a:solidFill>
-                  <a:srgbClr val="23343A"/>
+                  <a:srgbClr val="276E68"/>
                 </a:solidFill>
                 <a:latin typeface="Microsoft JhengHei"/>
                 <a:ea typeface="Microsoft JhengHei"/>
@@ -17914,7 +18815,7 @@
             <a:pPr algn="l">
               <a:defRPr sz="2700" b="1">
                 <a:solidFill>
-                  <a:srgbClr val="23343A"/>
+                  <a:srgbClr val="276E68"/>
                 </a:solidFill>
                 <a:latin typeface="Microsoft JhengHei"/>
                 <a:ea typeface="Microsoft JhengHei"/>
@@ -17924,45 +18825,46 @@
             <a:r>
               <a:rPr sz="2700" b="1">
                 <a:solidFill>
-                  <a:srgbClr val="23343A"/>
+                  <a:srgbClr val="276E68"/>
                 </a:solidFill>
                 <a:latin typeface="Microsoft JhengHei"/>
                 <a:ea typeface="Microsoft JhengHei"/>
                 <a:cs typeface="Microsoft JhengHei"/>
               </a:rPr>
-              <a:t>365 日半衰期</a:t>
+              <a:t>每早一年</a:t>
+            </a:r>
+          </a:p>
+          <a:p xmlns:a="http://schemas.openxmlformats.org/drawingml/2006/main">
+            <a:pPr algn="l">
+              <a:defRPr sz="2700" b="1">
+                <a:solidFill>
+                  <a:srgbClr val="276E68"/>
+                </a:solidFill>
+                <a:latin typeface="Microsoft JhengHei"/>
+                <a:ea typeface="Microsoft JhengHei"/>
+                <a:cs typeface="Microsoft JhengHei"/>
+              </a:defRPr>
+            </a:pPr>
+            <a:r>
+              <a:rPr sz="2700" b="1">
+                <a:solidFill>
+                  <a:srgbClr val="276E68"/>
+                </a:solidFill>
+                <a:latin typeface="Microsoft JhengHei"/>
+                <a:ea typeface="Microsoft JhengHei"/>
+                <a:cs typeface="Microsoft JhengHei"/>
+              </a:rPr>
+              <a:t>影響降為一半</a:t>
             </a:r>
           </a:p>
         </p:txBody>
       </p:sp>
-      <p:graphicFrame>
-        <p:nvGraphicFramePr>
-          <p:cNvPr id="4" name="Chart">
+      <p:sp>
+        <p:nvSpPr>
+          <p:cNvPr id="11" name="body">
             <a:extLst xmlns:a="http://schemas.openxmlformats.org/drawingml/2006/main">
               <a:ext uri="{FF2B5EF4-FFF2-40B4-BE49-F238E27FC236}">
-                <a16:creationId xmlns:a16="http://schemas.microsoft.com/office/drawing/2014/main" id="{D99C14DF-1989-4881-83F0-168CF35E70AE}"/>
-              </a:ext>
-            </a:extLst>
-          </p:cNvPr>
-          <p:cNvGraphicFramePr/>
-          <p:nvPr/>
-        </p:nvGraphicFramePr>
-        <p:xfrm>
-          <a:off xmlns:a="http://schemas.openxmlformats.org/drawingml/2006/main" x="762000" y="2171700"/>
-          <a:ext xmlns:a="http://schemas.openxmlformats.org/drawingml/2006/main" cx="7048500" cy="3219450"/>
-        </p:xfrm>
-        <a:graphic xmlns:a="http://schemas.openxmlformats.org/drawingml/2006/main">
-          <a:graphicData uri="http://schemas.openxmlformats.org/drawingml/2006/chart">
-            <c:chart xmlns:r="http://schemas.openxmlformats.org/officeDocument/2006/relationships" xmlns:c="http://schemas.openxmlformats.org/drawingml/2006/chart" r:id="Rfbf0a3a4a5224da3"/>
-          </a:graphicData>
-        </a:graphic>
-      </p:graphicFrame>
-      <p:sp>
-        <p:nvSpPr>
-          <p:cNvPr id="5" name="body">
-            <a:extLst xmlns:a="http://schemas.openxmlformats.org/drawingml/2006/main">
-              <a:ext uri="{FF2B5EF4-FFF2-40B4-BE49-F238E27FC236}">
-                <a16:creationId xmlns:a16="http://schemas.microsoft.com/office/drawing/2014/main" id="{F1C92124-6E73-40E7-9F36-A681ECB11D9B}"/>
+                <a16:creationId xmlns:a16="http://schemas.microsoft.com/office/drawing/2014/main" id="{2CD80CC3-035C-4BE7-A08E-623E8E716E24}"/>
               </a:ext>
             </a:extLst>
           </p:cNvPr>
@@ -17973,234 +18875,7 @@
         </p:nvSpPr>
         <p:spPr>
           <a:xfrm xmlns:a="http://schemas.openxmlformats.org/drawingml/2006/main">
-            <a:off x="8763000" y="2619375"/>
-            <a:ext cx="2667000" cy="428625"/>
-          </a:xfrm>
-          <a:prstGeom xmlns:a="http://schemas.openxmlformats.org/drawingml/2006/main" prst="rect">
-            <a:avLst/>
-          </a:prstGeom>
-          <a:noFill xmlns:a="http://schemas.openxmlformats.org/drawingml/2006/main"/>
-          <a:ln xmlns:a="http://schemas.openxmlformats.org/drawingml/2006/main" w="0">
-            <a:noFill/>
-          </a:ln>
-        </p:spPr>
-        <p:txBody>
-          <a:bodyPr xmlns:a="http://schemas.openxmlformats.org/drawingml/2006/main" wrap="square" lIns="0" tIns="0" rIns="0" bIns="0" anchor="t">
-            <a:noAutofit/>
-          </a:bodyPr>
-          <a:lstStyle xmlns:a="http://schemas.openxmlformats.org/drawingml/2006/main">
-            <a:defPPr algn="l">
-              <a:defRPr sz="2100" b="1">
-                <a:solidFill>
-                  <a:srgbClr val="276E68"/>
-                </a:solidFill>
-                <a:latin typeface="Microsoft JhengHei"/>
-                <a:ea typeface="Microsoft JhengHei"/>
-                <a:cs typeface="Microsoft JhengHei"/>
-              </a:defRPr>
-            </a:defPPr>
-          </a:lstStyle>
-          <a:p xmlns:a="http://schemas.openxmlformats.org/drawingml/2006/main">
-            <a:pPr algn="l">
-              <a:defRPr sz="2100" b="1">
-                <a:solidFill>
-                  <a:srgbClr val="276E68"/>
-                </a:solidFill>
-                <a:latin typeface="Microsoft JhengHei"/>
-                <a:ea typeface="Microsoft JhengHei"/>
-                <a:cs typeface="Microsoft JhengHei"/>
-              </a:defRPr>
-            </a:pPr>
-            <a:r>
-              <a:rPr sz="2100" b="1">
-                <a:solidFill>
-                  <a:srgbClr val="276E68"/>
-                </a:solidFill>
-                <a:latin typeface="Microsoft JhengHei"/>
-                <a:ea typeface="Microsoft JhengHei"/>
-                <a:cs typeface="Microsoft JhengHei"/>
-              </a:rPr>
-              <a:t>相差一年</a:t>
-            </a:r>
-          </a:p>
-        </p:txBody>
-      </p:sp>
-      <p:sp>
-        <p:nvSpPr>
-          <p:cNvPr id="6" name="body">
-            <a:extLst xmlns:a="http://schemas.openxmlformats.org/drawingml/2006/main">
-              <a:ext uri="{FF2B5EF4-FFF2-40B4-BE49-F238E27FC236}">
-                <a16:creationId xmlns:a16="http://schemas.microsoft.com/office/drawing/2014/main" id="{3A4F6656-0F67-4D74-A9A9-7B1DE48D8D19}"/>
-              </a:ext>
-            </a:extLst>
-          </p:cNvPr>
-          <p:cNvSpPr>
-            <a:spLocks xmlns:a="http://schemas.openxmlformats.org/drawingml/2006/main" noGrp="1"/>
-          </p:cNvSpPr>
-          <p:nvPr/>
-        </p:nvSpPr>
-        <p:spPr>
-          <a:xfrm xmlns:a="http://schemas.openxmlformats.org/drawingml/2006/main">
-            <a:off x="8677275" y="3238500"/>
-            <a:ext cx="2762250" cy="952500"/>
-          </a:xfrm>
-          <a:prstGeom xmlns:a="http://schemas.openxmlformats.org/drawingml/2006/main" prst="rect">
-            <a:avLst/>
-          </a:prstGeom>
-          <a:noFill xmlns:a="http://schemas.openxmlformats.org/drawingml/2006/main"/>
-          <a:ln xmlns:a="http://schemas.openxmlformats.org/drawingml/2006/main" w="0">
-            <a:noFill/>
-          </a:ln>
-        </p:spPr>
-        <p:txBody>
-          <a:bodyPr xmlns:a="http://schemas.openxmlformats.org/drawingml/2006/main" wrap="square" lIns="0" tIns="0" rIns="0" bIns="0" anchor="t">
-            <a:noAutofit/>
-          </a:bodyPr>
-          <a:lstStyle xmlns:a="http://schemas.openxmlformats.org/drawingml/2006/main">
-            <a:defPPr algn="l">
-              <a:defRPr sz="4875" b="1">
-                <a:solidFill>
-                  <a:srgbClr val="276E68"/>
-                </a:solidFill>
-                <a:latin typeface="Microsoft JhengHei"/>
-                <a:ea typeface="Microsoft JhengHei"/>
-                <a:cs typeface="Microsoft JhengHei"/>
-              </a:defRPr>
-            </a:defPPr>
-          </a:lstStyle>
-          <a:p xmlns:a="http://schemas.openxmlformats.org/drawingml/2006/main">
-            <a:pPr algn="l">
-              <a:defRPr sz="4875" b="1">
-                <a:solidFill>
-                  <a:srgbClr val="276E68"/>
-                </a:solidFill>
-                <a:latin typeface="Microsoft JhengHei"/>
-                <a:ea typeface="Microsoft JhengHei"/>
-                <a:cs typeface="Microsoft JhengHei"/>
-              </a:defRPr>
-            </a:pPr>
-            <a:r>
-              <a:rPr sz="4875" b="1">
-                <a:solidFill>
-                  <a:srgbClr val="276E68"/>
-                </a:solidFill>
-                <a:latin typeface="Microsoft JhengHei"/>
-                <a:ea typeface="Microsoft JhengHei"/>
-                <a:cs typeface="Microsoft JhengHei"/>
-              </a:rPr>
-              <a:t>1 : 2</a:t>
-            </a:r>
-          </a:p>
-        </p:txBody>
-      </p:sp>
-      <p:sp>
-        <p:nvSpPr>
-          <p:cNvPr id="7" name="body">
-            <a:extLst xmlns:a="http://schemas.openxmlformats.org/drawingml/2006/main">
-              <a:ext uri="{FF2B5EF4-FFF2-40B4-BE49-F238E27FC236}">
-                <a16:creationId xmlns:a16="http://schemas.microsoft.com/office/drawing/2014/main" id="{479A462B-5F21-4ED1-92AB-A0FC1EF6A257}"/>
-              </a:ext>
-            </a:extLst>
-          </p:cNvPr>
-          <p:cNvSpPr>
-            <a:spLocks xmlns:a="http://schemas.openxmlformats.org/drawingml/2006/main" noGrp="1"/>
-          </p:cNvSpPr>
-          <p:nvPr/>
-        </p:nvSpPr>
-        <p:spPr>
-          <a:xfrm xmlns:a="http://schemas.openxmlformats.org/drawingml/2006/main">
-            <a:off x="8763000" y="4371975"/>
-            <a:ext cx="2667000" cy="904875"/>
-          </a:xfrm>
-          <a:prstGeom xmlns:a="http://schemas.openxmlformats.org/drawingml/2006/main" prst="rect">
-            <a:avLst/>
-          </a:prstGeom>
-          <a:noFill xmlns:a="http://schemas.openxmlformats.org/drawingml/2006/main"/>
-          <a:ln xmlns:a="http://schemas.openxmlformats.org/drawingml/2006/main" w="0">
-            <a:noFill/>
-          </a:ln>
-        </p:spPr>
-        <p:txBody>
-          <a:bodyPr xmlns:a="http://schemas.openxmlformats.org/drawingml/2006/main" wrap="square" lIns="0" tIns="0" rIns="0" bIns="0" anchor="t">
-            <a:noAutofit/>
-          </a:bodyPr>
-          <a:lstStyle xmlns:a="http://schemas.openxmlformats.org/drawingml/2006/main">
-            <a:defPPr algn="l">
-              <a:defRPr sz="1950" b="0">
-                <a:solidFill>
-                  <a:srgbClr val="3A4A4E"/>
-                </a:solidFill>
-                <a:latin typeface="Microsoft JhengHei"/>
-                <a:ea typeface="Microsoft JhengHei"/>
-                <a:cs typeface="Microsoft JhengHei"/>
-              </a:defRPr>
-            </a:defPPr>
-          </a:lstStyle>
-          <a:p xmlns:a="http://schemas.openxmlformats.org/drawingml/2006/main">
-            <a:pPr algn="l">
-              <a:defRPr sz="1950" b="0">
-                <a:solidFill>
-                  <a:srgbClr val="3A4A4E"/>
-                </a:solidFill>
-                <a:latin typeface="Microsoft JhengHei"/>
-                <a:ea typeface="Microsoft JhengHei"/>
-                <a:cs typeface="Microsoft JhengHei"/>
-              </a:defRPr>
-            </a:pPr>
-            <a:r>
-              <a:rPr sz="1950" b="0">
-                <a:solidFill>
-                  <a:srgbClr val="3A4A4E"/>
-                </a:solidFill>
-                <a:latin typeface="Microsoft JhengHei"/>
-                <a:ea typeface="Microsoft JhengHei"/>
-                <a:cs typeface="Microsoft JhengHei"/>
-              </a:rPr>
-              <a:t>較舊與較新交易</a:t>
-            </a:r>
-          </a:p>
-          <a:p xmlns:a="http://schemas.openxmlformats.org/drawingml/2006/main">
-            <a:pPr algn="l">
-              <a:defRPr sz="1950" b="0">
-                <a:solidFill>
-                  <a:srgbClr val="3A4A4E"/>
-                </a:solidFill>
-                <a:latin typeface="Microsoft JhengHei"/>
-                <a:ea typeface="Microsoft JhengHei"/>
-                <a:cs typeface="Microsoft JhengHei"/>
-              </a:defRPr>
-            </a:pPr>
-            <a:r>
-              <a:rPr sz="1950" b="0">
-                <a:solidFill>
-                  <a:srgbClr val="3A4A4E"/>
-                </a:solidFill>
-                <a:latin typeface="Microsoft JhengHei"/>
-                <a:ea typeface="Microsoft JhengHei"/>
-                <a:cs typeface="Microsoft JhengHei"/>
-              </a:rPr>
-              <a:t>原始權重的比例</a:t>
-            </a:r>
-          </a:p>
-        </p:txBody>
-      </p:sp>
-      <p:sp>
-        <p:nvSpPr>
-          <p:cNvPr id="8" name="body">
-            <a:extLst xmlns:a="http://schemas.openxmlformats.org/drawingml/2006/main">
-              <a:ext uri="{FF2B5EF4-FFF2-40B4-BE49-F238E27FC236}">
-                <a16:creationId xmlns:a16="http://schemas.microsoft.com/office/drawing/2014/main" id="{AD6D1D57-772F-4248-9A2B-6DEB364D4917}"/>
-              </a:ext>
-            </a:extLst>
-          </p:cNvPr>
-          <p:cNvSpPr>
-            <a:spLocks xmlns:a="http://schemas.openxmlformats.org/drawingml/2006/main" noGrp="1"/>
-          </p:cNvSpPr>
-          <p:nvPr/>
-        </p:nvSpPr>
-        <p:spPr>
-          <a:xfrm xmlns:a="http://schemas.openxmlformats.org/drawingml/2006/main">
-            <a:off x="762000" y="5972175"/>
+            <a:off x="762000" y="5924550"/>
             <a:ext cx="10572750" cy="571500"/>
           </a:xfrm>
           <a:prstGeom xmlns:a="http://schemas.openxmlformats.org/drawingml/2006/main" prst="rect">
@@ -18247,7 +18922,7 @@
                 <a:ea typeface="Microsoft JhengHei"/>
                 <a:cs typeface="Microsoft JhengHei"/>
               </a:rPr>
-              <a:t>圖示為正規化前相對權重。權重改變學習影響，房價本身不乘權重。</a:t>
+              <a:t>圖為正規化前的相對比例。權重乘在訓練損失上，成交價本身不變。</a:t>
             </a:r>
           </a:p>
         </p:txBody>

</xml_diff>

<commit_message>
Organize presentation into four chapters with an opening outline
</commit_message>
<xml_diff>
--- a/teaching/final_presentation/台灣房屋銷售價格預測挑戰賽_上台簡報.pptx
+++ b/teaching/final_presentation/台灣房屋銷售價格預測挑戰賽_上台簡報.pptx
@@ -9,6 +9,7 @@
   </p:notesMasterIdLst>
   <p:sldIdLst>
     <p:sldId xmlns:r="http://schemas.openxmlformats.org/officeDocument/2006/relationships" id="256" r:id="Rdd409be40c044144"/>
+    <p:sldId xmlns:r="http://schemas.openxmlformats.org/officeDocument/2006/relationships" id="270" r:id="Rafc92b8307b14f18"/>
     <p:sldId xmlns:r="http://schemas.openxmlformats.org/officeDocument/2006/relationships" id="257" r:id="R1d898716f9e44c3c"/>
     <p:sldId xmlns:r="http://schemas.openxmlformats.org/officeDocument/2006/relationships" id="258" r:id="Ra3427099f22a4a68"/>
     <p:sldId xmlns:r="http://schemas.openxmlformats.org/officeDocument/2006/relationships" id="259" r:id="Rf472bb0f99b848ea"/>
@@ -18,11 +19,10 @@
     <p:sldId xmlns:r="http://schemas.openxmlformats.org/officeDocument/2006/relationships" id="263" r:id="Raa640f9763fb4bbb"/>
     <p:sldId xmlns:r="http://schemas.openxmlformats.org/officeDocument/2006/relationships" id="264" r:id="R08dc736f08364992"/>
     <p:sldId xmlns:r="http://schemas.openxmlformats.org/officeDocument/2006/relationships" id="265" r:id="Ra1e13966e8e24ebe"/>
-    <p:sldId xmlns:r="http://schemas.openxmlformats.org/officeDocument/2006/relationships" id="266" r:id="Rae1a7d18a51c477b"/>
     <p:sldId xmlns:r="http://schemas.openxmlformats.org/officeDocument/2006/relationships" id="267" r:id="Rce4567cb164e45c1"/>
     <p:sldId xmlns:r="http://schemas.openxmlformats.org/officeDocument/2006/relationships" id="268" r:id="Rb21fd0317fca4bfd"/>
     <p:sldId xmlns:r="http://schemas.openxmlformats.org/officeDocument/2006/relationships" id="269" r:id="R5cf005dc4bc14c42"/>
-    <p:sldId xmlns:r="http://schemas.openxmlformats.org/officeDocument/2006/relationships" id="270" r:id="Rafc92b8307b14f18"/>
+    <p:sldId xmlns:r="http://schemas.openxmlformats.org/officeDocument/2006/relationships" id="266" r:id="Rae1a7d18a51c477b"/>
     <p:sldId xmlns:r="http://schemas.openxmlformats.org/officeDocument/2006/relationships" id="271" r:id="R6a89f44cbee14852"/>
   </p:sldIdLst>
   <p:sldSz cx="12192000" cy="6858000"/>
@@ -717,6 +717,16 @@
           <a:lstStyle xmlns:a="http://schemas.openxmlformats.org/drawingml/2006/main"/>
           <a:p xmlns:a="http://schemas.openxmlformats.org/drawingml/2006/main">
             <a:r>
+              <a:t>總價的產生流程到這裡完成。接著說明檢查方式，先看另外保存的一支參考單價網路的訓練曲線。</a:t>
+            </a:r>
+          </a:p>
+          <a:p xmlns:a="http://schemas.openxmlformats.org/drawingml/2006/main">
+            <a:r>
+              <a:t/>
+            </a:r>
+          </a:p>
+          <a:p xmlns:a="http://schemas.openxmlformats.org/drawingml/2006/main">
+            <a:r>
               <a:t>較早的三十二萬一千五百五十筆交易用來訓練，日期截至二〇二三年八月十日。後面的十三萬三千六百九十七筆，是二〇二三年八月十一日至二〇二四年八月十日成交，保留驗證。兩批都從原本有答案的訓練資料切出，不是課程驗證檔或比賽測試檔。</a:t>
             </a:r>
           </a:p>
@@ -847,7 +857,7 @@
           <a:lstStyle xmlns:a="http://schemas.openxmlformats.org/drawingml/2006/main"/>
           <a:p xmlns:a="http://schemas.openxmlformats.org/drawingml/2006/main">
             <a:r>
-              <a:t>各模型先統一輸出總價元，再組成三條分支。第一路以單價ＣａｔＢｏｏｓｔ為主，第二路平均面積網路與參考單價網路，第三路平均直接總價與對數總價模型。</a:t>
+              <a:t>前面說明各模型怎麼估價，接下來把它們的預測組合起來。各模型先統一輸出總價元，再組成三條分支。第一路以單價ＣａｔＢｏｏｓｔ為主，第二路平均面積網路與參考單價網路，第三路平均直接總價與對數總價模型。</a:t>
             </a:r>
           </a:p>
           <a:p xmlns:a="http://schemas.openxmlformats.org/drawingml/2006/main">
@@ -1237,7 +1247,7 @@
           <a:lstStyle xmlns:a="http://schemas.openxmlformats.org/drawingml/2006/main"/>
           <a:p xmlns:a="http://schemas.openxmlformats.org/drawingml/2006/main">
             <a:r>
-              <a:t>完成流程後，我更換時間起點，重建當期模型與參考，再計算後一年的總價ＭＡＥ。表格每列是不同驗證期間，評分的是三分支修正後取中位數的完整方法。</a:t>
+              <a:t>今天的製作流程分成四個部分。第一是資料準備，先分清房屋條件與價格答案，整理欄位，再把較晚交易保留做檢查。第二是模型訓練，說明模型怎麼學估價，以及面積、日期和參考單價怎麼使用。第三是預測整合，把不同模型的估價組合、修正，得到一個總價。第四是驗證與檢查，觀察一支模型的訓練曲線，再檢查不同類型的估價誤差。接下來從資料開始。</a:t>
             </a:r>
           </a:p>
           <a:p xmlns:a="http://schemas.openxmlformats.org/drawingml/2006/main">
@@ -1247,32 +1257,12 @@
           </a:p>
           <a:p xmlns:a="http://schemas.openxmlformats.org/drawingml/2006/main">
             <a:r>
-              <a:t>比較時，先確認基準與目前方法使用同一批交易，再算目前方法減基準的差值。正數代表平均誤差增加，負數代表減少。最早年度是正差，中間、最近年度及二月起點是負差。</a:t>
-            </a:r>
-          </a:p>
-          <a:p xmlns:a="http://schemas.openxmlformats.org/drawingml/2006/main">
-            <a:r>
-              <a:t/>
-            </a:r>
-          </a:p>
-          <a:p xmlns:a="http://schemas.openxmlformats.org/drawingml/2006/main">
-            <a:r>
-              <a:t>保留四個期間，是檢查換到不同市場是否一致，不能畫成同一批資料越練越好的曲線。差值由未取整的ＭＡＥ計算。基準的參考單價網路採日期加權絕對誤差，其他設定固定。基準沿用保存預測，沒有同期配對重訓，不能把差異全歸因於平滑損失。窗口已反覆使用，也有選型限制。</a:t>
-            </a:r>
-          </a:p>
-          <a:p xmlns:a="http://schemas.openxmlformats.org/drawingml/2006/main">
-            <a:r>
-              <a:t/>
-            </a:r>
-          </a:p>
-          <a:p xmlns:a="http://schemas.openxmlformats.org/drawingml/2006/main">
-            <a:r>
               <a:t>補充理由</a:t>
             </a:r>
           </a:p>
           <a:p xmlns:a="http://schemas.openxmlformats.org/drawingml/2006/main">
             <a:r>
-              <a:t>呈現更換切點後重建與評分的檢查流程，保留不同集合與保存基準的比較限制。</a:t>
+              <a:t>四章依實際製作流程安排，頁碼範圍只提供導覽；未新增章節分隔頁。單一網路曲線與完整融合的分組評估分開說明。</a:t>
             </a:r>
           </a:p>
           <a:p xmlns:a="http://schemas.openxmlformats.org/drawingml/2006/main">
@@ -1357,6 +1347,16 @@
           <a:lstStyle xmlns:a="http://schemas.openxmlformats.org/drawingml/2006/main"/>
           <a:p xmlns:a="http://schemas.openxmlformats.org/drawingml/2006/main">
             <a:r>
+              <a:t>剛才的曲線檢查單一網路，最後回到完整流程，看看不同類型交易的誤差。</a:t>
+            </a:r>
+          </a:p>
+          <a:p xmlns:a="http://schemas.openxmlformats.org/drawingml/2006/main">
+            <a:r>
+              <a:t/>
+            </a:r>
+          </a:p>
+          <a:p xmlns:a="http://schemas.openxmlformats.org/drawingml/2006/main">
+            <a:r>
               <a:t>最後將驗證交易拆組檢查。我用當期訓練資料的城市、行政區與建案名稱，建立見過的建案清單，再分成既有建案、新建案和建案缺失，各組計算ＭＡＥ。也檢查城市、月份和價格帶，避免平均掩蓋某群問題。價格帶只在有真價的離線資料分析。</a:t>
             </a:r>
           </a:p>
@@ -1367,7 +1367,7 @@
           </a:p>
           <a:p xmlns:a="http://schemas.openxmlformats.org/drawingml/2006/main">
             <a:r>
-              <a:t>這是評估已有預測，沒有分群重新訓練。最近年度既有建案誤差增加二百一十三點一〇元，新建案減少二千八百四十一點六一元，不能宣稱每群改善。最早年度也退步，跨期一致改善的強推薦條件沒有通過。</a:t>
+              <a:t>這是評估已有預測，沒有分群重新訓練。最近年度既有建案誤差增加二百一十三點一〇元，新建案減少二千八百四十一點六一元，不能宣稱每群改善。與基準相比，完整流程在不同驗證期間有改善，也有退步，跨期一致改善的強推薦條件沒有通過。</a:t>
             </a:r>
           </a:p>
           <a:p xmlns:a="http://schemas.openxmlformats.org/drawingml/2006/main">
@@ -1402,7 +1402,7 @@
           </a:p>
           <a:p xmlns:a="http://schemas.openxmlformats.org/drawingml/2006/main">
             <a:r>
-              <a:t>說明如何建立群別及逐群評分，完整保留不利對照、重抽樣界線與未知Private。</a:t>
+              <a:t>說明如何建立群別及逐群評分，完整保留不利對照、重抽樣界線與未知Private。 原跨年度數字表移出主講，完整四窗數字仍保留在既有報告、發行及比較證據。基準沿用保存預測，沒有同期配對重訓，不能把差異全歸因於平滑損失。</a:t>
             </a:r>
           </a:p>
           <a:p xmlns:a="http://schemas.openxmlformats.org/drawingml/2006/main">
@@ -2117,7 +2117,7 @@
           <a:lstStyle xmlns:a="http://schemas.openxmlformats.org/drawingml/2006/main"/>
           <a:p xmlns:a="http://schemas.openxmlformats.org/drawingml/2006/main">
             <a:r>
-              <a:t>這頁先說清楚：有些模型先估單價，再乘回面積；也有模型直接估總價，不能把所有預測都再乘一次面積。樹模型和神經網路是學習方法，單價或總價則是要學的答案，這是兩個不同的選擇。</a:t>
+              <a:t>資料整理與時間界線確定後，接著說明模型怎麼從房屋條件學出價格。這頁先說清楚：有些模型先估單價，再乘回面積；也有模型直接估總價，不能把所有預測都再乘一次面積。樹模型和神經網路是學習方法，單價或總價則是要學的答案，這是兩個不同的選擇。</a:t>
             </a:r>
           </a:p>
           <a:p xmlns:a="http://schemas.openxmlformats.org/drawingml/2006/main">
@@ -6110,7 +6110,7 @@
                 <a:ea typeface="Microsoft JhengHei"/>
                 <a:cs typeface="Microsoft JhengHei"/>
               </a:rPr>
-              <a:t>10</a:t>
+              <a:t>11</a:t>
             </a:r>
           </a:p>
         </p:txBody>
@@ -7177,6 +7177,74 @@
                 <a:cs typeface="Microsoft JhengHei"/>
               </a:rPr>
               <a:t>這份參考單價稱為「分組先驗」，由當期訓練交易建立。</a:t>
+            </a:r>
+          </a:p>
+        </p:txBody>
+      </p:sp>
+      <p:sp>
+        <p:nvSpPr>
+          <p:cNvPr id="19" name="chapter-label">
+            <a:extLst xmlns:a="http://schemas.openxmlformats.org/drawingml/2006/main">
+              <a:ext uri="{FF2B5EF4-FFF2-40B4-BE49-F238E27FC236}">
+                <a16:creationId xmlns:a16="http://schemas.microsoft.com/office/drawing/2014/main" id="{EFD43309-8C2C-4576-93CF-AC39128A7BC1}"/>
+              </a:ext>
+            </a:extLst>
+          </p:cNvPr>
+          <p:cNvSpPr>
+            <a:spLocks xmlns:a="http://schemas.openxmlformats.org/drawingml/2006/main" noGrp="1"/>
+          </p:cNvSpPr>
+          <p:nvPr/>
+        </p:nvSpPr>
+        <p:spPr>
+          <a:xfrm xmlns:a="http://schemas.openxmlformats.org/drawingml/2006/main">
+            <a:off x="8572500" y="190500"/>
+            <a:ext cx="2857500" cy="228600"/>
+          </a:xfrm>
+          <a:prstGeom xmlns:a="http://schemas.openxmlformats.org/drawingml/2006/main" prst="rect">
+            <a:avLst/>
+          </a:prstGeom>
+          <a:noFill xmlns:a="http://schemas.openxmlformats.org/drawingml/2006/main"/>
+          <a:ln xmlns:a="http://schemas.openxmlformats.org/drawingml/2006/main" w="0">
+            <a:noFill/>
+          </a:ln>
+        </p:spPr>
+        <p:txBody>
+          <a:bodyPr xmlns:a="http://schemas.openxmlformats.org/drawingml/2006/main" wrap="square" lIns="0" tIns="0" rIns="0" bIns="0" anchor="t">
+            <a:noAutofit/>
+          </a:bodyPr>
+          <a:lstStyle xmlns:a="http://schemas.openxmlformats.org/drawingml/2006/main">
+            <a:defPPr algn="r">
+              <a:defRPr sz="1350" b="0">
+                <a:solidFill>
+                  <a:srgbClr val="718082"/>
+                </a:solidFill>
+                <a:latin typeface="Microsoft JhengHei"/>
+                <a:ea typeface="Microsoft JhengHei"/>
+                <a:cs typeface="Microsoft JhengHei"/>
+              </a:defRPr>
+            </a:defPPr>
+          </a:lstStyle>
+          <a:p xmlns:a="http://schemas.openxmlformats.org/drawingml/2006/main">
+            <a:pPr algn="r">
+              <a:defRPr sz="1350" b="0">
+                <a:solidFill>
+                  <a:srgbClr val="718082"/>
+                </a:solidFill>
+                <a:latin typeface="Microsoft JhengHei"/>
+                <a:ea typeface="Microsoft JhengHei"/>
+                <a:cs typeface="Microsoft JhengHei"/>
+              </a:defRPr>
+            </a:pPr>
+            <a:r>
+              <a:rPr sz="1350" b="0">
+                <a:solidFill>
+                  <a:srgbClr val="718082"/>
+                </a:solidFill>
+                <a:latin typeface="Microsoft JhengHei"/>
+                <a:ea typeface="Microsoft JhengHei"/>
+                <a:cs typeface="Microsoft JhengHei"/>
+              </a:rPr>
+              <a:t>02 模型訓練</a:t>
             </a:r>
           </a:p>
         </p:txBody>
@@ -7341,7 +7409,7 @@
                 <a:ea typeface="Microsoft JhengHei"/>
                 <a:cs typeface="Microsoft JhengHei"/>
               </a:rPr>
-              <a:t>11</a:t>
+              <a:t>15</a:t>
             </a:r>
           </a:p>
         </p:txBody>
@@ -7887,6 +7955,74 @@
                 <a:cs typeface="Microsoft JhengHei"/>
               </a:rPr>
               <a:t>固定30輪，不依最低點選輪數。曲線不能證明沒有過擬合，輪數也不代表模型容量。</a:t>
+            </a:r>
+          </a:p>
+        </p:txBody>
+      </p:sp>
+      <p:sp>
+        <p:nvSpPr>
+          <p:cNvPr id="11" name="chapter-label">
+            <a:extLst xmlns:a="http://schemas.openxmlformats.org/drawingml/2006/main">
+              <a:ext uri="{FF2B5EF4-FFF2-40B4-BE49-F238E27FC236}">
+                <a16:creationId xmlns:a16="http://schemas.microsoft.com/office/drawing/2014/main" id="{B16264A9-0257-4A06-B2C1-565DF486081C}"/>
+              </a:ext>
+            </a:extLst>
+          </p:cNvPr>
+          <p:cNvSpPr>
+            <a:spLocks xmlns:a="http://schemas.openxmlformats.org/drawingml/2006/main" noGrp="1"/>
+          </p:cNvSpPr>
+          <p:nvPr/>
+        </p:nvSpPr>
+        <p:spPr>
+          <a:xfrm xmlns:a="http://schemas.openxmlformats.org/drawingml/2006/main">
+            <a:off x="8572500" y="190500"/>
+            <a:ext cx="2857500" cy="228600"/>
+          </a:xfrm>
+          <a:prstGeom xmlns:a="http://schemas.openxmlformats.org/drawingml/2006/main" prst="rect">
+            <a:avLst/>
+          </a:prstGeom>
+          <a:noFill xmlns:a="http://schemas.openxmlformats.org/drawingml/2006/main"/>
+          <a:ln xmlns:a="http://schemas.openxmlformats.org/drawingml/2006/main" w="0">
+            <a:noFill/>
+          </a:ln>
+        </p:spPr>
+        <p:txBody>
+          <a:bodyPr xmlns:a="http://schemas.openxmlformats.org/drawingml/2006/main" wrap="square" lIns="0" tIns="0" rIns="0" bIns="0" anchor="t">
+            <a:noAutofit/>
+          </a:bodyPr>
+          <a:lstStyle xmlns:a="http://schemas.openxmlformats.org/drawingml/2006/main">
+            <a:defPPr algn="r">
+              <a:defRPr sz="1350" b="0">
+                <a:solidFill>
+                  <a:srgbClr val="718082"/>
+                </a:solidFill>
+                <a:latin typeface="Microsoft JhengHei"/>
+                <a:ea typeface="Microsoft JhengHei"/>
+                <a:cs typeface="Microsoft JhengHei"/>
+              </a:defRPr>
+            </a:defPPr>
+          </a:lstStyle>
+          <a:p xmlns:a="http://schemas.openxmlformats.org/drawingml/2006/main">
+            <a:pPr algn="r">
+              <a:defRPr sz="1350" b="0">
+                <a:solidFill>
+                  <a:srgbClr val="718082"/>
+                </a:solidFill>
+                <a:latin typeface="Microsoft JhengHei"/>
+                <a:ea typeface="Microsoft JhengHei"/>
+                <a:cs typeface="Microsoft JhengHei"/>
+              </a:defRPr>
+            </a:pPr>
+            <a:r>
+              <a:rPr sz="1350" b="0">
+                <a:solidFill>
+                  <a:srgbClr val="718082"/>
+                </a:solidFill>
+                <a:latin typeface="Microsoft JhengHei"/>
+                <a:ea typeface="Microsoft JhengHei"/>
+                <a:cs typeface="Microsoft JhengHei"/>
+              </a:rPr>
+              <a:t>04 驗證與檢查</a:t>
             </a:r>
           </a:p>
         </p:txBody>
@@ -8739,6 +8875,74 @@
           </a:p>
         </p:txBody>
       </p:sp>
+      <p:sp>
+        <p:nvSpPr>
+          <p:cNvPr id="7" name="chapter-label">
+            <a:extLst xmlns:a="http://schemas.openxmlformats.org/drawingml/2006/main">
+              <a:ext uri="{FF2B5EF4-FFF2-40B4-BE49-F238E27FC236}">
+                <a16:creationId xmlns:a16="http://schemas.microsoft.com/office/drawing/2014/main" id="{BB668D0D-070B-4CBC-B392-C5C2FA52EEE8}"/>
+              </a:ext>
+            </a:extLst>
+          </p:cNvPr>
+          <p:cNvSpPr>
+            <a:spLocks xmlns:a="http://schemas.openxmlformats.org/drawingml/2006/main" noGrp="1"/>
+          </p:cNvSpPr>
+          <p:nvPr/>
+        </p:nvSpPr>
+        <p:spPr>
+          <a:xfrm xmlns:a="http://schemas.openxmlformats.org/drawingml/2006/main">
+            <a:off x="8572500" y="190500"/>
+            <a:ext cx="2857500" cy="228600"/>
+          </a:xfrm>
+          <a:prstGeom xmlns:a="http://schemas.openxmlformats.org/drawingml/2006/main" prst="rect">
+            <a:avLst/>
+          </a:prstGeom>
+          <a:noFill xmlns:a="http://schemas.openxmlformats.org/drawingml/2006/main"/>
+          <a:ln xmlns:a="http://schemas.openxmlformats.org/drawingml/2006/main" w="0">
+            <a:noFill/>
+          </a:ln>
+        </p:spPr>
+        <p:txBody>
+          <a:bodyPr xmlns:a="http://schemas.openxmlformats.org/drawingml/2006/main" wrap="square" lIns="0" tIns="0" rIns="0" bIns="0" anchor="t">
+            <a:noAutofit/>
+          </a:bodyPr>
+          <a:lstStyle xmlns:a="http://schemas.openxmlformats.org/drawingml/2006/main">
+            <a:defPPr algn="r">
+              <a:defRPr sz="1350" b="0">
+                <a:solidFill>
+                  <a:srgbClr val="718082"/>
+                </a:solidFill>
+                <a:latin typeface="Microsoft JhengHei"/>
+                <a:ea typeface="Microsoft JhengHei"/>
+                <a:cs typeface="Microsoft JhengHei"/>
+              </a:defRPr>
+            </a:defPPr>
+          </a:lstStyle>
+          <a:p xmlns:a="http://schemas.openxmlformats.org/drawingml/2006/main">
+            <a:pPr algn="r">
+              <a:defRPr sz="1350" b="0">
+                <a:solidFill>
+                  <a:srgbClr val="718082"/>
+                </a:solidFill>
+                <a:latin typeface="Microsoft JhengHei"/>
+                <a:ea typeface="Microsoft JhengHei"/>
+                <a:cs typeface="Microsoft JhengHei"/>
+              </a:defRPr>
+            </a:pPr>
+            <a:r>
+              <a:rPr sz="1350" b="0">
+                <a:solidFill>
+                  <a:srgbClr val="718082"/>
+                </a:solidFill>
+                <a:latin typeface="Microsoft JhengHei"/>
+                <a:ea typeface="Microsoft JhengHei"/>
+                <a:cs typeface="Microsoft JhengHei"/>
+              </a:rPr>
+              <a:t>03 預測整合</a:t>
+            </a:r>
+          </a:p>
+        </p:txBody>
+      </p:sp>
     </p:spTree>
     <p:extLst>
       <p:ext uri="{BB962C8B-B14F-4D97-AF65-F5344CB8AC3E}">
@@ -9426,6 +9630,74 @@
           </a:p>
         </p:txBody>
       </p:sp>
+      <p:sp>
+        <p:nvSpPr>
+          <p:cNvPr id="11" name="chapter-label">
+            <a:extLst xmlns:a="http://schemas.openxmlformats.org/drawingml/2006/main">
+              <a:ext uri="{FF2B5EF4-FFF2-40B4-BE49-F238E27FC236}">
+                <a16:creationId xmlns:a16="http://schemas.microsoft.com/office/drawing/2014/main" id="{39178AE5-145D-4D82-ABD6-31D9A84CFC33}"/>
+              </a:ext>
+            </a:extLst>
+          </p:cNvPr>
+          <p:cNvSpPr>
+            <a:spLocks xmlns:a="http://schemas.openxmlformats.org/drawingml/2006/main" noGrp="1"/>
+          </p:cNvSpPr>
+          <p:nvPr/>
+        </p:nvSpPr>
+        <p:spPr>
+          <a:xfrm xmlns:a="http://schemas.openxmlformats.org/drawingml/2006/main">
+            <a:off x="8572500" y="190500"/>
+            <a:ext cx="2857500" cy="228600"/>
+          </a:xfrm>
+          <a:prstGeom xmlns:a="http://schemas.openxmlformats.org/drawingml/2006/main" prst="rect">
+            <a:avLst/>
+          </a:prstGeom>
+          <a:noFill xmlns:a="http://schemas.openxmlformats.org/drawingml/2006/main"/>
+          <a:ln xmlns:a="http://schemas.openxmlformats.org/drawingml/2006/main" w="0">
+            <a:noFill/>
+          </a:ln>
+        </p:spPr>
+        <p:txBody>
+          <a:bodyPr xmlns:a="http://schemas.openxmlformats.org/drawingml/2006/main" wrap="square" lIns="0" tIns="0" rIns="0" bIns="0" anchor="t">
+            <a:noAutofit/>
+          </a:bodyPr>
+          <a:lstStyle xmlns:a="http://schemas.openxmlformats.org/drawingml/2006/main">
+            <a:defPPr algn="r">
+              <a:defRPr sz="1350" b="0">
+                <a:solidFill>
+                  <a:srgbClr val="718082"/>
+                </a:solidFill>
+                <a:latin typeface="Microsoft JhengHei"/>
+                <a:ea typeface="Microsoft JhengHei"/>
+                <a:cs typeface="Microsoft JhengHei"/>
+              </a:defRPr>
+            </a:defPPr>
+          </a:lstStyle>
+          <a:p xmlns:a="http://schemas.openxmlformats.org/drawingml/2006/main">
+            <a:pPr algn="r">
+              <a:defRPr sz="1350" b="0">
+                <a:solidFill>
+                  <a:srgbClr val="718082"/>
+                </a:solidFill>
+                <a:latin typeface="Microsoft JhengHei"/>
+                <a:ea typeface="Microsoft JhengHei"/>
+                <a:cs typeface="Microsoft JhengHei"/>
+              </a:defRPr>
+            </a:pPr>
+            <a:r>
+              <a:rPr sz="1350" b="0">
+                <a:solidFill>
+                  <a:srgbClr val="718082"/>
+                </a:solidFill>
+                <a:latin typeface="Microsoft JhengHei"/>
+                <a:ea typeface="Microsoft JhengHei"/>
+                <a:cs typeface="Microsoft JhengHei"/>
+              </a:rPr>
+              <a:t>03 預測整合</a:t>
+            </a:r>
+          </a:p>
+        </p:txBody>
+      </p:sp>
     </p:spTree>
     <p:extLst>
       <p:ext uri="{BB962C8B-B14F-4D97-AF65-F5344CB8AC3E}">
@@ -10339,6 +10611,74 @@
           </a:p>
         </p:txBody>
       </p:sp>
+      <p:sp>
+        <p:nvSpPr>
+          <p:cNvPr id="15" name="chapter-label">
+            <a:extLst xmlns:a="http://schemas.openxmlformats.org/drawingml/2006/main">
+              <a:ext uri="{FF2B5EF4-FFF2-40B4-BE49-F238E27FC236}">
+                <a16:creationId xmlns:a16="http://schemas.microsoft.com/office/drawing/2014/main" id="{6BA4311F-666C-4CAB-B347-9DA3269E1398}"/>
+              </a:ext>
+            </a:extLst>
+          </p:cNvPr>
+          <p:cNvSpPr>
+            <a:spLocks xmlns:a="http://schemas.openxmlformats.org/drawingml/2006/main" noGrp="1"/>
+          </p:cNvSpPr>
+          <p:nvPr/>
+        </p:nvSpPr>
+        <p:spPr>
+          <a:xfrm xmlns:a="http://schemas.openxmlformats.org/drawingml/2006/main">
+            <a:off x="8572500" y="190500"/>
+            <a:ext cx="2857500" cy="228600"/>
+          </a:xfrm>
+          <a:prstGeom xmlns:a="http://schemas.openxmlformats.org/drawingml/2006/main" prst="rect">
+            <a:avLst/>
+          </a:prstGeom>
+          <a:noFill xmlns:a="http://schemas.openxmlformats.org/drawingml/2006/main"/>
+          <a:ln xmlns:a="http://schemas.openxmlformats.org/drawingml/2006/main" w="0">
+            <a:noFill/>
+          </a:ln>
+        </p:spPr>
+        <p:txBody>
+          <a:bodyPr xmlns:a="http://schemas.openxmlformats.org/drawingml/2006/main" wrap="square" lIns="0" tIns="0" rIns="0" bIns="0" anchor="t">
+            <a:noAutofit/>
+          </a:bodyPr>
+          <a:lstStyle xmlns:a="http://schemas.openxmlformats.org/drawingml/2006/main">
+            <a:defPPr algn="r">
+              <a:defRPr sz="1350" b="0">
+                <a:solidFill>
+                  <a:srgbClr val="718082"/>
+                </a:solidFill>
+                <a:latin typeface="Microsoft JhengHei"/>
+                <a:ea typeface="Microsoft JhengHei"/>
+                <a:cs typeface="Microsoft JhengHei"/>
+              </a:defRPr>
+            </a:defPPr>
+          </a:lstStyle>
+          <a:p xmlns:a="http://schemas.openxmlformats.org/drawingml/2006/main">
+            <a:pPr algn="r">
+              <a:defRPr sz="1350" b="0">
+                <a:solidFill>
+                  <a:srgbClr val="718082"/>
+                </a:solidFill>
+                <a:latin typeface="Microsoft JhengHei"/>
+                <a:ea typeface="Microsoft JhengHei"/>
+                <a:cs typeface="Microsoft JhengHei"/>
+              </a:defRPr>
+            </a:pPr>
+            <a:r>
+              <a:rPr sz="1350" b="0">
+                <a:solidFill>
+                  <a:srgbClr val="718082"/>
+                </a:solidFill>
+                <a:latin typeface="Microsoft JhengHei"/>
+                <a:ea typeface="Microsoft JhengHei"/>
+                <a:cs typeface="Microsoft JhengHei"/>
+              </a:rPr>
+              <a:t>03 預測整合</a:t>
+            </a:r>
+          </a:p>
+        </p:txBody>
+      </p:sp>
     </p:spTree>
     <p:extLst>
       <p:ext uri="{BB962C8B-B14F-4D97-AF65-F5344CB8AC3E}">
@@ -10370,10 +10710,10 @@
       </p:grpSpPr>
       <p:sp>
         <p:nvSpPr>
-          <p:cNvPr id="5" name="slide-title">
+          <p:cNvPr id="17" name="slide-title">
             <a:extLst xmlns:a="http://schemas.openxmlformats.org/drawingml/2006/main">
               <a:ext uri="{FF2B5EF4-FFF2-40B4-BE49-F238E27FC236}">
-                <a16:creationId xmlns:a16="http://schemas.microsoft.com/office/drawing/2014/main" id="{00B61648-3FB6-4B64-AAAA-06635AB2A0E8}"/>
+                <a16:creationId xmlns:a16="http://schemas.microsoft.com/office/drawing/2014/main" id="{A2946C59-E6C4-4705-B3E9-F1241B3ACF3A}"/>
               </a:ext>
             </a:extLst>
           </p:cNvPr>
@@ -10431,7 +10771,7 @@
                 <a:ea typeface="Microsoft JhengHei"/>
                 <a:cs typeface="Microsoft JhengHei"/>
               </a:rPr>
-              <a:t>跨年度檢查同一套流程</a:t>
+              <a:t>簡報大綱</a:t>
             </a:r>
           </a:p>
         </p:txBody>
@@ -10441,7 +10781,7 @@
           <p:cNvPr id="2" name="body">
             <a:extLst xmlns:a="http://schemas.openxmlformats.org/drawingml/2006/main">
               <a:ext uri="{FF2B5EF4-FFF2-40B4-BE49-F238E27FC236}">
-                <a16:creationId xmlns:a16="http://schemas.microsoft.com/office/drawing/2014/main" id="{03B605F1-8DCB-41D6-8FA6-86F32D5069D4}"/>
+                <a16:creationId xmlns:a16="http://schemas.microsoft.com/office/drawing/2014/main" id="{735DC46C-1F78-46C2-A62E-2980F3F2A065}"/>
               </a:ext>
             </a:extLst>
           </p:cNvPr>
@@ -10499,7 +10839,7 @@
                 <a:ea typeface="Microsoft JhengHei"/>
                 <a:cs typeface="Microsoft JhengHei"/>
               </a:rPr>
-              <a:t>15</a:t>
+              <a:t>02</a:t>
             </a:r>
           </a:p>
         </p:txBody>
@@ -10509,7 +10849,7 @@
           <p:cNvPr id="3" name="body">
             <a:extLst xmlns:a="http://schemas.openxmlformats.org/drawingml/2006/main">
               <a:ext uri="{FF2B5EF4-FFF2-40B4-BE49-F238E27FC236}">
-                <a16:creationId xmlns:a16="http://schemas.microsoft.com/office/drawing/2014/main" id="{B593D143-2110-4C20-AC4B-43DBD3591E17}"/>
+                <a16:creationId xmlns:a16="http://schemas.microsoft.com/office/drawing/2014/main" id="{39B09162-9478-48D4-ADB5-FEA844321816}"/>
               </a:ext>
             </a:extLst>
           </p:cNvPr>
@@ -10520,8 +10860,212 @@
         </p:nvSpPr>
         <p:spPr>
           <a:xfrm xmlns:a="http://schemas.openxmlformats.org/drawingml/2006/main">
-            <a:off x="762000" y="1343025"/>
-            <a:ext cx="10668000" cy="476250"/>
+            <a:off x="762000" y="1352550"/>
+            <a:ext cx="10668000" cy="438150"/>
+          </a:xfrm>
+          <a:prstGeom xmlns:a="http://schemas.openxmlformats.org/drawingml/2006/main" prst="rect">
+            <a:avLst/>
+          </a:prstGeom>
+          <a:noFill xmlns:a="http://schemas.openxmlformats.org/drawingml/2006/main"/>
+          <a:ln xmlns:a="http://schemas.openxmlformats.org/drawingml/2006/main" w="0">
+            <a:noFill/>
+          </a:ln>
+        </p:spPr>
+        <p:txBody>
+          <a:bodyPr xmlns:a="http://schemas.openxmlformats.org/drawingml/2006/main" wrap="square" lIns="0" tIns="0" rIns="0" bIns="0" anchor="t">
+            <a:noAutofit/>
+          </a:bodyPr>
+          <a:lstStyle xmlns:a="http://schemas.openxmlformats.org/drawingml/2006/main">
+            <a:defPPr algn="l">
+              <a:defRPr sz="2175" b="0">
+                <a:solidFill>
+                  <a:srgbClr val="718082"/>
+                </a:solidFill>
+                <a:latin typeface="Microsoft JhengHei"/>
+                <a:ea typeface="Microsoft JhengHei"/>
+                <a:cs typeface="Microsoft JhengHei"/>
+              </a:defRPr>
+            </a:defPPr>
+          </a:lstStyle>
+          <a:p xmlns:a="http://schemas.openxmlformats.org/drawingml/2006/main">
+            <a:pPr algn="l">
+              <a:defRPr sz="2175" b="0">
+                <a:solidFill>
+                  <a:srgbClr val="718082"/>
+                </a:solidFill>
+                <a:latin typeface="Microsoft JhengHei"/>
+                <a:ea typeface="Microsoft JhengHei"/>
+                <a:cs typeface="Microsoft JhengHei"/>
+              </a:defRPr>
+            </a:pPr>
+            <a:r>
+              <a:rPr sz="2175" b="0">
+                <a:solidFill>
+                  <a:srgbClr val="718082"/>
+                </a:solidFill>
+                <a:latin typeface="Microsoft JhengHei"/>
+                <a:ea typeface="Microsoft JhengHei"/>
+                <a:cs typeface="Microsoft JhengHei"/>
+              </a:rPr>
+              <a:t>從資料整理到估價檢查</a:t>
+            </a:r>
+          </a:p>
+        </p:txBody>
+      </p:sp>
+      <p:sp>
+        <p:nvSpPr>
+          <p:cNvPr id="4" name="body">
+            <a:extLst xmlns:a="http://schemas.openxmlformats.org/drawingml/2006/main">
+              <a:ext uri="{FF2B5EF4-FFF2-40B4-BE49-F238E27FC236}">
+                <a16:creationId xmlns:a16="http://schemas.microsoft.com/office/drawing/2014/main" id="{81B9D1A0-8241-4338-8132-61A590F2ADF5}"/>
+              </a:ext>
+            </a:extLst>
+          </p:cNvPr>
+          <p:cNvSpPr>
+            <a:spLocks xmlns:a="http://schemas.openxmlformats.org/drawingml/2006/main" noGrp="1"/>
+          </p:cNvSpPr>
+          <p:nvPr/>
+        </p:nvSpPr>
+        <p:spPr>
+          <a:xfrm xmlns:a="http://schemas.openxmlformats.org/drawingml/2006/main">
+            <a:off x="762000" y="2105025"/>
+            <a:ext cx="857250" cy="457200"/>
+          </a:xfrm>
+          <a:prstGeom xmlns:a="http://schemas.openxmlformats.org/drawingml/2006/main" prst="rect">
+            <a:avLst/>
+          </a:prstGeom>
+          <a:noFill xmlns:a="http://schemas.openxmlformats.org/drawingml/2006/main"/>
+          <a:ln xmlns:a="http://schemas.openxmlformats.org/drawingml/2006/main" w="0">
+            <a:noFill/>
+          </a:ln>
+        </p:spPr>
+        <p:txBody>
+          <a:bodyPr xmlns:a="http://schemas.openxmlformats.org/drawingml/2006/main" wrap="square" lIns="0" tIns="0" rIns="0" bIns="0" anchor="t">
+            <a:noAutofit/>
+          </a:bodyPr>
+          <a:lstStyle xmlns:a="http://schemas.openxmlformats.org/drawingml/2006/main">
+            <a:defPPr algn="l">
+              <a:defRPr sz="2550" b="1">
+                <a:solidFill>
+                  <a:srgbClr val="276E68"/>
+                </a:solidFill>
+                <a:latin typeface="Microsoft JhengHei"/>
+                <a:ea typeface="Microsoft JhengHei"/>
+                <a:cs typeface="Microsoft JhengHei"/>
+              </a:defRPr>
+            </a:defPPr>
+          </a:lstStyle>
+          <a:p xmlns:a="http://schemas.openxmlformats.org/drawingml/2006/main">
+            <a:pPr algn="l">
+              <a:defRPr sz="2550" b="1">
+                <a:solidFill>
+                  <a:srgbClr val="276E68"/>
+                </a:solidFill>
+                <a:latin typeface="Microsoft JhengHei"/>
+                <a:ea typeface="Microsoft JhengHei"/>
+                <a:cs typeface="Microsoft JhengHei"/>
+              </a:defRPr>
+            </a:pPr>
+            <a:r>
+              <a:rPr sz="2550" b="1">
+                <a:solidFill>
+                  <a:srgbClr val="276E68"/>
+                </a:solidFill>
+                <a:latin typeface="Microsoft JhengHei"/>
+                <a:ea typeface="Microsoft JhengHei"/>
+                <a:cs typeface="Microsoft JhengHei"/>
+              </a:rPr>
+              <a:t>01</a:t>
+            </a:r>
+          </a:p>
+        </p:txBody>
+      </p:sp>
+      <p:sp>
+        <p:nvSpPr>
+          <p:cNvPr id="5" name="body">
+            <a:extLst xmlns:a="http://schemas.openxmlformats.org/drawingml/2006/main">
+              <a:ext uri="{FF2B5EF4-FFF2-40B4-BE49-F238E27FC236}">
+                <a16:creationId xmlns:a16="http://schemas.microsoft.com/office/drawing/2014/main" id="{A4E1152D-F0A2-4271-B693-0BA5C5C39DD0}"/>
+              </a:ext>
+            </a:extLst>
+          </p:cNvPr>
+          <p:cNvSpPr>
+            <a:spLocks xmlns:a="http://schemas.openxmlformats.org/drawingml/2006/main" noGrp="1"/>
+          </p:cNvSpPr>
+          <p:nvPr/>
+        </p:nvSpPr>
+        <p:spPr>
+          <a:xfrm xmlns:a="http://schemas.openxmlformats.org/drawingml/2006/main">
+            <a:off x="1952625" y="2105025"/>
+            <a:ext cx="3429000" cy="457200"/>
+          </a:xfrm>
+          <a:prstGeom xmlns:a="http://schemas.openxmlformats.org/drawingml/2006/main" prst="rect">
+            <a:avLst/>
+          </a:prstGeom>
+          <a:noFill xmlns:a="http://schemas.openxmlformats.org/drawingml/2006/main"/>
+          <a:ln xmlns:a="http://schemas.openxmlformats.org/drawingml/2006/main" w="0">
+            <a:noFill/>
+          </a:ln>
+        </p:spPr>
+        <p:txBody>
+          <a:bodyPr xmlns:a="http://schemas.openxmlformats.org/drawingml/2006/main" wrap="square" lIns="0" tIns="0" rIns="0" bIns="0" anchor="t">
+            <a:noAutofit/>
+          </a:bodyPr>
+          <a:lstStyle xmlns:a="http://schemas.openxmlformats.org/drawingml/2006/main">
+            <a:defPPr algn="l">
+              <a:defRPr sz="2550" b="1">
+                <a:solidFill>
+                  <a:srgbClr val="23343A"/>
+                </a:solidFill>
+                <a:latin typeface="Microsoft JhengHei"/>
+                <a:ea typeface="Microsoft JhengHei"/>
+                <a:cs typeface="Microsoft JhengHei"/>
+              </a:defRPr>
+            </a:defPPr>
+          </a:lstStyle>
+          <a:p xmlns:a="http://schemas.openxmlformats.org/drawingml/2006/main">
+            <a:pPr algn="l">
+              <a:defRPr sz="2550" b="1">
+                <a:solidFill>
+                  <a:srgbClr val="23343A"/>
+                </a:solidFill>
+                <a:latin typeface="Microsoft JhengHei"/>
+                <a:ea typeface="Microsoft JhengHei"/>
+                <a:cs typeface="Microsoft JhengHei"/>
+              </a:defRPr>
+            </a:pPr>
+            <a:r>
+              <a:rPr sz="2550" b="1">
+                <a:solidFill>
+                  <a:srgbClr val="23343A"/>
+                </a:solidFill>
+                <a:latin typeface="Microsoft JhengHei"/>
+                <a:ea typeface="Microsoft JhengHei"/>
+                <a:cs typeface="Microsoft JhengHei"/>
+              </a:rPr>
+              <a:t>資料準備</a:t>
+            </a:r>
+          </a:p>
+        </p:txBody>
+      </p:sp>
+      <p:sp>
+        <p:nvSpPr>
+          <p:cNvPr id="6" name="body">
+            <a:extLst xmlns:a="http://schemas.openxmlformats.org/drawingml/2006/main">
+              <a:ext uri="{FF2B5EF4-FFF2-40B4-BE49-F238E27FC236}">
+                <a16:creationId xmlns:a16="http://schemas.microsoft.com/office/drawing/2014/main" id="{8662A407-35D6-4D64-A58B-17FB58D0082B}"/>
+              </a:ext>
+            </a:extLst>
+          </p:cNvPr>
+          <p:cNvSpPr>
+            <a:spLocks xmlns:a="http://schemas.openxmlformats.org/drawingml/2006/main" noGrp="1"/>
+          </p:cNvSpPr>
+          <p:nvPr/>
+        </p:nvSpPr>
+        <p:spPr>
+          <a:xfrm xmlns:a="http://schemas.openxmlformats.org/drawingml/2006/main">
+            <a:off x="5381625" y="2143125"/>
+            <a:ext cx="6048375" cy="428625"/>
           </a:xfrm>
           <a:prstGeom xmlns:a="http://schemas.openxmlformats.org/drawingml/2006/main" prst="rect">
             <a:avLst/>
@@ -10539,7 +11083,7 @@
             <a:defPPr algn="l">
               <a:defRPr sz="2025" b="0">
                 <a:solidFill>
-                  <a:srgbClr val="718082"/>
+                  <a:srgbClr val="3A4A4E"/>
                 </a:solidFill>
                 <a:latin typeface="Microsoft JhengHei"/>
                 <a:ea typeface="Microsoft JhengHei"/>
@@ -10551,7 +11095,7 @@
             <a:pPr algn="l">
               <a:defRPr sz="2025" b="0">
                 <a:solidFill>
-                  <a:srgbClr val="718082"/>
+                  <a:srgbClr val="3A4A4E"/>
                 </a:solidFill>
                 <a:latin typeface="Microsoft JhengHei"/>
                 <a:ea typeface="Microsoft JhengHei"/>
@@ -10561,891 +11105,697 @@
             <a:r>
               <a:rPr sz="2025" b="0">
                 <a:solidFill>
-                  <a:srgbClr val="718082"/>
+                  <a:srgbClr val="3A4A4E"/>
                 </a:solidFill>
                 <a:latin typeface="Microsoft JhengHei"/>
                 <a:ea typeface="Microsoft JhengHei"/>
                 <a:cs typeface="Microsoft JhengHei"/>
               </a:rPr>
-              <a:t>每個時間起點重建流程，再計算總價 MAE（元）</a:t>
+              <a:t>辨認條件與答案，整理欄位、切分時間</a:t>
             </a:r>
           </a:p>
         </p:txBody>
       </p:sp>
-      <p:graphicFrame>
-        <p:nvGraphicFramePr>
-          <p:cNvPr id="4" name="">
+      <p:sp>
+        <p:nvSpPr>
+          <p:cNvPr id="7" name="body">
             <a:extLst xmlns:a="http://schemas.openxmlformats.org/drawingml/2006/main">
               <a:ext uri="{FF2B5EF4-FFF2-40B4-BE49-F238E27FC236}">
-                <a16:creationId xmlns:a16="http://schemas.microsoft.com/office/drawing/2014/main" id="{FBF44D30-2B87-4A2F-A269-1307E521A527}"/>
+                <a16:creationId xmlns:a16="http://schemas.microsoft.com/office/drawing/2014/main" id="{2C3F35F1-2086-4B9F-824E-A33A0E6D340D}"/>
               </a:ext>
             </a:extLst>
           </p:cNvPr>
-          <p:cNvGraphicFramePr/>
+          <p:cNvSpPr>
+            <a:spLocks xmlns:a="http://schemas.openxmlformats.org/drawingml/2006/main" noGrp="1"/>
+          </p:cNvSpPr>
           <p:nvPr/>
-        </p:nvGraphicFramePr>
-        <p:xfrm>
-          <a:off xmlns:a="http://schemas.openxmlformats.org/drawingml/2006/main" x="762000" y="2143125"/>
-          <a:ext xmlns:a="http://schemas.openxmlformats.org/drawingml/2006/main" cx="10668000" cy="3190875"/>
-        </p:xfrm>
-        <a:graphic xmlns:a="http://schemas.openxmlformats.org/drawingml/2006/main">
-          <a:graphicData uri="http://schemas.openxmlformats.org/drawingml/2006/table">
-            <a:tbl>
-              <a:tblPr/>
-              <a:tblGrid>
-                <a:gridCol w="3476625"/>
-                <a:gridCol w="2476500"/>
-                <a:gridCol w="2476500"/>
-                <a:gridCol w="2238375"/>
-              </a:tblGrid>
-              <a:tr h="638175">
-                <a:tc>
-                  <a:txBody>
-                    <a:bodyPr lIns="133350" tIns="114300" rIns="152400" bIns="95250">
-                      <a:noAutofit/>
-                    </a:bodyPr>
-                    <a:lstStyle/>
-                    <a:p>
-                      <a:pPr algn="l"/>
-                      <a:r>
-                        <a:rPr sz="1800" b="1">
-                          <a:solidFill>
-                            <a:srgbClr val="23343A"/>
-                          </a:solidFill>
-                          <a:latin typeface="Microsoft JhengHei"/>
-                          <a:ea typeface="Microsoft JhengHei"/>
-                          <a:cs typeface="Microsoft JhengHei"/>
-                        </a:rPr>
-                        <a:t>評分期間</a:t>
-                      </a:r>
-                    </a:p>
-                  </a:txBody>
-                  <a:tcPr marL="91440" marR="91440" marT="45720" marB="45720" anchor="ctr">
-                    <a:lnL w="9525">
-                      <a:solidFill>
-                        <a:srgbClr val="FCFCFA"/>
-                      </a:solidFill>
-                      <a:prstDash val="solid"/>
-                    </a:lnL>
-                    <a:lnR w="9525">
-                      <a:solidFill>
-                        <a:srgbClr val="FCFCFA"/>
-                      </a:solidFill>
-                      <a:prstDash val="solid"/>
-                    </a:lnR>
-                    <a:lnT w="9525">
-                      <a:solidFill>
-                        <a:srgbClr val="FCFCFA"/>
-                      </a:solidFill>
-                      <a:prstDash val="solid"/>
-                    </a:lnT>
-                    <a:lnB w="7620">
-                      <a:solidFill>
-                        <a:srgbClr val="E1E7E4"/>
-                      </a:solidFill>
-                      <a:prstDash val="solid"/>
-                    </a:lnB>
-                    <a:solidFill>
-                      <a:srgbClr val="EEF3F0"/>
-                    </a:solidFill>
-                  </a:tcPr>
-                </a:tc>
-                <a:tc>
-                  <a:txBody>
-                    <a:bodyPr lIns="133350" tIns="114300" rIns="152400" bIns="95250">
-                      <a:noAutofit/>
-                    </a:bodyPr>
-                    <a:lstStyle/>
-                    <a:p>
-                      <a:pPr algn="r"/>
-                      <a:r>
-                        <a:rPr sz="1800" b="1">
-                          <a:solidFill>
-                            <a:srgbClr val="23343A"/>
-                          </a:solidFill>
-                          <a:latin typeface="Microsoft JhengHei"/>
-                          <a:ea typeface="Microsoft JhengHei"/>
-                          <a:cs typeface="Microsoft JhengHei"/>
-                        </a:rPr>
-                        <a:t>基準方法</a:t>
-                      </a:r>
-                    </a:p>
-                  </a:txBody>
-                  <a:tcPr marL="91440" marR="91440" marT="45720" marB="45720" anchor="ctr">
-                    <a:lnR w="9525">
-                      <a:solidFill>
-                        <a:srgbClr val="FCFCFA"/>
-                      </a:solidFill>
-                      <a:prstDash val="solid"/>
-                    </a:lnR>
-                    <a:lnT w="9525">
-                      <a:solidFill>
-                        <a:srgbClr val="FCFCFA"/>
-                      </a:solidFill>
-                      <a:prstDash val="solid"/>
-                    </a:lnT>
-                    <a:lnB w="7620">
-                      <a:solidFill>
-                        <a:srgbClr val="E1E7E4"/>
-                      </a:solidFill>
-                      <a:prstDash val="solid"/>
-                    </a:lnB>
-                    <a:solidFill>
-                      <a:srgbClr val="EEF3F0"/>
-                    </a:solidFill>
-                  </a:tcPr>
-                </a:tc>
-                <a:tc>
-                  <a:txBody>
-                    <a:bodyPr lIns="133350" tIns="114300" rIns="152400" bIns="95250">
-                      <a:noAutofit/>
-                    </a:bodyPr>
-                    <a:lstStyle/>
-                    <a:p>
-                      <a:pPr algn="r"/>
-                      <a:r>
-                        <a:rPr sz="1800" b="1">
-                          <a:solidFill>
-                            <a:srgbClr val="23343A"/>
-                          </a:solidFill>
-                          <a:latin typeface="Microsoft JhengHei"/>
-                          <a:ea typeface="Microsoft JhengHei"/>
-                          <a:cs typeface="Microsoft JhengHei"/>
-                        </a:rPr>
-                        <a:t>此方法</a:t>
-                      </a:r>
-                    </a:p>
-                  </a:txBody>
-                  <a:tcPr marL="91440" marR="91440" marT="45720" marB="45720" anchor="ctr">
-                    <a:lnR w="9525">
-                      <a:solidFill>
-                        <a:srgbClr val="FCFCFA"/>
-                      </a:solidFill>
-                      <a:prstDash val="solid"/>
-                    </a:lnR>
-                    <a:lnT w="9525">
-                      <a:solidFill>
-                        <a:srgbClr val="FCFCFA"/>
-                      </a:solidFill>
-                      <a:prstDash val="solid"/>
-                    </a:lnT>
-                    <a:lnB w="7620">
-                      <a:solidFill>
-                        <a:srgbClr val="E1E7E4"/>
-                      </a:solidFill>
-                      <a:prstDash val="solid"/>
-                    </a:lnB>
-                    <a:solidFill>
-                      <a:srgbClr val="EEF3F0"/>
-                    </a:solidFill>
-                  </a:tcPr>
-                </a:tc>
-                <a:tc>
-                  <a:txBody>
-                    <a:bodyPr lIns="133350" tIns="114300" rIns="152400" bIns="95250">
-                      <a:noAutofit/>
-                    </a:bodyPr>
-                    <a:lstStyle/>
-                    <a:p>
-                      <a:pPr algn="r"/>
-                      <a:r>
-                        <a:rPr sz="1800" b="1">
-                          <a:solidFill>
-                            <a:srgbClr val="23343A"/>
-                          </a:solidFill>
-                          <a:latin typeface="Microsoft JhengHei"/>
-                          <a:ea typeface="Microsoft JhengHei"/>
-                          <a:cs typeface="Microsoft JhengHei"/>
-                        </a:rPr>
-                        <a:t>此方法 − 基準</a:t>
-                      </a:r>
-                    </a:p>
-                  </a:txBody>
-                  <a:tcPr marL="91440" marR="91440" marT="45720" marB="45720" anchor="ctr">
-                    <a:lnR w="9525">
-                      <a:solidFill>
-                        <a:srgbClr val="FCFCFA"/>
-                      </a:solidFill>
-                      <a:prstDash val="solid"/>
-                    </a:lnR>
-                    <a:lnT w="9525">
-                      <a:solidFill>
-                        <a:srgbClr val="FCFCFA"/>
-                      </a:solidFill>
-                      <a:prstDash val="solid"/>
-                    </a:lnT>
-                    <a:lnB w="7620">
-                      <a:solidFill>
-                        <a:srgbClr val="E1E7E4"/>
-                      </a:solidFill>
-                      <a:prstDash val="solid"/>
-                    </a:lnB>
-                    <a:solidFill>
-                      <a:srgbClr val="EEF3F0"/>
-                    </a:solidFill>
-                  </a:tcPr>
-                </a:tc>
-              </a:tr>
-              <a:tr h="638175">
-                <a:tc>
-                  <a:txBody>
-                    <a:bodyPr lIns="133350" tIns="114300" rIns="152400" bIns="95250">
-                      <a:noAutofit/>
-                    </a:bodyPr>
-                    <a:lstStyle/>
-                    <a:p>
-                      <a:pPr algn="l"/>
-                      <a:r>
-                        <a:rPr sz="1800" b="0">
-                          <a:solidFill>
-                            <a:srgbClr val="3A4A4E"/>
-                          </a:solidFill>
-                          <a:latin typeface="Microsoft JhengHei"/>
-                          <a:ea typeface="Microsoft JhengHei"/>
-                          <a:cs typeface="Microsoft JhengHei"/>
-                        </a:rPr>
-                        <a:t>2021–2022 八月起點</a:t>
-                      </a:r>
-                    </a:p>
-                  </a:txBody>
-                  <a:tcPr marL="91440" marR="91440" marT="45720" marB="45720" anchor="ctr">
-                    <a:lnL w="9525">
-                      <a:solidFill>
-                        <a:srgbClr val="FCFCFA"/>
-                      </a:solidFill>
-                      <a:prstDash val="solid"/>
-                    </a:lnL>
-                    <a:lnR w="9525">
-                      <a:solidFill>
-                        <a:srgbClr val="FCFCFA"/>
-                      </a:solidFill>
-                      <a:prstDash val="solid"/>
-                    </a:lnR>
-                    <a:lnB w="7620">
-                      <a:solidFill>
-                        <a:srgbClr val="E1E7E4"/>
-                      </a:solidFill>
-                      <a:prstDash val="solid"/>
-                    </a:lnB>
-                    <a:solidFill>
-                      <a:srgbClr val="FCFCFA"/>
-                    </a:solidFill>
-                  </a:tcPr>
-                </a:tc>
-                <a:tc>
-                  <a:txBody>
-                    <a:bodyPr lIns="133350" tIns="114300" rIns="152400" bIns="95250">
-                      <a:noAutofit/>
-                    </a:bodyPr>
-                    <a:lstStyle/>
-                    <a:p>
-                      <a:pPr algn="r"/>
-                      <a:r>
-                        <a:rPr sz="1800" b="0">
-                          <a:solidFill>
-                            <a:srgbClr val="3A4A4E"/>
-                          </a:solidFill>
-                          <a:latin typeface="Microsoft JhengHei"/>
-                          <a:ea typeface="Microsoft JhengHei"/>
-                          <a:cs typeface="Microsoft JhengHei"/>
-                        </a:rPr>
-                        <a:t>2,309,352.36</a:t>
-                      </a:r>
-                    </a:p>
-                  </a:txBody>
-                  <a:tcPr marL="91440" marR="91440" marT="45720" marB="45720" anchor="ctr">
-                    <a:lnR w="9525">
-                      <a:solidFill>
-                        <a:srgbClr val="FCFCFA"/>
-                      </a:solidFill>
-                      <a:prstDash val="solid"/>
-                    </a:lnR>
-                    <a:lnB w="7620">
-                      <a:solidFill>
-                        <a:srgbClr val="E1E7E4"/>
-                      </a:solidFill>
-                      <a:prstDash val="solid"/>
-                    </a:lnB>
-                    <a:solidFill>
-                      <a:srgbClr val="FCFCFA"/>
-                    </a:solidFill>
-                  </a:tcPr>
-                </a:tc>
-                <a:tc>
-                  <a:txBody>
-                    <a:bodyPr lIns="133350" tIns="114300" rIns="152400" bIns="95250">
-                      <a:noAutofit/>
-                    </a:bodyPr>
-                    <a:lstStyle/>
-                    <a:p>
-                      <a:pPr algn="r"/>
-                      <a:r>
-                        <a:rPr sz="1800" b="0">
-                          <a:solidFill>
-                            <a:srgbClr val="3A4A4E"/>
-                          </a:solidFill>
-                          <a:latin typeface="Microsoft JhengHei"/>
-                          <a:ea typeface="Microsoft JhengHei"/>
-                          <a:cs typeface="Microsoft JhengHei"/>
-                        </a:rPr>
-                        <a:t>2,310,236.02</a:t>
-                      </a:r>
-                    </a:p>
-                  </a:txBody>
-                  <a:tcPr marL="91440" marR="91440" marT="45720" marB="45720" anchor="ctr">
-                    <a:lnR w="9525">
-                      <a:solidFill>
-                        <a:srgbClr val="FCFCFA"/>
-                      </a:solidFill>
-                      <a:prstDash val="solid"/>
-                    </a:lnR>
-                    <a:lnB w="7620">
-                      <a:solidFill>
-                        <a:srgbClr val="E1E7E4"/>
-                      </a:solidFill>
-                      <a:prstDash val="solid"/>
-                    </a:lnB>
-                    <a:solidFill>
-                      <a:srgbClr val="FCFCFA"/>
-                    </a:solidFill>
-                  </a:tcPr>
-                </a:tc>
-                <a:tc>
-                  <a:txBody>
-                    <a:bodyPr lIns="133350" tIns="114300" rIns="152400" bIns="95250">
-                      <a:noAutofit/>
-                    </a:bodyPr>
-                    <a:lstStyle/>
-                    <a:p>
-                      <a:pPr algn="r"/>
-                      <a:r>
-                        <a:rPr sz="1800" b="0">
-                          <a:solidFill>
-                            <a:srgbClr val="BA6548"/>
-                          </a:solidFill>
-                          <a:latin typeface="Microsoft JhengHei"/>
-                          <a:ea typeface="Microsoft JhengHei"/>
-                          <a:cs typeface="Microsoft JhengHei"/>
-                        </a:rPr>
-                        <a:t>+883.66</a:t>
-                      </a:r>
-                    </a:p>
-                  </a:txBody>
-                  <a:tcPr marL="91440" marR="91440" marT="45720" marB="45720" anchor="ctr">
-                    <a:lnR w="9525">
-                      <a:solidFill>
-                        <a:srgbClr val="FCFCFA"/>
-                      </a:solidFill>
-                      <a:prstDash val="solid"/>
-                    </a:lnR>
-                    <a:lnB w="7620">
-                      <a:solidFill>
-                        <a:srgbClr val="E1E7E4"/>
-                      </a:solidFill>
-                      <a:prstDash val="solid"/>
-                    </a:lnB>
-                    <a:solidFill>
-                      <a:srgbClr val="FCFCFA"/>
-                    </a:solidFill>
-                  </a:tcPr>
-                </a:tc>
-              </a:tr>
-              <a:tr h="638175">
-                <a:tc>
-                  <a:txBody>
-                    <a:bodyPr lIns="133350" tIns="114300" rIns="152400" bIns="95250">
-                      <a:noAutofit/>
-                    </a:bodyPr>
-                    <a:lstStyle/>
-                    <a:p>
-                      <a:pPr algn="l"/>
-                      <a:r>
-                        <a:rPr sz="1800" b="0">
-                          <a:solidFill>
-                            <a:srgbClr val="3A4A4E"/>
-                          </a:solidFill>
-                          <a:latin typeface="Microsoft JhengHei"/>
-                          <a:ea typeface="Microsoft JhengHei"/>
-                          <a:cs typeface="Microsoft JhengHei"/>
-                        </a:rPr>
-                        <a:t>2022–2023 八月起點</a:t>
-                      </a:r>
-                    </a:p>
-                  </a:txBody>
-                  <a:tcPr marL="91440" marR="91440" marT="45720" marB="45720" anchor="ctr">
-                    <a:lnL w="9525">
-                      <a:solidFill>
-                        <a:srgbClr val="FCFCFA"/>
-                      </a:solidFill>
-                      <a:prstDash val="solid"/>
-                    </a:lnL>
-                    <a:lnR w="9525">
-                      <a:solidFill>
-                        <a:srgbClr val="FCFCFA"/>
-                      </a:solidFill>
-                      <a:prstDash val="solid"/>
-                    </a:lnR>
-                    <a:lnB w="7620">
-                      <a:solidFill>
-                        <a:srgbClr val="E1E7E4"/>
-                      </a:solidFill>
-                      <a:prstDash val="solid"/>
-                    </a:lnB>
-                    <a:solidFill>
-                      <a:srgbClr val="FCFCFA"/>
-                    </a:solidFill>
-                  </a:tcPr>
-                </a:tc>
-                <a:tc>
-                  <a:txBody>
-                    <a:bodyPr lIns="133350" tIns="114300" rIns="152400" bIns="95250">
-                      <a:noAutofit/>
-                    </a:bodyPr>
-                    <a:lstStyle/>
-                    <a:p>
-                      <a:pPr algn="r"/>
-                      <a:r>
-                        <a:rPr sz="1800" b="0">
-                          <a:solidFill>
-                            <a:srgbClr val="3A4A4E"/>
-                          </a:solidFill>
-                          <a:latin typeface="Microsoft JhengHei"/>
-                          <a:ea typeface="Microsoft JhengHei"/>
-                          <a:cs typeface="Microsoft JhengHei"/>
-                        </a:rPr>
-                        <a:t>1,407,387.07</a:t>
-                      </a:r>
-                    </a:p>
-                  </a:txBody>
-                  <a:tcPr marL="91440" marR="91440" marT="45720" marB="45720" anchor="ctr">
-                    <a:lnR w="9525">
-                      <a:solidFill>
-                        <a:srgbClr val="FCFCFA"/>
-                      </a:solidFill>
-                      <a:prstDash val="solid"/>
-                    </a:lnR>
-                    <a:lnB w="7620">
-                      <a:solidFill>
-                        <a:srgbClr val="E1E7E4"/>
-                      </a:solidFill>
-                      <a:prstDash val="solid"/>
-                    </a:lnB>
-                    <a:solidFill>
-                      <a:srgbClr val="FCFCFA"/>
-                    </a:solidFill>
-                  </a:tcPr>
-                </a:tc>
-                <a:tc>
-                  <a:txBody>
-                    <a:bodyPr lIns="133350" tIns="114300" rIns="152400" bIns="95250">
-                      <a:noAutofit/>
-                    </a:bodyPr>
-                    <a:lstStyle/>
-                    <a:p>
-                      <a:pPr algn="r"/>
-                      <a:r>
-                        <a:rPr sz="1800" b="0">
-                          <a:solidFill>
-                            <a:srgbClr val="3A4A4E"/>
-                          </a:solidFill>
-                          <a:latin typeface="Microsoft JhengHei"/>
-                          <a:ea typeface="Microsoft JhengHei"/>
-                          <a:cs typeface="Microsoft JhengHei"/>
-                        </a:rPr>
-                        <a:t>1,405,971.19</a:t>
-                      </a:r>
-                    </a:p>
-                  </a:txBody>
-                  <a:tcPr marL="91440" marR="91440" marT="45720" marB="45720" anchor="ctr">
-                    <a:lnR w="9525">
-                      <a:solidFill>
-                        <a:srgbClr val="FCFCFA"/>
-                      </a:solidFill>
-                      <a:prstDash val="solid"/>
-                    </a:lnR>
-                    <a:lnB w="7620">
-                      <a:solidFill>
-                        <a:srgbClr val="E1E7E4"/>
-                      </a:solidFill>
-                      <a:prstDash val="solid"/>
-                    </a:lnB>
-                    <a:solidFill>
-                      <a:srgbClr val="FCFCFA"/>
-                    </a:solidFill>
-                  </a:tcPr>
-                </a:tc>
-                <a:tc>
-                  <a:txBody>
-                    <a:bodyPr lIns="133350" tIns="114300" rIns="152400" bIns="95250">
-                      <a:noAutofit/>
-                    </a:bodyPr>
-                    <a:lstStyle/>
-                    <a:p>
-                      <a:pPr algn="r"/>
-                      <a:r>
-                        <a:rPr sz="1800" b="0">
-                          <a:solidFill>
-                            <a:srgbClr val="276E68"/>
-                          </a:solidFill>
-                          <a:latin typeface="Microsoft JhengHei"/>
-                          <a:ea typeface="Microsoft JhengHei"/>
-                          <a:cs typeface="Microsoft JhengHei"/>
-                        </a:rPr>
-                        <a:t>−1,415.88</a:t>
-                      </a:r>
-                    </a:p>
-                  </a:txBody>
-                  <a:tcPr marL="91440" marR="91440" marT="45720" marB="45720" anchor="ctr">
-                    <a:lnR w="9525">
-                      <a:solidFill>
-                        <a:srgbClr val="FCFCFA"/>
-                      </a:solidFill>
-                      <a:prstDash val="solid"/>
-                    </a:lnR>
-                    <a:lnB w="7620">
-                      <a:solidFill>
-                        <a:srgbClr val="E1E7E4"/>
-                      </a:solidFill>
-                      <a:prstDash val="solid"/>
-                    </a:lnB>
-                    <a:solidFill>
-                      <a:srgbClr val="FCFCFA"/>
-                    </a:solidFill>
-                  </a:tcPr>
-                </a:tc>
-              </a:tr>
-              <a:tr h="638175">
-                <a:tc>
-                  <a:txBody>
-                    <a:bodyPr lIns="133350" tIns="114300" rIns="152400" bIns="95250">
-                      <a:noAutofit/>
-                    </a:bodyPr>
-                    <a:lstStyle/>
-                    <a:p>
-                      <a:pPr algn="l"/>
-                      <a:r>
-                        <a:rPr sz="1800" b="0">
-                          <a:solidFill>
-                            <a:srgbClr val="3A4A4E"/>
-                          </a:solidFill>
-                          <a:latin typeface="Microsoft JhengHei"/>
-                          <a:ea typeface="Microsoft JhengHei"/>
-                          <a:cs typeface="Microsoft JhengHei"/>
-                        </a:rPr>
-                        <a:t>2023–2024 八月起點</a:t>
-                      </a:r>
-                    </a:p>
-                  </a:txBody>
-                  <a:tcPr marL="91440" marR="91440" marT="45720" marB="45720" anchor="ctr">
-                    <a:lnL w="9525">
-                      <a:solidFill>
-                        <a:srgbClr val="FCFCFA"/>
-                      </a:solidFill>
-                      <a:prstDash val="solid"/>
-                    </a:lnL>
-                    <a:lnR w="9525">
-                      <a:solidFill>
-                        <a:srgbClr val="FCFCFA"/>
-                      </a:solidFill>
-                      <a:prstDash val="solid"/>
-                    </a:lnR>
-                    <a:lnB w="7620">
-                      <a:solidFill>
-                        <a:srgbClr val="E1E7E4"/>
-                      </a:solidFill>
-                      <a:prstDash val="solid"/>
-                    </a:lnB>
-                    <a:solidFill>
-                      <a:srgbClr val="E4EFEB"/>
-                    </a:solidFill>
-                  </a:tcPr>
-                </a:tc>
-                <a:tc>
-                  <a:txBody>
-                    <a:bodyPr lIns="133350" tIns="114300" rIns="152400" bIns="95250">
-                      <a:noAutofit/>
-                    </a:bodyPr>
-                    <a:lstStyle/>
-                    <a:p>
-                      <a:pPr algn="r"/>
-                      <a:r>
-                        <a:rPr sz="1800" b="0">
-                          <a:solidFill>
-                            <a:srgbClr val="3A4A4E"/>
-                          </a:solidFill>
-                          <a:latin typeface="Microsoft JhengHei"/>
-                          <a:ea typeface="Microsoft JhengHei"/>
-                          <a:cs typeface="Microsoft JhengHei"/>
-                        </a:rPr>
-                        <a:t>1,383,228.41</a:t>
-                      </a:r>
-                    </a:p>
-                  </a:txBody>
-                  <a:tcPr marL="91440" marR="91440" marT="45720" marB="45720" anchor="ctr">
-                    <a:lnR w="9525">
-                      <a:solidFill>
-                        <a:srgbClr val="FCFCFA"/>
-                      </a:solidFill>
-                      <a:prstDash val="solid"/>
-                    </a:lnR>
-                    <a:lnB w="7620">
-                      <a:solidFill>
-                        <a:srgbClr val="E1E7E4"/>
-                      </a:solidFill>
-                      <a:prstDash val="solid"/>
-                    </a:lnB>
-                    <a:solidFill>
-                      <a:srgbClr val="E4EFEB"/>
-                    </a:solidFill>
-                  </a:tcPr>
-                </a:tc>
-                <a:tc>
-                  <a:txBody>
-                    <a:bodyPr lIns="133350" tIns="114300" rIns="152400" bIns="95250">
-                      <a:noAutofit/>
-                    </a:bodyPr>
-                    <a:lstStyle/>
-                    <a:p>
-                      <a:pPr algn="r"/>
-                      <a:r>
-                        <a:rPr sz="1800" b="0">
-                          <a:solidFill>
-                            <a:srgbClr val="3A4A4E"/>
-                          </a:solidFill>
-                          <a:latin typeface="Microsoft JhengHei"/>
-                          <a:ea typeface="Microsoft JhengHei"/>
-                          <a:cs typeface="Microsoft JhengHei"/>
-                        </a:rPr>
-                        <a:t>1,381,702.87</a:t>
-                      </a:r>
-                    </a:p>
-                  </a:txBody>
-                  <a:tcPr marL="91440" marR="91440" marT="45720" marB="45720" anchor="ctr">
-                    <a:lnR w="9525">
-                      <a:solidFill>
-                        <a:srgbClr val="FCFCFA"/>
-                      </a:solidFill>
-                      <a:prstDash val="solid"/>
-                    </a:lnR>
-                    <a:lnB w="7620">
-                      <a:solidFill>
-                        <a:srgbClr val="E1E7E4"/>
-                      </a:solidFill>
-                      <a:prstDash val="solid"/>
-                    </a:lnB>
-                    <a:solidFill>
-                      <a:srgbClr val="E4EFEB"/>
-                    </a:solidFill>
-                  </a:tcPr>
-                </a:tc>
-                <a:tc>
-                  <a:txBody>
-                    <a:bodyPr lIns="133350" tIns="114300" rIns="152400" bIns="95250">
-                      <a:noAutofit/>
-                    </a:bodyPr>
-                    <a:lstStyle/>
-                    <a:p>
-                      <a:pPr algn="r"/>
-                      <a:r>
-                        <a:rPr sz="1800" b="0">
-                          <a:solidFill>
-                            <a:srgbClr val="276E68"/>
-                          </a:solidFill>
-                          <a:latin typeface="Microsoft JhengHei"/>
-                          <a:ea typeface="Microsoft JhengHei"/>
-                          <a:cs typeface="Microsoft JhengHei"/>
-                        </a:rPr>
-                        <a:t>−1,525.54</a:t>
-                      </a:r>
-                    </a:p>
-                  </a:txBody>
-                  <a:tcPr marL="91440" marR="91440" marT="45720" marB="45720" anchor="ctr">
-                    <a:lnR w="9525">
-                      <a:solidFill>
-                        <a:srgbClr val="FCFCFA"/>
-                      </a:solidFill>
-                      <a:prstDash val="solid"/>
-                    </a:lnR>
-                    <a:lnB w="7620">
-                      <a:solidFill>
-                        <a:srgbClr val="E1E7E4"/>
-                      </a:solidFill>
-                      <a:prstDash val="solid"/>
-                    </a:lnB>
-                    <a:solidFill>
-                      <a:srgbClr val="E4EFEB"/>
-                    </a:solidFill>
-                  </a:tcPr>
-                </a:tc>
-              </a:tr>
-              <a:tr h="638175">
-                <a:tc>
-                  <a:txBody>
-                    <a:bodyPr lIns="133350" tIns="114300" rIns="152400" bIns="95250">
-                      <a:noAutofit/>
-                    </a:bodyPr>
-                    <a:lstStyle/>
-                    <a:p>
-                      <a:pPr algn="l"/>
-                      <a:r>
-                        <a:rPr sz="1800" b="0">
-                          <a:solidFill>
-                            <a:srgbClr val="3A4A4E"/>
-                          </a:solidFill>
-                          <a:latin typeface="Microsoft JhengHei"/>
-                          <a:ea typeface="Microsoft JhengHei"/>
-                          <a:cs typeface="Microsoft JhengHei"/>
-                        </a:rPr>
-                        <a:t>2023–2024 二月起點</a:t>
-                      </a:r>
-                    </a:p>
-                  </a:txBody>
-                  <a:tcPr marL="91440" marR="91440" marT="45720" marB="45720" anchor="ctr">
-                    <a:lnL w="9525">
-                      <a:solidFill>
-                        <a:srgbClr val="FCFCFA"/>
-                      </a:solidFill>
-                      <a:prstDash val="solid"/>
-                    </a:lnL>
-                    <a:lnR w="9525">
-                      <a:solidFill>
-                        <a:srgbClr val="FCFCFA"/>
-                      </a:solidFill>
-                      <a:prstDash val="solid"/>
-                    </a:lnR>
-                    <a:lnB w="9525">
-                      <a:solidFill>
-                        <a:srgbClr val="FCFCFA"/>
-                      </a:solidFill>
-                      <a:prstDash val="solid"/>
-                    </a:lnB>
-                    <a:solidFill>
-                      <a:srgbClr val="FCFCFA"/>
-                    </a:solidFill>
-                  </a:tcPr>
-                </a:tc>
-                <a:tc>
-                  <a:txBody>
-                    <a:bodyPr lIns="133350" tIns="114300" rIns="152400" bIns="95250">
-                      <a:noAutofit/>
-                    </a:bodyPr>
-                    <a:lstStyle/>
-                    <a:p>
-                      <a:pPr algn="r"/>
-                      <a:r>
-                        <a:rPr sz="1800" b="0">
-                          <a:solidFill>
-                            <a:srgbClr val="3A4A4E"/>
-                          </a:solidFill>
-                          <a:latin typeface="Microsoft JhengHei"/>
-                          <a:ea typeface="Microsoft JhengHei"/>
-                          <a:cs typeface="Microsoft JhengHei"/>
-                        </a:rPr>
-                        <a:t>1,336,410.67</a:t>
-                      </a:r>
-                    </a:p>
-                  </a:txBody>
-                  <a:tcPr marL="91440" marR="91440" marT="45720" marB="45720" anchor="ctr">
-                    <a:lnR w="9525">
-                      <a:solidFill>
-                        <a:srgbClr val="FCFCFA"/>
-                      </a:solidFill>
-                      <a:prstDash val="solid"/>
-                    </a:lnR>
-                    <a:lnB w="9525">
-                      <a:solidFill>
-                        <a:srgbClr val="FCFCFA"/>
-                      </a:solidFill>
-                      <a:prstDash val="solid"/>
-                    </a:lnB>
-                    <a:solidFill>
-                      <a:srgbClr val="FCFCFA"/>
-                    </a:solidFill>
-                  </a:tcPr>
-                </a:tc>
-                <a:tc>
-                  <a:txBody>
-                    <a:bodyPr lIns="133350" tIns="114300" rIns="152400" bIns="95250">
-                      <a:noAutofit/>
-                    </a:bodyPr>
-                    <a:lstStyle/>
-                    <a:p>
-                      <a:pPr algn="r"/>
-                      <a:r>
-                        <a:rPr sz="1800" b="0">
-                          <a:solidFill>
-                            <a:srgbClr val="3A4A4E"/>
-                          </a:solidFill>
-                          <a:latin typeface="Microsoft JhengHei"/>
-                          <a:ea typeface="Microsoft JhengHei"/>
-                          <a:cs typeface="Microsoft JhengHei"/>
-                        </a:rPr>
-                        <a:t>1,336,107.62</a:t>
-                      </a:r>
-                    </a:p>
-                  </a:txBody>
-                  <a:tcPr marL="91440" marR="91440" marT="45720" marB="45720" anchor="ctr">
-                    <a:lnR w="9525">
-                      <a:solidFill>
-                        <a:srgbClr val="FCFCFA"/>
-                      </a:solidFill>
-                      <a:prstDash val="solid"/>
-                    </a:lnR>
-                    <a:lnB w="9525">
-                      <a:solidFill>
-                        <a:srgbClr val="FCFCFA"/>
-                      </a:solidFill>
-                      <a:prstDash val="solid"/>
-                    </a:lnB>
-                    <a:solidFill>
-                      <a:srgbClr val="FCFCFA"/>
-                    </a:solidFill>
-                  </a:tcPr>
-                </a:tc>
-                <a:tc>
-                  <a:txBody>
-                    <a:bodyPr lIns="133350" tIns="114300" rIns="152400" bIns="95250">
-                      <a:noAutofit/>
-                    </a:bodyPr>
-                    <a:lstStyle/>
-                    <a:p>
-                      <a:pPr algn="r"/>
-                      <a:r>
-                        <a:rPr sz="1800" b="0">
-                          <a:solidFill>
-                            <a:srgbClr val="276E68"/>
-                          </a:solidFill>
-                          <a:latin typeface="Microsoft JhengHei"/>
-                          <a:ea typeface="Microsoft JhengHei"/>
-                          <a:cs typeface="Microsoft JhengHei"/>
-                        </a:rPr>
-                        <a:t>−303.06</a:t>
-                      </a:r>
-                    </a:p>
-                  </a:txBody>
-                  <a:tcPr marL="91440" marR="91440" marT="45720" marB="45720" anchor="ctr">
-                    <a:lnR w="9525">
-                      <a:solidFill>
-                        <a:srgbClr val="FCFCFA"/>
-                      </a:solidFill>
-                      <a:prstDash val="solid"/>
-                    </a:lnR>
-                    <a:lnB w="9525">
-                      <a:solidFill>
-                        <a:srgbClr val="FCFCFA"/>
-                      </a:solidFill>
-                      <a:prstDash val="solid"/>
-                    </a:lnB>
-                    <a:solidFill>
-                      <a:srgbClr val="FCFCFA"/>
-                    </a:solidFill>
-                  </a:tcPr>
-                </a:tc>
-              </a:tr>
-            </a:tbl>
-          </a:graphicData>
-        </a:graphic>
-      </p:graphicFrame>
+        </p:nvSpPr>
+        <p:spPr>
+          <a:xfrm xmlns:a="http://schemas.openxmlformats.org/drawingml/2006/main">
+            <a:off x="762000" y="3067050"/>
+            <a:ext cx="857250" cy="457200"/>
+          </a:xfrm>
+          <a:prstGeom xmlns:a="http://schemas.openxmlformats.org/drawingml/2006/main" prst="rect">
+            <a:avLst/>
+          </a:prstGeom>
+          <a:noFill xmlns:a="http://schemas.openxmlformats.org/drawingml/2006/main"/>
+          <a:ln xmlns:a="http://schemas.openxmlformats.org/drawingml/2006/main" w="0">
+            <a:noFill/>
+          </a:ln>
+        </p:spPr>
+        <p:txBody>
+          <a:bodyPr xmlns:a="http://schemas.openxmlformats.org/drawingml/2006/main" wrap="square" lIns="0" tIns="0" rIns="0" bIns="0" anchor="t">
+            <a:noAutofit/>
+          </a:bodyPr>
+          <a:lstStyle xmlns:a="http://schemas.openxmlformats.org/drawingml/2006/main">
+            <a:defPPr algn="l">
+              <a:defRPr sz="2550" b="1">
+                <a:solidFill>
+                  <a:srgbClr val="276E68"/>
+                </a:solidFill>
+                <a:latin typeface="Microsoft JhengHei"/>
+                <a:ea typeface="Microsoft JhengHei"/>
+                <a:cs typeface="Microsoft JhengHei"/>
+              </a:defRPr>
+            </a:defPPr>
+          </a:lstStyle>
+          <a:p xmlns:a="http://schemas.openxmlformats.org/drawingml/2006/main">
+            <a:pPr algn="l">
+              <a:defRPr sz="2550" b="1">
+                <a:solidFill>
+                  <a:srgbClr val="276E68"/>
+                </a:solidFill>
+                <a:latin typeface="Microsoft JhengHei"/>
+                <a:ea typeface="Microsoft JhengHei"/>
+                <a:cs typeface="Microsoft JhengHei"/>
+              </a:defRPr>
+            </a:pPr>
+            <a:r>
+              <a:rPr sz="2550" b="1">
+                <a:solidFill>
+                  <a:srgbClr val="276E68"/>
+                </a:solidFill>
+                <a:latin typeface="Microsoft JhengHei"/>
+                <a:ea typeface="Microsoft JhengHei"/>
+                <a:cs typeface="Microsoft JhengHei"/>
+              </a:rPr>
+              <a:t>02</a:t>
+            </a:r>
+          </a:p>
+        </p:txBody>
+      </p:sp>
+      <p:sp>
+        <p:nvSpPr>
+          <p:cNvPr id="8" name="body">
+            <a:extLst xmlns:a="http://schemas.openxmlformats.org/drawingml/2006/main">
+              <a:ext uri="{FF2B5EF4-FFF2-40B4-BE49-F238E27FC236}">
+                <a16:creationId xmlns:a16="http://schemas.microsoft.com/office/drawing/2014/main" id="{E77FF3E7-68E0-446C-9332-1B21167D6D09}"/>
+              </a:ext>
+            </a:extLst>
+          </p:cNvPr>
+          <p:cNvSpPr>
+            <a:spLocks xmlns:a="http://schemas.openxmlformats.org/drawingml/2006/main" noGrp="1"/>
+          </p:cNvSpPr>
+          <p:nvPr/>
+        </p:nvSpPr>
+        <p:spPr>
+          <a:xfrm xmlns:a="http://schemas.openxmlformats.org/drawingml/2006/main">
+            <a:off x="1952625" y="3067050"/>
+            <a:ext cx="3429000" cy="457200"/>
+          </a:xfrm>
+          <a:prstGeom xmlns:a="http://schemas.openxmlformats.org/drawingml/2006/main" prst="rect">
+            <a:avLst/>
+          </a:prstGeom>
+          <a:noFill xmlns:a="http://schemas.openxmlformats.org/drawingml/2006/main"/>
+          <a:ln xmlns:a="http://schemas.openxmlformats.org/drawingml/2006/main" w="0">
+            <a:noFill/>
+          </a:ln>
+        </p:spPr>
+        <p:txBody>
+          <a:bodyPr xmlns:a="http://schemas.openxmlformats.org/drawingml/2006/main" wrap="square" lIns="0" tIns="0" rIns="0" bIns="0" anchor="t">
+            <a:noAutofit/>
+          </a:bodyPr>
+          <a:lstStyle xmlns:a="http://schemas.openxmlformats.org/drawingml/2006/main">
+            <a:defPPr algn="l">
+              <a:defRPr sz="2550" b="1">
+                <a:solidFill>
+                  <a:srgbClr val="23343A"/>
+                </a:solidFill>
+                <a:latin typeface="Microsoft JhengHei"/>
+                <a:ea typeface="Microsoft JhengHei"/>
+                <a:cs typeface="Microsoft JhengHei"/>
+              </a:defRPr>
+            </a:defPPr>
+          </a:lstStyle>
+          <a:p xmlns:a="http://schemas.openxmlformats.org/drawingml/2006/main">
+            <a:pPr algn="l">
+              <a:defRPr sz="2550" b="1">
+                <a:solidFill>
+                  <a:srgbClr val="23343A"/>
+                </a:solidFill>
+                <a:latin typeface="Microsoft JhengHei"/>
+                <a:ea typeface="Microsoft JhengHei"/>
+                <a:cs typeface="Microsoft JhengHei"/>
+              </a:defRPr>
+            </a:pPr>
+            <a:r>
+              <a:rPr sz="2550" b="1">
+                <a:solidFill>
+                  <a:srgbClr val="23343A"/>
+                </a:solidFill>
+                <a:latin typeface="Microsoft JhengHei"/>
+                <a:ea typeface="Microsoft JhengHei"/>
+                <a:cs typeface="Microsoft JhengHei"/>
+              </a:rPr>
+              <a:t>模型訓練</a:t>
+            </a:r>
+          </a:p>
+        </p:txBody>
+      </p:sp>
+      <p:sp>
+        <p:nvSpPr>
+          <p:cNvPr id="9" name="body">
+            <a:extLst xmlns:a="http://schemas.openxmlformats.org/drawingml/2006/main">
+              <a:ext uri="{FF2B5EF4-FFF2-40B4-BE49-F238E27FC236}">
+                <a16:creationId xmlns:a16="http://schemas.microsoft.com/office/drawing/2014/main" id="{3AE19456-353D-41B0-B7DD-E81F6F3AB3D7}"/>
+              </a:ext>
+            </a:extLst>
+          </p:cNvPr>
+          <p:cNvSpPr>
+            <a:spLocks xmlns:a="http://schemas.openxmlformats.org/drawingml/2006/main" noGrp="1"/>
+          </p:cNvSpPr>
+          <p:nvPr/>
+        </p:nvSpPr>
+        <p:spPr>
+          <a:xfrm xmlns:a="http://schemas.openxmlformats.org/drawingml/2006/main">
+            <a:off x="5381625" y="3105150"/>
+            <a:ext cx="6048375" cy="428625"/>
+          </a:xfrm>
+          <a:prstGeom xmlns:a="http://schemas.openxmlformats.org/drawingml/2006/main" prst="rect">
+            <a:avLst/>
+          </a:prstGeom>
+          <a:noFill xmlns:a="http://schemas.openxmlformats.org/drawingml/2006/main"/>
+          <a:ln xmlns:a="http://schemas.openxmlformats.org/drawingml/2006/main" w="0">
+            <a:noFill/>
+          </a:ln>
+        </p:spPr>
+        <p:txBody>
+          <a:bodyPr xmlns:a="http://schemas.openxmlformats.org/drawingml/2006/main" wrap="square" lIns="0" tIns="0" rIns="0" bIns="0" anchor="t">
+            <a:noAutofit/>
+          </a:bodyPr>
+          <a:lstStyle xmlns:a="http://schemas.openxmlformats.org/drawingml/2006/main">
+            <a:defPPr algn="l">
+              <a:defRPr sz="2025" b="0">
+                <a:solidFill>
+                  <a:srgbClr val="3A4A4E"/>
+                </a:solidFill>
+                <a:latin typeface="Microsoft JhengHei"/>
+                <a:ea typeface="Microsoft JhengHei"/>
+                <a:cs typeface="Microsoft JhengHei"/>
+              </a:defRPr>
+            </a:defPPr>
+          </a:lstStyle>
+          <a:p xmlns:a="http://schemas.openxmlformats.org/drawingml/2006/main">
+            <a:pPr algn="l">
+              <a:defRPr sz="2025" b="0">
+                <a:solidFill>
+                  <a:srgbClr val="3A4A4E"/>
+                </a:solidFill>
+                <a:latin typeface="Microsoft JhengHei"/>
+                <a:ea typeface="Microsoft JhengHei"/>
+                <a:cs typeface="Microsoft JhengHei"/>
+              </a:defRPr>
+            </a:pPr>
+            <a:r>
+              <a:rPr sz="2025" b="0">
+                <a:solidFill>
+                  <a:srgbClr val="3A4A4E"/>
+                </a:solidFill>
+                <a:latin typeface="Microsoft JhengHei"/>
+                <a:ea typeface="Microsoft JhengHei"/>
+                <a:cs typeface="Microsoft JhengHei"/>
+              </a:rPr>
+              <a:t>設定價格目標，處理面積、日期與參考價</a:t>
+            </a:r>
+          </a:p>
+        </p:txBody>
+      </p:sp>
+      <p:sp>
+        <p:nvSpPr>
+          <p:cNvPr id="10" name="body">
+            <a:extLst xmlns:a="http://schemas.openxmlformats.org/drawingml/2006/main">
+              <a:ext uri="{FF2B5EF4-FFF2-40B4-BE49-F238E27FC236}">
+                <a16:creationId xmlns:a16="http://schemas.microsoft.com/office/drawing/2014/main" id="{E07981F5-2A38-4ABD-BF2A-96B4445936B6}"/>
+              </a:ext>
+            </a:extLst>
+          </p:cNvPr>
+          <p:cNvSpPr>
+            <a:spLocks xmlns:a="http://schemas.openxmlformats.org/drawingml/2006/main" noGrp="1"/>
+          </p:cNvSpPr>
+          <p:nvPr/>
+        </p:nvSpPr>
+        <p:spPr>
+          <a:xfrm xmlns:a="http://schemas.openxmlformats.org/drawingml/2006/main">
+            <a:off x="762000" y="4029075"/>
+            <a:ext cx="857250" cy="457200"/>
+          </a:xfrm>
+          <a:prstGeom xmlns:a="http://schemas.openxmlformats.org/drawingml/2006/main" prst="rect">
+            <a:avLst/>
+          </a:prstGeom>
+          <a:noFill xmlns:a="http://schemas.openxmlformats.org/drawingml/2006/main"/>
+          <a:ln xmlns:a="http://schemas.openxmlformats.org/drawingml/2006/main" w="0">
+            <a:noFill/>
+          </a:ln>
+        </p:spPr>
+        <p:txBody>
+          <a:bodyPr xmlns:a="http://schemas.openxmlformats.org/drawingml/2006/main" wrap="square" lIns="0" tIns="0" rIns="0" bIns="0" anchor="t">
+            <a:noAutofit/>
+          </a:bodyPr>
+          <a:lstStyle xmlns:a="http://schemas.openxmlformats.org/drawingml/2006/main">
+            <a:defPPr algn="l">
+              <a:defRPr sz="2550" b="1">
+                <a:solidFill>
+                  <a:srgbClr val="276E68"/>
+                </a:solidFill>
+                <a:latin typeface="Microsoft JhengHei"/>
+                <a:ea typeface="Microsoft JhengHei"/>
+                <a:cs typeface="Microsoft JhengHei"/>
+              </a:defRPr>
+            </a:defPPr>
+          </a:lstStyle>
+          <a:p xmlns:a="http://schemas.openxmlformats.org/drawingml/2006/main">
+            <a:pPr algn="l">
+              <a:defRPr sz="2550" b="1">
+                <a:solidFill>
+                  <a:srgbClr val="276E68"/>
+                </a:solidFill>
+                <a:latin typeface="Microsoft JhengHei"/>
+                <a:ea typeface="Microsoft JhengHei"/>
+                <a:cs typeface="Microsoft JhengHei"/>
+              </a:defRPr>
+            </a:pPr>
+            <a:r>
+              <a:rPr sz="2550" b="1">
+                <a:solidFill>
+                  <a:srgbClr val="276E68"/>
+                </a:solidFill>
+                <a:latin typeface="Microsoft JhengHei"/>
+                <a:ea typeface="Microsoft JhengHei"/>
+                <a:cs typeface="Microsoft JhengHei"/>
+              </a:rPr>
+              <a:t>03</a:t>
+            </a:r>
+          </a:p>
+        </p:txBody>
+      </p:sp>
+      <p:sp>
+        <p:nvSpPr>
+          <p:cNvPr id="11" name="body">
+            <a:extLst xmlns:a="http://schemas.openxmlformats.org/drawingml/2006/main">
+              <a:ext uri="{FF2B5EF4-FFF2-40B4-BE49-F238E27FC236}">
+                <a16:creationId xmlns:a16="http://schemas.microsoft.com/office/drawing/2014/main" id="{73EAB168-D1EA-4B91-8288-6D11C9303C95}"/>
+              </a:ext>
+            </a:extLst>
+          </p:cNvPr>
+          <p:cNvSpPr>
+            <a:spLocks xmlns:a="http://schemas.openxmlformats.org/drawingml/2006/main" noGrp="1"/>
+          </p:cNvSpPr>
+          <p:nvPr/>
+        </p:nvSpPr>
+        <p:spPr>
+          <a:xfrm xmlns:a="http://schemas.openxmlformats.org/drawingml/2006/main">
+            <a:off x="1952625" y="4029075"/>
+            <a:ext cx="3429000" cy="457200"/>
+          </a:xfrm>
+          <a:prstGeom xmlns:a="http://schemas.openxmlformats.org/drawingml/2006/main" prst="rect">
+            <a:avLst/>
+          </a:prstGeom>
+          <a:noFill xmlns:a="http://schemas.openxmlformats.org/drawingml/2006/main"/>
+          <a:ln xmlns:a="http://schemas.openxmlformats.org/drawingml/2006/main" w="0">
+            <a:noFill/>
+          </a:ln>
+        </p:spPr>
+        <p:txBody>
+          <a:bodyPr xmlns:a="http://schemas.openxmlformats.org/drawingml/2006/main" wrap="square" lIns="0" tIns="0" rIns="0" bIns="0" anchor="t">
+            <a:noAutofit/>
+          </a:bodyPr>
+          <a:lstStyle xmlns:a="http://schemas.openxmlformats.org/drawingml/2006/main">
+            <a:defPPr algn="l">
+              <a:defRPr sz="2550" b="1">
+                <a:solidFill>
+                  <a:srgbClr val="23343A"/>
+                </a:solidFill>
+                <a:latin typeface="Microsoft JhengHei"/>
+                <a:ea typeface="Microsoft JhengHei"/>
+                <a:cs typeface="Microsoft JhengHei"/>
+              </a:defRPr>
+            </a:defPPr>
+          </a:lstStyle>
+          <a:p xmlns:a="http://schemas.openxmlformats.org/drawingml/2006/main">
+            <a:pPr algn="l">
+              <a:defRPr sz="2550" b="1">
+                <a:solidFill>
+                  <a:srgbClr val="23343A"/>
+                </a:solidFill>
+                <a:latin typeface="Microsoft JhengHei"/>
+                <a:ea typeface="Microsoft JhengHei"/>
+                <a:cs typeface="Microsoft JhengHei"/>
+              </a:defRPr>
+            </a:pPr>
+            <a:r>
+              <a:rPr sz="2550" b="1">
+                <a:solidFill>
+                  <a:srgbClr val="23343A"/>
+                </a:solidFill>
+                <a:latin typeface="Microsoft JhengHei"/>
+                <a:ea typeface="Microsoft JhengHei"/>
+                <a:cs typeface="Microsoft JhengHei"/>
+              </a:rPr>
+              <a:t>預測整合</a:t>
+            </a:r>
+          </a:p>
+        </p:txBody>
+      </p:sp>
+      <p:sp>
+        <p:nvSpPr>
+          <p:cNvPr id="12" name="body">
+            <a:extLst xmlns:a="http://schemas.openxmlformats.org/drawingml/2006/main">
+              <a:ext uri="{FF2B5EF4-FFF2-40B4-BE49-F238E27FC236}">
+                <a16:creationId xmlns:a16="http://schemas.microsoft.com/office/drawing/2014/main" id="{343AC7B0-8EEC-4B3A-8690-045656E6AE47}"/>
+              </a:ext>
+            </a:extLst>
+          </p:cNvPr>
+          <p:cNvSpPr>
+            <a:spLocks xmlns:a="http://schemas.openxmlformats.org/drawingml/2006/main" noGrp="1"/>
+          </p:cNvSpPr>
+          <p:nvPr/>
+        </p:nvSpPr>
+        <p:spPr>
+          <a:xfrm xmlns:a="http://schemas.openxmlformats.org/drawingml/2006/main">
+            <a:off x="5381625" y="4067175"/>
+            <a:ext cx="6048375" cy="428625"/>
+          </a:xfrm>
+          <a:prstGeom xmlns:a="http://schemas.openxmlformats.org/drawingml/2006/main" prst="rect">
+            <a:avLst/>
+          </a:prstGeom>
+          <a:noFill xmlns:a="http://schemas.openxmlformats.org/drawingml/2006/main"/>
+          <a:ln xmlns:a="http://schemas.openxmlformats.org/drawingml/2006/main" w="0">
+            <a:noFill/>
+          </a:ln>
+        </p:spPr>
+        <p:txBody>
+          <a:bodyPr xmlns:a="http://schemas.openxmlformats.org/drawingml/2006/main" wrap="square" lIns="0" tIns="0" rIns="0" bIns="0" anchor="t">
+            <a:noAutofit/>
+          </a:bodyPr>
+          <a:lstStyle xmlns:a="http://schemas.openxmlformats.org/drawingml/2006/main">
+            <a:defPPr algn="l">
+              <a:defRPr sz="2025" b="0">
+                <a:solidFill>
+                  <a:srgbClr val="3A4A4E"/>
+                </a:solidFill>
+                <a:latin typeface="Microsoft JhengHei"/>
+                <a:ea typeface="Microsoft JhengHei"/>
+                <a:cs typeface="Microsoft JhengHei"/>
+              </a:defRPr>
+            </a:defPPr>
+          </a:lstStyle>
+          <a:p xmlns:a="http://schemas.openxmlformats.org/drawingml/2006/main">
+            <a:pPr algn="l">
+              <a:defRPr sz="2025" b="0">
+                <a:solidFill>
+                  <a:srgbClr val="3A4A4E"/>
+                </a:solidFill>
+                <a:latin typeface="Microsoft JhengHei"/>
+                <a:ea typeface="Microsoft JhengHei"/>
+                <a:cs typeface="Microsoft JhengHei"/>
+              </a:defRPr>
+            </a:pPr>
+            <a:r>
+              <a:rPr sz="2025" b="0">
+                <a:solidFill>
+                  <a:srgbClr val="3A4A4E"/>
+                </a:solidFill>
+                <a:latin typeface="Microsoft JhengHei"/>
+                <a:ea typeface="Microsoft JhengHei"/>
+                <a:cs typeface="Microsoft JhengHei"/>
+              </a:rPr>
+              <a:t>組合不同模型，修正後取中位數</a:t>
+            </a:r>
+          </a:p>
+        </p:txBody>
+      </p:sp>
+      <p:sp>
+        <p:nvSpPr>
+          <p:cNvPr id="13" name="body">
+            <a:extLst xmlns:a="http://schemas.openxmlformats.org/drawingml/2006/main">
+              <a:ext uri="{FF2B5EF4-FFF2-40B4-BE49-F238E27FC236}">
+                <a16:creationId xmlns:a16="http://schemas.microsoft.com/office/drawing/2014/main" id="{B357ABE1-6D1F-4AC1-870C-83ED1228A51F}"/>
+              </a:ext>
+            </a:extLst>
+          </p:cNvPr>
+          <p:cNvSpPr>
+            <a:spLocks xmlns:a="http://schemas.openxmlformats.org/drawingml/2006/main" noGrp="1"/>
+          </p:cNvSpPr>
+          <p:nvPr/>
+        </p:nvSpPr>
+        <p:spPr>
+          <a:xfrm xmlns:a="http://schemas.openxmlformats.org/drawingml/2006/main">
+            <a:off x="762000" y="4991100"/>
+            <a:ext cx="857250" cy="457200"/>
+          </a:xfrm>
+          <a:prstGeom xmlns:a="http://schemas.openxmlformats.org/drawingml/2006/main" prst="rect">
+            <a:avLst/>
+          </a:prstGeom>
+          <a:noFill xmlns:a="http://schemas.openxmlformats.org/drawingml/2006/main"/>
+          <a:ln xmlns:a="http://schemas.openxmlformats.org/drawingml/2006/main" w="0">
+            <a:noFill/>
+          </a:ln>
+        </p:spPr>
+        <p:txBody>
+          <a:bodyPr xmlns:a="http://schemas.openxmlformats.org/drawingml/2006/main" wrap="square" lIns="0" tIns="0" rIns="0" bIns="0" anchor="t">
+            <a:noAutofit/>
+          </a:bodyPr>
+          <a:lstStyle xmlns:a="http://schemas.openxmlformats.org/drawingml/2006/main">
+            <a:defPPr algn="l">
+              <a:defRPr sz="2550" b="1">
+                <a:solidFill>
+                  <a:srgbClr val="276E68"/>
+                </a:solidFill>
+                <a:latin typeface="Microsoft JhengHei"/>
+                <a:ea typeface="Microsoft JhengHei"/>
+                <a:cs typeface="Microsoft JhengHei"/>
+              </a:defRPr>
+            </a:defPPr>
+          </a:lstStyle>
+          <a:p xmlns:a="http://schemas.openxmlformats.org/drawingml/2006/main">
+            <a:pPr algn="l">
+              <a:defRPr sz="2550" b="1">
+                <a:solidFill>
+                  <a:srgbClr val="276E68"/>
+                </a:solidFill>
+                <a:latin typeface="Microsoft JhengHei"/>
+                <a:ea typeface="Microsoft JhengHei"/>
+                <a:cs typeface="Microsoft JhengHei"/>
+              </a:defRPr>
+            </a:pPr>
+            <a:r>
+              <a:rPr sz="2550" b="1">
+                <a:solidFill>
+                  <a:srgbClr val="276E68"/>
+                </a:solidFill>
+                <a:latin typeface="Microsoft JhengHei"/>
+                <a:ea typeface="Microsoft JhengHei"/>
+                <a:cs typeface="Microsoft JhengHei"/>
+              </a:rPr>
+              <a:t>04</a:t>
+            </a:r>
+          </a:p>
+        </p:txBody>
+      </p:sp>
+      <p:sp>
+        <p:nvSpPr>
+          <p:cNvPr id="14" name="body">
+            <a:extLst xmlns:a="http://schemas.openxmlformats.org/drawingml/2006/main">
+              <a:ext uri="{FF2B5EF4-FFF2-40B4-BE49-F238E27FC236}">
+                <a16:creationId xmlns:a16="http://schemas.microsoft.com/office/drawing/2014/main" id="{A1A1DFC5-B7FE-42BC-BE46-B5283ABFB8E7}"/>
+              </a:ext>
+            </a:extLst>
+          </p:cNvPr>
+          <p:cNvSpPr>
+            <a:spLocks xmlns:a="http://schemas.openxmlformats.org/drawingml/2006/main" noGrp="1"/>
+          </p:cNvSpPr>
+          <p:nvPr/>
+        </p:nvSpPr>
+        <p:spPr>
+          <a:xfrm xmlns:a="http://schemas.openxmlformats.org/drawingml/2006/main">
+            <a:off x="1952625" y="4991100"/>
+            <a:ext cx="3429000" cy="457200"/>
+          </a:xfrm>
+          <a:prstGeom xmlns:a="http://schemas.openxmlformats.org/drawingml/2006/main" prst="rect">
+            <a:avLst/>
+          </a:prstGeom>
+          <a:noFill xmlns:a="http://schemas.openxmlformats.org/drawingml/2006/main"/>
+          <a:ln xmlns:a="http://schemas.openxmlformats.org/drawingml/2006/main" w="0">
+            <a:noFill/>
+          </a:ln>
+        </p:spPr>
+        <p:txBody>
+          <a:bodyPr xmlns:a="http://schemas.openxmlformats.org/drawingml/2006/main" wrap="square" lIns="0" tIns="0" rIns="0" bIns="0" anchor="t">
+            <a:noAutofit/>
+          </a:bodyPr>
+          <a:lstStyle xmlns:a="http://schemas.openxmlformats.org/drawingml/2006/main">
+            <a:defPPr algn="l">
+              <a:defRPr sz="2550" b="1">
+                <a:solidFill>
+                  <a:srgbClr val="23343A"/>
+                </a:solidFill>
+                <a:latin typeface="Microsoft JhengHei"/>
+                <a:ea typeface="Microsoft JhengHei"/>
+                <a:cs typeface="Microsoft JhengHei"/>
+              </a:defRPr>
+            </a:defPPr>
+          </a:lstStyle>
+          <a:p xmlns:a="http://schemas.openxmlformats.org/drawingml/2006/main">
+            <a:pPr algn="l">
+              <a:defRPr sz="2550" b="1">
+                <a:solidFill>
+                  <a:srgbClr val="23343A"/>
+                </a:solidFill>
+                <a:latin typeface="Microsoft JhengHei"/>
+                <a:ea typeface="Microsoft JhengHei"/>
+                <a:cs typeface="Microsoft JhengHei"/>
+              </a:defRPr>
+            </a:pPr>
+            <a:r>
+              <a:rPr sz="2550" b="1">
+                <a:solidFill>
+                  <a:srgbClr val="23343A"/>
+                </a:solidFill>
+                <a:latin typeface="Microsoft JhengHei"/>
+                <a:ea typeface="Microsoft JhengHei"/>
+                <a:cs typeface="Microsoft JhengHei"/>
+              </a:rPr>
+              <a:t>驗證與檢查</a:t>
+            </a:r>
+          </a:p>
+        </p:txBody>
+      </p:sp>
+      <p:sp>
+        <p:nvSpPr>
+          <p:cNvPr id="15" name="body">
+            <a:extLst xmlns:a="http://schemas.openxmlformats.org/drawingml/2006/main">
+              <a:ext uri="{FF2B5EF4-FFF2-40B4-BE49-F238E27FC236}">
+                <a16:creationId xmlns:a16="http://schemas.microsoft.com/office/drawing/2014/main" id="{1EDCD12E-1353-416E-A4B8-41B9B69C7F0B}"/>
+              </a:ext>
+            </a:extLst>
+          </p:cNvPr>
+          <p:cNvSpPr>
+            <a:spLocks xmlns:a="http://schemas.openxmlformats.org/drawingml/2006/main" noGrp="1"/>
+          </p:cNvSpPr>
+          <p:nvPr/>
+        </p:nvSpPr>
+        <p:spPr>
+          <a:xfrm xmlns:a="http://schemas.openxmlformats.org/drawingml/2006/main">
+            <a:off x="5381625" y="5029200"/>
+            <a:ext cx="6048375" cy="428625"/>
+          </a:xfrm>
+          <a:prstGeom xmlns:a="http://schemas.openxmlformats.org/drawingml/2006/main" prst="rect">
+            <a:avLst/>
+          </a:prstGeom>
+          <a:noFill xmlns:a="http://schemas.openxmlformats.org/drawingml/2006/main"/>
+          <a:ln xmlns:a="http://schemas.openxmlformats.org/drawingml/2006/main" w="0">
+            <a:noFill/>
+          </a:ln>
+        </p:spPr>
+        <p:txBody>
+          <a:bodyPr xmlns:a="http://schemas.openxmlformats.org/drawingml/2006/main" wrap="square" lIns="0" tIns="0" rIns="0" bIns="0" anchor="t">
+            <a:noAutofit/>
+          </a:bodyPr>
+          <a:lstStyle xmlns:a="http://schemas.openxmlformats.org/drawingml/2006/main">
+            <a:defPPr algn="l">
+              <a:defRPr sz="2025" b="0">
+                <a:solidFill>
+                  <a:srgbClr val="3A4A4E"/>
+                </a:solidFill>
+                <a:latin typeface="Microsoft JhengHei"/>
+                <a:ea typeface="Microsoft JhengHei"/>
+                <a:cs typeface="Microsoft JhengHei"/>
+              </a:defRPr>
+            </a:defPPr>
+          </a:lstStyle>
+          <a:p xmlns:a="http://schemas.openxmlformats.org/drawingml/2006/main">
+            <a:pPr algn="l">
+              <a:defRPr sz="2025" b="0">
+                <a:solidFill>
+                  <a:srgbClr val="3A4A4E"/>
+                </a:solidFill>
+                <a:latin typeface="Microsoft JhengHei"/>
+                <a:ea typeface="Microsoft JhengHei"/>
+                <a:cs typeface="Microsoft JhengHei"/>
+              </a:defRPr>
+            </a:pPr>
+            <a:r>
+              <a:rPr sz="2025" b="0">
+                <a:solidFill>
+                  <a:srgbClr val="3A4A4E"/>
+                </a:solidFill>
+                <a:latin typeface="Microsoft JhengHei"/>
+                <a:ea typeface="Microsoft JhengHei"/>
+                <a:cs typeface="Microsoft JhengHei"/>
+              </a:rPr>
+              <a:t>觀察訓練曲線，分組檢查估價誤差</a:t>
+            </a:r>
+          </a:p>
+        </p:txBody>
+      </p:sp>
+      <p:sp>
+        <p:nvSpPr>
+          <p:cNvPr id="16" name="body">
+            <a:extLst xmlns:a="http://schemas.openxmlformats.org/drawingml/2006/main">
+              <a:ext uri="{FF2B5EF4-FFF2-40B4-BE49-F238E27FC236}">
+                <a16:creationId xmlns:a16="http://schemas.microsoft.com/office/drawing/2014/main" id="{C2A8C9BA-F687-45A4-BBE8-BED53C110FB7}"/>
+              </a:ext>
+            </a:extLst>
+          </p:cNvPr>
+          <p:cNvSpPr>
+            <a:spLocks xmlns:a="http://schemas.openxmlformats.org/drawingml/2006/main" noGrp="1"/>
+          </p:cNvSpPr>
+          <p:nvPr/>
+        </p:nvSpPr>
+        <p:spPr>
+          <a:xfrm xmlns:a="http://schemas.openxmlformats.org/drawingml/2006/main">
+            <a:off x="762000" y="6076950"/>
+            <a:ext cx="10572750" cy="571500"/>
+          </a:xfrm>
+          <a:prstGeom xmlns:a="http://schemas.openxmlformats.org/drawingml/2006/main" prst="rect">
+            <a:avLst/>
+          </a:prstGeom>
+          <a:noFill xmlns:a="http://schemas.openxmlformats.org/drawingml/2006/main"/>
+          <a:ln xmlns:a="http://schemas.openxmlformats.org/drawingml/2006/main" w="0">
+            <a:noFill/>
+          </a:ln>
+        </p:spPr>
+        <p:txBody>
+          <a:bodyPr xmlns:a="http://schemas.openxmlformats.org/drawingml/2006/main" wrap="square" lIns="0" tIns="0" rIns="0" bIns="0" anchor="t">
+            <a:noAutofit/>
+          </a:bodyPr>
+          <a:lstStyle xmlns:a="http://schemas.openxmlformats.org/drawingml/2006/main">
+            <a:defPPr algn="l">
+              <a:defRPr sz="1725" b="0">
+                <a:solidFill>
+                  <a:srgbClr val="718082"/>
+                </a:solidFill>
+                <a:latin typeface="Microsoft JhengHei"/>
+                <a:ea typeface="Microsoft JhengHei"/>
+                <a:cs typeface="Microsoft JhengHei"/>
+              </a:defRPr>
+            </a:defPPr>
+          </a:lstStyle>
+          <a:p xmlns:a="http://schemas.openxmlformats.org/drawingml/2006/main">
+            <a:pPr algn="l">
+              <a:defRPr sz="1725" b="0">
+                <a:solidFill>
+                  <a:srgbClr val="718082"/>
+                </a:solidFill>
+                <a:latin typeface="Microsoft JhengHei"/>
+                <a:ea typeface="Microsoft JhengHei"/>
+                <a:cs typeface="Microsoft JhengHei"/>
+              </a:defRPr>
+            </a:pPr>
+            <a:r>
+              <a:rPr sz="1725" b="0">
+                <a:solidFill>
+                  <a:srgbClr val="718082"/>
+                </a:solidFill>
+                <a:latin typeface="Microsoft JhengHei"/>
+                <a:ea typeface="Microsoft JhengHei"/>
+                <a:cs typeface="Microsoft JhengHei"/>
+              </a:rPr>
+              <a:t>依照實際製作順序，說明每一步怎麼做、為什麼這樣做。</a:t>
+            </a:r>
+          </a:p>
+        </p:txBody>
+      </p:sp>
     </p:spTree>
     <p:extLst>
       <p:ext uri="{BB962C8B-B14F-4D97-AF65-F5344CB8AC3E}">
@@ -12223,6 +12573,74 @@
           </a:p>
         </p:txBody>
       </p:sp>
+      <p:sp>
+        <p:nvSpPr>
+          <p:cNvPr id="13" name="chapter-label">
+            <a:extLst xmlns:a="http://schemas.openxmlformats.org/drawingml/2006/main">
+              <a:ext uri="{FF2B5EF4-FFF2-40B4-BE49-F238E27FC236}">
+                <a16:creationId xmlns:a16="http://schemas.microsoft.com/office/drawing/2014/main" id="{1B898ACC-C12A-4CB0-9147-10DA6D393179}"/>
+              </a:ext>
+            </a:extLst>
+          </p:cNvPr>
+          <p:cNvSpPr>
+            <a:spLocks xmlns:a="http://schemas.openxmlformats.org/drawingml/2006/main" noGrp="1"/>
+          </p:cNvSpPr>
+          <p:nvPr/>
+        </p:nvSpPr>
+        <p:spPr>
+          <a:xfrm xmlns:a="http://schemas.openxmlformats.org/drawingml/2006/main">
+            <a:off x="8572500" y="190500"/>
+            <a:ext cx="2857500" cy="228600"/>
+          </a:xfrm>
+          <a:prstGeom xmlns:a="http://schemas.openxmlformats.org/drawingml/2006/main" prst="rect">
+            <a:avLst/>
+          </a:prstGeom>
+          <a:noFill xmlns:a="http://schemas.openxmlformats.org/drawingml/2006/main"/>
+          <a:ln xmlns:a="http://schemas.openxmlformats.org/drawingml/2006/main" w="0">
+            <a:noFill/>
+          </a:ln>
+        </p:spPr>
+        <p:txBody>
+          <a:bodyPr xmlns:a="http://schemas.openxmlformats.org/drawingml/2006/main" wrap="square" lIns="0" tIns="0" rIns="0" bIns="0" anchor="t">
+            <a:noAutofit/>
+          </a:bodyPr>
+          <a:lstStyle xmlns:a="http://schemas.openxmlformats.org/drawingml/2006/main">
+            <a:defPPr algn="r">
+              <a:defRPr sz="1350" b="0">
+                <a:solidFill>
+                  <a:srgbClr val="718082"/>
+                </a:solidFill>
+                <a:latin typeface="Microsoft JhengHei"/>
+                <a:ea typeface="Microsoft JhengHei"/>
+                <a:cs typeface="Microsoft JhengHei"/>
+              </a:defRPr>
+            </a:defPPr>
+          </a:lstStyle>
+          <a:p xmlns:a="http://schemas.openxmlformats.org/drawingml/2006/main">
+            <a:pPr algn="r">
+              <a:defRPr sz="1350" b="0">
+                <a:solidFill>
+                  <a:srgbClr val="718082"/>
+                </a:solidFill>
+                <a:latin typeface="Microsoft JhengHei"/>
+                <a:ea typeface="Microsoft JhengHei"/>
+                <a:cs typeface="Microsoft JhengHei"/>
+              </a:defRPr>
+            </a:pPr>
+            <a:r>
+              <a:rPr sz="1350" b="0">
+                <a:solidFill>
+                  <a:srgbClr val="718082"/>
+                </a:solidFill>
+                <a:latin typeface="Microsoft JhengHei"/>
+                <a:ea typeface="Microsoft JhengHei"/>
+                <a:cs typeface="Microsoft JhengHei"/>
+              </a:rPr>
+              <a:t>04 驗證與檢查</a:t>
+            </a:r>
+          </a:p>
+        </p:txBody>
+      </p:sp>
     </p:spTree>
     <p:extLst>
       <p:ext uri="{BB962C8B-B14F-4D97-AF65-F5344CB8AC3E}">
@@ -12383,7 +12801,7 @@
                 <a:ea typeface="Microsoft JhengHei"/>
                 <a:cs typeface="Microsoft JhengHei"/>
               </a:rPr>
-              <a:t>02</a:t>
+              <a:t>03</a:t>
             </a:r>
           </a:p>
         </p:txBody>
@@ -12866,6 +13284,74 @@
                 <a:cs typeface="Microsoft JhengHei"/>
               </a:rPr>
               <a:t>回歸預測連續金額。未知交易仍需要獨立驗證。</a:t>
+            </a:r>
+          </a:p>
+        </p:txBody>
+      </p:sp>
+      <p:sp>
+        <p:nvSpPr>
+          <p:cNvPr id="11" name="chapter-label">
+            <a:extLst xmlns:a="http://schemas.openxmlformats.org/drawingml/2006/main">
+              <a:ext uri="{FF2B5EF4-FFF2-40B4-BE49-F238E27FC236}">
+                <a16:creationId xmlns:a16="http://schemas.microsoft.com/office/drawing/2014/main" id="{B05CDFDB-F0C5-4202-9D9F-8FEA7892D953}"/>
+              </a:ext>
+            </a:extLst>
+          </p:cNvPr>
+          <p:cNvSpPr>
+            <a:spLocks xmlns:a="http://schemas.openxmlformats.org/drawingml/2006/main" noGrp="1"/>
+          </p:cNvSpPr>
+          <p:nvPr/>
+        </p:nvSpPr>
+        <p:spPr>
+          <a:xfrm xmlns:a="http://schemas.openxmlformats.org/drawingml/2006/main">
+            <a:off x="8572500" y="190500"/>
+            <a:ext cx="2857500" cy="228600"/>
+          </a:xfrm>
+          <a:prstGeom xmlns:a="http://schemas.openxmlformats.org/drawingml/2006/main" prst="rect">
+            <a:avLst/>
+          </a:prstGeom>
+          <a:noFill xmlns:a="http://schemas.openxmlformats.org/drawingml/2006/main"/>
+          <a:ln xmlns:a="http://schemas.openxmlformats.org/drawingml/2006/main" w="0">
+            <a:noFill/>
+          </a:ln>
+        </p:spPr>
+        <p:txBody>
+          <a:bodyPr xmlns:a="http://schemas.openxmlformats.org/drawingml/2006/main" wrap="square" lIns="0" tIns="0" rIns="0" bIns="0" anchor="t">
+            <a:noAutofit/>
+          </a:bodyPr>
+          <a:lstStyle xmlns:a="http://schemas.openxmlformats.org/drawingml/2006/main">
+            <a:defPPr algn="r">
+              <a:defRPr sz="1350" b="0">
+                <a:solidFill>
+                  <a:srgbClr val="718082"/>
+                </a:solidFill>
+                <a:latin typeface="Microsoft JhengHei"/>
+                <a:ea typeface="Microsoft JhengHei"/>
+                <a:cs typeface="Microsoft JhengHei"/>
+              </a:defRPr>
+            </a:defPPr>
+          </a:lstStyle>
+          <a:p xmlns:a="http://schemas.openxmlformats.org/drawingml/2006/main">
+            <a:pPr algn="r">
+              <a:defRPr sz="1350" b="0">
+                <a:solidFill>
+                  <a:srgbClr val="718082"/>
+                </a:solidFill>
+                <a:latin typeface="Microsoft JhengHei"/>
+                <a:ea typeface="Microsoft JhengHei"/>
+                <a:cs typeface="Microsoft JhengHei"/>
+              </a:defRPr>
+            </a:pPr>
+            <a:r>
+              <a:rPr sz="1350" b="0">
+                <a:solidFill>
+                  <a:srgbClr val="718082"/>
+                </a:solidFill>
+                <a:latin typeface="Microsoft JhengHei"/>
+                <a:ea typeface="Microsoft JhengHei"/>
+                <a:cs typeface="Microsoft JhengHei"/>
+              </a:rPr>
+              <a:t>01 資料準備</a:t>
             </a:r>
           </a:p>
         </p:txBody>
@@ -13030,7 +13516,7 @@
                 <a:ea typeface="Microsoft JhengHei"/>
                 <a:cs typeface="Microsoft JhengHei"/>
               </a:rPr>
-              <a:t>03</a:t>
+              <a:t>04</a:t>
             </a:r>
           </a:p>
         </p:txBody>
@@ -13989,6 +14475,74 @@
           </a:p>
         </p:txBody>
       </p:sp>
+      <p:sp>
+        <p:nvSpPr>
+          <p:cNvPr id="11" name="chapter-label">
+            <a:extLst xmlns:a="http://schemas.openxmlformats.org/drawingml/2006/main">
+              <a:ext uri="{FF2B5EF4-FFF2-40B4-BE49-F238E27FC236}">
+                <a16:creationId xmlns:a16="http://schemas.microsoft.com/office/drawing/2014/main" id="{6DBE1348-FE02-4D56-9DA6-480575FD18E8}"/>
+              </a:ext>
+            </a:extLst>
+          </p:cNvPr>
+          <p:cNvSpPr>
+            <a:spLocks xmlns:a="http://schemas.openxmlformats.org/drawingml/2006/main" noGrp="1"/>
+          </p:cNvSpPr>
+          <p:nvPr/>
+        </p:nvSpPr>
+        <p:spPr>
+          <a:xfrm xmlns:a="http://schemas.openxmlformats.org/drawingml/2006/main">
+            <a:off x="8572500" y="190500"/>
+            <a:ext cx="2857500" cy="228600"/>
+          </a:xfrm>
+          <a:prstGeom xmlns:a="http://schemas.openxmlformats.org/drawingml/2006/main" prst="rect">
+            <a:avLst/>
+          </a:prstGeom>
+          <a:noFill xmlns:a="http://schemas.openxmlformats.org/drawingml/2006/main"/>
+          <a:ln xmlns:a="http://schemas.openxmlformats.org/drawingml/2006/main" w="0">
+            <a:noFill/>
+          </a:ln>
+        </p:spPr>
+        <p:txBody>
+          <a:bodyPr xmlns:a="http://schemas.openxmlformats.org/drawingml/2006/main" wrap="square" lIns="0" tIns="0" rIns="0" bIns="0" anchor="t">
+            <a:noAutofit/>
+          </a:bodyPr>
+          <a:lstStyle xmlns:a="http://schemas.openxmlformats.org/drawingml/2006/main">
+            <a:defPPr algn="r">
+              <a:defRPr sz="1350" b="0">
+                <a:solidFill>
+                  <a:srgbClr val="718082"/>
+                </a:solidFill>
+                <a:latin typeface="Microsoft JhengHei"/>
+                <a:ea typeface="Microsoft JhengHei"/>
+                <a:cs typeface="Microsoft JhengHei"/>
+              </a:defRPr>
+            </a:defPPr>
+          </a:lstStyle>
+          <a:p xmlns:a="http://schemas.openxmlformats.org/drawingml/2006/main">
+            <a:pPr algn="r">
+              <a:defRPr sz="1350" b="0">
+                <a:solidFill>
+                  <a:srgbClr val="718082"/>
+                </a:solidFill>
+                <a:latin typeface="Microsoft JhengHei"/>
+                <a:ea typeface="Microsoft JhengHei"/>
+                <a:cs typeface="Microsoft JhengHei"/>
+              </a:defRPr>
+            </a:pPr>
+            <a:r>
+              <a:rPr sz="1350" b="0">
+                <a:solidFill>
+                  <a:srgbClr val="718082"/>
+                </a:solidFill>
+                <a:latin typeface="Microsoft JhengHei"/>
+                <a:ea typeface="Microsoft JhengHei"/>
+                <a:cs typeface="Microsoft JhengHei"/>
+              </a:rPr>
+              <a:t>01 資料準備</a:t>
+            </a:r>
+          </a:p>
+        </p:txBody>
+      </p:sp>
     </p:spTree>
     <p:extLst>
       <p:ext uri="{BB962C8B-B14F-4D97-AF65-F5344CB8AC3E}">
@@ -14149,7 +14703,7 @@
                 <a:ea typeface="Microsoft JhengHei"/>
                 <a:cs typeface="Microsoft JhengHei"/>
               </a:rPr>
-              <a:t>04</a:t>
+              <a:t>05</a:t>
             </a:r>
           </a:p>
         </p:txBody>
@@ -15019,6 +15573,74 @@
           </a:p>
         </p:txBody>
       </p:sp>
+      <p:sp>
+        <p:nvSpPr>
+          <p:cNvPr id="6" name="chapter-label">
+            <a:extLst xmlns:a="http://schemas.openxmlformats.org/drawingml/2006/main">
+              <a:ext uri="{FF2B5EF4-FFF2-40B4-BE49-F238E27FC236}">
+                <a16:creationId xmlns:a16="http://schemas.microsoft.com/office/drawing/2014/main" id="{64C1969D-4456-4BC3-AB56-50B19C2107F4}"/>
+              </a:ext>
+            </a:extLst>
+          </p:cNvPr>
+          <p:cNvSpPr>
+            <a:spLocks xmlns:a="http://schemas.openxmlformats.org/drawingml/2006/main" noGrp="1"/>
+          </p:cNvSpPr>
+          <p:nvPr/>
+        </p:nvSpPr>
+        <p:spPr>
+          <a:xfrm xmlns:a="http://schemas.openxmlformats.org/drawingml/2006/main">
+            <a:off x="8572500" y="190500"/>
+            <a:ext cx="2857500" cy="228600"/>
+          </a:xfrm>
+          <a:prstGeom xmlns:a="http://schemas.openxmlformats.org/drawingml/2006/main" prst="rect">
+            <a:avLst/>
+          </a:prstGeom>
+          <a:noFill xmlns:a="http://schemas.openxmlformats.org/drawingml/2006/main"/>
+          <a:ln xmlns:a="http://schemas.openxmlformats.org/drawingml/2006/main" w="0">
+            <a:noFill/>
+          </a:ln>
+        </p:spPr>
+        <p:txBody>
+          <a:bodyPr xmlns:a="http://schemas.openxmlformats.org/drawingml/2006/main" wrap="square" lIns="0" tIns="0" rIns="0" bIns="0" anchor="t">
+            <a:noAutofit/>
+          </a:bodyPr>
+          <a:lstStyle xmlns:a="http://schemas.openxmlformats.org/drawingml/2006/main">
+            <a:defPPr algn="r">
+              <a:defRPr sz="1350" b="0">
+                <a:solidFill>
+                  <a:srgbClr val="718082"/>
+                </a:solidFill>
+                <a:latin typeface="Microsoft JhengHei"/>
+                <a:ea typeface="Microsoft JhengHei"/>
+                <a:cs typeface="Microsoft JhengHei"/>
+              </a:defRPr>
+            </a:defPPr>
+          </a:lstStyle>
+          <a:p xmlns:a="http://schemas.openxmlformats.org/drawingml/2006/main">
+            <a:pPr algn="r">
+              <a:defRPr sz="1350" b="0">
+                <a:solidFill>
+                  <a:srgbClr val="718082"/>
+                </a:solidFill>
+                <a:latin typeface="Microsoft JhengHei"/>
+                <a:ea typeface="Microsoft JhengHei"/>
+                <a:cs typeface="Microsoft JhengHei"/>
+              </a:defRPr>
+            </a:pPr>
+            <a:r>
+              <a:rPr sz="1350" b="0">
+                <a:solidFill>
+                  <a:srgbClr val="718082"/>
+                </a:solidFill>
+                <a:latin typeface="Microsoft JhengHei"/>
+                <a:ea typeface="Microsoft JhengHei"/>
+                <a:cs typeface="Microsoft JhengHei"/>
+              </a:rPr>
+              <a:t>01 資料準備</a:t>
+            </a:r>
+          </a:p>
+        </p:txBody>
+      </p:sp>
     </p:spTree>
     <p:extLst>
       <p:ext uri="{BB962C8B-B14F-4D97-AF65-F5344CB8AC3E}">
@@ -15179,7 +15801,7 @@
                 <a:ea typeface="Microsoft JhengHei"/>
                 <a:cs typeface="Microsoft JhengHei"/>
               </a:rPr>
-              <a:t>05</a:t>
+              <a:t>06</a:t>
             </a:r>
           </a:p>
         </p:txBody>
@@ -15992,6 +16614,74 @@
           </a:p>
         </p:txBody>
       </p:sp>
+      <p:sp>
+        <p:nvSpPr>
+          <p:cNvPr id="7" name="chapter-label">
+            <a:extLst xmlns:a="http://schemas.openxmlformats.org/drawingml/2006/main">
+              <a:ext uri="{FF2B5EF4-FFF2-40B4-BE49-F238E27FC236}">
+                <a16:creationId xmlns:a16="http://schemas.microsoft.com/office/drawing/2014/main" id="{CF6C4272-B0A7-44E4-8CB8-A6FE154070AE}"/>
+              </a:ext>
+            </a:extLst>
+          </p:cNvPr>
+          <p:cNvSpPr>
+            <a:spLocks xmlns:a="http://schemas.openxmlformats.org/drawingml/2006/main" noGrp="1"/>
+          </p:cNvSpPr>
+          <p:nvPr/>
+        </p:nvSpPr>
+        <p:spPr>
+          <a:xfrm xmlns:a="http://schemas.openxmlformats.org/drawingml/2006/main">
+            <a:off x="8572500" y="190500"/>
+            <a:ext cx="2857500" cy="228600"/>
+          </a:xfrm>
+          <a:prstGeom xmlns:a="http://schemas.openxmlformats.org/drawingml/2006/main" prst="rect">
+            <a:avLst/>
+          </a:prstGeom>
+          <a:noFill xmlns:a="http://schemas.openxmlformats.org/drawingml/2006/main"/>
+          <a:ln xmlns:a="http://schemas.openxmlformats.org/drawingml/2006/main" w="0">
+            <a:noFill/>
+          </a:ln>
+        </p:spPr>
+        <p:txBody>
+          <a:bodyPr xmlns:a="http://schemas.openxmlformats.org/drawingml/2006/main" wrap="square" lIns="0" tIns="0" rIns="0" bIns="0" anchor="t">
+            <a:noAutofit/>
+          </a:bodyPr>
+          <a:lstStyle xmlns:a="http://schemas.openxmlformats.org/drawingml/2006/main">
+            <a:defPPr algn="r">
+              <a:defRPr sz="1350" b="0">
+                <a:solidFill>
+                  <a:srgbClr val="718082"/>
+                </a:solidFill>
+                <a:latin typeface="Microsoft JhengHei"/>
+                <a:ea typeface="Microsoft JhengHei"/>
+                <a:cs typeface="Microsoft JhengHei"/>
+              </a:defRPr>
+            </a:defPPr>
+          </a:lstStyle>
+          <a:p xmlns:a="http://schemas.openxmlformats.org/drawingml/2006/main">
+            <a:pPr algn="r">
+              <a:defRPr sz="1350" b="0">
+                <a:solidFill>
+                  <a:srgbClr val="718082"/>
+                </a:solidFill>
+                <a:latin typeface="Microsoft JhengHei"/>
+                <a:ea typeface="Microsoft JhengHei"/>
+                <a:cs typeface="Microsoft JhengHei"/>
+              </a:defRPr>
+            </a:pPr>
+            <a:r>
+              <a:rPr sz="1350" b="0">
+                <a:solidFill>
+                  <a:srgbClr val="718082"/>
+                </a:solidFill>
+                <a:latin typeface="Microsoft JhengHei"/>
+                <a:ea typeface="Microsoft JhengHei"/>
+                <a:cs typeface="Microsoft JhengHei"/>
+              </a:rPr>
+              <a:t>01 資料準備</a:t>
+            </a:r>
+          </a:p>
+        </p:txBody>
+      </p:sp>
     </p:spTree>
     <p:extLst>
       <p:ext uri="{BB962C8B-B14F-4D97-AF65-F5344CB8AC3E}">
@@ -16152,7 +16842,7 @@
                 <a:ea typeface="Microsoft JhengHei"/>
                 <a:cs typeface="Microsoft JhengHei"/>
               </a:rPr>
-              <a:t>06</a:t>
+              <a:t>07</a:t>
             </a:r>
           </a:p>
         </p:txBody>
@@ -16695,6 +17385,74 @@
           </a:p>
         </p:txBody>
       </p:sp>
+      <p:sp>
+        <p:nvSpPr>
+          <p:cNvPr id="6" name="chapter-label">
+            <a:extLst xmlns:a="http://schemas.openxmlformats.org/drawingml/2006/main">
+              <a:ext uri="{FF2B5EF4-FFF2-40B4-BE49-F238E27FC236}">
+                <a16:creationId xmlns:a16="http://schemas.microsoft.com/office/drawing/2014/main" id="{DEC26402-638F-4456-8A51-A16895DA2C25}"/>
+              </a:ext>
+            </a:extLst>
+          </p:cNvPr>
+          <p:cNvSpPr>
+            <a:spLocks xmlns:a="http://schemas.openxmlformats.org/drawingml/2006/main" noGrp="1"/>
+          </p:cNvSpPr>
+          <p:nvPr/>
+        </p:nvSpPr>
+        <p:spPr>
+          <a:xfrm xmlns:a="http://schemas.openxmlformats.org/drawingml/2006/main">
+            <a:off x="8572500" y="190500"/>
+            <a:ext cx="2857500" cy="228600"/>
+          </a:xfrm>
+          <a:prstGeom xmlns:a="http://schemas.openxmlformats.org/drawingml/2006/main" prst="rect">
+            <a:avLst/>
+          </a:prstGeom>
+          <a:noFill xmlns:a="http://schemas.openxmlformats.org/drawingml/2006/main"/>
+          <a:ln xmlns:a="http://schemas.openxmlformats.org/drawingml/2006/main" w="0">
+            <a:noFill/>
+          </a:ln>
+        </p:spPr>
+        <p:txBody>
+          <a:bodyPr xmlns:a="http://schemas.openxmlformats.org/drawingml/2006/main" wrap="square" lIns="0" tIns="0" rIns="0" bIns="0" anchor="t">
+            <a:noAutofit/>
+          </a:bodyPr>
+          <a:lstStyle xmlns:a="http://schemas.openxmlformats.org/drawingml/2006/main">
+            <a:defPPr algn="r">
+              <a:defRPr sz="1350" b="0">
+                <a:solidFill>
+                  <a:srgbClr val="718082"/>
+                </a:solidFill>
+                <a:latin typeface="Microsoft JhengHei"/>
+                <a:ea typeface="Microsoft JhengHei"/>
+                <a:cs typeface="Microsoft JhengHei"/>
+              </a:defRPr>
+            </a:defPPr>
+          </a:lstStyle>
+          <a:p xmlns:a="http://schemas.openxmlformats.org/drawingml/2006/main">
+            <a:pPr algn="r">
+              <a:defRPr sz="1350" b="0">
+                <a:solidFill>
+                  <a:srgbClr val="718082"/>
+                </a:solidFill>
+                <a:latin typeface="Microsoft JhengHei"/>
+                <a:ea typeface="Microsoft JhengHei"/>
+                <a:cs typeface="Microsoft JhengHei"/>
+              </a:defRPr>
+            </a:pPr>
+            <a:r>
+              <a:rPr sz="1350" b="0">
+                <a:solidFill>
+                  <a:srgbClr val="718082"/>
+                </a:solidFill>
+                <a:latin typeface="Microsoft JhengHei"/>
+                <a:ea typeface="Microsoft JhengHei"/>
+                <a:cs typeface="Microsoft JhengHei"/>
+              </a:rPr>
+              <a:t>01 資料準備</a:t>
+            </a:r>
+          </a:p>
+        </p:txBody>
+      </p:sp>
     </p:spTree>
     <p:extLst>
       <p:ext uri="{BB962C8B-B14F-4D97-AF65-F5344CB8AC3E}">
@@ -16855,7 +17613,7 @@
                 <a:ea typeface="Microsoft JhengHei"/>
                 <a:cs typeface="Microsoft JhengHei"/>
               </a:rPr>
-              <a:t>07</a:t>
+              <a:t>08</a:t>
             </a:r>
           </a:p>
         </p:txBody>
@@ -17804,6 +18562,74 @@
           </a:p>
         </p:txBody>
       </p:sp>
+      <p:sp>
+        <p:nvSpPr>
+          <p:cNvPr id="9" name="chapter-label">
+            <a:extLst xmlns:a="http://schemas.openxmlformats.org/drawingml/2006/main">
+              <a:ext uri="{FF2B5EF4-FFF2-40B4-BE49-F238E27FC236}">
+                <a16:creationId xmlns:a16="http://schemas.microsoft.com/office/drawing/2014/main" id="{ECC4B896-B442-41E8-9B96-B5235AC673BD}"/>
+              </a:ext>
+            </a:extLst>
+          </p:cNvPr>
+          <p:cNvSpPr>
+            <a:spLocks xmlns:a="http://schemas.openxmlformats.org/drawingml/2006/main" noGrp="1"/>
+          </p:cNvSpPr>
+          <p:nvPr/>
+        </p:nvSpPr>
+        <p:spPr>
+          <a:xfrm xmlns:a="http://schemas.openxmlformats.org/drawingml/2006/main">
+            <a:off x="8572500" y="190500"/>
+            <a:ext cx="2857500" cy="228600"/>
+          </a:xfrm>
+          <a:prstGeom xmlns:a="http://schemas.openxmlformats.org/drawingml/2006/main" prst="rect">
+            <a:avLst/>
+          </a:prstGeom>
+          <a:noFill xmlns:a="http://schemas.openxmlformats.org/drawingml/2006/main"/>
+          <a:ln xmlns:a="http://schemas.openxmlformats.org/drawingml/2006/main" w="0">
+            <a:noFill/>
+          </a:ln>
+        </p:spPr>
+        <p:txBody>
+          <a:bodyPr xmlns:a="http://schemas.openxmlformats.org/drawingml/2006/main" wrap="square" lIns="0" tIns="0" rIns="0" bIns="0" anchor="t">
+            <a:noAutofit/>
+          </a:bodyPr>
+          <a:lstStyle xmlns:a="http://schemas.openxmlformats.org/drawingml/2006/main">
+            <a:defPPr algn="r">
+              <a:defRPr sz="1350" b="0">
+                <a:solidFill>
+                  <a:srgbClr val="718082"/>
+                </a:solidFill>
+                <a:latin typeface="Microsoft JhengHei"/>
+                <a:ea typeface="Microsoft JhengHei"/>
+                <a:cs typeface="Microsoft JhengHei"/>
+              </a:defRPr>
+            </a:defPPr>
+          </a:lstStyle>
+          <a:p xmlns:a="http://schemas.openxmlformats.org/drawingml/2006/main">
+            <a:pPr algn="r">
+              <a:defRPr sz="1350" b="0">
+                <a:solidFill>
+                  <a:srgbClr val="718082"/>
+                </a:solidFill>
+                <a:latin typeface="Microsoft JhengHei"/>
+                <a:ea typeface="Microsoft JhengHei"/>
+                <a:cs typeface="Microsoft JhengHei"/>
+              </a:defRPr>
+            </a:pPr>
+            <a:r>
+              <a:rPr sz="1350" b="0">
+                <a:solidFill>
+                  <a:srgbClr val="718082"/>
+                </a:solidFill>
+                <a:latin typeface="Microsoft JhengHei"/>
+                <a:ea typeface="Microsoft JhengHei"/>
+                <a:cs typeface="Microsoft JhengHei"/>
+              </a:rPr>
+              <a:t>02 模型訓練</a:t>
+            </a:r>
+          </a:p>
+        </p:txBody>
+      </p:sp>
     </p:spTree>
     <p:extLst>
       <p:ext uri="{BB962C8B-B14F-4D97-AF65-F5344CB8AC3E}">
@@ -17964,7 +18790,7 @@
                 <a:ea typeface="Microsoft JhengHei"/>
                 <a:cs typeface="Microsoft JhengHei"/>
               </a:rPr>
-              <a:t>08</a:t>
+              <a:t>09</a:t>
             </a:r>
           </a:p>
         </p:txBody>
@@ -18350,6 +19176,74 @@
                 <a:cs typeface="Microsoft JhengHei"/>
               </a:rPr>
               <a:t>面積權重對齊總價差距。另保留直接總價與對數學法，最後皆還原為元。</a:t>
+            </a:r>
+          </a:p>
+        </p:txBody>
+      </p:sp>
+      <p:sp>
+        <p:nvSpPr>
+          <p:cNvPr id="10" name="chapter-label">
+            <a:extLst xmlns:a="http://schemas.openxmlformats.org/drawingml/2006/main">
+              <a:ext uri="{FF2B5EF4-FFF2-40B4-BE49-F238E27FC236}">
+                <a16:creationId xmlns:a16="http://schemas.microsoft.com/office/drawing/2014/main" id="{82C36A8F-9AF4-4A28-BB15-0DC235AE0193}"/>
+              </a:ext>
+            </a:extLst>
+          </p:cNvPr>
+          <p:cNvSpPr>
+            <a:spLocks xmlns:a="http://schemas.openxmlformats.org/drawingml/2006/main" noGrp="1"/>
+          </p:cNvSpPr>
+          <p:nvPr/>
+        </p:nvSpPr>
+        <p:spPr>
+          <a:xfrm xmlns:a="http://schemas.openxmlformats.org/drawingml/2006/main">
+            <a:off x="8572500" y="190500"/>
+            <a:ext cx="2857500" cy="228600"/>
+          </a:xfrm>
+          <a:prstGeom xmlns:a="http://schemas.openxmlformats.org/drawingml/2006/main" prst="rect">
+            <a:avLst/>
+          </a:prstGeom>
+          <a:noFill xmlns:a="http://schemas.openxmlformats.org/drawingml/2006/main"/>
+          <a:ln xmlns:a="http://schemas.openxmlformats.org/drawingml/2006/main" w="0">
+            <a:noFill/>
+          </a:ln>
+        </p:spPr>
+        <p:txBody>
+          <a:bodyPr xmlns:a="http://schemas.openxmlformats.org/drawingml/2006/main" wrap="square" lIns="0" tIns="0" rIns="0" bIns="0" anchor="t">
+            <a:noAutofit/>
+          </a:bodyPr>
+          <a:lstStyle xmlns:a="http://schemas.openxmlformats.org/drawingml/2006/main">
+            <a:defPPr algn="r">
+              <a:defRPr sz="1350" b="0">
+                <a:solidFill>
+                  <a:srgbClr val="718082"/>
+                </a:solidFill>
+                <a:latin typeface="Microsoft JhengHei"/>
+                <a:ea typeface="Microsoft JhengHei"/>
+                <a:cs typeface="Microsoft JhengHei"/>
+              </a:defRPr>
+            </a:defPPr>
+          </a:lstStyle>
+          <a:p xmlns:a="http://schemas.openxmlformats.org/drawingml/2006/main">
+            <a:pPr algn="r">
+              <a:defRPr sz="1350" b="0">
+                <a:solidFill>
+                  <a:srgbClr val="718082"/>
+                </a:solidFill>
+                <a:latin typeface="Microsoft JhengHei"/>
+                <a:ea typeface="Microsoft JhengHei"/>
+                <a:cs typeface="Microsoft JhengHei"/>
+              </a:defRPr>
+            </a:pPr>
+            <a:r>
+              <a:rPr sz="1350" b="0">
+                <a:solidFill>
+                  <a:srgbClr val="718082"/>
+                </a:solidFill>
+                <a:latin typeface="Microsoft JhengHei"/>
+                <a:ea typeface="Microsoft JhengHei"/>
+                <a:cs typeface="Microsoft JhengHei"/>
+              </a:rPr>
+              <a:t>02 模型訓練</a:t>
             </a:r>
           </a:p>
         </p:txBody>
@@ -18536,7 +19430,7 @@
                 <a:ea typeface="Microsoft JhengHei"/>
                 <a:cs typeface="Microsoft JhengHei"/>
               </a:rPr>
-              <a:t>09</a:t>
+              <a:t>10</a:t>
             </a:r>
           </a:p>
         </p:txBody>
@@ -18923,6 +19817,74 @@
                 <a:cs typeface="Microsoft JhengHei"/>
               </a:rPr>
               <a:t>圖為正規化前的相對比例。權重乘在訓練損失上，成交價本身不變。</a:t>
+            </a:r>
+          </a:p>
+        </p:txBody>
+      </p:sp>
+      <p:sp>
+        <p:nvSpPr>
+          <p:cNvPr id="12" name="chapter-label">
+            <a:extLst xmlns:a="http://schemas.openxmlformats.org/drawingml/2006/main">
+              <a:ext uri="{FF2B5EF4-FFF2-40B4-BE49-F238E27FC236}">
+                <a16:creationId xmlns:a16="http://schemas.microsoft.com/office/drawing/2014/main" id="{CEF09E86-3728-45A1-B9AC-90D412AEF7F2}"/>
+              </a:ext>
+            </a:extLst>
+          </p:cNvPr>
+          <p:cNvSpPr>
+            <a:spLocks xmlns:a="http://schemas.openxmlformats.org/drawingml/2006/main" noGrp="1"/>
+          </p:cNvSpPr>
+          <p:nvPr/>
+        </p:nvSpPr>
+        <p:spPr>
+          <a:xfrm xmlns:a="http://schemas.openxmlformats.org/drawingml/2006/main">
+            <a:off x="8572500" y="190500"/>
+            <a:ext cx="2857500" cy="228600"/>
+          </a:xfrm>
+          <a:prstGeom xmlns:a="http://schemas.openxmlformats.org/drawingml/2006/main" prst="rect">
+            <a:avLst/>
+          </a:prstGeom>
+          <a:noFill xmlns:a="http://schemas.openxmlformats.org/drawingml/2006/main"/>
+          <a:ln xmlns:a="http://schemas.openxmlformats.org/drawingml/2006/main" w="0">
+            <a:noFill/>
+          </a:ln>
+        </p:spPr>
+        <p:txBody>
+          <a:bodyPr xmlns:a="http://schemas.openxmlformats.org/drawingml/2006/main" wrap="square" lIns="0" tIns="0" rIns="0" bIns="0" anchor="t">
+            <a:noAutofit/>
+          </a:bodyPr>
+          <a:lstStyle xmlns:a="http://schemas.openxmlformats.org/drawingml/2006/main">
+            <a:defPPr algn="r">
+              <a:defRPr sz="1350" b="0">
+                <a:solidFill>
+                  <a:srgbClr val="718082"/>
+                </a:solidFill>
+                <a:latin typeface="Microsoft JhengHei"/>
+                <a:ea typeface="Microsoft JhengHei"/>
+                <a:cs typeface="Microsoft JhengHei"/>
+              </a:defRPr>
+            </a:defPPr>
+          </a:lstStyle>
+          <a:p xmlns:a="http://schemas.openxmlformats.org/drawingml/2006/main">
+            <a:pPr algn="r">
+              <a:defRPr sz="1350" b="0">
+                <a:solidFill>
+                  <a:srgbClr val="718082"/>
+                </a:solidFill>
+                <a:latin typeface="Microsoft JhengHei"/>
+                <a:ea typeface="Microsoft JhengHei"/>
+                <a:cs typeface="Microsoft JhengHei"/>
+              </a:defRPr>
+            </a:pPr>
+            <a:r>
+              <a:rPr sz="1350" b="0">
+                <a:solidFill>
+                  <a:srgbClr val="718082"/>
+                </a:solidFill>
+                <a:latin typeface="Microsoft JhengHei"/>
+                <a:ea typeface="Microsoft JhengHei"/>
+                <a:cs typeface="Microsoft JhengHei"/>
+              </a:rPr>
+              <a:t>02 模型訓練</a:t>
             </a:r>
           </a:p>
         </p:txBody>

</xml_diff>

<commit_message>
Add verified six-model inference and complete training sources
</commit_message>
<xml_diff>
--- a/teaching/final_presentation/台灣房屋銷售價格預測挑戰賽_上台簡報.pptx
+++ b/teaching/final_presentation/台灣房屋銷售價格預測挑戰賽_上台簡報.pptx
@@ -2,32 +2,32 @@
 <file path=ppt/presentation.xml><?xml version="1.0" encoding="utf-8"?>
 <p:presentation xmlns:p="http://schemas.openxmlformats.org/presentationml/2006/main">
   <p:sldMasterIdLst>
-    <p:sldMasterId xmlns:r="http://schemas.openxmlformats.org/officeDocument/2006/relationships" id="2147483648" r:id="R287a1ad12cfd4c17"/>
+    <p:sldMasterId xmlns:r="http://schemas.openxmlformats.org/officeDocument/2006/relationships" id="2147483648" r:id="R9c85832459414132"/>
   </p:sldMasterIdLst>
   <p:notesMasterIdLst>
-    <p:notesMasterId xmlns:r="http://schemas.openxmlformats.org/officeDocument/2006/relationships" r:id="Rac814532deed42e4"/>
+    <p:notesMasterId xmlns:r="http://schemas.openxmlformats.org/officeDocument/2006/relationships" r:id="Rfe18f986cffc4007"/>
   </p:notesMasterIdLst>
   <p:sldIdLst>
-    <p:sldId xmlns:r="http://schemas.openxmlformats.org/officeDocument/2006/relationships" id="256" r:id="R20544db0474c4771"/>
-    <p:sldId xmlns:r="http://schemas.openxmlformats.org/officeDocument/2006/relationships" id="257" r:id="R8924b080ff144e1e"/>
-    <p:sldId xmlns:r="http://schemas.openxmlformats.org/officeDocument/2006/relationships" id="258" r:id="R988e19deba1e4859"/>
-    <p:sldId xmlns:r="http://schemas.openxmlformats.org/officeDocument/2006/relationships" id="259" r:id="Reb58d72c455b479c"/>
-    <p:sldId xmlns:r="http://schemas.openxmlformats.org/officeDocument/2006/relationships" id="260" r:id="Rb0fa717fcc7e45de"/>
-    <p:sldId xmlns:r="http://schemas.openxmlformats.org/officeDocument/2006/relationships" id="261" r:id="R85ca92b28a17437e"/>
-    <p:sldId xmlns:r="http://schemas.openxmlformats.org/officeDocument/2006/relationships" id="262" r:id="R77b607eb56034ddb"/>
-    <p:sldId xmlns:r="http://schemas.openxmlformats.org/officeDocument/2006/relationships" id="263" r:id="R0438dbc4bfdc4e26"/>
-    <p:sldId xmlns:r="http://schemas.openxmlformats.org/officeDocument/2006/relationships" id="264" r:id="R308179905c864a4a"/>
-    <p:sldId xmlns:r="http://schemas.openxmlformats.org/officeDocument/2006/relationships" id="265" r:id="R4c4edb4e8b694e15"/>
-    <p:sldId xmlns:r="http://schemas.openxmlformats.org/officeDocument/2006/relationships" id="266" r:id="R29fd6876de4a427a"/>
-    <p:sldId xmlns:r="http://schemas.openxmlformats.org/officeDocument/2006/relationships" id="267" r:id="Rdd0121ea250c4810"/>
-    <p:sldId xmlns:r="http://schemas.openxmlformats.org/officeDocument/2006/relationships" id="268" r:id="R0c8173457bfb41db"/>
-    <p:sldId xmlns:r="http://schemas.openxmlformats.org/officeDocument/2006/relationships" id="269" r:id="R6ad3dcc6c5ca44d5"/>
-    <p:sldId xmlns:r="http://schemas.openxmlformats.org/officeDocument/2006/relationships" id="270" r:id="Rfa4841efb6964ab7"/>
-    <p:sldId xmlns:r="http://schemas.openxmlformats.org/officeDocument/2006/relationships" id="271" r:id="R6b9e523b246f44f7"/>
-    <p:sldId xmlns:r="http://schemas.openxmlformats.org/officeDocument/2006/relationships" id="272" r:id="R103cac1761834023"/>
-    <p:sldId xmlns:r="http://schemas.openxmlformats.org/officeDocument/2006/relationships" id="273" r:id="R56c1a403e25241b6"/>
-    <p:sldId xmlns:r="http://schemas.openxmlformats.org/officeDocument/2006/relationships" id="274" r:id="Rc57f844a0ebe4554"/>
-    <p:sldId xmlns:r="http://schemas.openxmlformats.org/officeDocument/2006/relationships" id="275" r:id="Re725f9f03899423a"/>
+    <p:sldId xmlns:r="http://schemas.openxmlformats.org/officeDocument/2006/relationships" id="256" r:id="R13b449e8dd584d83"/>
+    <p:sldId xmlns:r="http://schemas.openxmlformats.org/officeDocument/2006/relationships" id="257" r:id="Rc04533d0f1234f0d"/>
+    <p:sldId xmlns:r="http://schemas.openxmlformats.org/officeDocument/2006/relationships" id="258" r:id="Rf776a7db22b1410c"/>
+    <p:sldId xmlns:r="http://schemas.openxmlformats.org/officeDocument/2006/relationships" id="259" r:id="Re70199bca88148f9"/>
+    <p:sldId xmlns:r="http://schemas.openxmlformats.org/officeDocument/2006/relationships" id="260" r:id="R9aef1494944d4665"/>
+    <p:sldId xmlns:r="http://schemas.openxmlformats.org/officeDocument/2006/relationships" id="261" r:id="Rccf8e540caa64286"/>
+    <p:sldId xmlns:r="http://schemas.openxmlformats.org/officeDocument/2006/relationships" id="262" r:id="R4ddff04827b84923"/>
+    <p:sldId xmlns:r="http://schemas.openxmlformats.org/officeDocument/2006/relationships" id="263" r:id="Redcc36ffea624f5e"/>
+    <p:sldId xmlns:r="http://schemas.openxmlformats.org/officeDocument/2006/relationships" id="264" r:id="Rf286ad3ccd24446b"/>
+    <p:sldId xmlns:r="http://schemas.openxmlformats.org/officeDocument/2006/relationships" id="265" r:id="Rc06910efde14451f"/>
+    <p:sldId xmlns:r="http://schemas.openxmlformats.org/officeDocument/2006/relationships" id="266" r:id="R1e10444078c744c1"/>
+    <p:sldId xmlns:r="http://schemas.openxmlformats.org/officeDocument/2006/relationships" id="267" r:id="R4589bdc8d620495f"/>
+    <p:sldId xmlns:r="http://schemas.openxmlformats.org/officeDocument/2006/relationships" id="268" r:id="R9589f4605a764612"/>
+    <p:sldId xmlns:r="http://schemas.openxmlformats.org/officeDocument/2006/relationships" id="269" r:id="Re4cc826775ed40f4"/>
+    <p:sldId xmlns:r="http://schemas.openxmlformats.org/officeDocument/2006/relationships" id="270" r:id="Reb53bbaa11974df2"/>
+    <p:sldId xmlns:r="http://schemas.openxmlformats.org/officeDocument/2006/relationships" id="271" r:id="R0bba8b2f8a124767"/>
+    <p:sldId xmlns:r="http://schemas.openxmlformats.org/officeDocument/2006/relationships" id="272" r:id="R45135c0cd715417b"/>
+    <p:sldId xmlns:r="http://schemas.openxmlformats.org/officeDocument/2006/relationships" id="273" r:id="R17d32f9301c2420f"/>
+    <p:sldId xmlns:r="http://schemas.openxmlformats.org/officeDocument/2006/relationships" id="274" r:id="Ra1638485e7074340"/>
+    <p:sldId xmlns:r="http://schemas.openxmlformats.org/officeDocument/2006/relationships" id="275" r:id="R6e4868d473f4451a"/>
   </p:sldIdLst>
   <p:sldSz cx="12192000" cy="6858000"/>
   <p:notesSz cx="6858000" cy="9144000"/>
@@ -1411,7 +1411,7 @@
           </a:p>
           <a:p xmlns:a="http://schemas.openxmlformats.org/drawingml/2006/main">
             <a:r>
-              <a:t>最後取整一次，輸出編號與總價，核對四萬七千零七十三筆順序。全量只新增參考單價網路，其餘五個沿用保存預測；雖保存程式與證據，尚未驗證乾淨環境全部六模型從頭重訓。</a:t>
+              <a:t>最後取整一次，核對四萬七千零七十三筆編號和總價。原全量階段新增一支網路，其餘五模型用保存預測。後續在同機既有及全新套件環境，各重載六模型重新推論，十三份向量與整份答案表逐值一致。這驗證保存狀態的推論流程；六模型從頭重訓、換電腦測試仍未完成。</a:t>
             </a:r>
           </a:p>
           <a:p xmlns:a="http://schemas.openxmlformats.org/drawingml/2006/main">
@@ -1426,7 +1426,7 @@
           </a:p>
           <a:p xmlns:a="http://schemas.openxmlformats.org/drawingml/2006/main">
             <a:r>
-              <a:t>用排序手算建立median直覺，保留它可能阻擋正確極端與無法消除共同偏差的限制。</a:t>
+              <a:t>用排序手算建立median直覺，保留可能擋掉正確極端與共同偏差的限制。後續兩次完整推論在同一Windows主機與GPU上進行，分別用既有與全新套件環境。六模型重新forward後，13份47,073列向量值位元一致，CSV編號順序、整數價格和檔案bytes一致。保存向量只用來事後核對，新增fit為0。這是預測重現差而非真價MAE，不能推論換硬體／作業系統／不同套件版本或全六模型原始資料重訓已完成。R2直接中間向量沒有另行匯出，不主張該層直接相等。Private仍未知。</a:t>
             </a:r>
           </a:p>
           <a:p xmlns:a="http://schemas.openxmlformats.org/drawingml/2006/main">
@@ -1447,6 +1447,11 @@
           <a:p xmlns:a="http://schemas.openxmlformats.org/drawingml/2006/main">
             <a:r>
               <a:t>src/round107_final_candidate.py</a:t>
+            </a:r>
+          </a:p>
+          <a:p xmlns:a="http://schemas.openxmlformats.org/drawingml/2006/main">
+            <a:r>
+              <a:t>reproducibility_receipt.json</a:t>
             </a:r>
           </a:p>
         </p:txBody>
@@ -2231,7 +2236,7 @@
           </a:p>
           <a:p xmlns:a="http://schemas.openxmlformats.org/drawingml/2006/main">
             <a:r>
-              <a:t>有真價的保留交易用來計算誤差；未知測試交易則依指定順序輸出答案。程式分成讀取、特徵、模型、組合和發行模組，逐步保存結果，便於核對。最終交付只新增訓練一支參考單價網路，其餘五個模型沿用保存預測，不是這次把全部模型從頭重訓。</a:t>
+              <a:t>保留交易有真價才評分；未知交易依指定順序輸出。原全量階段只新訓練一支參考單價網路，其餘五模型沿用保存預測。後續另外重載六模型推論，檢查保存規則能否產生相同答案。</a:t>
             </a:r>
           </a:p>
           <a:p xmlns:a="http://schemas.openxmlformats.org/drawingml/2006/main">
@@ -2246,7 +2251,7 @@
           </a:p>
           <a:p xmlns:a="http://schemas.openxmlformats.org/drawingml/2006/main">
             <a:r>
-              <a:t>程式方塊圖將操作階段對應實際函式，區分當期fit狀態與保留交易套用。最終只新增1NN訓練、其餘保存向量，不將方法概念圖說成全六模型重訓紀錄。</a:t>
+              <a:t>程式方塊圖對應實際函式，區分當期fit狀態與保留交易套用。原全量階段只新增1NN訓練、其餘沿用保存向量。後續另做既有與全新套件環境的六模型真推論，保存預測只在推論完成後拿來核對，沒有當成模型輸入。</a:t>
             </a:r>
           </a:p>
           <a:p xmlns:a="http://schemas.openxmlformats.org/drawingml/2006/main">
@@ -2287,6 +2292,11 @@
           <a:p xmlns:a="http://schemas.openxmlformats.org/drawingml/2006/main">
             <a:r>
               <a:t>src/round107_full_release.py</a:t>
+            </a:r>
+          </a:p>
+          <a:p xmlns:a="http://schemas.openxmlformats.org/drawingml/2006/main">
+            <a:r>
+              <a:t>reproducibility_receipt.json</a:t>
             </a:r>
           </a:p>
         </p:txBody>
@@ -3133,7 +3143,7 @@
           <p:cNvPr id="3" name="Title">
             <a:extLst xmlns:a="http://schemas.openxmlformats.org/drawingml/2006/main">
               <a:ext uri="{FF2B5EF4-FFF2-40B4-BE49-F238E27FC236}">
-                <a16:creationId xmlns:a16="http://schemas.microsoft.com/office/drawing/2014/main" id="{421364C2-32A6-4097-B30D-0731D8163AED}"/>
+                <a16:creationId xmlns:a16="http://schemas.microsoft.com/office/drawing/2014/main" id="{9D6F40AD-B047-429D-BB85-5A370D3D6EC8}"/>
               </a:ext>
             </a:extLst>
           </p:cNvPr>
@@ -3290,7 +3300,7 @@
           <p:cNvPr id="2" name="Subtitle">
             <a:extLst xmlns:a="http://schemas.openxmlformats.org/drawingml/2006/main">
               <a:ext uri="{FF2B5EF4-FFF2-40B4-BE49-F238E27FC236}">
-                <a16:creationId xmlns:a16="http://schemas.microsoft.com/office/drawing/2014/main" id="{2AD2A8E0-45E2-47C6-B056-1E30BB04611B}"/>
+                <a16:creationId xmlns:a16="http://schemas.microsoft.com/office/drawing/2014/main" id="{FADDD277-0CDC-4A39-B3C1-C4A98FF32635}"/>
               </a:ext>
             </a:extLst>
           </p:cNvPr>
@@ -3464,7 +3474,7 @@
           <p:cNvPr id="2" name="Section title">
             <a:extLst xmlns:a="http://schemas.openxmlformats.org/drawingml/2006/main">
               <a:ext uri="{FF2B5EF4-FFF2-40B4-BE49-F238E27FC236}">
-                <a16:creationId xmlns:a16="http://schemas.microsoft.com/office/drawing/2014/main" id="{39632E21-0E93-437B-884D-08468E1FDA8B}"/>
+                <a16:creationId xmlns:a16="http://schemas.microsoft.com/office/drawing/2014/main" id="{84E93D1D-D629-4833-95E9-5E67F40291DC}"/>
               </a:ext>
             </a:extLst>
           </p:cNvPr>
@@ -3638,7 +3648,7 @@
           <p:cNvPr id="3" name="Title">
             <a:extLst xmlns:a="http://schemas.openxmlformats.org/drawingml/2006/main">
               <a:ext uri="{FF2B5EF4-FFF2-40B4-BE49-F238E27FC236}">
-                <a16:creationId xmlns:a16="http://schemas.microsoft.com/office/drawing/2014/main" id="{F55A5BBB-B4F8-440D-BA93-2F36696D47BA}"/>
+                <a16:creationId xmlns:a16="http://schemas.microsoft.com/office/drawing/2014/main" id="{0AA033AE-64A8-4964-A600-C09BD459D176}"/>
               </a:ext>
             </a:extLst>
           </p:cNvPr>
@@ -3795,7 +3805,7 @@
           <p:cNvPr id="2" name="Body">
             <a:extLst xmlns:a="http://schemas.openxmlformats.org/drawingml/2006/main">
               <a:ext uri="{FF2B5EF4-FFF2-40B4-BE49-F238E27FC236}">
-                <a16:creationId xmlns:a16="http://schemas.microsoft.com/office/drawing/2014/main" id="{7E006E0C-4298-4F4B-A6F4-1B205FE36904}"/>
+                <a16:creationId xmlns:a16="http://schemas.microsoft.com/office/drawing/2014/main" id="{640D290E-74A8-46E0-BB0A-39D9FA4CB9C2}"/>
               </a:ext>
             </a:extLst>
           </p:cNvPr>
@@ -3969,7 +3979,7 @@
           <p:cNvPr id="4" name="Title">
             <a:extLst xmlns:a="http://schemas.openxmlformats.org/drawingml/2006/main">
               <a:ext uri="{FF2B5EF4-FFF2-40B4-BE49-F238E27FC236}">
-                <a16:creationId xmlns:a16="http://schemas.microsoft.com/office/drawing/2014/main" id="{FC069FBA-DBA5-4F6C-BAF0-4E4348A28C9E}"/>
+                <a16:creationId xmlns:a16="http://schemas.microsoft.com/office/drawing/2014/main" id="{45D190EA-A647-4961-A1BA-414C6B142E0A}"/>
               </a:ext>
             </a:extLst>
           </p:cNvPr>
@@ -4126,7 +4136,7 @@
           <p:cNvPr id="2" name="Left column">
             <a:extLst xmlns:a="http://schemas.openxmlformats.org/drawingml/2006/main">
               <a:ext uri="{FF2B5EF4-FFF2-40B4-BE49-F238E27FC236}">
-                <a16:creationId xmlns:a16="http://schemas.microsoft.com/office/drawing/2014/main" id="{28FEE532-2D56-4276-AFF7-596A0C43B4A3}"/>
+                <a16:creationId xmlns:a16="http://schemas.microsoft.com/office/drawing/2014/main" id="{47BDAE3B-85AC-4E4B-929F-1ACF89CA55FA}"/>
               </a:ext>
             </a:extLst>
           </p:cNvPr>
@@ -4283,7 +4293,7 @@
           <p:cNvPr id="3" name="Right column">
             <a:extLst xmlns:a="http://schemas.openxmlformats.org/drawingml/2006/main">
               <a:ext uri="{FF2B5EF4-FFF2-40B4-BE49-F238E27FC236}">
-                <a16:creationId xmlns:a16="http://schemas.microsoft.com/office/drawing/2014/main" id="{DD70EE1C-BE9F-4F5C-9DD5-D6B831F1595D}"/>
+                <a16:creationId xmlns:a16="http://schemas.microsoft.com/office/drawing/2014/main" id="{3EDC12FD-4800-4FFA-998B-8E9F8ADE1093}"/>
               </a:ext>
             </a:extLst>
           </p:cNvPr>
@@ -4457,7 +4467,7 @@
           <p:cNvPr id="3" name="Title">
             <a:extLst xmlns:a="http://schemas.openxmlformats.org/drawingml/2006/main">
               <a:ext uri="{FF2B5EF4-FFF2-40B4-BE49-F238E27FC236}">
-                <a16:creationId xmlns:a16="http://schemas.microsoft.com/office/drawing/2014/main" id="{9B1F87D1-942F-465A-A66E-49B4470C5032}"/>
+                <a16:creationId xmlns:a16="http://schemas.microsoft.com/office/drawing/2014/main" id="{F102F6DC-BBE5-40C5-868D-63D25AFE56BF}"/>
               </a:ext>
             </a:extLst>
           </p:cNvPr>
@@ -4614,7 +4624,7 @@
           <p:cNvPr id="2" name="Left column">
             <a:extLst xmlns:a="http://schemas.openxmlformats.org/drawingml/2006/main">
               <a:ext uri="{FF2B5EF4-FFF2-40B4-BE49-F238E27FC236}">
-                <a16:creationId xmlns:a16="http://schemas.microsoft.com/office/drawing/2014/main" id="{03ED90BB-533E-452E-A243-A45FA52FC482}"/>
+                <a16:creationId xmlns:a16="http://schemas.microsoft.com/office/drawing/2014/main" id="{07F3092F-43A3-4742-BB0B-C07FF13BAE6D}"/>
               </a:ext>
             </a:extLst>
           </p:cNvPr>
@@ -4809,12 +4819,12 @@
   </p:cSld>
   <p:clrMap bg1="lt1" tx1="dk1" bg2="lt2" tx2="dk2" accent1="accent1" accent2="accent2" accent3="accent3" accent4="accent4" accent5="accent5" accent6="accent6" hlink="hlink" folHlink="folHlink"/>
   <p:sldLayoutIdLst>
-    <p:sldLayoutId xmlns:r="http://schemas.openxmlformats.org/officeDocument/2006/relationships" id="2147483649" r:id="R6e490c18083b40ea"/>
-    <p:sldLayoutId xmlns:r="http://schemas.openxmlformats.org/officeDocument/2006/relationships" id="2147483650" r:id="R84249aa020f74155"/>
-    <p:sldLayoutId xmlns:r="http://schemas.openxmlformats.org/officeDocument/2006/relationships" id="2147483651" r:id="Rd8e53e263c6a4756"/>
-    <p:sldLayoutId xmlns:r="http://schemas.openxmlformats.org/officeDocument/2006/relationships" id="2147483652" r:id="Rcd2fca37cacb4f66"/>
-    <p:sldLayoutId xmlns:r="http://schemas.openxmlformats.org/officeDocument/2006/relationships" id="2147483653" r:id="R4ef0c6f734074f3e"/>
-    <p:sldLayoutId xmlns:r="http://schemas.openxmlformats.org/officeDocument/2006/relationships" id="2147483654" r:id="R003996c450af4606"/>
+    <p:sldLayoutId xmlns:r="http://schemas.openxmlformats.org/officeDocument/2006/relationships" id="2147483649" r:id="R3bf86637253a4943"/>
+    <p:sldLayoutId xmlns:r="http://schemas.openxmlformats.org/officeDocument/2006/relationships" id="2147483650" r:id="Ra3ecaa579e6a451e"/>
+    <p:sldLayoutId xmlns:r="http://schemas.openxmlformats.org/officeDocument/2006/relationships" id="2147483651" r:id="Ra5a70665fd674f70"/>
+    <p:sldLayoutId xmlns:r="http://schemas.openxmlformats.org/officeDocument/2006/relationships" id="2147483652" r:id="R738e88842f064e45"/>
+    <p:sldLayoutId xmlns:r="http://schemas.openxmlformats.org/officeDocument/2006/relationships" id="2147483653" r:id="Rfd427db3b0bb4c8b"/>
+    <p:sldLayoutId xmlns:r="http://schemas.openxmlformats.org/officeDocument/2006/relationships" id="2147483654" r:id="R414b437d44874a67"/>
   </p:sldLayoutIdLst>
   <p:txStyles>
     <p:titleStyle>
@@ -6738,7 +6748,7 @@
           <p:cNvPr id="2" name="body">
             <a:extLst xmlns:a="http://schemas.openxmlformats.org/drawingml/2006/main">
               <a:ext uri="{FF2B5EF4-FFF2-40B4-BE49-F238E27FC236}">
-                <a16:creationId xmlns:a16="http://schemas.microsoft.com/office/drawing/2014/main" id="{0CC83BD7-64B3-4E74-A8AE-E277EC0C4A87}"/>
+                <a16:creationId xmlns:a16="http://schemas.microsoft.com/office/drawing/2014/main" id="{5858CCBD-B309-4AE4-AA5C-6490915971FB}"/>
               </a:ext>
             </a:extLst>
           </p:cNvPr>
@@ -6806,7 +6816,7 @@
           <p:cNvPr id="3" name="slide-title">
             <a:extLst xmlns:a="http://schemas.openxmlformats.org/drawingml/2006/main">
               <a:ext uri="{FF2B5EF4-FFF2-40B4-BE49-F238E27FC236}">
-                <a16:creationId xmlns:a16="http://schemas.microsoft.com/office/drawing/2014/main" id="{88C37157-50FE-4C07-B090-354EB72733E1}"/>
+                <a16:creationId xmlns:a16="http://schemas.microsoft.com/office/drawing/2014/main" id="{6B1CB3AA-5C26-4422-95C6-2E5C09374F1E}"/>
               </a:ext>
             </a:extLst>
           </p:cNvPr>
@@ -6897,7 +6907,7 @@
           <p:cNvPr id="4" name="body">
             <a:extLst xmlns:a="http://schemas.openxmlformats.org/drawingml/2006/main">
               <a:ext uri="{FF2B5EF4-FFF2-40B4-BE49-F238E27FC236}">
-                <a16:creationId xmlns:a16="http://schemas.microsoft.com/office/drawing/2014/main" id="{1A2B2E74-BBB6-44D8-B103-4212E1D2ED47}"/>
+                <a16:creationId xmlns:a16="http://schemas.microsoft.com/office/drawing/2014/main" id="{6A58751E-1573-43F5-85D9-3CE95CC4A20D}"/>
               </a:ext>
             </a:extLst>
           </p:cNvPr>
@@ -6986,7 +6996,7 @@
     </p:spTree>
     <p:extLst>
       <p:ext uri="{BB962C8B-B14F-4D97-AF65-F5344CB8AC3E}">
-        <p14:creationId xmlns:p14="http://schemas.microsoft.com/office/powerpoint/2010/main" val="100332363"/>
+        <p14:creationId xmlns:p14="http://schemas.microsoft.com/office/powerpoint/2010/main" val="646556945"/>
       </p:ext>
     </p:extLst>
   </p:cSld>
@@ -7017,7 +7027,7 @@
           <p:cNvPr id="9" name="slide-title">
             <a:extLst xmlns:a="http://schemas.openxmlformats.org/drawingml/2006/main">
               <a:ext uri="{FF2B5EF4-FFF2-40B4-BE49-F238E27FC236}">
-                <a16:creationId xmlns:a16="http://schemas.microsoft.com/office/drawing/2014/main" id="{15D30276-A47F-4C36-838C-D3B33E6DC4B2}"/>
+                <a16:creationId xmlns:a16="http://schemas.microsoft.com/office/drawing/2014/main" id="{99263C92-40ED-44EB-B803-073165ADE0AE}"/>
               </a:ext>
             </a:extLst>
           </p:cNvPr>
@@ -7085,7 +7095,7 @@
           <p:cNvPr id="2" name="body">
             <a:extLst xmlns:a="http://schemas.openxmlformats.org/drawingml/2006/main">
               <a:ext uri="{FF2B5EF4-FFF2-40B4-BE49-F238E27FC236}">
-                <a16:creationId xmlns:a16="http://schemas.microsoft.com/office/drawing/2014/main" id="{E018D823-13E5-4E9D-8FA0-E8146783A9A3}"/>
+                <a16:creationId xmlns:a16="http://schemas.microsoft.com/office/drawing/2014/main" id="{45915EA8-881B-4F3B-96F1-4B7F1F4ECD10}"/>
               </a:ext>
             </a:extLst>
           </p:cNvPr>
@@ -7153,7 +7163,7 @@
           <p:cNvPr id="3" name="chapter-label">
             <a:extLst xmlns:a="http://schemas.openxmlformats.org/drawingml/2006/main">
               <a:ext uri="{FF2B5EF4-FFF2-40B4-BE49-F238E27FC236}">
-                <a16:creationId xmlns:a16="http://schemas.microsoft.com/office/drawing/2014/main" id="{FFAC5823-5034-4061-91D8-5C0764214337}"/>
+                <a16:creationId xmlns:a16="http://schemas.microsoft.com/office/drawing/2014/main" id="{76B77665-03B2-4582-BF02-073AC9D28522}"/>
               </a:ext>
             </a:extLst>
           </p:cNvPr>
@@ -7221,7 +7231,7 @@
           <p:cNvPr id="4" name="body">
             <a:extLst xmlns:a="http://schemas.openxmlformats.org/drawingml/2006/main">
               <a:ext uri="{FF2B5EF4-FFF2-40B4-BE49-F238E27FC236}">
-                <a16:creationId xmlns:a16="http://schemas.microsoft.com/office/drawing/2014/main" id="{FC4DD26A-324E-4F95-8EAB-F3CDD7BDE31E}"/>
+                <a16:creationId xmlns:a16="http://schemas.microsoft.com/office/drawing/2014/main" id="{1F07659E-5664-42D9-B633-A70CC99BCAFF}"/>
               </a:ext>
             </a:extLst>
           </p:cNvPr>
@@ -7289,7 +7299,7 @@
           <p:cNvPr id="5" name="">
             <a:extLst xmlns:a="http://schemas.openxmlformats.org/drawingml/2006/main">
               <a:ext uri="{FF2B5EF4-FFF2-40B4-BE49-F238E27FC236}">
-                <a16:creationId xmlns:a16="http://schemas.microsoft.com/office/drawing/2014/main" id="{1CD0EF67-7248-4945-BB73-843AA561FE2E}"/>
+                <a16:creationId xmlns:a16="http://schemas.microsoft.com/office/drawing/2014/main" id="{9479554D-6085-4858-BDA2-ED340EC13B4E}"/>
               </a:ext>
             </a:extLst>
           </p:cNvPr>
@@ -7961,7 +7971,7 @@
           <p:cNvPr id="6" name="body">
             <a:extLst xmlns:a="http://schemas.openxmlformats.org/drawingml/2006/main">
               <a:ext uri="{FF2B5EF4-FFF2-40B4-BE49-F238E27FC236}">
-                <a16:creationId xmlns:a16="http://schemas.microsoft.com/office/drawing/2014/main" id="{0AC4E718-E343-4F24-AA89-B2FE5972454F}"/>
+                <a16:creationId xmlns:a16="http://schemas.microsoft.com/office/drawing/2014/main" id="{01986DD8-1866-4EA2-AE96-517A1F5119B3}"/>
               </a:ext>
             </a:extLst>
           </p:cNvPr>
@@ -8029,7 +8039,7 @@
           <p:cNvPr id="7" name="body">
             <a:extLst xmlns:a="http://schemas.openxmlformats.org/drawingml/2006/main">
               <a:ext uri="{FF2B5EF4-FFF2-40B4-BE49-F238E27FC236}">
-                <a16:creationId xmlns:a16="http://schemas.microsoft.com/office/drawing/2014/main" id="{6A8CC6A9-C97B-4A7A-9F9F-9525BFC948D5}"/>
+                <a16:creationId xmlns:a16="http://schemas.microsoft.com/office/drawing/2014/main" id="{82E688CA-C321-4659-A19E-8918CD88606B}"/>
               </a:ext>
             </a:extLst>
           </p:cNvPr>
@@ -8097,7 +8107,7 @@
           <p:cNvPr id="8" name="body">
             <a:extLst xmlns:a="http://schemas.openxmlformats.org/drawingml/2006/main">
               <a:ext uri="{FF2B5EF4-FFF2-40B4-BE49-F238E27FC236}">
-                <a16:creationId xmlns:a16="http://schemas.microsoft.com/office/drawing/2014/main" id="{E14E4B43-43B1-4345-BECC-81705634F535}"/>
+                <a16:creationId xmlns:a16="http://schemas.microsoft.com/office/drawing/2014/main" id="{2F46E8FC-F8E1-4097-9330-20762E395AAA}"/>
               </a:ext>
             </a:extLst>
           </p:cNvPr>
@@ -8163,7 +8173,7 @@
     </p:spTree>
     <p:extLst>
       <p:ext uri="{BB962C8B-B14F-4D97-AF65-F5344CB8AC3E}">
-        <p14:creationId xmlns:p14="http://schemas.microsoft.com/office/powerpoint/2010/main" val="1713154136"/>
+        <p14:creationId xmlns:p14="http://schemas.microsoft.com/office/powerpoint/2010/main" val="120002988"/>
       </p:ext>
     </p:extLst>
   </p:cSld>
@@ -8194,7 +8204,7 @@
           <p:cNvPr id="10" name="slide-title">
             <a:extLst xmlns:a="http://schemas.openxmlformats.org/drawingml/2006/main">
               <a:ext uri="{FF2B5EF4-FFF2-40B4-BE49-F238E27FC236}">
-                <a16:creationId xmlns:a16="http://schemas.microsoft.com/office/drawing/2014/main" id="{7720AFB9-D54D-4144-85F5-D1F99DA45615}"/>
+                <a16:creationId xmlns:a16="http://schemas.microsoft.com/office/drawing/2014/main" id="{8626D012-6FB2-4ED4-BDD1-DEF5E2734D15}"/>
               </a:ext>
             </a:extLst>
           </p:cNvPr>
@@ -8262,7 +8272,7 @@
           <p:cNvPr id="2" name="body">
             <a:extLst xmlns:a="http://schemas.openxmlformats.org/drawingml/2006/main">
               <a:ext uri="{FF2B5EF4-FFF2-40B4-BE49-F238E27FC236}">
-                <a16:creationId xmlns:a16="http://schemas.microsoft.com/office/drawing/2014/main" id="{75BCA7E1-E20B-4BFB-9007-FE573C907477}"/>
+                <a16:creationId xmlns:a16="http://schemas.microsoft.com/office/drawing/2014/main" id="{E5975E65-E3BB-4290-A2CF-185041E2227C}"/>
               </a:ext>
             </a:extLst>
           </p:cNvPr>
@@ -8330,7 +8340,7 @@
           <p:cNvPr id="3" name="chapter-label">
             <a:extLst xmlns:a="http://schemas.openxmlformats.org/drawingml/2006/main">
               <a:ext uri="{FF2B5EF4-FFF2-40B4-BE49-F238E27FC236}">
-                <a16:creationId xmlns:a16="http://schemas.microsoft.com/office/drawing/2014/main" id="{176F85DD-9C2E-4F83-B171-66880BCCA858}"/>
+                <a16:creationId xmlns:a16="http://schemas.microsoft.com/office/drawing/2014/main" id="{7932988E-8BFD-49A4-B0EA-062092A69AAF}"/>
               </a:ext>
             </a:extLst>
           </p:cNvPr>
@@ -8398,7 +8408,7 @@
           <p:cNvPr id="4" name="body">
             <a:extLst xmlns:a="http://schemas.openxmlformats.org/drawingml/2006/main">
               <a:ext uri="{FF2B5EF4-FFF2-40B4-BE49-F238E27FC236}">
-                <a16:creationId xmlns:a16="http://schemas.microsoft.com/office/drawing/2014/main" id="{90B824CF-20AC-49CE-BDC0-624CF733E9D9}"/>
+                <a16:creationId xmlns:a16="http://schemas.microsoft.com/office/drawing/2014/main" id="{D62B1287-7629-426E-8E63-80D87BCEE511}"/>
               </a:ext>
             </a:extLst>
           </p:cNvPr>
@@ -8466,7 +8476,7 @@
           <p:cNvPr id="5" name="body">
             <a:extLst xmlns:a="http://schemas.openxmlformats.org/drawingml/2006/main">
               <a:ext uri="{FF2B5EF4-FFF2-40B4-BE49-F238E27FC236}">
-                <a16:creationId xmlns:a16="http://schemas.microsoft.com/office/drawing/2014/main" id="{FB9CB76E-6035-485D-8666-18542AF3A44B}"/>
+                <a16:creationId xmlns:a16="http://schemas.microsoft.com/office/drawing/2014/main" id="{8ECC1926-BAC1-4C3D-B176-188F5A6CC619}"/>
               </a:ext>
             </a:extLst>
           </p:cNvPr>
@@ -8557,7 +8567,7 @@
           <p:cNvPr id="6" name="body">
             <a:extLst xmlns:a="http://schemas.openxmlformats.org/drawingml/2006/main">
               <a:ext uri="{FF2B5EF4-FFF2-40B4-BE49-F238E27FC236}">
-                <a16:creationId xmlns:a16="http://schemas.microsoft.com/office/drawing/2014/main" id="{6B163068-14CE-4AF3-B47B-4B77254D6526}"/>
+                <a16:creationId xmlns:a16="http://schemas.microsoft.com/office/drawing/2014/main" id="{136A4894-60B7-409C-8D5E-196598133216}"/>
               </a:ext>
             </a:extLst>
           </p:cNvPr>
@@ -8625,7 +8635,7 @@
           <p:cNvPr id="7" name="Chart">
             <a:extLst xmlns:a="http://schemas.openxmlformats.org/drawingml/2006/main">
               <a:ext uri="{FF2B5EF4-FFF2-40B4-BE49-F238E27FC236}">
-                <a16:creationId xmlns:a16="http://schemas.microsoft.com/office/drawing/2014/main" id="{AEC4F066-8F4C-4D69-B91B-6CDEEE05B9B8}"/>
+                <a16:creationId xmlns:a16="http://schemas.microsoft.com/office/drawing/2014/main" id="{991CAC92-2A6F-4210-A9A2-90B9425F3360}"/>
               </a:ext>
             </a:extLst>
           </p:cNvPr>
@@ -8638,7 +8648,7 @@
         </p:xfrm>
         <a:graphic xmlns:a="http://schemas.openxmlformats.org/drawingml/2006/main">
           <a:graphicData uri="http://schemas.openxmlformats.org/drawingml/2006/chart">
-            <c:chart xmlns:r="http://schemas.openxmlformats.org/officeDocument/2006/relationships" xmlns:c="http://schemas.openxmlformats.org/drawingml/2006/chart" r:id="Rc07fa08994674ee6"/>
+            <c:chart xmlns:r="http://schemas.openxmlformats.org/officeDocument/2006/relationships" xmlns:c="http://schemas.openxmlformats.org/drawingml/2006/chart" r:id="Rac3cc4c481a54c3e"/>
           </a:graphicData>
         </a:graphic>
       </p:graphicFrame>
@@ -8647,7 +8657,7 @@
           <p:cNvPr id="8" name="body">
             <a:extLst xmlns:a="http://schemas.openxmlformats.org/drawingml/2006/main">
               <a:ext uri="{FF2B5EF4-FFF2-40B4-BE49-F238E27FC236}">
-                <a16:creationId xmlns:a16="http://schemas.microsoft.com/office/drawing/2014/main" id="{A974229A-EDB2-41A0-B151-A8ECEC5A802C}"/>
+                <a16:creationId xmlns:a16="http://schemas.microsoft.com/office/drawing/2014/main" id="{D389A2B6-FAD4-449D-8D0D-AE001BB507E9}"/>
               </a:ext>
             </a:extLst>
           </p:cNvPr>
@@ -8715,7 +8725,7 @@
           <p:cNvPr id="9" name="body">
             <a:extLst xmlns:a="http://schemas.openxmlformats.org/drawingml/2006/main">
               <a:ext uri="{FF2B5EF4-FFF2-40B4-BE49-F238E27FC236}">
-                <a16:creationId xmlns:a16="http://schemas.microsoft.com/office/drawing/2014/main" id="{036E8E64-8B31-4357-B179-9C7E68B68685}"/>
+                <a16:creationId xmlns:a16="http://schemas.microsoft.com/office/drawing/2014/main" id="{E394285C-95B4-4B29-9BB1-E7518223E35E}"/>
               </a:ext>
             </a:extLst>
           </p:cNvPr>
@@ -8781,7 +8791,7 @@
     </p:spTree>
     <p:extLst>
       <p:ext uri="{BB962C8B-B14F-4D97-AF65-F5344CB8AC3E}">
-        <p14:creationId xmlns:p14="http://schemas.microsoft.com/office/powerpoint/2010/main" val="2075741362"/>
+        <p14:creationId xmlns:p14="http://schemas.microsoft.com/office/powerpoint/2010/main" val="1398171590"/>
       </p:ext>
     </p:extLst>
   </p:cSld>
@@ -8812,7 +8822,7 @@
           <p:cNvPr id="10" name="slide-title">
             <a:extLst xmlns:a="http://schemas.openxmlformats.org/drawingml/2006/main">
               <a:ext uri="{FF2B5EF4-FFF2-40B4-BE49-F238E27FC236}">
-                <a16:creationId xmlns:a16="http://schemas.microsoft.com/office/drawing/2014/main" id="{1E61C685-D9D3-47BB-AA75-ACF7DDF08201}"/>
+                <a16:creationId xmlns:a16="http://schemas.microsoft.com/office/drawing/2014/main" id="{FB1B0D76-909B-4561-B5EA-04C4E510A3A9}"/>
               </a:ext>
             </a:extLst>
           </p:cNvPr>
@@ -8880,7 +8890,7 @@
           <p:cNvPr id="2" name="body">
             <a:extLst xmlns:a="http://schemas.openxmlformats.org/drawingml/2006/main">
               <a:ext uri="{FF2B5EF4-FFF2-40B4-BE49-F238E27FC236}">
-                <a16:creationId xmlns:a16="http://schemas.microsoft.com/office/drawing/2014/main" id="{82D5C072-0910-4AD5-8457-7D2FC07B8B1E}"/>
+                <a16:creationId xmlns:a16="http://schemas.microsoft.com/office/drawing/2014/main" id="{B04EE246-BE80-404F-AAAF-0D70331E5D0A}"/>
               </a:ext>
             </a:extLst>
           </p:cNvPr>
@@ -8948,7 +8958,7 @@
           <p:cNvPr id="3" name="chapter-label">
             <a:extLst xmlns:a="http://schemas.openxmlformats.org/drawingml/2006/main">
               <a:ext uri="{FF2B5EF4-FFF2-40B4-BE49-F238E27FC236}">
-                <a16:creationId xmlns:a16="http://schemas.microsoft.com/office/drawing/2014/main" id="{5563DEE0-7EB4-4339-B65B-87FDCD9628BE}"/>
+                <a16:creationId xmlns:a16="http://schemas.microsoft.com/office/drawing/2014/main" id="{A2D8BD25-D2C5-4B8C-898B-5F78C8A684AC}"/>
               </a:ext>
             </a:extLst>
           </p:cNvPr>
@@ -9016,7 +9026,7 @@
           <p:cNvPr id="4" name="body">
             <a:extLst xmlns:a="http://schemas.openxmlformats.org/drawingml/2006/main">
               <a:ext uri="{FF2B5EF4-FFF2-40B4-BE49-F238E27FC236}">
-                <a16:creationId xmlns:a16="http://schemas.microsoft.com/office/drawing/2014/main" id="{57DE6EF4-FEA9-4F43-90C8-4F573C5EFEFF}"/>
+                <a16:creationId xmlns:a16="http://schemas.microsoft.com/office/drawing/2014/main" id="{71A8169A-2843-48C1-ABDC-B33CC71E32B7}"/>
               </a:ext>
             </a:extLst>
           </p:cNvPr>
@@ -9084,7 +9094,7 @@
           <p:cNvPr id="5" name="body">
             <a:extLst xmlns:a="http://schemas.openxmlformats.org/drawingml/2006/main">
               <a:ext uri="{FF2B5EF4-FFF2-40B4-BE49-F238E27FC236}">
-                <a16:creationId xmlns:a16="http://schemas.microsoft.com/office/drawing/2014/main" id="{9C29F066-4281-4E21-8607-C82DD9E53C9D}"/>
+                <a16:creationId xmlns:a16="http://schemas.microsoft.com/office/drawing/2014/main" id="{47ECB1A8-5697-499B-AFA1-90D1A0560FAC}"/>
               </a:ext>
             </a:extLst>
           </p:cNvPr>
@@ -9152,7 +9162,7 @@
           <p:cNvPr id="6" name="Chart">
             <a:extLst xmlns:a="http://schemas.openxmlformats.org/drawingml/2006/main">
               <a:ext uri="{FF2B5EF4-FFF2-40B4-BE49-F238E27FC236}">
-                <a16:creationId xmlns:a16="http://schemas.microsoft.com/office/drawing/2014/main" id="{1AC5D004-05DE-48E5-BB65-0EA2A40CE697}"/>
+                <a16:creationId xmlns:a16="http://schemas.microsoft.com/office/drawing/2014/main" id="{D2F0D9D3-BB86-47EB-A425-19A5187E7930}"/>
               </a:ext>
             </a:extLst>
           </p:cNvPr>
@@ -9165,7 +9175,7 @@
         </p:xfrm>
         <a:graphic xmlns:a="http://schemas.openxmlformats.org/drawingml/2006/main">
           <a:graphicData uri="http://schemas.openxmlformats.org/drawingml/2006/chart">
-            <c:chart xmlns:r="http://schemas.openxmlformats.org/officeDocument/2006/relationships" xmlns:c="http://schemas.openxmlformats.org/drawingml/2006/chart" r:id="R05a0afb60b7c4c1a"/>
+            <c:chart xmlns:r="http://schemas.openxmlformats.org/officeDocument/2006/relationships" xmlns:c="http://schemas.openxmlformats.org/drawingml/2006/chart" r:id="Ra33cb5ef86f94f5d"/>
           </a:graphicData>
         </a:graphic>
       </p:graphicFrame>
@@ -9174,7 +9184,7 @@
           <p:cNvPr id="7" name="body">
             <a:extLst xmlns:a="http://schemas.openxmlformats.org/drawingml/2006/main">
               <a:ext uri="{FF2B5EF4-FFF2-40B4-BE49-F238E27FC236}">
-                <a16:creationId xmlns:a16="http://schemas.microsoft.com/office/drawing/2014/main" id="{41797AEF-F610-4F94-92B9-CD453D2BB467}"/>
+                <a16:creationId xmlns:a16="http://schemas.microsoft.com/office/drawing/2014/main" id="{C64F8072-B6E0-475E-BB18-9B9233A24922}"/>
               </a:ext>
             </a:extLst>
           </p:cNvPr>
@@ -9265,7 +9275,7 @@
           <p:cNvPr id="8" name="body">
             <a:extLst xmlns:a="http://schemas.openxmlformats.org/drawingml/2006/main">
               <a:ext uri="{FF2B5EF4-FFF2-40B4-BE49-F238E27FC236}">
-                <a16:creationId xmlns:a16="http://schemas.microsoft.com/office/drawing/2014/main" id="{E6CB852D-BEE7-4652-91A8-E4BAA53D05E3}"/>
+                <a16:creationId xmlns:a16="http://schemas.microsoft.com/office/drawing/2014/main" id="{8933EBC6-F0BE-4FC7-8688-3E15175AE1F3}"/>
               </a:ext>
             </a:extLst>
           </p:cNvPr>
@@ -9356,7 +9366,7 @@
           <p:cNvPr id="9" name="body">
             <a:extLst xmlns:a="http://schemas.openxmlformats.org/drawingml/2006/main">
               <a:ext uri="{FF2B5EF4-FFF2-40B4-BE49-F238E27FC236}">
-                <a16:creationId xmlns:a16="http://schemas.microsoft.com/office/drawing/2014/main" id="{D88F58A4-D15C-4F40-83EF-0160CB75BD35}"/>
+                <a16:creationId xmlns:a16="http://schemas.microsoft.com/office/drawing/2014/main" id="{260E9858-814B-46ED-9DEF-D5A6FC924164}"/>
               </a:ext>
             </a:extLst>
           </p:cNvPr>
@@ -9422,7 +9432,7 @@
     </p:spTree>
     <p:extLst>
       <p:ext uri="{BB962C8B-B14F-4D97-AF65-F5344CB8AC3E}">
-        <p14:creationId xmlns:p14="http://schemas.microsoft.com/office/powerpoint/2010/main" val="955731018"/>
+        <p14:creationId xmlns:p14="http://schemas.microsoft.com/office/powerpoint/2010/main" val="602252782"/>
       </p:ext>
     </p:extLst>
   </p:cSld>
@@ -9453,7 +9463,7 @@
           <p:cNvPr id="19" name="slide-title">
             <a:extLst xmlns:a="http://schemas.openxmlformats.org/drawingml/2006/main">
               <a:ext uri="{FF2B5EF4-FFF2-40B4-BE49-F238E27FC236}">
-                <a16:creationId xmlns:a16="http://schemas.microsoft.com/office/drawing/2014/main" id="{9D234EB1-395C-4F92-AFC3-E857FA769706}"/>
+                <a16:creationId xmlns:a16="http://schemas.microsoft.com/office/drawing/2014/main" id="{A8D1C474-0F43-4DC0-BE78-F4799F864DDF}"/>
               </a:ext>
             </a:extLst>
           </p:cNvPr>
@@ -9521,7 +9531,7 @@
           <p:cNvPr id="2" name="body">
             <a:extLst xmlns:a="http://schemas.openxmlformats.org/drawingml/2006/main">
               <a:ext uri="{FF2B5EF4-FFF2-40B4-BE49-F238E27FC236}">
-                <a16:creationId xmlns:a16="http://schemas.microsoft.com/office/drawing/2014/main" id="{4CAFFCC7-A3F7-40BA-A2AB-989120C76C6A}"/>
+                <a16:creationId xmlns:a16="http://schemas.microsoft.com/office/drawing/2014/main" id="{64E492FE-96E4-48F9-957F-7603A6DB9BC6}"/>
               </a:ext>
             </a:extLst>
           </p:cNvPr>
@@ -9589,7 +9599,7 @@
           <p:cNvPr id="3" name="chapter-label">
             <a:extLst xmlns:a="http://schemas.openxmlformats.org/drawingml/2006/main">
               <a:ext uri="{FF2B5EF4-FFF2-40B4-BE49-F238E27FC236}">
-                <a16:creationId xmlns:a16="http://schemas.microsoft.com/office/drawing/2014/main" id="{4D4A0B0E-D3D7-49CC-A8C9-D57A68541DC1}"/>
+                <a16:creationId xmlns:a16="http://schemas.microsoft.com/office/drawing/2014/main" id="{557CAF62-21D9-4CC5-B956-96905DE3444E}"/>
               </a:ext>
             </a:extLst>
           </p:cNvPr>
@@ -9657,7 +9667,7 @@
           <p:cNvPr id="4" name="body">
             <a:extLst xmlns:a="http://schemas.openxmlformats.org/drawingml/2006/main">
               <a:ext uri="{FF2B5EF4-FFF2-40B4-BE49-F238E27FC236}">
-                <a16:creationId xmlns:a16="http://schemas.microsoft.com/office/drawing/2014/main" id="{D761E317-658E-48C3-84B1-A173BAD22074}"/>
+                <a16:creationId xmlns:a16="http://schemas.microsoft.com/office/drawing/2014/main" id="{519B5AA9-42BF-40CC-B88E-A1EB93873DD5}"/>
               </a:ext>
             </a:extLst>
           </p:cNvPr>
@@ -9725,7 +9735,7 @@
           <p:cNvPr id="5" name="body">
             <a:extLst xmlns:a="http://schemas.openxmlformats.org/drawingml/2006/main">
               <a:ext uri="{FF2B5EF4-FFF2-40B4-BE49-F238E27FC236}">
-                <a16:creationId xmlns:a16="http://schemas.microsoft.com/office/drawing/2014/main" id="{BD691AB4-6B37-405E-88E7-E7BB2615C874}"/>
+                <a16:creationId xmlns:a16="http://schemas.microsoft.com/office/drawing/2014/main" id="{C6F357D5-FDD5-4C7F-B10E-78D9AA23A593}"/>
               </a:ext>
             </a:extLst>
           </p:cNvPr>
@@ -9793,7 +9803,7 @@
           <p:cNvPr id="6" name="body">
             <a:extLst xmlns:a="http://schemas.openxmlformats.org/drawingml/2006/main">
               <a:ext uri="{FF2B5EF4-FFF2-40B4-BE49-F238E27FC236}">
-                <a16:creationId xmlns:a16="http://schemas.microsoft.com/office/drawing/2014/main" id="{7198F25C-582A-430E-945B-C75A4CE62414}"/>
+                <a16:creationId xmlns:a16="http://schemas.microsoft.com/office/drawing/2014/main" id="{26ED182D-F388-420A-B295-FA937DBDFF96}"/>
               </a:ext>
             </a:extLst>
           </p:cNvPr>
@@ -9861,7 +9871,7 @@
           <p:cNvPr id="7" name="body">
             <a:extLst xmlns:a="http://schemas.openxmlformats.org/drawingml/2006/main">
               <a:ext uri="{FF2B5EF4-FFF2-40B4-BE49-F238E27FC236}">
-                <a16:creationId xmlns:a16="http://schemas.microsoft.com/office/drawing/2014/main" id="{0589FF43-858D-4109-B186-3A04CD90D05D}"/>
+                <a16:creationId xmlns:a16="http://schemas.microsoft.com/office/drawing/2014/main" id="{BC317185-DBC8-408C-88AA-72E018679161}"/>
               </a:ext>
             </a:extLst>
           </p:cNvPr>
@@ -9929,7 +9939,7 @@
           <p:cNvPr id="8" name="body">
             <a:extLst xmlns:a="http://schemas.openxmlformats.org/drawingml/2006/main">
               <a:ext uri="{FF2B5EF4-FFF2-40B4-BE49-F238E27FC236}">
-                <a16:creationId xmlns:a16="http://schemas.microsoft.com/office/drawing/2014/main" id="{A40C758F-6FB5-4F23-8980-CA9F009DC4F6}"/>
+                <a16:creationId xmlns:a16="http://schemas.microsoft.com/office/drawing/2014/main" id="{B1AC47AB-4C22-4D11-AFFC-55BB60DD6F38}"/>
               </a:ext>
             </a:extLst>
           </p:cNvPr>
@@ -9997,7 +10007,7 @@
           <p:cNvPr id="9" name="body">
             <a:extLst xmlns:a="http://schemas.openxmlformats.org/drawingml/2006/main">
               <a:ext uri="{FF2B5EF4-FFF2-40B4-BE49-F238E27FC236}">
-                <a16:creationId xmlns:a16="http://schemas.microsoft.com/office/drawing/2014/main" id="{95F585C2-F83B-47A1-80FE-F0577D103B10}"/>
+                <a16:creationId xmlns:a16="http://schemas.microsoft.com/office/drawing/2014/main" id="{428E2A5A-5FD4-49DF-9AD1-71028AA8657C}"/>
               </a:ext>
             </a:extLst>
           </p:cNvPr>
@@ -10065,7 +10075,7 @@
           <p:cNvPr id="10" name="body">
             <a:extLst xmlns:a="http://schemas.openxmlformats.org/drawingml/2006/main">
               <a:ext uri="{FF2B5EF4-FFF2-40B4-BE49-F238E27FC236}">
-                <a16:creationId xmlns:a16="http://schemas.microsoft.com/office/drawing/2014/main" id="{EFCEDC2B-5077-44D3-B351-9F0DFC908553}"/>
+                <a16:creationId xmlns:a16="http://schemas.microsoft.com/office/drawing/2014/main" id="{E6BC64C1-CE31-48CC-BA02-F8E6C08027C5}"/>
               </a:ext>
             </a:extLst>
           </p:cNvPr>
@@ -10133,7 +10143,7 @@
           <p:cNvPr id="11" name="body">
             <a:extLst xmlns:a="http://schemas.openxmlformats.org/drawingml/2006/main">
               <a:ext uri="{FF2B5EF4-FFF2-40B4-BE49-F238E27FC236}">
-                <a16:creationId xmlns:a16="http://schemas.microsoft.com/office/drawing/2014/main" id="{4AC29DBA-43A8-45EE-A3A3-F409AF69E67E}"/>
+                <a16:creationId xmlns:a16="http://schemas.microsoft.com/office/drawing/2014/main" id="{11980ABB-3216-4B9D-B0D1-D5DD52A94364}"/>
               </a:ext>
             </a:extLst>
           </p:cNvPr>
@@ -10201,7 +10211,7 @@
           <p:cNvPr id="12" name="body">
             <a:extLst xmlns:a="http://schemas.openxmlformats.org/drawingml/2006/main">
               <a:ext uri="{FF2B5EF4-FFF2-40B4-BE49-F238E27FC236}">
-                <a16:creationId xmlns:a16="http://schemas.microsoft.com/office/drawing/2014/main" id="{A63B4FBF-E6BE-439F-9E84-8CF854E9F3D7}"/>
+                <a16:creationId xmlns:a16="http://schemas.microsoft.com/office/drawing/2014/main" id="{613C70C7-78B8-4ED1-AE3F-E8679352AB34}"/>
               </a:ext>
             </a:extLst>
           </p:cNvPr>
@@ -10269,7 +10279,7 @@
           <p:cNvPr id="13" name="body">
             <a:extLst xmlns:a="http://schemas.openxmlformats.org/drawingml/2006/main">
               <a:ext uri="{FF2B5EF4-FFF2-40B4-BE49-F238E27FC236}">
-                <a16:creationId xmlns:a16="http://schemas.microsoft.com/office/drawing/2014/main" id="{451DCF7D-533C-4402-A33B-BFF5783AD28C}"/>
+                <a16:creationId xmlns:a16="http://schemas.microsoft.com/office/drawing/2014/main" id="{13A4CE63-CB47-4BA6-BFC8-4DEE79469CC1}"/>
               </a:ext>
             </a:extLst>
           </p:cNvPr>
@@ -10337,7 +10347,7 @@
           <p:cNvPr id="14" name="body">
             <a:extLst xmlns:a="http://schemas.openxmlformats.org/drawingml/2006/main">
               <a:ext uri="{FF2B5EF4-FFF2-40B4-BE49-F238E27FC236}">
-                <a16:creationId xmlns:a16="http://schemas.microsoft.com/office/drawing/2014/main" id="{A510D984-BDD3-4D97-8A57-A4772D85CEDD}"/>
+                <a16:creationId xmlns:a16="http://schemas.microsoft.com/office/drawing/2014/main" id="{062B07E2-E05A-4B18-87FD-D7521EFEE134}"/>
               </a:ext>
             </a:extLst>
           </p:cNvPr>
@@ -10405,7 +10415,7 @@
           <p:cNvPr id="15" name="body">
             <a:extLst xmlns:a="http://schemas.openxmlformats.org/drawingml/2006/main">
               <a:ext uri="{FF2B5EF4-FFF2-40B4-BE49-F238E27FC236}">
-                <a16:creationId xmlns:a16="http://schemas.microsoft.com/office/drawing/2014/main" id="{7260632E-26F4-4B50-9FEE-A10821EA78E3}"/>
+                <a16:creationId xmlns:a16="http://schemas.microsoft.com/office/drawing/2014/main" id="{833761B7-5A07-4733-8B64-0F2C60E1AB17}"/>
               </a:ext>
             </a:extLst>
           </p:cNvPr>
@@ -10496,7 +10506,7 @@
           <p:cNvPr id="16" name="body">
             <a:extLst xmlns:a="http://schemas.openxmlformats.org/drawingml/2006/main">
               <a:ext uri="{FF2B5EF4-FFF2-40B4-BE49-F238E27FC236}">
-                <a16:creationId xmlns:a16="http://schemas.microsoft.com/office/drawing/2014/main" id="{3A8FD1AA-4F1B-4DF1-8854-2FC291A97AB7}"/>
+                <a16:creationId xmlns:a16="http://schemas.microsoft.com/office/drawing/2014/main" id="{233FF17C-E1DA-400D-A506-ABF67DCD880D}"/>
               </a:ext>
             </a:extLst>
           </p:cNvPr>
@@ -10564,7 +10574,7 @@
           <p:cNvPr id="17" name="body">
             <a:extLst xmlns:a="http://schemas.openxmlformats.org/drawingml/2006/main">
               <a:ext uri="{FF2B5EF4-FFF2-40B4-BE49-F238E27FC236}">
-                <a16:creationId xmlns:a16="http://schemas.microsoft.com/office/drawing/2014/main" id="{1D376E1C-7023-44CF-A869-C019F97472EE}"/>
+                <a16:creationId xmlns:a16="http://schemas.microsoft.com/office/drawing/2014/main" id="{7E856546-0507-41B9-955C-A1615B226C88}"/>
               </a:ext>
             </a:extLst>
           </p:cNvPr>
@@ -10655,7 +10665,7 @@
           <p:cNvPr id="18" name="body">
             <a:extLst xmlns:a="http://schemas.openxmlformats.org/drawingml/2006/main">
               <a:ext uri="{FF2B5EF4-FFF2-40B4-BE49-F238E27FC236}">
-                <a16:creationId xmlns:a16="http://schemas.microsoft.com/office/drawing/2014/main" id="{E5EE8EF6-DDF5-4BCB-905E-65D832668CFC}"/>
+                <a16:creationId xmlns:a16="http://schemas.microsoft.com/office/drawing/2014/main" id="{096F195D-C4F4-42D5-8A7E-665CC8592900}"/>
               </a:ext>
             </a:extLst>
           </p:cNvPr>
@@ -10721,7 +10731,7 @@
     </p:spTree>
     <p:extLst>
       <p:ext uri="{BB962C8B-B14F-4D97-AF65-F5344CB8AC3E}">
-        <p14:creationId xmlns:p14="http://schemas.microsoft.com/office/powerpoint/2010/main" val="37236354"/>
+        <p14:creationId xmlns:p14="http://schemas.microsoft.com/office/powerpoint/2010/main" val="1731292718"/>
       </p:ext>
     </p:extLst>
   </p:cSld>
@@ -10752,7 +10762,7 @@
           <p:cNvPr id="7" name="slide-title">
             <a:extLst xmlns:a="http://schemas.openxmlformats.org/drawingml/2006/main">
               <a:ext uri="{FF2B5EF4-FFF2-40B4-BE49-F238E27FC236}">
-                <a16:creationId xmlns:a16="http://schemas.microsoft.com/office/drawing/2014/main" id="{EABECC8A-6E62-43FD-8CEB-5711C9658F23}"/>
+                <a16:creationId xmlns:a16="http://schemas.microsoft.com/office/drawing/2014/main" id="{CCE04C69-A4B2-4863-B0BB-3E23830E53F3}"/>
               </a:ext>
             </a:extLst>
           </p:cNvPr>
@@ -10820,7 +10830,7 @@
           <p:cNvPr id="2" name="body">
             <a:extLst xmlns:a="http://schemas.openxmlformats.org/drawingml/2006/main">
               <a:ext uri="{FF2B5EF4-FFF2-40B4-BE49-F238E27FC236}">
-                <a16:creationId xmlns:a16="http://schemas.microsoft.com/office/drawing/2014/main" id="{9670D774-BFDD-45BC-A8B3-A369B16372E3}"/>
+                <a16:creationId xmlns:a16="http://schemas.microsoft.com/office/drawing/2014/main" id="{C1664D8D-67ED-4DCF-BA80-77AAE3826184}"/>
               </a:ext>
             </a:extLst>
           </p:cNvPr>
@@ -10888,7 +10898,7 @@
           <p:cNvPr id="3" name="chapter-label">
             <a:extLst xmlns:a="http://schemas.openxmlformats.org/drawingml/2006/main">
               <a:ext uri="{FF2B5EF4-FFF2-40B4-BE49-F238E27FC236}">
-                <a16:creationId xmlns:a16="http://schemas.microsoft.com/office/drawing/2014/main" id="{25428CB2-EF23-4D37-82F6-9CA2E50CF994}"/>
+                <a16:creationId xmlns:a16="http://schemas.microsoft.com/office/drawing/2014/main" id="{668CAC9A-6706-4521-A7B6-141EEEF733AD}"/>
               </a:ext>
             </a:extLst>
           </p:cNvPr>
@@ -10956,7 +10966,7 @@
           <p:cNvPr id="4" name="body">
             <a:extLst xmlns:a="http://schemas.openxmlformats.org/drawingml/2006/main">
               <a:ext uri="{FF2B5EF4-FFF2-40B4-BE49-F238E27FC236}">
-                <a16:creationId xmlns:a16="http://schemas.microsoft.com/office/drawing/2014/main" id="{EE5DB2C5-B67F-460C-B9C2-493F266BE79E}"/>
+                <a16:creationId xmlns:a16="http://schemas.microsoft.com/office/drawing/2014/main" id="{5B6E3E3F-251C-460C-996B-ECD8E387B38D}"/>
               </a:ext>
             </a:extLst>
           </p:cNvPr>
@@ -11024,7 +11034,7 @@
           <p:cNvPr id="5" name="">
             <a:extLst xmlns:a="http://schemas.openxmlformats.org/drawingml/2006/main">
               <a:ext uri="{FF2B5EF4-FFF2-40B4-BE49-F238E27FC236}">
-                <a16:creationId xmlns:a16="http://schemas.microsoft.com/office/drawing/2014/main" id="{1845656D-593E-4A01-9152-E79C393899A0}"/>
+                <a16:creationId xmlns:a16="http://schemas.microsoft.com/office/drawing/2014/main" id="{BBDB9738-D5F7-49CA-8447-9BB4AFC0A2FC}"/>
               </a:ext>
             </a:extLst>
           </p:cNvPr>
@@ -11571,7 +11581,7 @@
           <p:cNvPr id="6" name="body">
             <a:extLst xmlns:a="http://schemas.openxmlformats.org/drawingml/2006/main">
               <a:ext uri="{FF2B5EF4-FFF2-40B4-BE49-F238E27FC236}">
-                <a16:creationId xmlns:a16="http://schemas.microsoft.com/office/drawing/2014/main" id="{AFAF6BD1-FE4D-4918-A0D5-0F79AE039071}"/>
+                <a16:creationId xmlns:a16="http://schemas.microsoft.com/office/drawing/2014/main" id="{FEE0150A-CBB2-4474-89AC-D96D245AA9FC}"/>
               </a:ext>
             </a:extLst>
           </p:cNvPr>
@@ -11637,7 +11647,7 @@
     </p:spTree>
     <p:extLst>
       <p:ext uri="{BB962C8B-B14F-4D97-AF65-F5344CB8AC3E}">
-        <p14:creationId xmlns:p14="http://schemas.microsoft.com/office/powerpoint/2010/main" val="893474846"/>
+        <p14:creationId xmlns:p14="http://schemas.microsoft.com/office/powerpoint/2010/main" val="1918127468"/>
       </p:ext>
     </p:extLst>
   </p:cSld>
@@ -11668,7 +11678,7 @@
           <p:cNvPr id="11" name="slide-title">
             <a:extLst xmlns:a="http://schemas.openxmlformats.org/drawingml/2006/main">
               <a:ext uri="{FF2B5EF4-FFF2-40B4-BE49-F238E27FC236}">
-                <a16:creationId xmlns:a16="http://schemas.microsoft.com/office/drawing/2014/main" id="{F7A63762-C3D7-4084-ACC9-7B0138DACE2B}"/>
+                <a16:creationId xmlns:a16="http://schemas.microsoft.com/office/drawing/2014/main" id="{BA654AD7-D9B3-415A-8D57-33EBD82FC509}"/>
               </a:ext>
             </a:extLst>
           </p:cNvPr>
@@ -11736,7 +11746,7 @@
           <p:cNvPr id="2" name="body">
             <a:extLst xmlns:a="http://schemas.openxmlformats.org/drawingml/2006/main">
               <a:ext uri="{FF2B5EF4-FFF2-40B4-BE49-F238E27FC236}">
-                <a16:creationId xmlns:a16="http://schemas.microsoft.com/office/drawing/2014/main" id="{765F0605-5C7D-49D9-978F-1AA45D90FA2F}"/>
+                <a16:creationId xmlns:a16="http://schemas.microsoft.com/office/drawing/2014/main" id="{E0369059-EFA2-4D1D-8B40-A3115DDC7145}"/>
               </a:ext>
             </a:extLst>
           </p:cNvPr>
@@ -11804,7 +11814,7 @@
           <p:cNvPr id="3" name="chapter-label">
             <a:extLst xmlns:a="http://schemas.openxmlformats.org/drawingml/2006/main">
               <a:ext uri="{FF2B5EF4-FFF2-40B4-BE49-F238E27FC236}">
-                <a16:creationId xmlns:a16="http://schemas.microsoft.com/office/drawing/2014/main" id="{E326428B-F398-4A48-8EEB-5F2A1C49267E}"/>
+                <a16:creationId xmlns:a16="http://schemas.microsoft.com/office/drawing/2014/main" id="{AEEB6243-FDCA-4AD9-97FB-9E4B06A4ABB8}"/>
               </a:ext>
             </a:extLst>
           </p:cNvPr>
@@ -11872,7 +11882,7 @@
           <p:cNvPr id="4" name="body">
             <a:extLst xmlns:a="http://schemas.openxmlformats.org/drawingml/2006/main">
               <a:ext uri="{FF2B5EF4-FFF2-40B4-BE49-F238E27FC236}">
-                <a16:creationId xmlns:a16="http://schemas.microsoft.com/office/drawing/2014/main" id="{0D210EE1-EC98-4AD1-A9A1-583BC7F10514}"/>
+                <a16:creationId xmlns:a16="http://schemas.microsoft.com/office/drawing/2014/main" id="{515161BA-6389-4D5C-8A7F-4EE8E51525A9}"/>
               </a:ext>
             </a:extLst>
           </p:cNvPr>
@@ -11940,7 +11950,7 @@
           <p:cNvPr id="5" name="body">
             <a:extLst xmlns:a="http://schemas.openxmlformats.org/drawingml/2006/main">
               <a:ext uri="{FF2B5EF4-FFF2-40B4-BE49-F238E27FC236}">
-                <a16:creationId xmlns:a16="http://schemas.microsoft.com/office/drawing/2014/main" id="{D287D926-2E7A-4189-89CC-7D72E37E46B4}"/>
+                <a16:creationId xmlns:a16="http://schemas.microsoft.com/office/drawing/2014/main" id="{BFF99256-18B0-4C6F-84EE-886B522BEC14}"/>
               </a:ext>
             </a:extLst>
           </p:cNvPr>
@@ -12008,7 +12018,7 @@
           <p:cNvPr id="6" name="body">
             <a:extLst xmlns:a="http://schemas.openxmlformats.org/drawingml/2006/main">
               <a:ext uri="{FF2B5EF4-FFF2-40B4-BE49-F238E27FC236}">
-                <a16:creationId xmlns:a16="http://schemas.microsoft.com/office/drawing/2014/main" id="{B81253ED-7751-4DD3-A0B7-1006DB5CC6BF}"/>
+                <a16:creationId xmlns:a16="http://schemas.microsoft.com/office/drawing/2014/main" id="{8BB85965-6752-4F92-AFED-B6929B088691}"/>
               </a:ext>
             </a:extLst>
           </p:cNvPr>
@@ -12099,7 +12109,7 @@
           <p:cNvPr id="7" name="body">
             <a:extLst xmlns:a="http://schemas.openxmlformats.org/drawingml/2006/main">
               <a:ext uri="{FF2B5EF4-FFF2-40B4-BE49-F238E27FC236}">
-                <a16:creationId xmlns:a16="http://schemas.microsoft.com/office/drawing/2014/main" id="{9CBA461F-6E13-4F4D-9F45-2C6BED27EB72}"/>
+                <a16:creationId xmlns:a16="http://schemas.microsoft.com/office/drawing/2014/main" id="{A1AA3358-D9A7-4933-A247-146E1716A3E0}"/>
               </a:ext>
             </a:extLst>
           </p:cNvPr>
@@ -12167,7 +12177,7 @@
           <p:cNvPr id="8" name="body">
             <a:extLst xmlns:a="http://schemas.openxmlformats.org/drawingml/2006/main">
               <a:ext uri="{FF2B5EF4-FFF2-40B4-BE49-F238E27FC236}">
-                <a16:creationId xmlns:a16="http://schemas.microsoft.com/office/drawing/2014/main" id="{228CF383-3E76-403D-8443-ED4A8A895E96}"/>
+                <a16:creationId xmlns:a16="http://schemas.microsoft.com/office/drawing/2014/main" id="{E26B2A07-BABF-4F1C-8912-7872E8DD744F}"/>
               </a:ext>
             </a:extLst>
           </p:cNvPr>
@@ -12235,7 +12245,7 @@
           <p:cNvPr id="9" name="body">
             <a:extLst xmlns:a="http://schemas.openxmlformats.org/drawingml/2006/main">
               <a:ext uri="{FF2B5EF4-FFF2-40B4-BE49-F238E27FC236}">
-                <a16:creationId xmlns:a16="http://schemas.microsoft.com/office/drawing/2014/main" id="{754ECFF2-EE6E-4503-9B2F-EBDA9973B2A8}"/>
+                <a16:creationId xmlns:a16="http://schemas.microsoft.com/office/drawing/2014/main" id="{01603367-5124-4254-B439-015A432BDD0D}"/>
               </a:ext>
             </a:extLst>
           </p:cNvPr>
@@ -12326,7 +12336,7 @@
           <p:cNvPr id="10" name="body">
             <a:extLst xmlns:a="http://schemas.openxmlformats.org/drawingml/2006/main">
               <a:ext uri="{FF2B5EF4-FFF2-40B4-BE49-F238E27FC236}">
-                <a16:creationId xmlns:a16="http://schemas.microsoft.com/office/drawing/2014/main" id="{3848F358-EDFC-440F-B1A7-7E6949D3EA69}"/>
+                <a16:creationId xmlns:a16="http://schemas.microsoft.com/office/drawing/2014/main" id="{7A717B8B-8C09-4A22-BA24-55FB92ED97C0}"/>
               </a:ext>
             </a:extLst>
           </p:cNvPr>
@@ -12392,7 +12402,7 @@
     </p:spTree>
     <p:extLst>
       <p:ext uri="{BB962C8B-B14F-4D97-AF65-F5344CB8AC3E}">
-        <p14:creationId xmlns:p14="http://schemas.microsoft.com/office/powerpoint/2010/main" val="324109640"/>
+        <p14:creationId xmlns:p14="http://schemas.microsoft.com/office/powerpoint/2010/main" val="1906756552"/>
       </p:ext>
     </p:extLst>
   </p:cSld>
@@ -12420,10 +12430,10 @@
       </p:grpSpPr>
       <p:sp>
         <p:nvSpPr>
-          <p:cNvPr id="15" name="slide-title">
+          <p:cNvPr id="16" name="slide-title">
             <a:extLst xmlns:a="http://schemas.openxmlformats.org/drawingml/2006/main">
               <a:ext uri="{FF2B5EF4-FFF2-40B4-BE49-F238E27FC236}">
-                <a16:creationId xmlns:a16="http://schemas.microsoft.com/office/drawing/2014/main" id="{19B04362-A495-4841-833C-FEA7B3143210}"/>
+                <a16:creationId xmlns:a16="http://schemas.microsoft.com/office/drawing/2014/main" id="{D744B949-4C19-497E-BC2A-1943BEEEAE37}"/>
               </a:ext>
             </a:extLst>
           </p:cNvPr>
@@ -12491,7 +12501,7 @@
           <p:cNvPr id="2" name="body">
             <a:extLst xmlns:a="http://schemas.openxmlformats.org/drawingml/2006/main">
               <a:ext uri="{FF2B5EF4-FFF2-40B4-BE49-F238E27FC236}">
-                <a16:creationId xmlns:a16="http://schemas.microsoft.com/office/drawing/2014/main" id="{78DD944E-AC34-417C-A993-94DD50A0FBCE}"/>
+                <a16:creationId xmlns:a16="http://schemas.microsoft.com/office/drawing/2014/main" id="{A58CB6E9-0CA3-480A-A1FE-CEE215591E96}"/>
               </a:ext>
             </a:extLst>
           </p:cNvPr>
@@ -12559,7 +12569,7 @@
           <p:cNvPr id="3" name="chapter-label">
             <a:extLst xmlns:a="http://schemas.openxmlformats.org/drawingml/2006/main">
               <a:ext uri="{FF2B5EF4-FFF2-40B4-BE49-F238E27FC236}">
-                <a16:creationId xmlns:a16="http://schemas.microsoft.com/office/drawing/2014/main" id="{C70AC071-C8F7-4261-B43A-2A814E07479F}"/>
+                <a16:creationId xmlns:a16="http://schemas.microsoft.com/office/drawing/2014/main" id="{D013E9AD-E057-4DB2-8481-67F27C8F9F22}"/>
               </a:ext>
             </a:extLst>
           </p:cNvPr>
@@ -12627,7 +12637,7 @@
           <p:cNvPr id="4" name="body">
             <a:extLst xmlns:a="http://schemas.openxmlformats.org/drawingml/2006/main">
               <a:ext uri="{FF2B5EF4-FFF2-40B4-BE49-F238E27FC236}">
-                <a16:creationId xmlns:a16="http://schemas.microsoft.com/office/drawing/2014/main" id="{1372856A-3892-4518-9A32-A03F34ADB83A}"/>
+                <a16:creationId xmlns:a16="http://schemas.microsoft.com/office/drawing/2014/main" id="{F61651CE-D8A2-4740-B784-A884FD163AA4}"/>
               </a:ext>
             </a:extLst>
           </p:cNvPr>
@@ -12695,7 +12705,7 @@
           <p:cNvPr id="5" name="body">
             <a:extLst xmlns:a="http://schemas.openxmlformats.org/drawingml/2006/main">
               <a:ext uri="{FF2B5EF4-FFF2-40B4-BE49-F238E27FC236}">
-                <a16:creationId xmlns:a16="http://schemas.microsoft.com/office/drawing/2014/main" id="{7DEC2A21-3F85-4777-A680-408B95B57657}"/>
+                <a16:creationId xmlns:a16="http://schemas.microsoft.com/office/drawing/2014/main" id="{F0AD124A-2635-4F81-8684-E5B65CB88B06}"/>
               </a:ext>
             </a:extLst>
           </p:cNvPr>
@@ -12763,7 +12773,7 @@
           <p:cNvPr id="6" name="body">
             <a:extLst xmlns:a="http://schemas.openxmlformats.org/drawingml/2006/main">
               <a:ext uri="{FF2B5EF4-FFF2-40B4-BE49-F238E27FC236}">
-                <a16:creationId xmlns:a16="http://schemas.microsoft.com/office/drawing/2014/main" id="{8DF6F034-8FD0-4160-AC29-355468FDCACA}"/>
+                <a16:creationId xmlns:a16="http://schemas.microsoft.com/office/drawing/2014/main" id="{CD26FD02-D7F3-4F89-8E61-643DB50C9871}"/>
               </a:ext>
             </a:extLst>
           </p:cNvPr>
@@ -12831,7 +12841,7 @@
           <p:cNvPr id="7" name="body">
             <a:extLst xmlns:a="http://schemas.openxmlformats.org/drawingml/2006/main">
               <a:ext uri="{FF2B5EF4-FFF2-40B4-BE49-F238E27FC236}">
-                <a16:creationId xmlns:a16="http://schemas.microsoft.com/office/drawing/2014/main" id="{51C4B705-080B-494B-B82E-466BA88A6716}"/>
+                <a16:creationId xmlns:a16="http://schemas.microsoft.com/office/drawing/2014/main" id="{9EF8E22B-3DB0-4924-9EDD-FAEE1FD2391D}"/>
               </a:ext>
             </a:extLst>
           </p:cNvPr>
@@ -12899,7 +12909,7 @@
           <p:cNvPr id="8" name="body">
             <a:extLst xmlns:a="http://schemas.openxmlformats.org/drawingml/2006/main">
               <a:ext uri="{FF2B5EF4-FFF2-40B4-BE49-F238E27FC236}">
-                <a16:creationId xmlns:a16="http://schemas.microsoft.com/office/drawing/2014/main" id="{4A38E58B-3E6C-4B3B-A8F0-7E16B4C093B1}"/>
+                <a16:creationId xmlns:a16="http://schemas.microsoft.com/office/drawing/2014/main" id="{4038422B-3357-4B1D-BCF0-49F9E5D494D4}"/>
               </a:ext>
             </a:extLst>
           </p:cNvPr>
@@ -12967,7 +12977,7 @@
           <p:cNvPr id="9" name="body">
             <a:extLst xmlns:a="http://schemas.openxmlformats.org/drawingml/2006/main">
               <a:ext uri="{FF2B5EF4-FFF2-40B4-BE49-F238E27FC236}">
-                <a16:creationId xmlns:a16="http://schemas.microsoft.com/office/drawing/2014/main" id="{A36F4C20-5A69-4C26-A75B-35401986EC02}"/>
+                <a16:creationId xmlns:a16="http://schemas.microsoft.com/office/drawing/2014/main" id="{A1D63AD9-0807-44A3-ABA4-39FE176732C1}"/>
               </a:ext>
             </a:extLst>
           </p:cNvPr>
@@ -13035,7 +13045,7 @@
           <p:cNvPr id="10" name="body">
             <a:extLst xmlns:a="http://schemas.openxmlformats.org/drawingml/2006/main">
               <a:ext uri="{FF2B5EF4-FFF2-40B4-BE49-F238E27FC236}">
-                <a16:creationId xmlns:a16="http://schemas.microsoft.com/office/drawing/2014/main" id="{CA6507D1-DA67-4C3E-8608-879DF0F903AC}"/>
+                <a16:creationId xmlns:a16="http://schemas.microsoft.com/office/drawing/2014/main" id="{BBA30AB6-9349-44E4-B614-CF78E9851169}"/>
               </a:ext>
             </a:extLst>
           </p:cNvPr>
@@ -13103,7 +13113,7 @@
           <p:cNvPr id="11" name="body">
             <a:extLst xmlns:a="http://schemas.openxmlformats.org/drawingml/2006/main">
               <a:ext uri="{FF2B5EF4-FFF2-40B4-BE49-F238E27FC236}">
-                <a16:creationId xmlns:a16="http://schemas.microsoft.com/office/drawing/2014/main" id="{187609D7-0A77-4C21-86CB-2F4286AC622D}"/>
+                <a16:creationId xmlns:a16="http://schemas.microsoft.com/office/drawing/2014/main" id="{B4C6DE05-AA06-4C92-BFF9-70E36F48063F}"/>
               </a:ext>
             </a:extLst>
           </p:cNvPr>
@@ -13171,7 +13181,7 @@
           <p:cNvPr id="12" name="body">
             <a:extLst xmlns:a="http://schemas.openxmlformats.org/drawingml/2006/main">
               <a:ext uri="{FF2B5EF4-FFF2-40B4-BE49-F238E27FC236}">
-                <a16:creationId xmlns:a16="http://schemas.microsoft.com/office/drawing/2014/main" id="{D16948ED-91BF-4F50-BDD3-BE6E67575260}"/>
+                <a16:creationId xmlns:a16="http://schemas.microsoft.com/office/drawing/2014/main" id="{6880A578-DD6F-44E8-A188-6E468701734F}"/>
               </a:ext>
             </a:extLst>
           </p:cNvPr>
@@ -13239,7 +13249,7 @@
           <p:cNvPr id="13" name="body">
             <a:extLst xmlns:a="http://schemas.openxmlformats.org/drawingml/2006/main">
               <a:ext uri="{FF2B5EF4-FFF2-40B4-BE49-F238E27FC236}">
-                <a16:creationId xmlns:a16="http://schemas.microsoft.com/office/drawing/2014/main" id="{99FD87E8-92A0-4756-A2FC-05782CF66D32}"/>
+                <a16:creationId xmlns:a16="http://schemas.microsoft.com/office/drawing/2014/main" id="{71D25734-6090-4BC3-872F-ECDC89EEC673}"/>
               </a:ext>
             </a:extLst>
           </p:cNvPr>
@@ -13307,7 +13317,7 @@
           <p:cNvPr id="14" name="body">
             <a:extLst xmlns:a="http://schemas.openxmlformats.org/drawingml/2006/main">
               <a:ext uri="{FF2B5EF4-FFF2-40B4-BE49-F238E27FC236}">
-                <a16:creationId xmlns:a16="http://schemas.microsoft.com/office/drawing/2014/main" id="{47807D44-C22F-42C3-9952-66971108CE47}"/>
+                <a16:creationId xmlns:a16="http://schemas.microsoft.com/office/drawing/2014/main" id="{E8D711DE-E02B-4C63-A884-6764C256C3C0}"/>
               </a:ext>
             </a:extLst>
           </p:cNvPr>
@@ -13370,10 +13380,78 @@
           </a:p>
         </p:txBody>
       </p:sp>
+      <p:sp>
+        <p:nvSpPr>
+          <p:cNvPr id="15" name="body">
+            <a:extLst xmlns:a="http://schemas.openxmlformats.org/drawingml/2006/main">
+              <a:ext uri="{FF2B5EF4-FFF2-40B4-BE49-F238E27FC236}">
+                <a16:creationId xmlns:a16="http://schemas.microsoft.com/office/drawing/2014/main" id="{D4E56311-AD20-4D63-9395-56174F2140C7}"/>
+              </a:ext>
+            </a:extLst>
+          </p:cNvPr>
+          <p:cNvSpPr>
+            <a:spLocks xmlns:a="http://schemas.openxmlformats.org/drawingml/2006/main" noGrp="1"/>
+          </p:cNvSpPr>
+          <p:nvPr/>
+        </p:nvSpPr>
+        <p:spPr>
+          <a:xfrm xmlns:a="http://schemas.openxmlformats.org/drawingml/2006/main">
+            <a:off x="762000" y="6286500"/>
+            <a:ext cx="9953625" cy="323850"/>
+          </a:xfrm>
+          <a:prstGeom xmlns:a="http://schemas.openxmlformats.org/drawingml/2006/main" prst="rect">
+            <a:avLst/>
+          </a:prstGeom>
+          <a:noFill xmlns:a="http://schemas.openxmlformats.org/drawingml/2006/main"/>
+          <a:ln xmlns:a="http://schemas.openxmlformats.org/drawingml/2006/main" w="0">
+            <a:noFill/>
+          </a:ln>
+        </p:spPr>
+        <p:txBody>
+          <a:bodyPr xmlns:a="http://schemas.openxmlformats.org/drawingml/2006/main" wrap="square" lIns="0" tIns="0" rIns="0" bIns="0" anchor="t">
+            <a:noAutofit/>
+          </a:bodyPr>
+          <a:lstStyle xmlns:a="http://schemas.openxmlformats.org/drawingml/2006/main">
+            <a:defPPr algn="l">
+              <a:defRPr sz="1575" b="0">
+                <a:solidFill>
+                  <a:srgbClr val="718082"/>
+                </a:solidFill>
+                <a:latin typeface="Microsoft JhengHei"/>
+                <a:ea typeface="Microsoft JhengHei"/>
+                <a:cs typeface="Microsoft JhengHei"/>
+              </a:defRPr>
+            </a:defPPr>
+          </a:lstStyle>
+          <a:p xmlns:a="http://schemas.openxmlformats.org/drawingml/2006/main">
+            <a:pPr algn="l">
+              <a:defRPr sz="1575" b="0">
+                <a:solidFill>
+                  <a:srgbClr val="718082"/>
+                </a:solidFill>
+                <a:latin typeface="Microsoft JhengHei"/>
+                <a:ea typeface="Microsoft JhengHei"/>
+                <a:cs typeface="Microsoft JhengHei"/>
+              </a:defRPr>
+            </a:pPr>
+            <a:r>
+              <a:rPr sz="1575" b="0">
+                <a:solidFill>
+                  <a:srgbClr val="718082"/>
+                </a:solidFill>
+                <a:latin typeface="Microsoft JhengHei"/>
+                <a:ea typeface="Microsoft JhengHei"/>
+                <a:cs typeface="Microsoft JhengHei"/>
+              </a:rPr>
+              <a:t>後續兩種同機環境：6模型推論，13份向量與47,073筆CSV完全一致。</a:t>
+            </a:r>
+          </a:p>
+        </p:txBody>
+      </p:sp>
     </p:spTree>
     <p:extLst>
       <p:ext uri="{BB962C8B-B14F-4D97-AF65-F5344CB8AC3E}">
-        <p14:creationId xmlns:p14="http://schemas.microsoft.com/office/powerpoint/2010/main" val="1598277229"/>
+        <p14:creationId xmlns:p14="http://schemas.microsoft.com/office/powerpoint/2010/main" val="325484224"/>
       </p:ext>
     </p:extLst>
   </p:cSld>
@@ -13404,7 +13482,7 @@
           <p:cNvPr id="11" name="slide-title">
             <a:extLst xmlns:a="http://schemas.openxmlformats.org/drawingml/2006/main">
               <a:ext uri="{FF2B5EF4-FFF2-40B4-BE49-F238E27FC236}">
-                <a16:creationId xmlns:a16="http://schemas.microsoft.com/office/drawing/2014/main" id="{2753D568-8F85-4E93-997F-FC9B175B30B2}"/>
+                <a16:creationId xmlns:a16="http://schemas.microsoft.com/office/drawing/2014/main" id="{D2BCDE0B-E070-4F80-9275-87BB2A4A1D6B}"/>
               </a:ext>
             </a:extLst>
           </p:cNvPr>
@@ -13472,7 +13550,7 @@
           <p:cNvPr id="2" name="body">
             <a:extLst xmlns:a="http://schemas.openxmlformats.org/drawingml/2006/main">
               <a:ext uri="{FF2B5EF4-FFF2-40B4-BE49-F238E27FC236}">
-                <a16:creationId xmlns:a16="http://schemas.microsoft.com/office/drawing/2014/main" id="{03A071B3-1181-4437-A6DF-712F6C24E914}"/>
+                <a16:creationId xmlns:a16="http://schemas.microsoft.com/office/drawing/2014/main" id="{A6543480-9476-4DD6-B347-31C578B06923}"/>
               </a:ext>
             </a:extLst>
           </p:cNvPr>
@@ -13540,7 +13618,7 @@
           <p:cNvPr id="3" name="chapter-label">
             <a:extLst xmlns:a="http://schemas.openxmlformats.org/drawingml/2006/main">
               <a:ext uri="{FF2B5EF4-FFF2-40B4-BE49-F238E27FC236}">
-                <a16:creationId xmlns:a16="http://schemas.microsoft.com/office/drawing/2014/main" id="{B25EBE5B-8473-4DFE-B0B5-FD72817C7B7C}"/>
+                <a16:creationId xmlns:a16="http://schemas.microsoft.com/office/drawing/2014/main" id="{9B7F6FD1-64A9-46E6-A9D3-B5ABFBC984F5}"/>
               </a:ext>
             </a:extLst>
           </p:cNvPr>
@@ -13608,7 +13686,7 @@
           <p:cNvPr id="4" name="body">
             <a:extLst xmlns:a="http://schemas.openxmlformats.org/drawingml/2006/main">
               <a:ext uri="{FF2B5EF4-FFF2-40B4-BE49-F238E27FC236}">
-                <a16:creationId xmlns:a16="http://schemas.microsoft.com/office/drawing/2014/main" id="{852FF652-7D4F-49BC-9542-35585D9B8FD3}"/>
+                <a16:creationId xmlns:a16="http://schemas.microsoft.com/office/drawing/2014/main" id="{EF93BB83-8E60-4B20-AD32-CC7E5C7AC18F}"/>
               </a:ext>
             </a:extLst>
           </p:cNvPr>
@@ -13676,7 +13754,7 @@
           <p:cNvPr id="5" name="body">
             <a:extLst xmlns:a="http://schemas.openxmlformats.org/drawingml/2006/main">
               <a:ext uri="{FF2B5EF4-FFF2-40B4-BE49-F238E27FC236}">
-                <a16:creationId xmlns:a16="http://schemas.microsoft.com/office/drawing/2014/main" id="{1A12E576-E9EC-4F67-85F2-FE470344F505}"/>
+                <a16:creationId xmlns:a16="http://schemas.microsoft.com/office/drawing/2014/main" id="{18DBDF38-51F3-41AA-987E-498EC690BAD1}"/>
               </a:ext>
             </a:extLst>
           </p:cNvPr>
@@ -13744,7 +13822,7 @@
           <p:cNvPr id="6" name="body">
             <a:extLst xmlns:a="http://schemas.openxmlformats.org/drawingml/2006/main">
               <a:ext uri="{FF2B5EF4-FFF2-40B4-BE49-F238E27FC236}">
-                <a16:creationId xmlns:a16="http://schemas.microsoft.com/office/drawing/2014/main" id="{EB531BD6-B717-442C-BBCA-816F2A28E30A}"/>
+                <a16:creationId xmlns:a16="http://schemas.microsoft.com/office/drawing/2014/main" id="{CC3D6CA0-7BF7-45FB-A603-25750434D07D}"/>
               </a:ext>
             </a:extLst>
           </p:cNvPr>
@@ -13927,7 +14005,7 @@
           <p:cNvPr id="7" name="body">
             <a:extLst xmlns:a="http://schemas.openxmlformats.org/drawingml/2006/main">
               <a:ext uri="{FF2B5EF4-FFF2-40B4-BE49-F238E27FC236}">
-                <a16:creationId xmlns:a16="http://schemas.microsoft.com/office/drawing/2014/main" id="{1D27EB8D-EFA1-49B0-884E-799531D4F205}"/>
+                <a16:creationId xmlns:a16="http://schemas.microsoft.com/office/drawing/2014/main" id="{4A6158B4-981B-4DC3-BACC-6DEE5CA889E4}"/>
               </a:ext>
             </a:extLst>
           </p:cNvPr>
@@ -13995,7 +14073,7 @@
           <p:cNvPr id="8" name="Chart">
             <a:extLst xmlns:a="http://schemas.openxmlformats.org/drawingml/2006/main">
               <a:ext uri="{FF2B5EF4-FFF2-40B4-BE49-F238E27FC236}">
-                <a16:creationId xmlns:a16="http://schemas.microsoft.com/office/drawing/2014/main" id="{3E6E66C1-B47D-49BE-AC0C-8EE12BE40784}"/>
+                <a16:creationId xmlns:a16="http://schemas.microsoft.com/office/drawing/2014/main" id="{8A011699-B3D4-49B1-9D7C-52CD10E94CD7}"/>
               </a:ext>
             </a:extLst>
           </p:cNvPr>
@@ -14008,7 +14086,7 @@
         </p:xfrm>
         <a:graphic xmlns:a="http://schemas.openxmlformats.org/drawingml/2006/main">
           <a:graphicData uri="http://schemas.openxmlformats.org/drawingml/2006/chart">
-            <c:chart xmlns:r="http://schemas.openxmlformats.org/officeDocument/2006/relationships" xmlns:c="http://schemas.openxmlformats.org/drawingml/2006/chart" r:id="R6971f0f2dc9546fe"/>
+            <c:chart xmlns:r="http://schemas.openxmlformats.org/officeDocument/2006/relationships" xmlns:c="http://schemas.openxmlformats.org/drawingml/2006/chart" r:id="R0d5f0f2e4b5c434b"/>
           </a:graphicData>
         </a:graphic>
       </p:graphicFrame>
@@ -14017,7 +14095,7 @@
           <p:cNvPr id="9" name="body">
             <a:extLst xmlns:a="http://schemas.openxmlformats.org/drawingml/2006/main">
               <a:ext uri="{FF2B5EF4-FFF2-40B4-BE49-F238E27FC236}">
-                <a16:creationId xmlns:a16="http://schemas.microsoft.com/office/drawing/2014/main" id="{A4AF995B-115C-4B51-A7E1-FA22E8EA1345}"/>
+                <a16:creationId xmlns:a16="http://schemas.microsoft.com/office/drawing/2014/main" id="{07FFFC6D-CD6D-42F5-A26F-51130C69CDDE}"/>
               </a:ext>
             </a:extLst>
           </p:cNvPr>
@@ -14085,7 +14163,7 @@
           <p:cNvPr id="10" name="body">
             <a:extLst xmlns:a="http://schemas.openxmlformats.org/drawingml/2006/main">
               <a:ext uri="{FF2B5EF4-FFF2-40B4-BE49-F238E27FC236}">
-                <a16:creationId xmlns:a16="http://schemas.microsoft.com/office/drawing/2014/main" id="{D76DF90F-C050-4D7A-AEE3-F88ADF339B59}"/>
+                <a16:creationId xmlns:a16="http://schemas.microsoft.com/office/drawing/2014/main" id="{A9A100A2-3F6E-43D7-8DF2-8C533A03ABC4}"/>
               </a:ext>
             </a:extLst>
           </p:cNvPr>
@@ -14151,7 +14229,7 @@
     </p:spTree>
     <p:extLst>
       <p:ext uri="{BB962C8B-B14F-4D97-AF65-F5344CB8AC3E}">
-        <p14:creationId xmlns:p14="http://schemas.microsoft.com/office/powerpoint/2010/main" val="1416779171"/>
+        <p14:creationId xmlns:p14="http://schemas.microsoft.com/office/powerpoint/2010/main" val="1216079347"/>
       </p:ext>
     </p:extLst>
   </p:cSld>
@@ -14182,7 +14260,7 @@
           <p:cNvPr id="13" name="slide-title">
             <a:extLst xmlns:a="http://schemas.openxmlformats.org/drawingml/2006/main">
               <a:ext uri="{FF2B5EF4-FFF2-40B4-BE49-F238E27FC236}">
-                <a16:creationId xmlns:a16="http://schemas.microsoft.com/office/drawing/2014/main" id="{E0BB5BB8-303A-4B4B-A559-4B40FCE614C0}"/>
+                <a16:creationId xmlns:a16="http://schemas.microsoft.com/office/drawing/2014/main" id="{33CD536E-A39A-4F61-B733-0171F5739731}"/>
               </a:ext>
             </a:extLst>
           </p:cNvPr>
@@ -14250,7 +14328,7 @@
           <p:cNvPr id="2" name="body">
             <a:extLst xmlns:a="http://schemas.openxmlformats.org/drawingml/2006/main">
               <a:ext uri="{FF2B5EF4-FFF2-40B4-BE49-F238E27FC236}">
-                <a16:creationId xmlns:a16="http://schemas.microsoft.com/office/drawing/2014/main" id="{B4C53C5C-9DB8-403B-BDC0-1FD8662D3987}"/>
+                <a16:creationId xmlns:a16="http://schemas.microsoft.com/office/drawing/2014/main" id="{6AE6445E-7A16-4B0A-A1D0-E4DD33350D3C}"/>
               </a:ext>
             </a:extLst>
           </p:cNvPr>
@@ -14318,7 +14396,7 @@
           <p:cNvPr id="3" name="chapter-label">
             <a:extLst xmlns:a="http://schemas.openxmlformats.org/drawingml/2006/main">
               <a:ext uri="{FF2B5EF4-FFF2-40B4-BE49-F238E27FC236}">
-                <a16:creationId xmlns:a16="http://schemas.microsoft.com/office/drawing/2014/main" id="{953163AB-2EF5-40F1-872C-41268CB3E22E}"/>
+                <a16:creationId xmlns:a16="http://schemas.microsoft.com/office/drawing/2014/main" id="{5B22FCB6-DF55-4B7A-96FA-74F80249196B}"/>
               </a:ext>
             </a:extLst>
           </p:cNvPr>
@@ -14386,7 +14464,7 @@
           <p:cNvPr id="4" name="body">
             <a:extLst xmlns:a="http://schemas.openxmlformats.org/drawingml/2006/main">
               <a:ext uri="{FF2B5EF4-FFF2-40B4-BE49-F238E27FC236}">
-                <a16:creationId xmlns:a16="http://schemas.microsoft.com/office/drawing/2014/main" id="{9E9EFBD3-6F72-4D35-84D1-32130BCCC89B}"/>
+                <a16:creationId xmlns:a16="http://schemas.microsoft.com/office/drawing/2014/main" id="{D3129634-B031-400A-BFFF-9232B9562FB0}"/>
               </a:ext>
             </a:extLst>
           </p:cNvPr>
@@ -14454,7 +14532,7 @@
           <p:cNvPr id="5" name="Chart">
             <a:extLst xmlns:a="http://schemas.openxmlformats.org/drawingml/2006/main">
               <a:ext uri="{FF2B5EF4-FFF2-40B4-BE49-F238E27FC236}">
-                <a16:creationId xmlns:a16="http://schemas.microsoft.com/office/drawing/2014/main" id="{C2EEFEFF-C597-4ABE-9A07-BB968AC8EFE5}"/>
+                <a16:creationId xmlns:a16="http://schemas.microsoft.com/office/drawing/2014/main" id="{E47941D8-B5C8-489F-82B0-68D15491A59C}"/>
               </a:ext>
             </a:extLst>
           </p:cNvPr>
@@ -14467,7 +14545,7 @@
         </p:xfrm>
         <a:graphic xmlns:a="http://schemas.openxmlformats.org/drawingml/2006/main">
           <a:graphicData uri="http://schemas.openxmlformats.org/drawingml/2006/chart">
-            <c:chart xmlns:r="http://schemas.openxmlformats.org/officeDocument/2006/relationships" xmlns:c="http://schemas.openxmlformats.org/drawingml/2006/chart" r:id="Rbc8e31786c3440cd"/>
+            <c:chart xmlns:r="http://schemas.openxmlformats.org/officeDocument/2006/relationships" xmlns:c="http://schemas.openxmlformats.org/drawingml/2006/chart" r:id="R3f3cfac7f83642a7"/>
           </a:graphicData>
         </a:graphic>
       </p:graphicFrame>
@@ -14476,7 +14554,7 @@
           <p:cNvPr id="6" name="body">
             <a:extLst xmlns:a="http://schemas.openxmlformats.org/drawingml/2006/main">
               <a:ext uri="{FF2B5EF4-FFF2-40B4-BE49-F238E27FC236}">
-                <a16:creationId xmlns:a16="http://schemas.microsoft.com/office/drawing/2014/main" id="{21F8D599-FCDE-4618-A707-6ACA092FF38D}"/>
+                <a16:creationId xmlns:a16="http://schemas.microsoft.com/office/drawing/2014/main" id="{72392B9B-F325-452E-BAF6-BDB0795565C7}"/>
               </a:ext>
             </a:extLst>
           </p:cNvPr>
@@ -14544,7 +14622,7 @@
           <p:cNvPr id="7" name="body">
             <a:extLst xmlns:a="http://schemas.openxmlformats.org/drawingml/2006/main">
               <a:ext uri="{FF2B5EF4-FFF2-40B4-BE49-F238E27FC236}">
-                <a16:creationId xmlns:a16="http://schemas.microsoft.com/office/drawing/2014/main" id="{56AB49ED-BD10-463B-83C7-0BCCEC47E7DD}"/>
+                <a16:creationId xmlns:a16="http://schemas.microsoft.com/office/drawing/2014/main" id="{1F5FC9B1-7235-4EB0-821D-33D7A89423B8}"/>
               </a:ext>
             </a:extLst>
           </p:cNvPr>
@@ -14612,7 +14690,7 @@
           <p:cNvPr id="8" name="body">
             <a:extLst xmlns:a="http://schemas.openxmlformats.org/drawingml/2006/main">
               <a:ext uri="{FF2B5EF4-FFF2-40B4-BE49-F238E27FC236}">
-                <a16:creationId xmlns:a16="http://schemas.microsoft.com/office/drawing/2014/main" id="{BCFEB617-B668-4E5A-845B-9F73C744C4E7}"/>
+                <a16:creationId xmlns:a16="http://schemas.microsoft.com/office/drawing/2014/main" id="{3B4ED141-551E-456C-861D-150E5AA35C34}"/>
               </a:ext>
             </a:extLst>
           </p:cNvPr>
@@ -14680,7 +14758,7 @@
           <p:cNvPr id="9" name="body">
             <a:extLst xmlns:a="http://schemas.openxmlformats.org/drawingml/2006/main">
               <a:ext uri="{FF2B5EF4-FFF2-40B4-BE49-F238E27FC236}">
-                <a16:creationId xmlns:a16="http://schemas.microsoft.com/office/drawing/2014/main" id="{46DDE900-A135-467F-ADD2-E4031D9F57C4}"/>
+                <a16:creationId xmlns:a16="http://schemas.microsoft.com/office/drawing/2014/main" id="{C8B5C0A5-F812-4BF0-9634-FE96A88F10DD}"/>
               </a:ext>
             </a:extLst>
           </p:cNvPr>
@@ -14748,7 +14826,7 @@
           <p:cNvPr id="10" name="body">
             <a:extLst xmlns:a="http://schemas.openxmlformats.org/drawingml/2006/main">
               <a:ext uri="{FF2B5EF4-FFF2-40B4-BE49-F238E27FC236}">
-                <a16:creationId xmlns:a16="http://schemas.microsoft.com/office/drawing/2014/main" id="{59E071BC-79D2-40B6-844F-D01A4B21A56E}"/>
+                <a16:creationId xmlns:a16="http://schemas.microsoft.com/office/drawing/2014/main" id="{5FC6C6D1-7F03-4263-B974-54A646F50D2F}"/>
               </a:ext>
             </a:extLst>
           </p:cNvPr>
@@ -14816,7 +14894,7 @@
           <p:cNvPr id="11" name="body">
             <a:extLst xmlns:a="http://schemas.openxmlformats.org/drawingml/2006/main">
               <a:ext uri="{FF2B5EF4-FFF2-40B4-BE49-F238E27FC236}">
-                <a16:creationId xmlns:a16="http://schemas.microsoft.com/office/drawing/2014/main" id="{B548694B-B4A8-406A-9949-6175F310C814}"/>
+                <a16:creationId xmlns:a16="http://schemas.microsoft.com/office/drawing/2014/main" id="{65758439-0C14-46FE-B507-2222499B050D}"/>
               </a:ext>
             </a:extLst>
           </p:cNvPr>
@@ -14907,7 +14985,7 @@
           <p:cNvPr id="12" name="body">
             <a:extLst xmlns:a="http://schemas.openxmlformats.org/drawingml/2006/main">
               <a:ext uri="{FF2B5EF4-FFF2-40B4-BE49-F238E27FC236}">
-                <a16:creationId xmlns:a16="http://schemas.microsoft.com/office/drawing/2014/main" id="{B7B2309E-1F39-46D1-9482-5ED8F187DF8B}"/>
+                <a16:creationId xmlns:a16="http://schemas.microsoft.com/office/drawing/2014/main" id="{44986C59-B736-451D-B3F2-298BB9B6357C}"/>
               </a:ext>
             </a:extLst>
           </p:cNvPr>
@@ -14973,7 +15051,7 @@
     </p:spTree>
     <p:extLst>
       <p:ext uri="{BB962C8B-B14F-4D97-AF65-F5344CB8AC3E}">
-        <p14:creationId xmlns:p14="http://schemas.microsoft.com/office/powerpoint/2010/main" val="289986100"/>
+        <p14:creationId xmlns:p14="http://schemas.microsoft.com/office/powerpoint/2010/main" val="324606864"/>
       </p:ext>
     </p:extLst>
   </p:cSld>
@@ -15004,7 +15082,7 @@
           <p:cNvPr id="13" name="slide-title">
             <a:extLst xmlns:a="http://schemas.openxmlformats.org/drawingml/2006/main">
               <a:ext uri="{FF2B5EF4-FFF2-40B4-BE49-F238E27FC236}">
-                <a16:creationId xmlns:a16="http://schemas.microsoft.com/office/drawing/2014/main" id="{708DA15A-EADA-4D2F-BD2D-2E3498577028}"/>
+                <a16:creationId xmlns:a16="http://schemas.microsoft.com/office/drawing/2014/main" id="{B0F442B6-02B9-4C24-92E7-882040631EA6}"/>
               </a:ext>
             </a:extLst>
           </p:cNvPr>
@@ -15072,7 +15150,7 @@
           <p:cNvPr id="2" name="body">
             <a:extLst xmlns:a="http://schemas.openxmlformats.org/drawingml/2006/main">
               <a:ext uri="{FF2B5EF4-FFF2-40B4-BE49-F238E27FC236}">
-                <a16:creationId xmlns:a16="http://schemas.microsoft.com/office/drawing/2014/main" id="{D38393B3-39D0-488F-8388-6DC83A20B172}"/>
+                <a16:creationId xmlns:a16="http://schemas.microsoft.com/office/drawing/2014/main" id="{145B0880-1AB6-45F6-BEE8-7852E911A9E7}"/>
               </a:ext>
             </a:extLst>
           </p:cNvPr>
@@ -15140,7 +15218,7 @@
           <p:cNvPr id="3" name="chapter-label">
             <a:extLst xmlns:a="http://schemas.openxmlformats.org/drawingml/2006/main">
               <a:ext uri="{FF2B5EF4-FFF2-40B4-BE49-F238E27FC236}">
-                <a16:creationId xmlns:a16="http://schemas.microsoft.com/office/drawing/2014/main" id="{0532F640-6EEA-4065-AA62-0E75536253F4}"/>
+                <a16:creationId xmlns:a16="http://schemas.microsoft.com/office/drawing/2014/main" id="{1DC43B85-004D-4312-A7EB-3716E24C41BF}"/>
               </a:ext>
             </a:extLst>
           </p:cNvPr>
@@ -15208,7 +15286,7 @@
           <p:cNvPr id="4" name="body">
             <a:extLst xmlns:a="http://schemas.openxmlformats.org/drawingml/2006/main">
               <a:ext uri="{FF2B5EF4-FFF2-40B4-BE49-F238E27FC236}">
-                <a16:creationId xmlns:a16="http://schemas.microsoft.com/office/drawing/2014/main" id="{F4D444B1-E3DD-4491-B0C5-6AC5C362CABD}"/>
+                <a16:creationId xmlns:a16="http://schemas.microsoft.com/office/drawing/2014/main" id="{F0846391-FE0A-4A4F-A37C-DE656A82BBAE}"/>
               </a:ext>
             </a:extLst>
           </p:cNvPr>
@@ -15276,7 +15354,7 @@
           <p:cNvPr id="5" name="body">
             <a:extLst xmlns:a="http://schemas.openxmlformats.org/drawingml/2006/main">
               <a:ext uri="{FF2B5EF4-FFF2-40B4-BE49-F238E27FC236}">
-                <a16:creationId xmlns:a16="http://schemas.microsoft.com/office/drawing/2014/main" id="{FD2DF008-F172-4DDE-B69B-699CF4E45475}"/>
+                <a16:creationId xmlns:a16="http://schemas.microsoft.com/office/drawing/2014/main" id="{E5D1E179-F8A2-4DF9-A70C-5253E2D38A57}"/>
               </a:ext>
             </a:extLst>
           </p:cNvPr>
@@ -15344,7 +15422,7 @@
           <p:cNvPr id="6" name="body">
             <a:extLst xmlns:a="http://schemas.openxmlformats.org/drawingml/2006/main">
               <a:ext uri="{FF2B5EF4-FFF2-40B4-BE49-F238E27FC236}">
-                <a16:creationId xmlns:a16="http://schemas.microsoft.com/office/drawing/2014/main" id="{2F6CBB77-627D-4E46-9DC8-EF09EFA04527}"/>
+                <a16:creationId xmlns:a16="http://schemas.microsoft.com/office/drawing/2014/main" id="{A99B2693-A4E7-4721-9057-4BE70CD5FB97}"/>
               </a:ext>
             </a:extLst>
           </p:cNvPr>
@@ -15412,7 +15490,7 @@
           <p:cNvPr id="7" name="body">
             <a:extLst xmlns:a="http://schemas.openxmlformats.org/drawingml/2006/main">
               <a:ext uri="{FF2B5EF4-FFF2-40B4-BE49-F238E27FC236}">
-                <a16:creationId xmlns:a16="http://schemas.microsoft.com/office/drawing/2014/main" id="{5E86FB21-EFD3-4288-A5BB-959C70F287D4}"/>
+                <a16:creationId xmlns:a16="http://schemas.microsoft.com/office/drawing/2014/main" id="{796B387B-C3A7-4A93-9B12-48CD73227CCF}"/>
               </a:ext>
             </a:extLst>
           </p:cNvPr>
@@ -15480,7 +15558,7 @@
           <p:cNvPr id="8" name="body">
             <a:extLst xmlns:a="http://schemas.openxmlformats.org/drawingml/2006/main">
               <a:ext uri="{FF2B5EF4-FFF2-40B4-BE49-F238E27FC236}">
-                <a16:creationId xmlns:a16="http://schemas.microsoft.com/office/drawing/2014/main" id="{455BDB38-C45E-4628-9DB9-ACC1B1DBE03C}"/>
+                <a16:creationId xmlns:a16="http://schemas.microsoft.com/office/drawing/2014/main" id="{86914FEC-FA4C-4E62-8905-3353B20E554D}"/>
               </a:ext>
             </a:extLst>
           </p:cNvPr>
@@ -15548,7 +15626,7 @@
           <p:cNvPr id="9" name="body">
             <a:extLst xmlns:a="http://schemas.openxmlformats.org/drawingml/2006/main">
               <a:ext uri="{FF2B5EF4-FFF2-40B4-BE49-F238E27FC236}">
-                <a16:creationId xmlns:a16="http://schemas.microsoft.com/office/drawing/2014/main" id="{5A7944AC-69B7-4A62-AEE2-5EE1775F3340}"/>
+                <a16:creationId xmlns:a16="http://schemas.microsoft.com/office/drawing/2014/main" id="{21090B79-0FE0-4EBD-B60C-CCCA057CC1EF}"/>
               </a:ext>
             </a:extLst>
           </p:cNvPr>
@@ -15616,7 +15694,7 @@
           <p:cNvPr id="10" name="body">
             <a:extLst xmlns:a="http://schemas.openxmlformats.org/drawingml/2006/main">
               <a:ext uri="{FF2B5EF4-FFF2-40B4-BE49-F238E27FC236}">
-                <a16:creationId xmlns:a16="http://schemas.microsoft.com/office/drawing/2014/main" id="{44B3819B-C91B-4F7A-838F-E82AF9D903FB}"/>
+                <a16:creationId xmlns:a16="http://schemas.microsoft.com/office/drawing/2014/main" id="{B7A08130-7711-4D9B-AA61-80A6F6FBA404}"/>
               </a:ext>
             </a:extLst>
           </p:cNvPr>
@@ -15684,7 +15762,7 @@
           <p:cNvPr id="11" name="body">
             <a:extLst xmlns:a="http://schemas.openxmlformats.org/drawingml/2006/main">
               <a:ext uri="{FF2B5EF4-FFF2-40B4-BE49-F238E27FC236}">
-                <a16:creationId xmlns:a16="http://schemas.microsoft.com/office/drawing/2014/main" id="{B0540A05-EF1A-49C6-B368-E510CD861BD3}"/>
+                <a16:creationId xmlns:a16="http://schemas.microsoft.com/office/drawing/2014/main" id="{F507C56D-4EE5-4CD2-BE0B-1F3B0D3BCACB}"/>
               </a:ext>
             </a:extLst>
           </p:cNvPr>
@@ -15752,7 +15830,7 @@
           <p:cNvPr id="12" name="body">
             <a:extLst xmlns:a="http://schemas.openxmlformats.org/drawingml/2006/main">
               <a:ext uri="{FF2B5EF4-FFF2-40B4-BE49-F238E27FC236}">
-                <a16:creationId xmlns:a16="http://schemas.microsoft.com/office/drawing/2014/main" id="{FDE858AA-886C-4527-94B5-FC40E04951C6}"/>
+                <a16:creationId xmlns:a16="http://schemas.microsoft.com/office/drawing/2014/main" id="{E4787525-7A5A-488C-9BA5-811691474FC5}"/>
               </a:ext>
             </a:extLst>
           </p:cNvPr>
@@ -15818,7 +15896,7 @@
     </p:spTree>
     <p:extLst>
       <p:ext uri="{BB962C8B-B14F-4D97-AF65-F5344CB8AC3E}">
-        <p14:creationId xmlns:p14="http://schemas.microsoft.com/office/powerpoint/2010/main" val="98000513"/>
+        <p14:creationId xmlns:p14="http://schemas.microsoft.com/office/powerpoint/2010/main" val="633572861"/>
       </p:ext>
     </p:extLst>
   </p:cSld>
@@ -15849,7 +15927,7 @@
           <p:cNvPr id="17" name="slide-title">
             <a:extLst xmlns:a="http://schemas.openxmlformats.org/drawingml/2006/main">
               <a:ext uri="{FF2B5EF4-FFF2-40B4-BE49-F238E27FC236}">
-                <a16:creationId xmlns:a16="http://schemas.microsoft.com/office/drawing/2014/main" id="{24748381-399F-4C4A-AE4E-C6676F617DD1}"/>
+                <a16:creationId xmlns:a16="http://schemas.microsoft.com/office/drawing/2014/main" id="{91DAAF2F-10AC-4F03-8637-069D77AD0FEB}"/>
               </a:ext>
             </a:extLst>
           </p:cNvPr>
@@ -15917,7 +15995,7 @@
           <p:cNvPr id="2" name="body">
             <a:extLst xmlns:a="http://schemas.openxmlformats.org/drawingml/2006/main">
               <a:ext uri="{FF2B5EF4-FFF2-40B4-BE49-F238E27FC236}">
-                <a16:creationId xmlns:a16="http://schemas.microsoft.com/office/drawing/2014/main" id="{2CCA9482-AFAB-42EC-9133-7E32090A43E1}"/>
+                <a16:creationId xmlns:a16="http://schemas.microsoft.com/office/drawing/2014/main" id="{A571F24C-B3A1-4CDA-AE74-D40C93B2ED02}"/>
               </a:ext>
             </a:extLst>
           </p:cNvPr>
@@ -15985,7 +16063,7 @@
           <p:cNvPr id="3" name="body">
             <a:extLst xmlns:a="http://schemas.openxmlformats.org/drawingml/2006/main">
               <a:ext uri="{FF2B5EF4-FFF2-40B4-BE49-F238E27FC236}">
-                <a16:creationId xmlns:a16="http://schemas.microsoft.com/office/drawing/2014/main" id="{9F2EF05F-03AB-4B15-9E02-1CBE732255ED}"/>
+                <a16:creationId xmlns:a16="http://schemas.microsoft.com/office/drawing/2014/main" id="{BB3B3630-E3B0-42B5-9254-28219548850D}"/>
               </a:ext>
             </a:extLst>
           </p:cNvPr>
@@ -16053,7 +16131,7 @@
           <p:cNvPr id="4" name="body">
             <a:extLst xmlns:a="http://schemas.openxmlformats.org/drawingml/2006/main">
               <a:ext uri="{FF2B5EF4-FFF2-40B4-BE49-F238E27FC236}">
-                <a16:creationId xmlns:a16="http://schemas.microsoft.com/office/drawing/2014/main" id="{F5B3AF50-27CD-4E3E-B851-1479B99B9D63}"/>
+                <a16:creationId xmlns:a16="http://schemas.microsoft.com/office/drawing/2014/main" id="{D44B58F3-9F15-47E8-9AA0-390FE7E0301C}"/>
               </a:ext>
             </a:extLst>
           </p:cNvPr>
@@ -16121,7 +16199,7 @@
           <p:cNvPr id="5" name="body">
             <a:extLst xmlns:a="http://schemas.openxmlformats.org/drawingml/2006/main">
               <a:ext uri="{FF2B5EF4-FFF2-40B4-BE49-F238E27FC236}">
-                <a16:creationId xmlns:a16="http://schemas.microsoft.com/office/drawing/2014/main" id="{32D8EBB2-6069-4D3E-9B39-18E619E58CF2}"/>
+                <a16:creationId xmlns:a16="http://schemas.microsoft.com/office/drawing/2014/main" id="{C792B96A-3B99-4CD2-967E-A85E73CF2B2A}"/>
               </a:ext>
             </a:extLst>
           </p:cNvPr>
@@ -16189,7 +16267,7 @@
           <p:cNvPr id="6" name="body">
             <a:extLst xmlns:a="http://schemas.openxmlformats.org/drawingml/2006/main">
               <a:ext uri="{FF2B5EF4-FFF2-40B4-BE49-F238E27FC236}">
-                <a16:creationId xmlns:a16="http://schemas.microsoft.com/office/drawing/2014/main" id="{738BDD71-E512-472B-A615-7574B87E8016}"/>
+                <a16:creationId xmlns:a16="http://schemas.microsoft.com/office/drawing/2014/main" id="{CF8F3661-AA0A-4E2C-B330-C408FD2ACE35}"/>
               </a:ext>
             </a:extLst>
           </p:cNvPr>
@@ -16257,7 +16335,7 @@
           <p:cNvPr id="7" name="body">
             <a:extLst xmlns:a="http://schemas.openxmlformats.org/drawingml/2006/main">
               <a:ext uri="{FF2B5EF4-FFF2-40B4-BE49-F238E27FC236}">
-                <a16:creationId xmlns:a16="http://schemas.microsoft.com/office/drawing/2014/main" id="{CE8F82A4-C778-4F61-AC14-D3AEA8EF19D6}"/>
+                <a16:creationId xmlns:a16="http://schemas.microsoft.com/office/drawing/2014/main" id="{016C5828-6BD6-4189-A36A-EF62878BF0D5}"/>
               </a:ext>
             </a:extLst>
           </p:cNvPr>
@@ -16325,7 +16403,7 @@
           <p:cNvPr id="8" name="body">
             <a:extLst xmlns:a="http://schemas.openxmlformats.org/drawingml/2006/main">
               <a:ext uri="{FF2B5EF4-FFF2-40B4-BE49-F238E27FC236}">
-                <a16:creationId xmlns:a16="http://schemas.microsoft.com/office/drawing/2014/main" id="{2B193D9F-D161-4695-8E5F-2D9005F66D92}"/>
+                <a16:creationId xmlns:a16="http://schemas.microsoft.com/office/drawing/2014/main" id="{99814686-9FC6-4367-9F18-960672C9C485}"/>
               </a:ext>
             </a:extLst>
           </p:cNvPr>
@@ -16393,7 +16471,7 @@
           <p:cNvPr id="9" name="body">
             <a:extLst xmlns:a="http://schemas.openxmlformats.org/drawingml/2006/main">
               <a:ext uri="{FF2B5EF4-FFF2-40B4-BE49-F238E27FC236}">
-                <a16:creationId xmlns:a16="http://schemas.microsoft.com/office/drawing/2014/main" id="{D9EC5D84-E80C-44D4-A313-1229091B6E29}"/>
+                <a16:creationId xmlns:a16="http://schemas.microsoft.com/office/drawing/2014/main" id="{D03B88CF-8E0B-4C4A-AD8A-7D036C5A34A1}"/>
               </a:ext>
             </a:extLst>
           </p:cNvPr>
@@ -16461,7 +16539,7 @@
           <p:cNvPr id="10" name="body">
             <a:extLst xmlns:a="http://schemas.openxmlformats.org/drawingml/2006/main">
               <a:ext uri="{FF2B5EF4-FFF2-40B4-BE49-F238E27FC236}">
-                <a16:creationId xmlns:a16="http://schemas.microsoft.com/office/drawing/2014/main" id="{F6CE0351-9AE8-4EBA-B417-0236E071DEE4}"/>
+                <a16:creationId xmlns:a16="http://schemas.microsoft.com/office/drawing/2014/main" id="{94941DD7-8D9E-4E52-8996-10740442C644}"/>
               </a:ext>
             </a:extLst>
           </p:cNvPr>
@@ -16529,7 +16607,7 @@
           <p:cNvPr id="11" name="body">
             <a:extLst xmlns:a="http://schemas.openxmlformats.org/drawingml/2006/main">
               <a:ext uri="{FF2B5EF4-FFF2-40B4-BE49-F238E27FC236}">
-                <a16:creationId xmlns:a16="http://schemas.microsoft.com/office/drawing/2014/main" id="{FA6140A9-0534-4FB6-BF37-40D2BAFD536C}"/>
+                <a16:creationId xmlns:a16="http://schemas.microsoft.com/office/drawing/2014/main" id="{12079726-6812-421B-ADAC-E0E36095BCB4}"/>
               </a:ext>
             </a:extLst>
           </p:cNvPr>
@@ -16597,7 +16675,7 @@
           <p:cNvPr id="12" name="body">
             <a:extLst xmlns:a="http://schemas.openxmlformats.org/drawingml/2006/main">
               <a:ext uri="{FF2B5EF4-FFF2-40B4-BE49-F238E27FC236}">
-                <a16:creationId xmlns:a16="http://schemas.microsoft.com/office/drawing/2014/main" id="{F9B66236-C927-45FD-9E05-394EC1DFDC29}"/>
+                <a16:creationId xmlns:a16="http://schemas.microsoft.com/office/drawing/2014/main" id="{2133FABE-6878-4A9E-B967-636940DF1C04}"/>
               </a:ext>
             </a:extLst>
           </p:cNvPr>
@@ -16665,7 +16743,7 @@
           <p:cNvPr id="13" name="body">
             <a:extLst xmlns:a="http://schemas.openxmlformats.org/drawingml/2006/main">
               <a:ext uri="{FF2B5EF4-FFF2-40B4-BE49-F238E27FC236}">
-                <a16:creationId xmlns:a16="http://schemas.microsoft.com/office/drawing/2014/main" id="{F5BAA079-87A8-43B0-AC62-5024AE4E2F0B}"/>
+                <a16:creationId xmlns:a16="http://schemas.microsoft.com/office/drawing/2014/main" id="{D4A7BA50-7F83-4CFA-9D93-B9D3E5591C6E}"/>
               </a:ext>
             </a:extLst>
           </p:cNvPr>
@@ -16733,7 +16811,7 @@
           <p:cNvPr id="14" name="body">
             <a:extLst xmlns:a="http://schemas.openxmlformats.org/drawingml/2006/main">
               <a:ext uri="{FF2B5EF4-FFF2-40B4-BE49-F238E27FC236}">
-                <a16:creationId xmlns:a16="http://schemas.microsoft.com/office/drawing/2014/main" id="{F5BA4358-0334-4370-BCD1-5A73252FA100}"/>
+                <a16:creationId xmlns:a16="http://schemas.microsoft.com/office/drawing/2014/main" id="{A4C27393-828B-44E3-81E6-DC4920B6B386}"/>
               </a:ext>
             </a:extLst>
           </p:cNvPr>
@@ -16801,7 +16879,7 @@
           <p:cNvPr id="15" name="body">
             <a:extLst xmlns:a="http://schemas.openxmlformats.org/drawingml/2006/main">
               <a:ext uri="{FF2B5EF4-FFF2-40B4-BE49-F238E27FC236}">
-                <a16:creationId xmlns:a16="http://schemas.microsoft.com/office/drawing/2014/main" id="{5E106BEF-DF2C-44A7-B9F1-20A938CEEB74}"/>
+                <a16:creationId xmlns:a16="http://schemas.microsoft.com/office/drawing/2014/main" id="{D42CB712-0133-44E3-BB8E-E7A5C83DE8B7}"/>
               </a:ext>
             </a:extLst>
           </p:cNvPr>
@@ -16869,7 +16947,7 @@
           <p:cNvPr id="16" name="body">
             <a:extLst xmlns:a="http://schemas.openxmlformats.org/drawingml/2006/main">
               <a:ext uri="{FF2B5EF4-FFF2-40B4-BE49-F238E27FC236}">
-                <a16:creationId xmlns:a16="http://schemas.microsoft.com/office/drawing/2014/main" id="{CFBA2B19-1159-4A6D-8B1B-93B135755B42}"/>
+                <a16:creationId xmlns:a16="http://schemas.microsoft.com/office/drawing/2014/main" id="{7186A344-7110-4FE2-A53C-B80E888EEEE8}"/>
               </a:ext>
             </a:extLst>
           </p:cNvPr>
@@ -16935,7 +17013,7 @@
     </p:spTree>
     <p:extLst>
       <p:ext uri="{BB962C8B-B14F-4D97-AF65-F5344CB8AC3E}">
-        <p14:creationId xmlns:p14="http://schemas.microsoft.com/office/powerpoint/2010/main" val="428787427"/>
+        <p14:creationId xmlns:p14="http://schemas.microsoft.com/office/powerpoint/2010/main" val="635897385"/>
       </p:ext>
     </p:extLst>
   </p:cSld>
@@ -16966,7 +17044,7 @@
           <p:cNvPr id="12" name="slide-title">
             <a:extLst xmlns:a="http://schemas.openxmlformats.org/drawingml/2006/main">
               <a:ext uri="{FF2B5EF4-FFF2-40B4-BE49-F238E27FC236}">
-                <a16:creationId xmlns:a16="http://schemas.microsoft.com/office/drawing/2014/main" id="{DCD62E1F-26C3-4F05-8ECA-B41EBA4EF7A5}"/>
+                <a16:creationId xmlns:a16="http://schemas.microsoft.com/office/drawing/2014/main" id="{050E7B28-7451-4E4B-8CC4-D689C500A21F}"/>
               </a:ext>
             </a:extLst>
           </p:cNvPr>
@@ -17034,7 +17112,7 @@
           <p:cNvPr id="2" name="body">
             <a:extLst xmlns:a="http://schemas.openxmlformats.org/drawingml/2006/main">
               <a:ext uri="{FF2B5EF4-FFF2-40B4-BE49-F238E27FC236}">
-                <a16:creationId xmlns:a16="http://schemas.microsoft.com/office/drawing/2014/main" id="{CC291C41-E637-44D6-A6C7-A086B7BFD6DA}"/>
+                <a16:creationId xmlns:a16="http://schemas.microsoft.com/office/drawing/2014/main" id="{9663C8E9-20E5-4EBA-8CEF-B789A8334741}"/>
               </a:ext>
             </a:extLst>
           </p:cNvPr>
@@ -17102,7 +17180,7 @@
           <p:cNvPr id="3" name="chapter-label">
             <a:extLst xmlns:a="http://schemas.openxmlformats.org/drawingml/2006/main">
               <a:ext uri="{FF2B5EF4-FFF2-40B4-BE49-F238E27FC236}">
-                <a16:creationId xmlns:a16="http://schemas.microsoft.com/office/drawing/2014/main" id="{23713CE8-347D-4A62-A144-E925225CEE02}"/>
+                <a16:creationId xmlns:a16="http://schemas.microsoft.com/office/drawing/2014/main" id="{C91BB019-4F86-424E-8D85-BA4032991970}"/>
               </a:ext>
             </a:extLst>
           </p:cNvPr>
@@ -17170,7 +17248,7 @@
           <p:cNvPr id="4" name="body">
             <a:extLst xmlns:a="http://schemas.openxmlformats.org/drawingml/2006/main">
               <a:ext uri="{FF2B5EF4-FFF2-40B4-BE49-F238E27FC236}">
-                <a16:creationId xmlns:a16="http://schemas.microsoft.com/office/drawing/2014/main" id="{3DC84867-26F3-47C6-A4CF-9590B5A259A1}"/>
+                <a16:creationId xmlns:a16="http://schemas.microsoft.com/office/drawing/2014/main" id="{5C6448AF-FCE6-4414-9906-79FF01FD4958}"/>
               </a:ext>
             </a:extLst>
           </p:cNvPr>
@@ -17238,7 +17316,7 @@
           <p:cNvPr id="5" name="">
             <a:extLst xmlns:a="http://schemas.openxmlformats.org/drawingml/2006/main">
               <a:ext uri="{FF2B5EF4-FFF2-40B4-BE49-F238E27FC236}">
-                <a16:creationId xmlns:a16="http://schemas.microsoft.com/office/drawing/2014/main" id="{BD2D35F9-6D66-424C-9F08-EBD2BD62B8E9}"/>
+                <a16:creationId xmlns:a16="http://schemas.microsoft.com/office/drawing/2014/main" id="{BB4048D9-9ACC-4F3D-A3F4-675E93620D19}"/>
               </a:ext>
             </a:extLst>
           </p:cNvPr>
@@ -17936,7 +18014,7 @@
           <p:cNvPr id="6" name="body">
             <a:extLst xmlns:a="http://schemas.openxmlformats.org/drawingml/2006/main">
               <a:ext uri="{FF2B5EF4-FFF2-40B4-BE49-F238E27FC236}">
-                <a16:creationId xmlns:a16="http://schemas.microsoft.com/office/drawing/2014/main" id="{9BB175F8-4C3A-4FAE-842B-5018AA1EEC45}"/>
+                <a16:creationId xmlns:a16="http://schemas.microsoft.com/office/drawing/2014/main" id="{01FE5E7D-223D-4820-B10B-2FA540B51ECB}"/>
               </a:ext>
             </a:extLst>
           </p:cNvPr>
@@ -18004,7 +18082,7 @@
           <p:cNvPr id="7" name="body">
             <a:extLst xmlns:a="http://schemas.openxmlformats.org/drawingml/2006/main">
               <a:ext uri="{FF2B5EF4-FFF2-40B4-BE49-F238E27FC236}">
-                <a16:creationId xmlns:a16="http://schemas.microsoft.com/office/drawing/2014/main" id="{74F3FF27-601C-4077-9E6A-347973B75DA5}"/>
+                <a16:creationId xmlns:a16="http://schemas.microsoft.com/office/drawing/2014/main" id="{46573F1A-AB9B-4CA7-A0DB-4B401E689D36}"/>
               </a:ext>
             </a:extLst>
           </p:cNvPr>
@@ -18072,7 +18150,7 @@
           <p:cNvPr id="8" name="body">
             <a:extLst xmlns:a="http://schemas.openxmlformats.org/drawingml/2006/main">
               <a:ext uri="{FF2B5EF4-FFF2-40B4-BE49-F238E27FC236}">
-                <a16:creationId xmlns:a16="http://schemas.microsoft.com/office/drawing/2014/main" id="{E659DD0D-32A2-4129-918B-7D2217E870AD}"/>
+                <a16:creationId xmlns:a16="http://schemas.microsoft.com/office/drawing/2014/main" id="{49F1CCC5-D675-45A5-B805-8D448A32FED0}"/>
               </a:ext>
             </a:extLst>
           </p:cNvPr>
@@ -18163,7 +18241,7 @@
           <p:cNvPr id="9" name="body">
             <a:extLst xmlns:a="http://schemas.openxmlformats.org/drawingml/2006/main">
               <a:ext uri="{FF2B5EF4-FFF2-40B4-BE49-F238E27FC236}">
-                <a16:creationId xmlns:a16="http://schemas.microsoft.com/office/drawing/2014/main" id="{DCB2B648-1486-454E-B2F5-4C0762A600E7}"/>
+                <a16:creationId xmlns:a16="http://schemas.microsoft.com/office/drawing/2014/main" id="{C2C83D1F-9FC2-40A1-B96A-75DF9F90CDDD}"/>
               </a:ext>
             </a:extLst>
           </p:cNvPr>
@@ -18231,7 +18309,7 @@
           <p:cNvPr id="10" name="body">
             <a:extLst xmlns:a="http://schemas.openxmlformats.org/drawingml/2006/main">
               <a:ext uri="{FF2B5EF4-FFF2-40B4-BE49-F238E27FC236}">
-                <a16:creationId xmlns:a16="http://schemas.microsoft.com/office/drawing/2014/main" id="{92DAB079-421A-45C3-9B52-0B5DDB24071E}"/>
+                <a16:creationId xmlns:a16="http://schemas.microsoft.com/office/drawing/2014/main" id="{40C22C8F-CF67-4BCC-9FC1-48AC00DAE46B}"/>
               </a:ext>
             </a:extLst>
           </p:cNvPr>
@@ -18322,7 +18400,7 @@
           <p:cNvPr id="11" name="body">
             <a:extLst xmlns:a="http://schemas.openxmlformats.org/drawingml/2006/main">
               <a:ext uri="{FF2B5EF4-FFF2-40B4-BE49-F238E27FC236}">
-                <a16:creationId xmlns:a16="http://schemas.microsoft.com/office/drawing/2014/main" id="{63ECC7C7-2AC6-4FA8-A5C3-609EA6CD0582}"/>
+                <a16:creationId xmlns:a16="http://schemas.microsoft.com/office/drawing/2014/main" id="{D22BA6EC-EA02-4001-BF37-46FB5A0A5AE7}"/>
               </a:ext>
             </a:extLst>
           </p:cNvPr>
@@ -18388,7 +18466,7 @@
     </p:spTree>
     <p:extLst>
       <p:ext uri="{BB962C8B-B14F-4D97-AF65-F5344CB8AC3E}">
-        <p14:creationId xmlns:p14="http://schemas.microsoft.com/office/powerpoint/2010/main" val="258787383"/>
+        <p14:creationId xmlns:p14="http://schemas.microsoft.com/office/powerpoint/2010/main" val="1215481341"/>
       </p:ext>
     </p:extLst>
   </p:cSld>
@@ -18419,7 +18497,7 @@
           <p:cNvPr id="26" name="">
             <a:extLst xmlns:a="http://schemas.openxmlformats.org/drawingml/2006/main">
               <a:ext uri="{FF2B5EF4-FFF2-40B4-BE49-F238E27FC236}">
-                <a16:creationId xmlns:a16="http://schemas.microsoft.com/office/drawing/2014/main" id="{B2A9ED7B-80FD-4CC3-B44B-3F2FE5CC4CD0}"/>
+                <a16:creationId xmlns:a16="http://schemas.microsoft.com/office/drawing/2014/main" id="{158EFBB7-45A7-44C2-8852-E155B0C564DB}"/>
               </a:ext>
             </a:extLst>
           </p:cNvPr>
@@ -18451,7 +18529,7 @@
           <p:cNvPr id="25" name="">
             <a:extLst xmlns:a="http://schemas.openxmlformats.org/drawingml/2006/main">
               <a:ext uri="{FF2B5EF4-FFF2-40B4-BE49-F238E27FC236}">
-                <a16:creationId xmlns:a16="http://schemas.microsoft.com/office/drawing/2014/main" id="{677C7F60-B48A-4999-9CA0-A87EA0DEFF52}"/>
+                <a16:creationId xmlns:a16="http://schemas.microsoft.com/office/drawing/2014/main" id="{76E5ECB0-49A3-48E4-AEEF-F8230800BF58}"/>
               </a:ext>
             </a:extLst>
           </p:cNvPr>
@@ -18483,7 +18561,7 @@
           <p:cNvPr id="24" name="">
             <a:extLst xmlns:a="http://schemas.openxmlformats.org/drawingml/2006/main">
               <a:ext uri="{FF2B5EF4-FFF2-40B4-BE49-F238E27FC236}">
-                <a16:creationId xmlns:a16="http://schemas.microsoft.com/office/drawing/2014/main" id="{2F602EBC-6D49-4F9A-AC70-ACDFF009F357}"/>
+                <a16:creationId xmlns:a16="http://schemas.microsoft.com/office/drawing/2014/main" id="{B55D849A-7EA6-4DEA-A59D-8D985A8F709C}"/>
               </a:ext>
             </a:extLst>
           </p:cNvPr>
@@ -18515,7 +18593,7 @@
           <p:cNvPr id="23" name="">
             <a:extLst xmlns:a="http://schemas.openxmlformats.org/drawingml/2006/main">
               <a:ext uri="{FF2B5EF4-FFF2-40B4-BE49-F238E27FC236}">
-                <a16:creationId xmlns:a16="http://schemas.microsoft.com/office/drawing/2014/main" id="{BA5E77EE-8357-4CAC-A845-54A9FBF44DC6}"/>
+                <a16:creationId xmlns:a16="http://schemas.microsoft.com/office/drawing/2014/main" id="{1F81BC36-6FF1-4CAD-91B2-B0AA7BEA2E33}"/>
               </a:ext>
             </a:extLst>
           </p:cNvPr>
@@ -18547,7 +18625,7 @@
           <p:cNvPr id="22" name="">
             <a:extLst xmlns:a="http://schemas.openxmlformats.org/drawingml/2006/main">
               <a:ext uri="{FF2B5EF4-FFF2-40B4-BE49-F238E27FC236}">
-                <a16:creationId xmlns:a16="http://schemas.microsoft.com/office/drawing/2014/main" id="{A5B87987-E48C-4975-9209-637CBB981EF0}"/>
+                <a16:creationId xmlns:a16="http://schemas.microsoft.com/office/drawing/2014/main" id="{C2AED39F-7E1A-42FC-858E-E25CFDE2D15D}"/>
               </a:ext>
             </a:extLst>
           </p:cNvPr>
@@ -18579,7 +18657,7 @@
           <p:cNvPr id="29" name="slide-title">
             <a:extLst xmlns:a="http://schemas.openxmlformats.org/drawingml/2006/main">
               <a:ext uri="{FF2B5EF4-FFF2-40B4-BE49-F238E27FC236}">
-                <a16:creationId xmlns:a16="http://schemas.microsoft.com/office/drawing/2014/main" id="{7D2A7804-77E8-4138-960F-3B5EEFEB8E55}"/>
+                <a16:creationId xmlns:a16="http://schemas.microsoft.com/office/drawing/2014/main" id="{2118F132-4BEF-4861-943E-28E29E3F4E2E}"/>
               </a:ext>
             </a:extLst>
           </p:cNvPr>
@@ -18647,7 +18725,7 @@
           <p:cNvPr id="2" name="body">
             <a:extLst xmlns:a="http://schemas.openxmlformats.org/drawingml/2006/main">
               <a:ext uri="{FF2B5EF4-FFF2-40B4-BE49-F238E27FC236}">
-                <a16:creationId xmlns:a16="http://schemas.microsoft.com/office/drawing/2014/main" id="{D55BF7F1-67F3-4392-A027-31009678195A}"/>
+                <a16:creationId xmlns:a16="http://schemas.microsoft.com/office/drawing/2014/main" id="{83D56BDD-028B-425E-8974-DD385E56D409}"/>
               </a:ext>
             </a:extLst>
           </p:cNvPr>
@@ -18715,7 +18793,7 @@
           <p:cNvPr id="3" name="chapter-label">
             <a:extLst xmlns:a="http://schemas.openxmlformats.org/drawingml/2006/main">
               <a:ext uri="{FF2B5EF4-FFF2-40B4-BE49-F238E27FC236}">
-                <a16:creationId xmlns:a16="http://schemas.microsoft.com/office/drawing/2014/main" id="{88AD4899-96BB-46FE-9E26-7FD2FD8485C7}"/>
+                <a16:creationId xmlns:a16="http://schemas.microsoft.com/office/drawing/2014/main" id="{34296CAA-3750-489B-8673-3A53EC97A860}"/>
               </a:ext>
             </a:extLst>
           </p:cNvPr>
@@ -18783,7 +18861,7 @@
           <p:cNvPr id="4" name="program-flow-block">
             <a:extLst xmlns:a="http://schemas.openxmlformats.org/drawingml/2006/main">
               <a:ext uri="{FF2B5EF4-FFF2-40B4-BE49-F238E27FC236}">
-                <a16:creationId xmlns:a16="http://schemas.microsoft.com/office/drawing/2014/main" id="{6FEFCB6B-3DD7-43A5-9A76-12A988024449}"/>
+                <a16:creationId xmlns:a16="http://schemas.microsoft.com/office/drawing/2014/main" id="{71AF3882-B517-4D26-A5AF-D438744A3B92}"/>
               </a:ext>
             </a:extLst>
           </p:cNvPr>
@@ -18816,7 +18894,7 @@
           <p:cNvPr id="5" name="body">
             <a:extLst xmlns:a="http://schemas.openxmlformats.org/drawingml/2006/main">
               <a:ext uri="{FF2B5EF4-FFF2-40B4-BE49-F238E27FC236}">
-                <a16:creationId xmlns:a16="http://schemas.microsoft.com/office/drawing/2014/main" id="{F10FD9B1-DD91-4F2F-BC60-56C0E2711CDA}"/>
+                <a16:creationId xmlns:a16="http://schemas.microsoft.com/office/drawing/2014/main" id="{F0B247C6-F4AB-459D-B6A4-17B73F82751C}"/>
               </a:ext>
             </a:extLst>
           </p:cNvPr>
@@ -18884,7 +18962,7 @@
           <p:cNvPr id="6" name="body">
             <a:extLst xmlns:a="http://schemas.openxmlformats.org/drawingml/2006/main">
               <a:ext uri="{FF2B5EF4-FFF2-40B4-BE49-F238E27FC236}">
-                <a16:creationId xmlns:a16="http://schemas.microsoft.com/office/drawing/2014/main" id="{E2981B7E-BF15-4CE6-802E-16417EB90D38}"/>
+                <a16:creationId xmlns:a16="http://schemas.microsoft.com/office/drawing/2014/main" id="{93CF7CDF-4968-41DB-9613-17C7644A5A84}"/>
               </a:ext>
             </a:extLst>
           </p:cNvPr>
@@ -18952,7 +19030,7 @@
           <p:cNvPr id="7" name="program-flow-block">
             <a:extLst xmlns:a="http://schemas.openxmlformats.org/drawingml/2006/main">
               <a:ext uri="{FF2B5EF4-FFF2-40B4-BE49-F238E27FC236}">
-                <a16:creationId xmlns:a16="http://schemas.microsoft.com/office/drawing/2014/main" id="{B5B283B2-C779-4FAA-AC0F-C61F014B5DE2}"/>
+                <a16:creationId xmlns:a16="http://schemas.microsoft.com/office/drawing/2014/main" id="{7E891964-5BFB-4D19-B5FD-26AD57142286}"/>
               </a:ext>
             </a:extLst>
           </p:cNvPr>
@@ -18985,7 +19063,7 @@
           <p:cNvPr id="8" name="body">
             <a:extLst xmlns:a="http://schemas.openxmlformats.org/drawingml/2006/main">
               <a:ext uri="{FF2B5EF4-FFF2-40B4-BE49-F238E27FC236}">
-                <a16:creationId xmlns:a16="http://schemas.microsoft.com/office/drawing/2014/main" id="{B876EFE0-64A2-465E-AB05-7CADC10FFC59}"/>
+                <a16:creationId xmlns:a16="http://schemas.microsoft.com/office/drawing/2014/main" id="{466AA839-3738-44CD-A3DA-5AB72E304CBB}"/>
               </a:ext>
             </a:extLst>
           </p:cNvPr>
@@ -19053,7 +19131,7 @@
           <p:cNvPr id="9" name="body">
             <a:extLst xmlns:a="http://schemas.openxmlformats.org/drawingml/2006/main">
               <a:ext uri="{FF2B5EF4-FFF2-40B4-BE49-F238E27FC236}">
-                <a16:creationId xmlns:a16="http://schemas.microsoft.com/office/drawing/2014/main" id="{DE727203-E983-4869-810C-6B3032131D2E}"/>
+                <a16:creationId xmlns:a16="http://schemas.microsoft.com/office/drawing/2014/main" id="{BEAEC8B1-6001-42E1-9572-251E1B9BFA64}"/>
               </a:ext>
             </a:extLst>
           </p:cNvPr>
@@ -19121,7 +19199,7 @@
           <p:cNvPr id="10" name="program-flow-block">
             <a:extLst xmlns:a="http://schemas.openxmlformats.org/drawingml/2006/main">
               <a:ext uri="{FF2B5EF4-FFF2-40B4-BE49-F238E27FC236}">
-                <a16:creationId xmlns:a16="http://schemas.microsoft.com/office/drawing/2014/main" id="{C81919BB-6571-44F7-A4AB-4FD28F55EEC9}"/>
+                <a16:creationId xmlns:a16="http://schemas.microsoft.com/office/drawing/2014/main" id="{9F998C89-6890-4D6C-9099-27EEF9D0100A}"/>
               </a:ext>
             </a:extLst>
           </p:cNvPr>
@@ -19154,7 +19232,7 @@
           <p:cNvPr id="11" name="body">
             <a:extLst xmlns:a="http://schemas.openxmlformats.org/drawingml/2006/main">
               <a:ext uri="{FF2B5EF4-FFF2-40B4-BE49-F238E27FC236}">
-                <a16:creationId xmlns:a16="http://schemas.microsoft.com/office/drawing/2014/main" id="{76559376-FFA0-4C43-8E31-019FA5134BEE}"/>
+                <a16:creationId xmlns:a16="http://schemas.microsoft.com/office/drawing/2014/main" id="{A836B2D9-2782-4E84-A465-33CDA756E440}"/>
               </a:ext>
             </a:extLst>
           </p:cNvPr>
@@ -19222,7 +19300,7 @@
           <p:cNvPr id="12" name="body">
             <a:extLst xmlns:a="http://schemas.openxmlformats.org/drawingml/2006/main">
               <a:ext uri="{FF2B5EF4-FFF2-40B4-BE49-F238E27FC236}">
-                <a16:creationId xmlns:a16="http://schemas.microsoft.com/office/drawing/2014/main" id="{7AF882D1-26C8-465B-B484-ABF4C2AE6A16}"/>
+                <a16:creationId xmlns:a16="http://schemas.microsoft.com/office/drawing/2014/main" id="{80FBB3EA-60C3-4DAB-AB38-4459AAA3E28E}"/>
               </a:ext>
             </a:extLst>
           </p:cNvPr>
@@ -19290,7 +19368,7 @@
           <p:cNvPr id="13" name="program-flow-block">
             <a:extLst xmlns:a="http://schemas.openxmlformats.org/drawingml/2006/main">
               <a:ext uri="{FF2B5EF4-FFF2-40B4-BE49-F238E27FC236}">
-                <a16:creationId xmlns:a16="http://schemas.microsoft.com/office/drawing/2014/main" id="{3B2F5E29-6A6B-4282-8F2A-8DC2C364463A}"/>
+                <a16:creationId xmlns:a16="http://schemas.microsoft.com/office/drawing/2014/main" id="{D6A5AE15-469C-4119-9848-D8F5B3B3D357}"/>
               </a:ext>
             </a:extLst>
           </p:cNvPr>
@@ -19323,7 +19401,7 @@
           <p:cNvPr id="14" name="body">
             <a:extLst xmlns:a="http://schemas.openxmlformats.org/drawingml/2006/main">
               <a:ext uri="{FF2B5EF4-FFF2-40B4-BE49-F238E27FC236}">
-                <a16:creationId xmlns:a16="http://schemas.microsoft.com/office/drawing/2014/main" id="{DF49DD56-D0D9-45E5-B7EF-74381B84BCA7}"/>
+                <a16:creationId xmlns:a16="http://schemas.microsoft.com/office/drawing/2014/main" id="{B7C15FF7-55F7-4D1F-91CE-E3E4DB62C25A}"/>
               </a:ext>
             </a:extLst>
           </p:cNvPr>
@@ -19391,7 +19469,7 @@
           <p:cNvPr id="15" name="body">
             <a:extLst xmlns:a="http://schemas.openxmlformats.org/drawingml/2006/main">
               <a:ext uri="{FF2B5EF4-FFF2-40B4-BE49-F238E27FC236}">
-                <a16:creationId xmlns:a16="http://schemas.microsoft.com/office/drawing/2014/main" id="{6A0B0A59-324C-4E6A-B6AF-1C13204BEB27}"/>
+                <a16:creationId xmlns:a16="http://schemas.microsoft.com/office/drawing/2014/main" id="{6DFB7C0D-1710-48B8-B46A-E0F2F96661C8}"/>
               </a:ext>
             </a:extLst>
           </p:cNvPr>
@@ -19459,7 +19537,7 @@
           <p:cNvPr id="16" name="program-flow-block">
             <a:extLst xmlns:a="http://schemas.openxmlformats.org/drawingml/2006/main">
               <a:ext uri="{FF2B5EF4-FFF2-40B4-BE49-F238E27FC236}">
-                <a16:creationId xmlns:a16="http://schemas.microsoft.com/office/drawing/2014/main" id="{3D43E65A-8FC7-47AF-80B4-B1229B3CC2FC}"/>
+                <a16:creationId xmlns:a16="http://schemas.microsoft.com/office/drawing/2014/main" id="{87C1742C-FBEF-4781-8870-E496194FDD02}"/>
               </a:ext>
             </a:extLst>
           </p:cNvPr>
@@ -19492,7 +19570,7 @@
           <p:cNvPr id="17" name="body">
             <a:extLst xmlns:a="http://schemas.openxmlformats.org/drawingml/2006/main">
               <a:ext uri="{FF2B5EF4-FFF2-40B4-BE49-F238E27FC236}">
-                <a16:creationId xmlns:a16="http://schemas.microsoft.com/office/drawing/2014/main" id="{D0BD6350-AC51-4B2F-9D29-910B9C244E2B}"/>
+                <a16:creationId xmlns:a16="http://schemas.microsoft.com/office/drawing/2014/main" id="{21E7AFA5-3126-4AA5-B0B1-E8D01FAA2493}"/>
               </a:ext>
             </a:extLst>
           </p:cNvPr>
@@ -19560,7 +19638,7 @@
           <p:cNvPr id="18" name="body">
             <a:extLst xmlns:a="http://schemas.openxmlformats.org/drawingml/2006/main">
               <a:ext uri="{FF2B5EF4-FFF2-40B4-BE49-F238E27FC236}">
-                <a16:creationId xmlns:a16="http://schemas.microsoft.com/office/drawing/2014/main" id="{90AE0437-7DD8-444D-8E1D-9F19C49D92FB}"/>
+                <a16:creationId xmlns:a16="http://schemas.microsoft.com/office/drawing/2014/main" id="{51EC6B94-4B0E-42E6-BFC5-3B574D1D608A}"/>
               </a:ext>
             </a:extLst>
           </p:cNvPr>
@@ -19628,7 +19706,7 @@
           <p:cNvPr id="19" name="program-flow-block">
             <a:extLst xmlns:a="http://schemas.openxmlformats.org/drawingml/2006/main">
               <a:ext uri="{FF2B5EF4-FFF2-40B4-BE49-F238E27FC236}">
-                <a16:creationId xmlns:a16="http://schemas.microsoft.com/office/drawing/2014/main" id="{0D13BF6D-FA3C-495C-B70E-5CBE4E33D8A7}"/>
+                <a16:creationId xmlns:a16="http://schemas.microsoft.com/office/drawing/2014/main" id="{C924EF57-FEFA-4358-AFA4-5C5CD99BDBCF}"/>
               </a:ext>
             </a:extLst>
           </p:cNvPr>
@@ -19661,7 +19739,7 @@
           <p:cNvPr id="20" name="body">
             <a:extLst xmlns:a="http://schemas.openxmlformats.org/drawingml/2006/main">
               <a:ext uri="{FF2B5EF4-FFF2-40B4-BE49-F238E27FC236}">
-                <a16:creationId xmlns:a16="http://schemas.microsoft.com/office/drawing/2014/main" id="{DA4B5FE7-8EE4-454C-A7A3-3E0DCCBB700B}"/>
+                <a16:creationId xmlns:a16="http://schemas.microsoft.com/office/drawing/2014/main" id="{59E63CEF-C14E-4EA7-B61A-BE254FF8A052}"/>
               </a:ext>
             </a:extLst>
           </p:cNvPr>
@@ -19729,7 +19807,7 @@
           <p:cNvPr id="21" name="body">
             <a:extLst xmlns:a="http://schemas.openxmlformats.org/drawingml/2006/main">
               <a:ext uri="{FF2B5EF4-FFF2-40B4-BE49-F238E27FC236}">
-                <a16:creationId xmlns:a16="http://schemas.microsoft.com/office/drawing/2014/main" id="{F4A389C7-3E13-4BD1-8A11-F8A3D9C4A447}"/>
+                <a16:creationId xmlns:a16="http://schemas.microsoft.com/office/drawing/2014/main" id="{E7C5F07D-68DE-4645-8499-44FE6D90B077}"/>
               </a:ext>
             </a:extLst>
           </p:cNvPr>
@@ -19797,7 +19875,7 @@
           <p:cNvPr id="27" name="body">
             <a:extLst xmlns:a="http://schemas.openxmlformats.org/drawingml/2006/main">
               <a:ext uri="{FF2B5EF4-FFF2-40B4-BE49-F238E27FC236}">
-                <a16:creationId xmlns:a16="http://schemas.microsoft.com/office/drawing/2014/main" id="{4B68F971-138F-46B0-9F10-F5906B0CF5E0}"/>
+                <a16:creationId xmlns:a16="http://schemas.microsoft.com/office/drawing/2014/main" id="{B6B9F681-1C9F-4EBB-838B-6BAF3677A66D}"/>
               </a:ext>
             </a:extLst>
           </p:cNvPr>
@@ -19865,7 +19943,7 @@
           <p:cNvPr id="28" name="body">
             <a:extLst xmlns:a="http://schemas.openxmlformats.org/drawingml/2006/main">
               <a:ext uri="{FF2B5EF4-FFF2-40B4-BE49-F238E27FC236}">
-                <a16:creationId xmlns:a16="http://schemas.microsoft.com/office/drawing/2014/main" id="{CF2365B5-CE54-491E-AC04-6538A10DAB83}"/>
+                <a16:creationId xmlns:a16="http://schemas.microsoft.com/office/drawing/2014/main" id="{02AD0006-B269-47FC-AFA3-5C856C6010E1}"/>
               </a:ext>
             </a:extLst>
           </p:cNvPr>
@@ -19923,7 +20001,7 @@
                 <a:ea typeface="Microsoft JhengHei"/>
                 <a:cs typeface="Microsoft JhengHei"/>
               </a:rPr>
-              <a:t>最終只新增一支網路訓練，其餘五模型沿用保存預測。</a:t>
+              <a:t>原全量階段新增一支網路訓練，其餘五模型沿用保存預測。</a:t>
             </a:r>
           </a:p>
         </p:txBody>
@@ -19931,7 +20009,7 @@
     </p:spTree>
     <p:extLst>
       <p:ext uri="{BB962C8B-B14F-4D97-AF65-F5344CB8AC3E}">
-        <p14:creationId xmlns:p14="http://schemas.microsoft.com/office/powerpoint/2010/main" val="1317380005"/>
+        <p14:creationId xmlns:p14="http://schemas.microsoft.com/office/powerpoint/2010/main" val="1541951664"/>
       </p:ext>
     </p:extLst>
   </p:cSld>
@@ -19962,7 +20040,7 @@
           <p:cNvPr id="11" name="slide-title">
             <a:extLst xmlns:a="http://schemas.openxmlformats.org/drawingml/2006/main">
               <a:ext uri="{FF2B5EF4-FFF2-40B4-BE49-F238E27FC236}">
-                <a16:creationId xmlns:a16="http://schemas.microsoft.com/office/drawing/2014/main" id="{01AF93EC-5984-4850-AD7A-A540145B141C}"/>
+                <a16:creationId xmlns:a16="http://schemas.microsoft.com/office/drawing/2014/main" id="{8A2B1B99-3EAF-45F9-8C17-3EBDDAF7DDE0}"/>
               </a:ext>
             </a:extLst>
           </p:cNvPr>
@@ -20030,7 +20108,7 @@
           <p:cNvPr id="2" name="body">
             <a:extLst xmlns:a="http://schemas.openxmlformats.org/drawingml/2006/main">
               <a:ext uri="{FF2B5EF4-FFF2-40B4-BE49-F238E27FC236}">
-                <a16:creationId xmlns:a16="http://schemas.microsoft.com/office/drawing/2014/main" id="{E32BCF1E-FE79-4C07-B657-41CFF9415B41}"/>
+                <a16:creationId xmlns:a16="http://schemas.microsoft.com/office/drawing/2014/main" id="{6B21EDA5-2887-43E9-AFCD-6B1109CCD82F}"/>
               </a:ext>
             </a:extLst>
           </p:cNvPr>
@@ -20098,7 +20176,7 @@
           <p:cNvPr id="3" name="chapter-label">
             <a:extLst xmlns:a="http://schemas.openxmlformats.org/drawingml/2006/main">
               <a:ext uri="{FF2B5EF4-FFF2-40B4-BE49-F238E27FC236}">
-                <a16:creationId xmlns:a16="http://schemas.microsoft.com/office/drawing/2014/main" id="{BCE4385B-8A9F-43FE-8EB2-D7557776A546}"/>
+                <a16:creationId xmlns:a16="http://schemas.microsoft.com/office/drawing/2014/main" id="{BF3031DC-1495-414D-B8AB-88CF2DAB7046}"/>
               </a:ext>
             </a:extLst>
           </p:cNvPr>
@@ -20166,7 +20244,7 @@
           <p:cNvPr id="4" name="body">
             <a:extLst xmlns:a="http://schemas.openxmlformats.org/drawingml/2006/main">
               <a:ext uri="{FF2B5EF4-FFF2-40B4-BE49-F238E27FC236}">
-                <a16:creationId xmlns:a16="http://schemas.microsoft.com/office/drawing/2014/main" id="{ADEEA53A-DA65-493C-B9D3-0CAD9CC335DE}"/>
+                <a16:creationId xmlns:a16="http://schemas.microsoft.com/office/drawing/2014/main" id="{6C5B764B-9543-4584-849A-BBC8A866CC78}"/>
               </a:ext>
             </a:extLst>
           </p:cNvPr>
@@ -20234,7 +20312,7 @@
           <p:cNvPr id="5" name="body">
             <a:extLst xmlns:a="http://schemas.openxmlformats.org/drawingml/2006/main">
               <a:ext uri="{FF2B5EF4-FFF2-40B4-BE49-F238E27FC236}">
-                <a16:creationId xmlns:a16="http://schemas.microsoft.com/office/drawing/2014/main" id="{69A82674-E62B-467D-802F-EF584621E16B}"/>
+                <a16:creationId xmlns:a16="http://schemas.microsoft.com/office/drawing/2014/main" id="{08E329B8-4D70-419C-9193-F053256C5C07}"/>
               </a:ext>
             </a:extLst>
           </p:cNvPr>
@@ -20325,7 +20403,7 @@
           <p:cNvPr id="6" name="body">
             <a:extLst xmlns:a="http://schemas.openxmlformats.org/drawingml/2006/main">
               <a:ext uri="{FF2B5EF4-FFF2-40B4-BE49-F238E27FC236}">
-                <a16:creationId xmlns:a16="http://schemas.microsoft.com/office/drawing/2014/main" id="{8829F90B-202F-475F-A1EF-65B9CF7780DB}"/>
+                <a16:creationId xmlns:a16="http://schemas.microsoft.com/office/drawing/2014/main" id="{5956DE3B-3CC0-4D4B-A475-EC4A274924A9}"/>
               </a:ext>
             </a:extLst>
           </p:cNvPr>
@@ -20393,7 +20471,7 @@
           <p:cNvPr id="7" name="body">
             <a:extLst xmlns:a="http://schemas.openxmlformats.org/drawingml/2006/main">
               <a:ext uri="{FF2B5EF4-FFF2-40B4-BE49-F238E27FC236}">
-                <a16:creationId xmlns:a16="http://schemas.microsoft.com/office/drawing/2014/main" id="{B786CA98-3EB3-4F2B-99B0-E2D57B800408}"/>
+                <a16:creationId xmlns:a16="http://schemas.microsoft.com/office/drawing/2014/main" id="{03A4C1E5-0913-4F1E-A89B-7799083EEC61}"/>
               </a:ext>
             </a:extLst>
           </p:cNvPr>
@@ -20461,7 +20539,7 @@
           <p:cNvPr id="8" name="body">
             <a:extLst xmlns:a="http://schemas.openxmlformats.org/drawingml/2006/main">
               <a:ext uri="{FF2B5EF4-FFF2-40B4-BE49-F238E27FC236}">
-                <a16:creationId xmlns:a16="http://schemas.microsoft.com/office/drawing/2014/main" id="{5AF268FB-AD5D-46B7-B279-113694F315E3}"/>
+                <a16:creationId xmlns:a16="http://schemas.microsoft.com/office/drawing/2014/main" id="{ACEF88CE-FE21-4E38-A725-443FAA5386F4}"/>
               </a:ext>
             </a:extLst>
           </p:cNvPr>
@@ -20552,7 +20630,7 @@
           <p:cNvPr id="9" name="">
             <a:extLst xmlns:a="http://schemas.openxmlformats.org/drawingml/2006/main">
               <a:ext uri="{FF2B5EF4-FFF2-40B4-BE49-F238E27FC236}">
-                <a16:creationId xmlns:a16="http://schemas.microsoft.com/office/drawing/2014/main" id="{FF07CDAB-8931-4A9E-A8BC-4E4F865502C9}"/>
+                <a16:creationId xmlns:a16="http://schemas.microsoft.com/office/drawing/2014/main" id="{D98FB17B-876E-4AF2-A2CC-6F177311C492}"/>
               </a:ext>
             </a:extLst>
           </p:cNvPr>
@@ -20562,7 +20640,7 @@
           <p:nvPr/>
         </p:nvPicPr>
         <p:blipFill>
-          <a:blip xmlns:r="http://schemas.openxmlformats.org/officeDocument/2006/relationships" xmlns:a="http://schemas.openxmlformats.org/drawingml/2006/main" r:embed="R3653ca8e74b74d20"/>
+          <a:blip xmlns:r="http://schemas.openxmlformats.org/officeDocument/2006/relationships" xmlns:a="http://schemas.openxmlformats.org/drawingml/2006/main" r:embed="R27d20f3e7ee7468f"/>
           <a:stretch xmlns:a="http://schemas.openxmlformats.org/drawingml/2006/main"/>
         </p:blipFill>
         <p:spPr>
@@ -20580,7 +20658,7 @@
           <p:cNvPr id="10" name="body">
             <a:extLst xmlns:a="http://schemas.openxmlformats.org/drawingml/2006/main">
               <a:ext uri="{FF2B5EF4-FFF2-40B4-BE49-F238E27FC236}">
-                <a16:creationId xmlns:a16="http://schemas.microsoft.com/office/drawing/2014/main" id="{C2C53E2D-62FB-4D78-ABC8-187CB008269C}"/>
+                <a16:creationId xmlns:a16="http://schemas.microsoft.com/office/drawing/2014/main" id="{0EF5B1A4-92E1-4243-93BA-B4DAB3A2246E}"/>
               </a:ext>
             </a:extLst>
           </p:cNvPr>
@@ -20646,7 +20724,7 @@
     </p:spTree>
     <p:extLst>
       <p:ext uri="{BB962C8B-B14F-4D97-AF65-F5344CB8AC3E}">
-        <p14:creationId xmlns:p14="http://schemas.microsoft.com/office/powerpoint/2010/main" val="782817266"/>
+        <p14:creationId xmlns:p14="http://schemas.microsoft.com/office/powerpoint/2010/main" val="307277528"/>
       </p:ext>
     </p:extLst>
   </p:cSld>
@@ -20677,7 +20755,7 @@
           <p:cNvPr id="11" name="slide-title">
             <a:extLst xmlns:a="http://schemas.openxmlformats.org/drawingml/2006/main">
               <a:ext uri="{FF2B5EF4-FFF2-40B4-BE49-F238E27FC236}">
-                <a16:creationId xmlns:a16="http://schemas.microsoft.com/office/drawing/2014/main" id="{D908E9C9-78D6-4AD5-A29C-D077F8C3E331}"/>
+                <a16:creationId xmlns:a16="http://schemas.microsoft.com/office/drawing/2014/main" id="{76978C9C-2217-44D7-8540-068E241C5784}"/>
               </a:ext>
             </a:extLst>
           </p:cNvPr>
@@ -20745,7 +20823,7 @@
           <p:cNvPr id="2" name="body">
             <a:extLst xmlns:a="http://schemas.openxmlformats.org/drawingml/2006/main">
               <a:ext uri="{FF2B5EF4-FFF2-40B4-BE49-F238E27FC236}">
-                <a16:creationId xmlns:a16="http://schemas.microsoft.com/office/drawing/2014/main" id="{AB77A16D-C361-42EF-BC6E-A6CFE1C67CD3}"/>
+                <a16:creationId xmlns:a16="http://schemas.microsoft.com/office/drawing/2014/main" id="{EAE9BFD2-4E3D-4084-B455-21A2EB55DC6F}"/>
               </a:ext>
             </a:extLst>
           </p:cNvPr>
@@ -20813,7 +20891,7 @@
           <p:cNvPr id="3" name="chapter-label">
             <a:extLst xmlns:a="http://schemas.openxmlformats.org/drawingml/2006/main">
               <a:ext uri="{FF2B5EF4-FFF2-40B4-BE49-F238E27FC236}">
-                <a16:creationId xmlns:a16="http://schemas.microsoft.com/office/drawing/2014/main" id="{3CA20E16-C6C1-4548-B8B1-B493E18C702E}"/>
+                <a16:creationId xmlns:a16="http://schemas.microsoft.com/office/drawing/2014/main" id="{ECD0C1A2-43B7-4EA5-AAD2-D6260B8D26C0}"/>
               </a:ext>
             </a:extLst>
           </p:cNvPr>
@@ -20881,7 +20959,7 @@
           <p:cNvPr id="4" name="body">
             <a:extLst xmlns:a="http://schemas.openxmlformats.org/drawingml/2006/main">
               <a:ext uri="{FF2B5EF4-FFF2-40B4-BE49-F238E27FC236}">
-                <a16:creationId xmlns:a16="http://schemas.microsoft.com/office/drawing/2014/main" id="{2D9869AE-1BD2-4D75-BB81-C120B75B86C0}"/>
+                <a16:creationId xmlns:a16="http://schemas.microsoft.com/office/drawing/2014/main" id="{998834CE-70E0-48C7-A10A-CC84F7111680}"/>
               </a:ext>
             </a:extLst>
           </p:cNvPr>
@@ -20949,7 +21027,7 @@
           <p:cNvPr id="5" name="">
             <a:extLst xmlns:a="http://schemas.openxmlformats.org/drawingml/2006/main">
               <a:ext uri="{FF2B5EF4-FFF2-40B4-BE49-F238E27FC236}">
-                <a16:creationId xmlns:a16="http://schemas.microsoft.com/office/drawing/2014/main" id="{8EC4A89F-2243-4B04-8ABC-F2A020C8665D}"/>
+                <a16:creationId xmlns:a16="http://schemas.microsoft.com/office/drawing/2014/main" id="{9F8EAC78-BF8C-4E6B-9F45-73530100C646}"/>
               </a:ext>
             </a:extLst>
           </p:cNvPr>
@@ -21495,7 +21573,7 @@
           <p:cNvPr id="6" name="body">
             <a:extLst xmlns:a="http://schemas.openxmlformats.org/drawingml/2006/main">
               <a:ext uri="{FF2B5EF4-FFF2-40B4-BE49-F238E27FC236}">
-                <a16:creationId xmlns:a16="http://schemas.microsoft.com/office/drawing/2014/main" id="{8630521B-3DAD-4065-ADA8-306DDF482555}"/>
+                <a16:creationId xmlns:a16="http://schemas.microsoft.com/office/drawing/2014/main" id="{CA645AD0-F3F0-46BE-966F-CA093A03D539}"/>
               </a:ext>
             </a:extLst>
           </p:cNvPr>
@@ -21563,7 +21641,7 @@
           <p:cNvPr id="7" name="body">
             <a:extLst xmlns:a="http://schemas.openxmlformats.org/drawingml/2006/main">
               <a:ext uri="{FF2B5EF4-FFF2-40B4-BE49-F238E27FC236}">
-                <a16:creationId xmlns:a16="http://schemas.microsoft.com/office/drawing/2014/main" id="{1EA9BD78-3BB6-49CF-BBB7-8380ABCF5558}"/>
+                <a16:creationId xmlns:a16="http://schemas.microsoft.com/office/drawing/2014/main" id="{1CBDD0C5-B477-43E1-87B9-E5FF8299F2E1}"/>
               </a:ext>
             </a:extLst>
           </p:cNvPr>
@@ -21631,7 +21709,7 @@
           <p:cNvPr id="8" name="body">
             <a:extLst xmlns:a="http://schemas.openxmlformats.org/drawingml/2006/main">
               <a:ext uri="{FF2B5EF4-FFF2-40B4-BE49-F238E27FC236}">
-                <a16:creationId xmlns:a16="http://schemas.microsoft.com/office/drawing/2014/main" id="{00430557-9999-4BA2-ABA9-572A24EF9609}"/>
+                <a16:creationId xmlns:a16="http://schemas.microsoft.com/office/drawing/2014/main" id="{D484C59A-B745-4FC5-ADA6-37CC6A9F83AE}"/>
               </a:ext>
             </a:extLst>
           </p:cNvPr>
@@ -21699,7 +21777,7 @@
           <p:cNvPr id="9" name="body">
             <a:extLst xmlns:a="http://schemas.openxmlformats.org/drawingml/2006/main">
               <a:ext uri="{FF2B5EF4-FFF2-40B4-BE49-F238E27FC236}">
-                <a16:creationId xmlns:a16="http://schemas.microsoft.com/office/drawing/2014/main" id="{E2DF0D3F-1865-4FC2-B792-8727A3659072}"/>
+                <a16:creationId xmlns:a16="http://schemas.microsoft.com/office/drawing/2014/main" id="{59D51269-4F8D-4FCD-BEAB-86240928D83D}"/>
               </a:ext>
             </a:extLst>
           </p:cNvPr>
@@ -21767,7 +21845,7 @@
           <p:cNvPr id="10" name="body">
             <a:extLst xmlns:a="http://schemas.openxmlformats.org/drawingml/2006/main">
               <a:ext uri="{FF2B5EF4-FFF2-40B4-BE49-F238E27FC236}">
-                <a16:creationId xmlns:a16="http://schemas.microsoft.com/office/drawing/2014/main" id="{5898B2E8-E94D-4611-B690-439D02FB4D8D}"/>
+                <a16:creationId xmlns:a16="http://schemas.microsoft.com/office/drawing/2014/main" id="{8B32DF11-129F-4F05-8DBE-2A14A94D2489}"/>
               </a:ext>
             </a:extLst>
           </p:cNvPr>
@@ -21833,7 +21911,7 @@
     </p:spTree>
     <p:extLst>
       <p:ext uri="{BB962C8B-B14F-4D97-AF65-F5344CB8AC3E}">
-        <p14:creationId xmlns:p14="http://schemas.microsoft.com/office/powerpoint/2010/main" val="1169830218"/>
+        <p14:creationId xmlns:p14="http://schemas.microsoft.com/office/powerpoint/2010/main" val="1727266397"/>
       </p:ext>
     </p:extLst>
   </p:cSld>
@@ -21864,7 +21942,7 @@
           <p:cNvPr id="9" name="slide-title">
             <a:extLst xmlns:a="http://schemas.openxmlformats.org/drawingml/2006/main">
               <a:ext uri="{FF2B5EF4-FFF2-40B4-BE49-F238E27FC236}">
-                <a16:creationId xmlns:a16="http://schemas.microsoft.com/office/drawing/2014/main" id="{7BAE9DBA-40DD-4C3C-9CB6-5CA6A6E787B4}"/>
+                <a16:creationId xmlns:a16="http://schemas.microsoft.com/office/drawing/2014/main" id="{BF5144AE-3935-45C6-A581-8E621D64B65C}"/>
               </a:ext>
             </a:extLst>
           </p:cNvPr>
@@ -21932,7 +22010,7 @@
           <p:cNvPr id="2" name="body">
             <a:extLst xmlns:a="http://schemas.openxmlformats.org/drawingml/2006/main">
               <a:ext uri="{FF2B5EF4-FFF2-40B4-BE49-F238E27FC236}">
-                <a16:creationId xmlns:a16="http://schemas.microsoft.com/office/drawing/2014/main" id="{DB25D40B-700B-481C-8F6B-972C53A4DF90}"/>
+                <a16:creationId xmlns:a16="http://schemas.microsoft.com/office/drawing/2014/main" id="{CED87961-E6FE-40EB-A655-C7DAAAEC9B72}"/>
               </a:ext>
             </a:extLst>
           </p:cNvPr>
@@ -22000,7 +22078,7 @@
           <p:cNvPr id="3" name="chapter-label">
             <a:extLst xmlns:a="http://schemas.openxmlformats.org/drawingml/2006/main">
               <a:ext uri="{FF2B5EF4-FFF2-40B4-BE49-F238E27FC236}">
-                <a16:creationId xmlns:a16="http://schemas.microsoft.com/office/drawing/2014/main" id="{851F4A60-0A89-4D00-AC38-C84E46A319B9}"/>
+                <a16:creationId xmlns:a16="http://schemas.microsoft.com/office/drawing/2014/main" id="{ED8FB7CD-A823-4C43-A601-226B0D9732A0}"/>
               </a:ext>
             </a:extLst>
           </p:cNvPr>
@@ -22068,7 +22146,7 @@
           <p:cNvPr id="4" name="body">
             <a:extLst xmlns:a="http://schemas.openxmlformats.org/drawingml/2006/main">
               <a:ext uri="{FF2B5EF4-FFF2-40B4-BE49-F238E27FC236}">
-                <a16:creationId xmlns:a16="http://schemas.microsoft.com/office/drawing/2014/main" id="{1C589D71-2B0E-4C1B-ABF4-08AA69EAE0DD}"/>
+                <a16:creationId xmlns:a16="http://schemas.microsoft.com/office/drawing/2014/main" id="{62FB4740-594F-4E10-9DFA-2622AEB2EFE4}"/>
               </a:ext>
             </a:extLst>
           </p:cNvPr>
@@ -22136,7 +22214,7 @@
           <p:cNvPr id="5" name="Chart">
             <a:extLst xmlns:a="http://schemas.openxmlformats.org/drawingml/2006/main">
               <a:ext uri="{FF2B5EF4-FFF2-40B4-BE49-F238E27FC236}">
-                <a16:creationId xmlns:a16="http://schemas.microsoft.com/office/drawing/2014/main" id="{8FC913D6-5153-460C-BD8E-41400FBE205E}"/>
+                <a16:creationId xmlns:a16="http://schemas.microsoft.com/office/drawing/2014/main" id="{C7A86D2A-CA14-43AD-8503-6690F205C2B0}"/>
               </a:ext>
             </a:extLst>
           </p:cNvPr>
@@ -22149,7 +22227,7 @@
         </p:xfrm>
         <a:graphic xmlns:a="http://schemas.openxmlformats.org/drawingml/2006/main">
           <a:graphicData uri="http://schemas.openxmlformats.org/drawingml/2006/chart">
-            <c:chart xmlns:r="http://schemas.openxmlformats.org/officeDocument/2006/relationships" xmlns:c="http://schemas.openxmlformats.org/drawingml/2006/chart" r:id="Re0a5055752df40f2"/>
+            <c:chart xmlns:r="http://schemas.openxmlformats.org/officeDocument/2006/relationships" xmlns:c="http://schemas.openxmlformats.org/drawingml/2006/chart" r:id="R9c54a517d36b407e"/>
           </a:graphicData>
         </a:graphic>
       </p:graphicFrame>
@@ -22158,7 +22236,7 @@
           <p:cNvPr id="6" name="body">
             <a:extLst xmlns:a="http://schemas.openxmlformats.org/drawingml/2006/main">
               <a:ext uri="{FF2B5EF4-FFF2-40B4-BE49-F238E27FC236}">
-                <a16:creationId xmlns:a16="http://schemas.microsoft.com/office/drawing/2014/main" id="{351D5A51-17F8-4C81-809B-7B00F913949D}"/>
+                <a16:creationId xmlns:a16="http://schemas.microsoft.com/office/drawing/2014/main" id="{BC4C259D-B666-49FC-8DAE-685726D71F37}"/>
               </a:ext>
             </a:extLst>
           </p:cNvPr>
@@ -22226,7 +22304,7 @@
           <p:cNvPr id="7" name="">
             <a:extLst xmlns:a="http://schemas.openxmlformats.org/drawingml/2006/main">
               <a:ext uri="{FF2B5EF4-FFF2-40B4-BE49-F238E27FC236}">
-                <a16:creationId xmlns:a16="http://schemas.microsoft.com/office/drawing/2014/main" id="{476E21AB-5F05-46CC-BA85-272F8C46C473}"/>
+                <a16:creationId xmlns:a16="http://schemas.microsoft.com/office/drawing/2014/main" id="{383FC48D-5350-4E8E-AE37-F0371C43DC8C}"/>
               </a:ext>
             </a:extLst>
           </p:cNvPr>
@@ -22868,7 +22946,7 @@
           <p:cNvPr id="8" name="body">
             <a:extLst xmlns:a="http://schemas.openxmlformats.org/drawingml/2006/main">
               <a:ext uri="{FF2B5EF4-FFF2-40B4-BE49-F238E27FC236}">
-                <a16:creationId xmlns:a16="http://schemas.microsoft.com/office/drawing/2014/main" id="{4B9CA39E-9F28-4CAE-97BF-3C6D0F815BB2}"/>
+                <a16:creationId xmlns:a16="http://schemas.microsoft.com/office/drawing/2014/main" id="{0F560EA1-0168-4636-871A-0C3EE8F2BC25}"/>
               </a:ext>
             </a:extLst>
           </p:cNvPr>
@@ -22934,7 +23012,7 @@
     </p:spTree>
     <p:extLst>
       <p:ext uri="{BB962C8B-B14F-4D97-AF65-F5344CB8AC3E}">
-        <p14:creationId xmlns:p14="http://schemas.microsoft.com/office/powerpoint/2010/main" val="1940754736"/>
+        <p14:creationId xmlns:p14="http://schemas.microsoft.com/office/powerpoint/2010/main" val="1829954866"/>
       </p:ext>
     </p:extLst>
   </p:cSld>
@@ -22965,7 +23043,7 @@
           <p:cNvPr id="6" name="slide-title">
             <a:extLst xmlns:a="http://schemas.openxmlformats.org/drawingml/2006/main">
               <a:ext uri="{FF2B5EF4-FFF2-40B4-BE49-F238E27FC236}">
-                <a16:creationId xmlns:a16="http://schemas.microsoft.com/office/drawing/2014/main" id="{6514E190-C04A-44ED-B5BA-250CFB31284A}"/>
+                <a16:creationId xmlns:a16="http://schemas.microsoft.com/office/drawing/2014/main" id="{2CBC561B-5EF8-482C-9E80-B19BFC9DE28E}"/>
               </a:ext>
             </a:extLst>
           </p:cNvPr>
@@ -23033,7 +23111,7 @@
           <p:cNvPr id="2" name="body">
             <a:extLst xmlns:a="http://schemas.openxmlformats.org/drawingml/2006/main">
               <a:ext uri="{FF2B5EF4-FFF2-40B4-BE49-F238E27FC236}">
-                <a16:creationId xmlns:a16="http://schemas.microsoft.com/office/drawing/2014/main" id="{B6B739A0-BD4A-4831-BBAF-78B69FFDA790}"/>
+                <a16:creationId xmlns:a16="http://schemas.microsoft.com/office/drawing/2014/main" id="{346ED5CA-BD7F-4307-AAC6-DDD4495E34F1}"/>
               </a:ext>
             </a:extLst>
           </p:cNvPr>
@@ -23101,7 +23179,7 @@
           <p:cNvPr id="3" name="chapter-label">
             <a:extLst xmlns:a="http://schemas.openxmlformats.org/drawingml/2006/main">
               <a:ext uri="{FF2B5EF4-FFF2-40B4-BE49-F238E27FC236}">
-                <a16:creationId xmlns:a16="http://schemas.microsoft.com/office/drawing/2014/main" id="{586B29FE-7572-45A5-B265-7308ABB77B3C}"/>
+                <a16:creationId xmlns:a16="http://schemas.microsoft.com/office/drawing/2014/main" id="{6DF07B0A-C2EA-4AF1-8361-C512063B3200}"/>
               </a:ext>
             </a:extLst>
           </p:cNvPr>
@@ -23169,7 +23247,7 @@
           <p:cNvPr id="4" name="">
             <a:extLst xmlns:a="http://schemas.openxmlformats.org/drawingml/2006/main">
               <a:ext uri="{FF2B5EF4-FFF2-40B4-BE49-F238E27FC236}">
-                <a16:creationId xmlns:a16="http://schemas.microsoft.com/office/drawing/2014/main" id="{488B8D41-B2A9-48FF-B41D-627AFB9A063C}"/>
+                <a16:creationId xmlns:a16="http://schemas.microsoft.com/office/drawing/2014/main" id="{117FECBD-B0C3-426A-B01C-666600D49BEA}"/>
               </a:ext>
             </a:extLst>
           </p:cNvPr>
@@ -23966,7 +24044,7 @@
           <p:cNvPr id="5" name="body">
             <a:extLst xmlns:a="http://schemas.openxmlformats.org/drawingml/2006/main">
               <a:ext uri="{FF2B5EF4-FFF2-40B4-BE49-F238E27FC236}">
-                <a16:creationId xmlns:a16="http://schemas.microsoft.com/office/drawing/2014/main" id="{2B41359D-2E20-4B17-9D64-1658B58A7125}"/>
+                <a16:creationId xmlns:a16="http://schemas.microsoft.com/office/drawing/2014/main" id="{EBF33C63-369D-4B3A-B3A8-B32B1BCD9BF7}"/>
               </a:ext>
             </a:extLst>
           </p:cNvPr>
@@ -24032,7 +24110,7 @@
     </p:spTree>
     <p:extLst>
       <p:ext uri="{BB962C8B-B14F-4D97-AF65-F5344CB8AC3E}">
-        <p14:creationId xmlns:p14="http://schemas.microsoft.com/office/powerpoint/2010/main" val="934140163"/>
+        <p14:creationId xmlns:p14="http://schemas.microsoft.com/office/powerpoint/2010/main" val="1431496892"/>
       </p:ext>
     </p:extLst>
   </p:cSld>
@@ -24063,7 +24141,7 @@
           <p:cNvPr id="7" name="slide-title">
             <a:extLst xmlns:a="http://schemas.openxmlformats.org/drawingml/2006/main">
               <a:ext uri="{FF2B5EF4-FFF2-40B4-BE49-F238E27FC236}">
-                <a16:creationId xmlns:a16="http://schemas.microsoft.com/office/drawing/2014/main" id="{2ACC6548-B343-47A8-BE81-974F9D81F6A7}"/>
+                <a16:creationId xmlns:a16="http://schemas.microsoft.com/office/drawing/2014/main" id="{623F5B45-00CA-4F47-BF61-ED3423286836}"/>
               </a:ext>
             </a:extLst>
           </p:cNvPr>
@@ -24131,7 +24209,7 @@
           <p:cNvPr id="2" name="body">
             <a:extLst xmlns:a="http://schemas.openxmlformats.org/drawingml/2006/main">
               <a:ext uri="{FF2B5EF4-FFF2-40B4-BE49-F238E27FC236}">
-                <a16:creationId xmlns:a16="http://schemas.microsoft.com/office/drawing/2014/main" id="{87AB8C67-AF78-41B8-AD13-19D8E22F10A9}"/>
+                <a16:creationId xmlns:a16="http://schemas.microsoft.com/office/drawing/2014/main" id="{FCF28976-2FC0-4293-B46B-68EBDBA5C893}"/>
               </a:ext>
             </a:extLst>
           </p:cNvPr>
@@ -24199,7 +24277,7 @@
           <p:cNvPr id="3" name="chapter-label">
             <a:extLst xmlns:a="http://schemas.openxmlformats.org/drawingml/2006/main">
               <a:ext uri="{FF2B5EF4-FFF2-40B4-BE49-F238E27FC236}">
-                <a16:creationId xmlns:a16="http://schemas.microsoft.com/office/drawing/2014/main" id="{A8401B67-E0F4-4870-93F3-FD513E3BBC29}"/>
+                <a16:creationId xmlns:a16="http://schemas.microsoft.com/office/drawing/2014/main" id="{DEA2A9F5-D8D5-4572-B1AC-BE794A94A224}"/>
               </a:ext>
             </a:extLst>
           </p:cNvPr>
@@ -24267,7 +24345,7 @@
           <p:cNvPr id="4" name="body">
             <a:extLst xmlns:a="http://schemas.openxmlformats.org/drawingml/2006/main">
               <a:ext uri="{FF2B5EF4-FFF2-40B4-BE49-F238E27FC236}">
-                <a16:creationId xmlns:a16="http://schemas.microsoft.com/office/drawing/2014/main" id="{37664761-099E-47CA-80BC-0954DC115411}"/>
+                <a16:creationId xmlns:a16="http://schemas.microsoft.com/office/drawing/2014/main" id="{28308168-0FBE-41F1-AFDB-6C25668BEC83}"/>
               </a:ext>
             </a:extLst>
           </p:cNvPr>
@@ -24335,7 +24413,7 @@
           <p:cNvPr id="5" name="">
             <a:extLst xmlns:a="http://schemas.openxmlformats.org/drawingml/2006/main">
               <a:ext uri="{FF2B5EF4-FFF2-40B4-BE49-F238E27FC236}">
-                <a16:creationId xmlns:a16="http://schemas.microsoft.com/office/drawing/2014/main" id="{816A5F0E-40BB-41D8-9743-75445C585860}"/>
+                <a16:creationId xmlns:a16="http://schemas.microsoft.com/office/drawing/2014/main" id="{A12F4F1C-2DC5-4433-9D2F-E85E1157C035}"/>
               </a:ext>
             </a:extLst>
           </p:cNvPr>
@@ -25007,7 +25085,7 @@
           <p:cNvPr id="6" name="body">
             <a:extLst xmlns:a="http://schemas.openxmlformats.org/drawingml/2006/main">
               <a:ext uri="{FF2B5EF4-FFF2-40B4-BE49-F238E27FC236}">
-                <a16:creationId xmlns:a16="http://schemas.microsoft.com/office/drawing/2014/main" id="{660C122F-B8E0-4B55-A978-666D7AE1510C}"/>
+                <a16:creationId xmlns:a16="http://schemas.microsoft.com/office/drawing/2014/main" id="{46204556-CA40-409A-A212-4410A0AA0D10}"/>
               </a:ext>
             </a:extLst>
           </p:cNvPr>
@@ -25073,7 +25151,7 @@
     </p:spTree>
     <p:extLst>
       <p:ext uri="{BB962C8B-B14F-4D97-AF65-F5344CB8AC3E}">
-        <p14:creationId xmlns:p14="http://schemas.microsoft.com/office/powerpoint/2010/main" val="249118357"/>
+        <p14:creationId xmlns:p14="http://schemas.microsoft.com/office/powerpoint/2010/main" val="1713748923"/>
       </p:ext>
     </p:extLst>
   </p:cSld>
@@ -25104,7 +25182,7 @@
           <p:cNvPr id="6" name="slide-title">
             <a:extLst xmlns:a="http://schemas.openxmlformats.org/drawingml/2006/main">
               <a:ext uri="{FF2B5EF4-FFF2-40B4-BE49-F238E27FC236}">
-                <a16:creationId xmlns:a16="http://schemas.microsoft.com/office/drawing/2014/main" id="{175DCFE2-F07D-4506-9D33-595BBA95CE16}"/>
+                <a16:creationId xmlns:a16="http://schemas.microsoft.com/office/drawing/2014/main" id="{092C386D-4E67-4C1D-BCA6-5171880338DB}"/>
               </a:ext>
             </a:extLst>
           </p:cNvPr>
@@ -25172,7 +25250,7 @@
           <p:cNvPr id="2" name="body">
             <a:extLst xmlns:a="http://schemas.openxmlformats.org/drawingml/2006/main">
               <a:ext uri="{FF2B5EF4-FFF2-40B4-BE49-F238E27FC236}">
-                <a16:creationId xmlns:a16="http://schemas.microsoft.com/office/drawing/2014/main" id="{B36C300A-25EE-4855-8424-14BE07D642FC}"/>
+                <a16:creationId xmlns:a16="http://schemas.microsoft.com/office/drawing/2014/main" id="{F6D1CA16-D36A-4862-85E0-F243F4ACA4F4}"/>
               </a:ext>
             </a:extLst>
           </p:cNvPr>
@@ -25240,7 +25318,7 @@
           <p:cNvPr id="3" name="chapter-label">
             <a:extLst xmlns:a="http://schemas.openxmlformats.org/drawingml/2006/main">
               <a:ext uri="{FF2B5EF4-FFF2-40B4-BE49-F238E27FC236}">
-                <a16:creationId xmlns:a16="http://schemas.microsoft.com/office/drawing/2014/main" id="{6F153948-6E2C-48EC-8E24-549776A85AC0}"/>
+                <a16:creationId xmlns:a16="http://schemas.microsoft.com/office/drawing/2014/main" id="{8A8D4C9F-93C0-45C7-A065-983B2328DDFD}"/>
               </a:ext>
             </a:extLst>
           </p:cNvPr>
@@ -25308,7 +25386,7 @@
           <p:cNvPr id="4" name="">
             <a:extLst xmlns:a="http://schemas.openxmlformats.org/drawingml/2006/main">
               <a:ext uri="{FF2B5EF4-FFF2-40B4-BE49-F238E27FC236}">
-                <a16:creationId xmlns:a16="http://schemas.microsoft.com/office/drawing/2014/main" id="{45DD2A99-CB4C-496B-8CB8-FD27E90C8C47}"/>
+                <a16:creationId xmlns:a16="http://schemas.microsoft.com/office/drawing/2014/main" id="{9EB09892-B96A-43DB-996A-1B6587841EE7}"/>
               </a:ext>
             </a:extLst>
           </p:cNvPr>
@@ -25778,7 +25856,7 @@
           <p:cNvPr id="5" name="body">
             <a:extLst xmlns:a="http://schemas.openxmlformats.org/drawingml/2006/main">
               <a:ext uri="{FF2B5EF4-FFF2-40B4-BE49-F238E27FC236}">
-                <a16:creationId xmlns:a16="http://schemas.microsoft.com/office/drawing/2014/main" id="{AF79027E-96EB-4B54-9A5B-47E698454F69}"/>
+                <a16:creationId xmlns:a16="http://schemas.microsoft.com/office/drawing/2014/main" id="{441A7124-BA72-4FFA-9184-A76C8A57C860}"/>
               </a:ext>
             </a:extLst>
           </p:cNvPr>
@@ -25844,7 +25922,7 @@
     </p:spTree>
     <p:extLst>
       <p:ext uri="{BB962C8B-B14F-4D97-AF65-F5344CB8AC3E}">
-        <p14:creationId xmlns:p14="http://schemas.microsoft.com/office/powerpoint/2010/main" val="1143333370"/>
+        <p14:creationId xmlns:p14="http://schemas.microsoft.com/office/powerpoint/2010/main" val="923666696"/>
       </p:ext>
     </p:extLst>
   </p:cSld>

</xml_diff>